<commit_message>
checkBounce test project, tutorial 1 .h/.c slide
- ass1/solution/checkBounce: CubeIDE project (from hardwaret_test) measuring
  contact bounce on the I2C buttons, B1 (EXTI and polled) and the IR sensor,
  driven via Live Expressions; checkBounce_instructions.txt to fill in
- tutorials: header/source split slide in tutorial 1
- MP.md: ass1/solution is TA-only

Co-Authored-By: Claude Opus 5.5 <noreply@anthropic.com>
</commit_message>
<xml_diff>
--- a/tutorials/MP_tutorials_2026.pptx
+++ b/tutorials/MP_tutorials_2026.pptx
@@ -29,9 +29,10 @@
     <p:sldId id="277" r:id="rId23"/>
     <p:sldId id="278" r:id="rId24"/>
     <p:sldId id="279" r:id="rId25"/>
+    <p:sldId id="280" r:id="rId26"/>
   </p:sldIdLst>
   <p:notesMasterIdLst>
-    <p:notesMasterId r:id="rId26"/>
+    <p:notesMasterId r:id="rId27"/>
   </p:notesMasterIdLst>
   <p:sldSz cx="9144000" cy="5143500"/>
   <p:notesSz cx="5143500" cy="9144000"/>
@@ -130,7 +131,7 @@
   <p:extLst>
     <p:ext uri="{521415D9-36F7-43E2-AB2F-B90AF26B5E84}">
       <p14:sectionLst xmlns:p14="http://schemas.microsoft.com/office/powerpoint/2010/main">
-        <p14:section name="Tutorial 1: Your first STM32 application" id="{39e3d92f-ca16-4504-146e-94e833e60b46}">
+        <p14:section name="Tutorial 1: Your first STM32 application" id="{21852f4d-8d07-89b6-eb29-170220c8d091}">
           <p14:sldIdLst>
             <p14:sldId id="257"/>
             <p14:sldId id="258"/>
@@ -138,71 +139,72 @@
             <p14:sldId id="260"/>
             <p14:sldId id="261"/>
             <p14:sldId id="262"/>
-          </p14:sldIdLst>
-        </p14:section>
-        <p14:section name="Tutorial 2: Numbers and bits on the board" id="{857b055a-24ea-eefc-534e-5d148bb60cc8}">
-          <p14:sldIdLst>
             <p14:sldId id="263"/>
           </p14:sldIdLst>
         </p14:section>
-        <p14:section name="Tutorial 3: RGB LEDs and buttons" id="{66513637-fe24-2f62-1c42-7ef2ebd06775}">
+        <p14:section name="Tutorial 2: Numbers and bits on the board" id="{81abeccf-daea-5e57-0c8a-f263c913ee52}">
           <p14:sldIdLst>
             <p14:sldId id="264"/>
           </p14:sldIdLst>
         </p14:section>
-        <p14:section name="Tutorial 4: Timer interrupts and state machines" id="{eb4facff-8f81-f6f4-c1aa-38ba2bff3b5f}">
+        <p14:section name="Tutorial 3: RGB LEDs and buttons" id="{6c23e798-5a8c-637a-a5ff-c04b23936a69}">
           <p14:sldIdLst>
             <p14:sldId id="265"/>
+          </p14:sldIdLst>
+        </p14:section>
+        <p14:section name="Tutorial 4: Timer interrupts and state machines" id="{da6a7aea-7eb3-59ac-9d17-ae34229a1c57}">
+          <p14:sldIdLst>
             <p14:sldId id="266"/>
             <p14:sldId id="267"/>
             <p14:sldId id="268"/>
             <p14:sldId id="269"/>
             <p14:sldId id="270"/>
-          </p14:sldIdLst>
-        </p14:section>
-        <p14:section name="Tutorial 5: Inside the I2C bus" id="{854f6696-4beb-f561-80e8-020763c13d15}">
-          <p14:sldIdLst>
             <p14:sldId id="271"/>
           </p14:sldIdLst>
         </p14:section>
-        <p14:section name="Tutorial 6: PWM, input capture and EXTI" id="{f621d223-e472-8f55-bf6f-b2750787baaa}">
+        <p14:section name="Tutorial 5: Inside the I2C bus" id="{8b5bd772-d041-1bc7-1881-0e7c1e314f69}">
           <p14:sldIdLst>
             <p14:sldId id="272"/>
           </p14:sldIdLst>
         </p14:section>
-        <p14:section name="Tutorial 7: One wheel in the air" id="{98c71408-7ec3-a53d-9738-d28625e89e24}">
+        <p14:section name="Tutorial 6: PWM, input capture and EXTI" id="{849e91d2-3af2-ca64-266a-33033f532278}">
           <p14:sldIdLst>
             <p14:sldId id="273"/>
           </p14:sldIdLst>
         </p14:section>
-        <p14:section name="Tutorial 8: From model to PI controller" id="{83820f1d-17be-3785-c338-69621c5de9b8}">
+        <p14:section name="Tutorial 7: One wheel in the air" id="{c24085cd-2cd8-eddc-9058-d02a689da798}">
           <p14:sldIdLst>
             <p14:sldId id="274"/>
           </p14:sldIdLst>
         </p14:section>
-        <p14:section name="Tutorial 9: UART commands and a MATLAB GUI" id="{3b2f7f42-19c3-5015-e279-947931f47a6f}">
+        <p14:section name="Tutorial 8: From model to PI controller" id="{065b6652-cad1-a652-bec0-04c56f9e9267}">
           <p14:sldIdLst>
             <p14:sldId id="275"/>
           </p14:sldIdLst>
         </p14:section>
-        <p14:section name="Tutorial 10: Driving the cart" id="{07fa4217-fd7f-0e70-ddd9-8d8d97e3e143}">
+        <p14:section name="Tutorial 9: UART commands and a MATLAB GUI" id="{63dcb04d-2deb-c2be-8ab0-594d7cfb6e3c}">
           <p14:sldIdLst>
             <p14:sldId id="276"/>
           </p14:sldIdLst>
         </p14:section>
-        <p14:section name="Tutorial 11: Simulink to C" id="{3770a895-344a-6151-4976-bc455699d3ea}">
+        <p14:section name="Tutorial 10: Driving the cart" id="{5d1d97ab-b8a1-beaa-b805-96a8caeb2dcb}">
           <p14:sldIdLst>
             <p14:sldId id="277"/>
           </p14:sldIdLst>
         </p14:section>
-        <p14:section name="Tutorial 12: Project clinic" id="{1ad2cda3-8897-be05-ccfd-aae3e522addd}">
+        <p14:section name="Tutorial 11: Simulink to C" id="{a5c0355f-7040-414c-151b-c4f6be01b350}">
           <p14:sldIdLst>
             <p14:sldId id="278"/>
           </p14:sldIdLst>
         </p14:section>
-        <p14:section name="Session 13" id="{9c009391-3ae8-1054-a2db-3355ffa53171}">
+        <p14:section name="Tutorial 12: Project clinic" id="{4a30cbd3-6d52-1f0c-ca1c-9014489b045d}">
           <p14:sldIdLst>
             <p14:sldId id="279"/>
+          </p14:sldIdLst>
+        </p14:section>
+        <p14:section name="Session 13" id="{8e310e0f-46c6-3f0a-de7b-fe25a9c4335b}">
+          <p14:sldIdLst>
+            <p14:sldId id="280"/>
           </p14:sldIdLst>
         </p14:section>
       </p14:sectionLst>
@@ -2041,6 +2043,94 @@
             <a:fld id="{F7021451-1387-4CA6-816F-3879F97B5CBC}" type="slidenum">
               <a:rPr lang="en-US"/>
               <a:t>24</a:t>
+            </a:fld>
+            <a:endParaRPr lang="en-US"/>
+          </a:p>
+        </p:txBody>
+      </p:sp>
+    </p:spTree>
+    <p:extLst>
+      <p:ext uri="{BB962C8B-B14F-4D97-AF65-F5344CB8AC3E}">
+        <p14:creationId xmlns:p14="http://schemas.microsoft.com/office/powerpoint/2010/main" val="1024086991"/>
+      </p:ext>
+    </p:extLst>
+  </p:cSld>
+  <p:clrMapOvr>
+    <a:masterClrMapping/>
+  </p:clrMapOvr>
+</p:notes>
+</file>
+
+<file path=ppt/notesSlides/notesSlide25.xml><?xml version="1.0" encoding="utf-8"?>
+<p:notes xmlns:a="http://schemas.openxmlformats.org/drawingml/2006/main" xmlns:r="http://schemas.openxmlformats.org/officeDocument/2006/relationships" xmlns:p="http://schemas.openxmlformats.org/presentationml/2006/main">
+  <p:cSld>
+    <p:spTree>
+      <p:nvGrpSpPr>
+        <p:cNvPr id="1" name=""/>
+        <p:cNvGrpSpPr/>
+        <p:nvPr/>
+      </p:nvGrpSpPr>
+      <p:grpSpPr>
+        <a:xfrm>
+          <a:off x="0" y="0"/>
+          <a:ext cx="0" cy="0"/>
+          <a:chOff x="0" y="0"/>
+          <a:chExt cx="0" cy="0"/>
+        </a:xfrm>
+      </p:grpSpPr>
+      <p:sp>
+        <p:nvSpPr>
+          <p:cNvPr id="2" name="Slide Image Placeholder 1"/>
+          <p:cNvSpPr>
+            <a:spLocks noGrp="1" noRot="1" noChangeAspect="1"/>
+          </p:cNvSpPr>
+          <p:nvPr>
+            <p:ph type="sldImg"/>
+          </p:nvPr>
+        </p:nvSpPr>
+        <p:spPr/>
+      </p:sp>
+      <p:sp>
+        <p:nvSpPr>
+          <p:cNvPr id="3" name="Notes Placeholder 2"/>
+          <p:cNvSpPr>
+            <a:spLocks noGrp="1"/>
+          </p:cNvSpPr>
+          <p:nvPr>
+            <p:ph type="body" idx="1"/>
+          </p:nvPr>
+        </p:nvSpPr>
+        <p:spPr/>
+        <p:txBody>
+          <a:bodyPr/>
+          <a:lstStyle/>
+          <a:p>
+            <a:r>
+              <a:rPr lang="en-US" dirty="0"/>
+              <a:t/>
+            </a:r>
+            <a:endParaRPr lang="en-US" dirty="0"/>
+          </a:p>
+        </p:txBody>
+      </p:sp>
+      <p:sp>
+        <p:nvSpPr>
+          <p:cNvPr id="4" name="Slide Number Placeholder 3"/>
+          <p:cNvSpPr>
+            <a:spLocks noGrp="1"/>
+          </p:cNvSpPr>
+          <p:nvPr>
+            <p:ph type="sldNum" sz="quarter" idx="10"/>
+          </p:nvPr>
+        </p:nvSpPr>
+        <p:spPr/>
+        <p:txBody>
+          <a:bodyPr/>
+          <a:lstStyle/>
+          <a:p>
+            <a:fld id="{F7021451-1387-4CA6-816F-3879F97B5CBC}" type="slidenum">
+              <a:rPr lang="en-US"/>
+              <a:t>25</a:t>
             </a:fld>
             <a:endParaRPr lang="en-US"/>
           </a:p>
@@ -3600,7 +3690,7 @@
                   <a:schemeClr val="bg2"/>
                 </a:solidFill>
               </a:rPr>
-              <a:t>TUTORIAL 4  ·  23.11.2026</a:t>
+              <a:t>TUTORIAL 3  ·  16.11.2026</a:t>
             </a:r>
             <a:endParaRPr lang="en-US" sz="1600" dirty="0"/>
           </a:p>
@@ -3638,7 +3728,7 @@
                   <a:schemeClr val="bg1"/>
                 </a:solidFill>
               </a:rPr>
-              <a:t>Timer interrupts and state machines</a:t>
+              <a:t>RGB LEDs and buttons</a:t>
             </a:r>
             <a:endParaRPr lang="en-US" sz="3600" dirty="0"/>
           </a:p>
@@ -3676,7 +3766,7 @@
                   <a:schemeClr val="bg1"/>
                 </a:solidFill>
               </a:rPr>
-              <a:t>Multi-rate blinking from a timer interrupt (no HAL_Delay); a state-machine skeleton with enum and switch.</a:t>
+              <a:t>A set_rgb helper; a walking dot with masks; saturating brightness up and down; one press = one action.</a:t>
             </a:r>
             <a:endParaRPr lang="en-US" sz="1600" dirty="0"/>
           </a:p>
@@ -3757,13 +3847,13 @@
           <p:cNvPr id="2" name="Text 0"/>
           <p:cNvSpPr/>
           <p:nvPr>
-            <p:ph idx="100" type="title" hasCustomPrompt="1"/>
+            <p:ph idx="100" type="body" hasCustomPrompt="1"/>
           </p:nvPr>
         </p:nvSpPr>
         <p:spPr>
           <a:xfrm>
-            <a:off x="457200" y="274320"/>
-            <a:ext cx="8229600" cy="640080"/>
+            <a:off x="548640" y="914400"/>
+            <a:ext cx="8046720" cy="457200"/>
           </a:xfrm>
           <a:prstGeom prst="rect">
             <a:avLst/>
@@ -3772,61 +3862,36 @@
           <a:ln/>
         </p:spPr>
         <p:txBody>
-          <a:bodyPr wrap="square" rtlCol="0" anchor="ctr"/>
+          <a:bodyPr wrap="square" rtlCol="0"/>
           <a:lstStyle/>
           <a:p>
             <a:pPr algn="l" indent="0" marL="0">
               <a:buNone/>
             </a:pPr>
             <a:r>
-              <a:rPr lang="en-US" sz="2600" b="1" dirty="0">
-                <a:solidFill>
-                  <a:schemeClr val="tx2"/>
-                </a:solidFill>
-              </a:rPr>
-              <a:t>Why some outputs are fast and others slow</a:t>
-            </a:r>
-            <a:endParaRPr lang="en-US" sz="2600" dirty="0"/>
-          </a:p>
-        </p:txBody>
-      </p:sp>
-      <p:sp>
-        <p:nvSpPr>
-          <p:cNvPr id="3" name="speed card 1"/>
+              <a:rPr lang="en-US" sz="1600" b="1" dirty="0">
+                <a:solidFill>
+                  <a:schemeClr val="bg2"/>
+                </a:solidFill>
+              </a:rPr>
+              <a:t>TUTORIAL 4  ·  23.11.2026</a:t>
+            </a:r>
+            <a:endParaRPr lang="en-US" sz="1600" dirty="0"/>
+          </a:p>
+        </p:txBody>
+      </p:sp>
+      <p:sp>
+        <p:nvSpPr>
+          <p:cNvPr id="3" name="Text 0"/>
           <p:cNvSpPr/>
-          <p:nvPr/>
+          <p:nvPr>
+            <p:ph idx="101" type="title" hasCustomPrompt="1"/>
+          </p:nvPr>
         </p:nvSpPr>
         <p:spPr>
           <a:xfrm>
-            <a:off x="457200" y="1097280"/>
-            <a:ext cx="3977640" cy="2606040"/>
-          </a:xfrm>
-          <a:prstGeom prst="roundRect">
-            <a:avLst>
-              <a:gd name="adj" fmla="val 3509"/>
-            </a:avLst>
-          </a:prstGeom>
-          <a:solidFill>
-            <a:srgbClr val="EEF3EF"/>
-          </a:solidFill>
-          <a:ln w="12700">
-            <a:solidFill>
-              <a:srgbClr val="EEF3EF"/>
-            </a:solidFill>
-            <a:prstDash val="solid"/>
-          </a:ln>
-        </p:spPr>
-      </p:sp>
-      <p:sp>
-        <p:nvSpPr>
-          <p:cNvPr id="4" name="speed card 1 head"/>
-          <p:cNvSpPr txBox="1"/>
-          <p:nvPr/>
-        </p:nvSpPr>
-        <p:spPr>
-          <a:xfrm>
-            <a:off x="685800" y="1234440"/>
-            <a:ext cx="3520440" cy="411480"/>
+            <a:off x="548640" y="1371600"/>
+            <a:ext cx="8046720" cy="1097280"/>
           </a:xfrm>
           <a:prstGeom prst="rect">
             <a:avLst/>
@@ -3835,34 +3900,36 @@
           <a:ln/>
         </p:spPr>
         <p:txBody>
-          <a:bodyPr wrap="square" lIns="0" tIns="0" rIns="0" bIns="0" rtlCol="0" anchor="ctr"/>
+          <a:bodyPr wrap="square" rtlCol="0" anchor="t"/>
           <a:lstStyle/>
           <a:p>
-            <a:pPr indent="0" marL="0">
+            <a:pPr algn="l" indent="0" marL="0">
               <a:buNone/>
             </a:pPr>
             <a:r>
-              <a:rPr lang="en-US" sz="1600" b="1" dirty="0">
-                <a:solidFill>
-                  <a:srgbClr val="123524"/>
-                </a:solidFill>
-              </a:rPr>
-              <a:t>Wheel PWM: TIM2-&gt;CCR1 = value;</a:t>
-            </a:r>
-            <a:endParaRPr lang="en-US" sz="1600" dirty="0"/>
-          </a:p>
-        </p:txBody>
-      </p:sp>
-      <p:sp>
-        <p:nvSpPr>
-          <p:cNvPr id="5" name="speed card 1 stat"/>
-          <p:cNvSpPr txBox="1"/>
-          <p:nvPr/>
+              <a:rPr lang="en-US" sz="3600" b="1" dirty="0">
+                <a:solidFill>
+                  <a:schemeClr val="bg1"/>
+                </a:solidFill>
+              </a:rPr>
+              <a:t>Timer interrupts and state machines</a:t>
+            </a:r>
+            <a:endParaRPr lang="en-US" sz="3600" dirty="0"/>
+          </a:p>
+        </p:txBody>
+      </p:sp>
+      <p:sp>
+        <p:nvSpPr>
+          <p:cNvPr id="4" name="Text 0"/>
+          <p:cNvSpPr/>
+          <p:nvPr>
+            <p:ph idx="102" type="body" hasCustomPrompt="1"/>
+          </p:nvPr>
         </p:nvSpPr>
         <p:spPr>
           <a:xfrm>
-            <a:off x="685800" y="1691640"/>
-            <a:ext cx="3520440" cy="777240"/>
+            <a:off x="548640" y="2743200"/>
+            <a:ext cx="8046720" cy="1737360"/>
           </a:xfrm>
           <a:prstGeom prst="rect">
             <a:avLst/>
@@ -3871,214 +3938,21 @@
           <a:ln/>
         </p:spPr>
         <p:txBody>
-          <a:bodyPr wrap="square" lIns="0" tIns="0" rIns="0" bIns="0" rtlCol="0" anchor="ctr"/>
+          <a:bodyPr wrap="square" rtlCol="0" anchor="t"/>
           <a:lstStyle/>
           <a:p>
-            <a:pPr indent="0" marL="0">
+            <a:pPr algn="l" indent="0" marL="0">
               <a:buNone/>
             </a:pPr>
             <a:r>
-              <a:rPr lang="en-US" sz="4400" b="1" dirty="0">
-                <a:solidFill>
-                  <a:srgbClr val="1F6E43"/>
-                </a:solidFill>
-              </a:rPr>
-              <a:t>~20</a:t>
-            </a:r>
-            <a:pPr indent="0" marL="0">
-              <a:buNone/>
-            </a:pPr>
-            <a:r>
-              <a:rPr lang="en-US" sz="1800" dirty="0">
-                <a:solidFill>
-                  <a:srgbClr val="1F6E43"/>
-                </a:solidFill>
-              </a:rPr>
-              <a:t>  ns</a:t>
-            </a:r>
-            <a:endParaRPr lang="en-US" sz="4400" dirty="0"/>
-          </a:p>
-        </p:txBody>
-      </p:sp>
-      <p:sp>
-        <p:nvSpPr>
-          <p:cNvPr id="6" name="speed card 1 body"/>
-          <p:cNvSpPr txBox="1"/>
-          <p:nvPr/>
-        </p:nvSpPr>
-        <p:spPr>
-          <a:xfrm>
-            <a:off x="685800" y="2560320"/>
-            <a:ext cx="3520440" cy="1645920"/>
-          </a:xfrm>
-          <a:prstGeom prst="rect">
-            <a:avLst/>
-          </a:prstGeom>
-          <a:noFill/>
-          <a:ln/>
-        </p:spPr>
-        <p:txBody>
-          <a:bodyPr wrap="square" lIns="0" tIns="0" rIns="0" bIns="0" rtlCol="0" anchor="t"/>
-          <a:lstStyle/>
-          <a:p>
-            <a:pPr indent="0" marL="0">
-              <a:buNone/>
-            </a:pPr>
-            <a:r>
-              <a:rPr lang="en-US" sz="1300" dirty="0">
-                <a:solidFill>
-                  <a:srgbClr val="1C1C1C"/>
-                </a:solidFill>
-              </a:rPr>
-              <a:t>The register is inside the STM32. It has a memory address, so one store instruction over the internal bus writes it: a few clock cycles at 170 MHz (1 cycle = 5.9 ns). TIM2 then makes the PWM by itself.</a:t>
-            </a:r>
-            <a:endParaRPr lang="en-US" sz="1300" dirty="0"/>
-          </a:p>
-        </p:txBody>
-      </p:sp>
-      <p:sp>
-        <p:nvSpPr>
-          <p:cNvPr id="7" name="speed card 2"/>
-          <p:cNvSpPr/>
-          <p:nvPr/>
-        </p:nvSpPr>
-        <p:spPr>
-          <a:xfrm>
-            <a:off x="4709160" y="1097280"/>
-            <a:ext cx="3977640" cy="2606040"/>
-          </a:xfrm>
-          <a:prstGeom prst="roundRect">
-            <a:avLst>
-              <a:gd name="adj" fmla="val 3509"/>
-            </a:avLst>
-          </a:prstGeom>
-          <a:solidFill>
-            <a:srgbClr val="EEF3EF"/>
-          </a:solidFill>
-          <a:ln w="12700">
-            <a:solidFill>
-              <a:srgbClr val="EEF3EF"/>
-            </a:solidFill>
-            <a:prstDash val="solid"/>
-          </a:ln>
-        </p:spPr>
-      </p:sp>
-      <p:sp>
-        <p:nvSpPr>
-          <p:cNvPr id="8" name="speed card 2 head"/>
-          <p:cNvSpPr txBox="1"/>
-          <p:nvPr/>
-        </p:nvSpPr>
-        <p:spPr>
-          <a:xfrm>
-            <a:off x="4937760" y="1234440"/>
-            <a:ext cx="3520440" cy="411480"/>
-          </a:xfrm>
-          <a:prstGeom prst="rect">
-            <a:avLst/>
-          </a:prstGeom>
-          <a:noFill/>
-          <a:ln/>
-        </p:spPr>
-        <p:txBody>
-          <a:bodyPr wrap="square" lIns="0" tIns="0" rIns="0" bIns="0" rtlCol="0" anchor="ctr"/>
-          <a:lstStyle/>
-          <a:p>
-            <a:pPr indent="0" marL="0">
-              <a:buNone/>
-            </a:pPr>
-            <a:r>
-              <a:rPr lang="en-US" sz="1600" b="1" dirty="0">
-                <a:solidFill>
-                  <a:srgbClr val="123524"/>
-                </a:solidFill>
-              </a:rPr>
-              <a:t>LED brightness: HAL_I2C_Mem_Write</a:t>
+              <a:rPr lang="en-US" sz="1600" dirty="0">
+                <a:solidFill>
+                  <a:schemeClr val="bg1"/>
+                </a:solidFill>
+              </a:rPr>
+              <a:t>Multi-rate blinking from a timer interrupt (no HAL_Delay); a state-machine skeleton with enum and switch.</a:t>
             </a:r>
             <a:endParaRPr lang="en-US" sz="1600" dirty="0"/>
-          </a:p>
-        </p:txBody>
-      </p:sp>
-      <p:sp>
-        <p:nvSpPr>
-          <p:cNvPr id="9" name="speed card 2 stat"/>
-          <p:cNvSpPr txBox="1"/>
-          <p:nvPr/>
-        </p:nvSpPr>
-        <p:spPr>
-          <a:xfrm>
-            <a:off x="4937760" y="1691640"/>
-            <a:ext cx="3520440" cy="777240"/>
-          </a:xfrm>
-          <a:prstGeom prst="rect">
-            <a:avLst/>
-          </a:prstGeom>
-          <a:noFill/>
-          <a:ln/>
-        </p:spPr>
-        <p:txBody>
-          <a:bodyPr wrap="square" lIns="0" tIns="0" rIns="0" bIns="0" rtlCol="0" anchor="ctr"/>
-          <a:lstStyle/>
-          <a:p>
-            <a:pPr indent="0" marL="0">
-              <a:buNone/>
-            </a:pPr>
-            <a:r>
-              <a:rPr lang="en-US" sz="4400" b="1" dirty="0">
-                <a:solidFill>
-                  <a:srgbClr val="B23A48"/>
-                </a:solidFill>
-              </a:rPr>
-              <a:t>~0.3</a:t>
-            </a:r>
-            <a:pPr indent="0" marL="0">
-              <a:buNone/>
-            </a:pPr>
-            <a:r>
-              <a:rPr lang="en-US" sz="1800" dirty="0">
-                <a:solidFill>
-                  <a:srgbClr val="B23A48"/>
-                </a:solidFill>
-              </a:rPr>
-              <a:t>  ms</a:t>
-            </a:r>
-            <a:endParaRPr lang="en-US" sz="4400" dirty="0"/>
-          </a:p>
-        </p:txBody>
-      </p:sp>
-      <p:sp>
-        <p:nvSpPr>
-          <p:cNvPr id="10" name="speed card 2 body"/>
-          <p:cNvSpPr txBox="1"/>
-          <p:nvPr/>
-        </p:nvSpPr>
-        <p:spPr>
-          <a:xfrm>
-            <a:off x="4937760" y="2560320"/>
-            <a:ext cx="3520440" cy="1645920"/>
-          </a:xfrm>
-          <a:prstGeom prst="rect">
-            <a:avLst/>
-          </a:prstGeom>
-          <a:noFill/>
-          <a:ln/>
-        </p:spPr>
-        <p:txBody>
-          <a:bodyPr wrap="square" lIns="0" tIns="0" rIns="0" bIns="0" rtlCol="0" anchor="t"/>
-          <a:lstStyle/>
-          <a:p>
-            <a:pPr indent="0" marL="0">
-              <a:buNone/>
-            </a:pPr>
-            <a:r>
-              <a:rPr lang="en-US" sz="1300" dirty="0">
-                <a:solidFill>
-                  <a:srgbClr val="1C1C1C"/>
-                </a:solidFill>
-              </a:rPr>
-              <a:t>The register is inside the PCA9634, another chip. The only way in is the I2C bus at 100 kHz: 10 µs per bit. Address + register + data, each with an ACK, is about 29 bits. The CPU waits all that time.</a:t>
-            </a:r>
-            <a:endParaRPr lang="en-US" sz="1300" dirty="0"/>
           </a:p>
         </p:txBody>
       </p:sp>
@@ -4112,7 +3986,7 @@
             <a:lvl1pPr>
               <a:defRPr sz="1000">
                 <a:solidFill>
-                  <a:schemeClr val="tx2"/>
+                  <a:schemeClr val="bg2"/>
                 </a:solidFill>
               </a:defRPr>
             </a:lvl1pPr>
@@ -4184,7 +4058,7 @@
                   <a:schemeClr val="tx2"/>
                 </a:solidFill>
               </a:rPr>
-              <a:t>Blocking: updating all 24 LED registers at once</a:t>
+              <a:t>Why some outputs are fast and others slow</a:t>
             </a:r>
             <a:endParaRPr lang="en-US" sz="2600" dirty="0"/>
           </a:p>
@@ -4192,26 +4066,26 @@
       </p:sp>
       <p:sp>
         <p:nvSpPr>
-          <p:cNvPr id="3" name="blocking box"/>
+          <p:cNvPr id="3" name="speed card 1"/>
           <p:cNvSpPr/>
           <p:nvPr/>
         </p:nvSpPr>
         <p:spPr>
           <a:xfrm>
             <a:off x="457200" y="1097280"/>
-            <a:ext cx="4114800" cy="1508760"/>
+            <a:ext cx="3977640" cy="2606040"/>
           </a:xfrm>
           <a:prstGeom prst="roundRect">
             <a:avLst>
-              <a:gd name="adj" fmla="val 4848"/>
+              <a:gd name="adj" fmla="val 3509"/>
             </a:avLst>
           </a:prstGeom>
           <a:solidFill>
-            <a:srgbClr val="F4F6F4"/>
+            <a:srgbClr val="EEF3EF"/>
           </a:solidFill>
-          <a:ln w="9525">
+          <a:ln w="12700">
             <a:solidFill>
-              <a:srgbClr val="D5DDD6"/>
+              <a:srgbClr val="EEF3EF"/>
             </a:solidFill>
             <a:prstDash val="solid"/>
           </a:ln>
@@ -4219,14 +4093,14 @@
       </p:sp>
       <p:sp>
         <p:nvSpPr>
-          <p:cNvPr id="4" name="blocking code"/>
+          <p:cNvPr id="4" name="speed card 1 head"/>
           <p:cNvSpPr txBox="1"/>
           <p:nvPr/>
         </p:nvSpPr>
         <p:spPr>
           <a:xfrm>
-            <a:off x="594360" y="1188720"/>
-            <a:ext cx="3840480" cy="1325880"/>
+            <a:off x="685800" y="1234440"/>
+            <a:ext cx="3520440" cy="411480"/>
           </a:xfrm>
           <a:prstGeom prst="rect">
             <a:avLst/>
@@ -4235,122 +4109,34 @@
           <a:ln/>
         </p:spPr>
         <p:txBody>
-          <a:bodyPr wrap="square" lIns="0" tIns="0" rIns="0" bIns="0" rtlCol="0" anchor="t"/>
+          <a:bodyPr wrap="square" lIns="0" tIns="0" rIns="0" bIns="0" rtlCol="0" anchor="ctr"/>
           <a:lstStyle/>
           <a:p>
             <a:pPr indent="0" marL="0">
               <a:buNone/>
             </a:pPr>
             <a:r>
-              <a:rPr lang="en-US" sz="1100" dirty="0">
-                <a:solidFill>
-                  <a:srgbClr val="5C5C5C"/>
-                </a:solidFill>
-                <a:latin typeface="Courier New" pitchFamily="34" charset="0"/>
-                <a:ea typeface="Courier New" pitchFamily="34" charset="-122"/>
-                <a:cs typeface="Courier New" pitchFamily="34" charset="-120"/>
-              </a:rPr>
-              <a:t>for (ch = 0; ch &lt; 8; ch++) {</a:t>
-            </a:r>
-            <a:endParaRPr lang="en-US" sz="1100" dirty="0"/>
-          </a:p>
-          <a:p>
-            <a:pPr indent="0" marL="0">
-              <a:buNone/>
-            </a:pPr>
-            <a:r>
-              <a:rPr lang="en-US" sz="1100" dirty="0">
-                <a:solidFill>
-                  <a:srgbClr val="B23A48"/>
-                </a:solidFill>
-                <a:latin typeface="Courier New" pitchFamily="34" charset="0"/>
-                <a:ea typeface="Courier New" pitchFamily="34" charset="-122"/>
-                <a:cs typeface="Courier New" pitchFamily="34" charset="-120"/>
-              </a:rPr>
-              <a:t>  setLedChannel(RED,   ch, r);  // 0.3 ms</a:t>
-            </a:r>
-            <a:endParaRPr lang="en-US" sz="1100" dirty="0"/>
-          </a:p>
-          <a:p>
-            <a:pPr indent="0" marL="0">
-              <a:buNone/>
-            </a:pPr>
-            <a:r>
-              <a:rPr lang="en-US" sz="1100" dirty="0">
-                <a:solidFill>
-                  <a:srgbClr val="B23A48"/>
-                </a:solidFill>
-                <a:latin typeface="Courier New" pitchFamily="34" charset="0"/>
-                <a:ea typeface="Courier New" pitchFamily="34" charset="-122"/>
-                <a:cs typeface="Courier New" pitchFamily="34" charset="-120"/>
-              </a:rPr>
-              <a:t>  setLedChannel(GREEN, ch, g);  // 0.3 ms</a:t>
-            </a:r>
-            <a:endParaRPr lang="en-US" sz="1100" dirty="0"/>
-          </a:p>
-          <a:p>
-            <a:pPr indent="0" marL="0">
-              <a:buNone/>
-            </a:pPr>
-            <a:r>
-              <a:rPr lang="en-US" sz="1100" dirty="0">
-                <a:solidFill>
-                  <a:srgbClr val="B23A48"/>
-                </a:solidFill>
-                <a:latin typeface="Courier New" pitchFamily="34" charset="0"/>
-                <a:ea typeface="Courier New" pitchFamily="34" charset="-122"/>
-                <a:cs typeface="Courier New" pitchFamily="34" charset="-120"/>
-              </a:rPr>
-              <a:t>  setLedChannel(BLUE,  ch, b);  // 0.3 ms</a:t>
-            </a:r>
-            <a:endParaRPr lang="en-US" sz="1100" dirty="0"/>
-          </a:p>
-          <a:p>
-            <a:pPr indent="0" marL="0">
-              <a:buNone/>
-            </a:pPr>
-            <a:r>
-              <a:rPr lang="en-US" sz="1100" dirty="0">
-                <a:solidFill>
-                  <a:srgbClr val="5C5C5C"/>
-                </a:solidFill>
-                <a:latin typeface="Courier New" pitchFamily="34" charset="0"/>
-                <a:ea typeface="Courier New" pitchFamily="34" charset="-122"/>
-                <a:cs typeface="Courier New" pitchFamily="34" charset="-120"/>
-              </a:rPr>
-              <a:t>}</a:t>
-            </a:r>
-            <a:endParaRPr lang="en-US" sz="1100" dirty="0"/>
-          </a:p>
-          <a:p>
-            <a:pPr indent="0" marL="0">
-              <a:buNone/>
-            </a:pPr>
-            <a:r>
-              <a:rPr lang="en-US" sz="1100" b="1" dirty="0">
-                <a:solidFill>
-                  <a:srgbClr val="B23A48"/>
-                </a:solidFill>
-                <a:latin typeface="Courier New" pitchFamily="34" charset="0"/>
-                <a:ea typeface="Courier New" pitchFamily="34" charset="-122"/>
-                <a:cs typeface="Courier New" pitchFamily="34" charset="-120"/>
-              </a:rPr>
-              <a:t>// about 7 to 9 ms with the loop stuck here</a:t>
-            </a:r>
-            <a:endParaRPr lang="en-US" sz="1100" dirty="0"/>
-          </a:p>
-        </p:txBody>
-      </p:sp>
-      <p:sp>
-        <p:nvSpPr>
-          <p:cNvPr id="5" name="blocking bullets"/>
+              <a:rPr lang="en-US" sz="1600" b="1" dirty="0">
+                <a:solidFill>
+                  <a:srgbClr val="123524"/>
+                </a:solidFill>
+              </a:rPr>
+              <a:t>Wheel PWM: TIM2-&gt;CCR1 = value;</a:t>
+            </a:r>
+            <a:endParaRPr lang="en-US" sz="1600" dirty="0"/>
+          </a:p>
+        </p:txBody>
+      </p:sp>
+      <p:sp>
+        <p:nvSpPr>
+          <p:cNvPr id="5" name="speed card 1 stat"/>
           <p:cNvSpPr txBox="1"/>
           <p:nvPr/>
         </p:nvSpPr>
         <p:spPr>
           <a:xfrm>
-            <a:off x="4846320" y="1097280"/>
-            <a:ext cx="3840480" cy="3291840"/>
+            <a:off x="685800" y="1691640"/>
+            <a:ext cx="3520440" cy="777240"/>
           </a:xfrm>
           <a:prstGeom prst="rect">
             <a:avLst/>
@@ -4359,96 +4145,214 @@
           <a:ln/>
         </p:spPr>
         <p:txBody>
-          <a:bodyPr wrap="square" rtlCol="0" anchor="t"/>
+          <a:bodyPr wrap="square" lIns="0" tIns="0" rIns="0" bIns="0" rtlCol="0" anchor="ctr"/>
           <a:lstStyle/>
           <a:p>
             <a:pPr indent="0" marL="0">
-              <a:spcAft>
-                <a:spcPts val="800"/>
-              </a:spcAft>
               <a:buNone/>
             </a:pPr>
             <a:r>
-              <a:rPr lang="en-US" sz="1500" b="1" dirty="0">
-                <a:solidFill>
-                  <a:srgbClr val="000000"/>
-                </a:solidFill>
-              </a:rPr>
-              <a:t>While stuck, the main loop cannot:</a:t>
-            </a:r>
-            <a:endParaRPr lang="en-US" sz="1500" dirty="0"/>
-          </a:p>
-          <a:p>
-            <a:pPr marL="342900" indent="-342900">
-              <a:spcAft>
-                <a:spcPts val="800"/>
-              </a:spcAft>
-              <a:buSzPct val="100000"/>
-              <a:buChar char="•"/>
-            </a:pPr>
-            <a:r>
-              <a:rPr lang="en-US" sz="1500" dirty="0">
-                <a:solidFill>
-                  <a:srgbClr val="000000"/>
-                </a:solidFill>
-              </a:rPr>
-              <a:t>see a new command or state</a:t>
-            </a:r>
-            <a:endParaRPr lang="en-US" sz="1500" dirty="0"/>
-          </a:p>
-          <a:p>
-            <a:pPr marL="342900" indent="-342900">
-              <a:spcAft>
-                <a:spcPts val="800"/>
-              </a:spcAft>
-              <a:buSzPct val="100000"/>
-              <a:buChar char="•"/>
-            </a:pPr>
-            <a:r>
-              <a:rPr lang="en-US" sz="1500" dirty="0">
-                <a:solidFill>
-                  <a:srgbClr val="000000"/>
-                </a:solidFill>
-              </a:rPr>
-              <a:t>poll the IR obstacle sensor (an emergency stop!)</a:t>
-            </a:r>
-            <a:endParaRPr lang="en-US" sz="1500" dirty="0"/>
-          </a:p>
-          <a:p>
-            <a:pPr marL="342900" indent="-342900">
-              <a:spcAft>
-                <a:spcPts val="800"/>
-              </a:spcAft>
-              <a:buSzPct val="100000"/>
-              <a:buChar char="•"/>
-            </a:pPr>
-            <a:r>
-              <a:rPr lang="en-US" sz="1500" dirty="0">
-                <a:solidFill>
-                  <a:srgbClr val="000000"/>
-                </a:solidFill>
-              </a:rPr>
-              <a:t>run the state's work or print status</a:t>
-            </a:r>
-            <a:endParaRPr lang="en-US" sz="1500" dirty="0"/>
-          </a:p>
-          <a:p>
-            <a:pPr marL="342900" indent="-342900">
-              <a:spcAft>
-                <a:spcPts val="800"/>
-              </a:spcAft>
-              <a:buSzPct val="100000"/>
-              <a:buChar char="•"/>
-            </a:pPr>
-            <a:r>
-              <a:rPr lang="en-US" sz="1500" dirty="0">
+              <a:rPr lang="en-US" sz="4400" b="1" dirty="0">
                 <a:solidFill>
                   <a:srgbClr val="1F6E43"/>
                 </a:solidFill>
               </a:rPr>
-              <a:t>Interrupts still run: TIM2 keeps the PWM going and TIM5 still captures the ultrasonic echo.</a:t>
-            </a:r>
-            <a:endParaRPr lang="en-US" sz="1500" dirty="0"/>
+              <a:t>~20</a:t>
+            </a:r>
+            <a:pPr indent="0" marL="0">
+              <a:buNone/>
+            </a:pPr>
+            <a:r>
+              <a:rPr lang="en-US" sz="1800" dirty="0">
+                <a:solidFill>
+                  <a:srgbClr val="1F6E43"/>
+                </a:solidFill>
+              </a:rPr>
+              <a:t>  ns</a:t>
+            </a:r>
+            <a:endParaRPr lang="en-US" sz="4400" dirty="0"/>
+          </a:p>
+        </p:txBody>
+      </p:sp>
+      <p:sp>
+        <p:nvSpPr>
+          <p:cNvPr id="6" name="speed card 1 body"/>
+          <p:cNvSpPr txBox="1"/>
+          <p:nvPr/>
+        </p:nvSpPr>
+        <p:spPr>
+          <a:xfrm>
+            <a:off x="685800" y="2560320"/>
+            <a:ext cx="3520440" cy="1645920"/>
+          </a:xfrm>
+          <a:prstGeom prst="rect">
+            <a:avLst/>
+          </a:prstGeom>
+          <a:noFill/>
+          <a:ln/>
+        </p:spPr>
+        <p:txBody>
+          <a:bodyPr wrap="square" lIns="0" tIns="0" rIns="0" bIns="0" rtlCol="0" anchor="t"/>
+          <a:lstStyle/>
+          <a:p>
+            <a:pPr indent="0" marL="0">
+              <a:buNone/>
+            </a:pPr>
+            <a:r>
+              <a:rPr lang="en-US" sz="1300" dirty="0">
+                <a:solidFill>
+                  <a:srgbClr val="1C1C1C"/>
+                </a:solidFill>
+              </a:rPr>
+              <a:t>The register is inside the STM32. It has a memory address, so one store instruction over the internal bus writes it: a few clock cycles at 170 MHz (1 cycle = 5.9 ns). TIM2 then makes the PWM by itself.</a:t>
+            </a:r>
+            <a:endParaRPr lang="en-US" sz="1300" dirty="0"/>
+          </a:p>
+        </p:txBody>
+      </p:sp>
+      <p:sp>
+        <p:nvSpPr>
+          <p:cNvPr id="7" name="speed card 2"/>
+          <p:cNvSpPr/>
+          <p:nvPr/>
+        </p:nvSpPr>
+        <p:spPr>
+          <a:xfrm>
+            <a:off x="4709160" y="1097280"/>
+            <a:ext cx="3977640" cy="2606040"/>
+          </a:xfrm>
+          <a:prstGeom prst="roundRect">
+            <a:avLst>
+              <a:gd name="adj" fmla="val 3509"/>
+            </a:avLst>
+          </a:prstGeom>
+          <a:solidFill>
+            <a:srgbClr val="EEF3EF"/>
+          </a:solidFill>
+          <a:ln w="12700">
+            <a:solidFill>
+              <a:srgbClr val="EEF3EF"/>
+            </a:solidFill>
+            <a:prstDash val="solid"/>
+          </a:ln>
+        </p:spPr>
+      </p:sp>
+      <p:sp>
+        <p:nvSpPr>
+          <p:cNvPr id="8" name="speed card 2 head"/>
+          <p:cNvSpPr txBox="1"/>
+          <p:nvPr/>
+        </p:nvSpPr>
+        <p:spPr>
+          <a:xfrm>
+            <a:off x="4937760" y="1234440"/>
+            <a:ext cx="3520440" cy="411480"/>
+          </a:xfrm>
+          <a:prstGeom prst="rect">
+            <a:avLst/>
+          </a:prstGeom>
+          <a:noFill/>
+          <a:ln/>
+        </p:spPr>
+        <p:txBody>
+          <a:bodyPr wrap="square" lIns="0" tIns="0" rIns="0" bIns="0" rtlCol="0" anchor="ctr"/>
+          <a:lstStyle/>
+          <a:p>
+            <a:pPr indent="0" marL="0">
+              <a:buNone/>
+            </a:pPr>
+            <a:r>
+              <a:rPr lang="en-US" sz="1600" b="1" dirty="0">
+                <a:solidFill>
+                  <a:srgbClr val="123524"/>
+                </a:solidFill>
+              </a:rPr>
+              <a:t>LED brightness: HAL_I2C_Mem_Write</a:t>
+            </a:r>
+            <a:endParaRPr lang="en-US" sz="1600" dirty="0"/>
+          </a:p>
+        </p:txBody>
+      </p:sp>
+      <p:sp>
+        <p:nvSpPr>
+          <p:cNvPr id="9" name="speed card 2 stat"/>
+          <p:cNvSpPr txBox="1"/>
+          <p:nvPr/>
+        </p:nvSpPr>
+        <p:spPr>
+          <a:xfrm>
+            <a:off x="4937760" y="1691640"/>
+            <a:ext cx="3520440" cy="777240"/>
+          </a:xfrm>
+          <a:prstGeom prst="rect">
+            <a:avLst/>
+          </a:prstGeom>
+          <a:noFill/>
+          <a:ln/>
+        </p:spPr>
+        <p:txBody>
+          <a:bodyPr wrap="square" lIns="0" tIns="0" rIns="0" bIns="0" rtlCol="0" anchor="ctr"/>
+          <a:lstStyle/>
+          <a:p>
+            <a:pPr indent="0" marL="0">
+              <a:buNone/>
+            </a:pPr>
+            <a:r>
+              <a:rPr lang="en-US" sz="4400" b="1" dirty="0">
+                <a:solidFill>
+                  <a:srgbClr val="B23A48"/>
+                </a:solidFill>
+              </a:rPr>
+              <a:t>~0.3</a:t>
+            </a:r>
+            <a:pPr indent="0" marL="0">
+              <a:buNone/>
+            </a:pPr>
+            <a:r>
+              <a:rPr lang="en-US" sz="1800" dirty="0">
+                <a:solidFill>
+                  <a:srgbClr val="B23A48"/>
+                </a:solidFill>
+              </a:rPr>
+              <a:t>  ms</a:t>
+            </a:r>
+            <a:endParaRPr lang="en-US" sz="4400" dirty="0"/>
+          </a:p>
+        </p:txBody>
+      </p:sp>
+      <p:sp>
+        <p:nvSpPr>
+          <p:cNvPr id="10" name="speed card 2 body"/>
+          <p:cNvSpPr txBox="1"/>
+          <p:nvPr/>
+        </p:nvSpPr>
+        <p:spPr>
+          <a:xfrm>
+            <a:off x="4937760" y="2560320"/>
+            <a:ext cx="3520440" cy="1645920"/>
+          </a:xfrm>
+          <a:prstGeom prst="rect">
+            <a:avLst/>
+          </a:prstGeom>
+          <a:noFill/>
+          <a:ln/>
+        </p:spPr>
+        <p:txBody>
+          <a:bodyPr wrap="square" lIns="0" tIns="0" rIns="0" bIns="0" rtlCol="0" anchor="t"/>
+          <a:lstStyle/>
+          <a:p>
+            <a:pPr indent="0" marL="0">
+              <a:buNone/>
+            </a:pPr>
+            <a:r>
+              <a:rPr lang="en-US" sz="1300" dirty="0">
+                <a:solidFill>
+                  <a:srgbClr val="1C1C1C"/>
+                </a:solidFill>
+              </a:rPr>
+              <a:t>The register is inside the PCA9634, another chip. The only way in is the I2C bus at 100 kHz: 10 µs per bit. Address + register + data, each with an ACK, is about 29 bits. The CPU waits all that time.</a:t>
+            </a:r>
+            <a:endParaRPr lang="en-US" sz="1300" dirty="0"/>
           </a:p>
         </p:txBody>
       </p:sp>
@@ -4554,7 +4458,7 @@
                   <a:schemeClr val="tx2"/>
                 </a:solidFill>
               </a:rPr>
-              <a:t>Non-blocking: one register per loop pass</a:t>
+              <a:t>Blocking: updating all 24 LED registers at once</a:t>
             </a:r>
             <a:endParaRPr lang="en-US" sz="2600" dirty="0"/>
           </a:p>
@@ -4562,18 +4466,18 @@
       </p:sp>
       <p:sp>
         <p:nvSpPr>
-          <p:cNvPr id="3" name="service box"/>
+          <p:cNvPr id="3" name="blocking box"/>
           <p:cNvSpPr/>
           <p:nvPr/>
         </p:nvSpPr>
         <p:spPr>
           <a:xfrm>
             <a:off x="457200" y="1097280"/>
-            <a:ext cx="4572000" cy="1828800"/>
+            <a:ext cx="4114800" cy="1508760"/>
           </a:xfrm>
           <a:prstGeom prst="roundRect">
             <a:avLst>
-              <a:gd name="adj" fmla="val 4000"/>
+              <a:gd name="adj" fmla="val 4848"/>
             </a:avLst>
           </a:prstGeom>
           <a:solidFill>
@@ -4589,14 +4493,14 @@
       </p:sp>
       <p:sp>
         <p:nvSpPr>
-          <p:cNvPr id="4" name="service code"/>
+          <p:cNvPr id="4" name="blocking code"/>
           <p:cNvSpPr txBox="1"/>
           <p:nvPr/>
         </p:nvSpPr>
         <p:spPr>
           <a:xfrm>
             <a:off x="594360" y="1188720"/>
-            <a:ext cx="4297680" cy="1645920"/>
+            <a:ext cx="3840480" cy="1325880"/>
           </a:xfrm>
           <a:prstGeom prst="rect">
             <a:avLst/>
@@ -4620,7 +4524,7 @@
                 <a:ea typeface="Courier New" pitchFamily="34" charset="-122"/>
                 <a:cs typeface="Courier New" pitchFamily="34" charset="-120"/>
               </a:rPr>
-              <a:t>static void serviceRgbOutputs(void)</a:t>
+              <a:t>for (ch = 0; ch &lt; 8; ch++) {</a:t>
             </a:r>
             <a:endParaRPr lang="en-US" sz="1100" dirty="0"/>
           </a:p>
@@ -4631,13 +4535,13 @@
             <a:r>
               <a:rPr lang="en-US" sz="1100" dirty="0">
                 <a:solidFill>
-                  <a:srgbClr val="5C5C5C"/>
+                  <a:srgbClr val="B23A48"/>
                 </a:solidFill>
                 <a:latin typeface="Courier New" pitchFamily="34" charset="0"/>
                 <a:ea typeface="Courier New" pitchFamily="34" charset="-122"/>
                 <a:cs typeface="Courier New" pitchFamily="34" charset="-120"/>
               </a:rPr>
-              <a:t>{</a:t>
+              <a:t>  setLedChannel(RED,   ch, r);  // 0.3 ms</a:t>
             </a:r>
             <a:endParaRPr lang="en-US" sz="1100" dirty="0"/>
           </a:p>
@@ -4646,15 +4550,15 @@
               <a:buNone/>
             </a:pPr>
             <a:r>
-              <a:rPr lang="en-US" sz="1100" b="1" dirty="0">
-                <a:solidFill>
-                  <a:srgbClr val="1F6E43"/>
+              <a:rPr lang="en-US" sz="1100" dirty="0">
+                <a:solidFill>
+                  <a:srgbClr val="B23A48"/>
                 </a:solidFill>
                 <a:latin typeface="Courier New" pitchFamily="34" charset="0"/>
                 <a:ea typeface="Courier New" pitchFamily="34" charset="-122"/>
                 <a:cs typeface="Courier New" pitchFamily="34" charset="-120"/>
               </a:rPr>
-              <a:t>  if (micros() - lastUs &lt; 1200) return;</a:t>
+              <a:t>  setLedChannel(GREEN, ch, g);  // 0.3 ms</a:t>
             </a:r>
             <a:endParaRPr lang="en-US" sz="1100" dirty="0"/>
           </a:p>
@@ -4665,13 +4569,13 @@
             <a:r>
               <a:rPr lang="en-US" sz="1100" dirty="0">
                 <a:solidFill>
-                  <a:srgbClr val="5C5C5C"/>
+                  <a:srgbClr val="B23A48"/>
                 </a:solidFill>
                 <a:latin typeface="Courier New" pitchFamily="34" charset="0"/>
                 <a:ea typeface="Courier New" pitchFamily="34" charset="-122"/>
                 <a:cs typeface="Courier New" pitchFamily="34" charset="-120"/>
               </a:rPr>
-              <a:t>  lastUs = micros();</a:t>
+              <a:t>  setLedChannel(BLUE,  ch, b);  // 0.3 ms</a:t>
             </a:r>
             <a:endParaRPr lang="en-US" sz="1100" dirty="0"/>
           </a:p>
@@ -4679,22 +4583,16 @@
             <a:pPr indent="0" marL="0">
               <a:buNone/>
             </a:pPr>
-            <a:endParaRPr lang="en-US" sz="1100" dirty="0"/>
-          </a:p>
-          <a:p>
-            <a:pPr indent="0" marL="0">
-              <a:buNone/>
-            </a:pPr>
             <a:r>
               <a:rPr lang="en-US" sz="1100" dirty="0">
                 <a:solidFill>
-                  <a:srgbClr val="1F6E43"/>
+                  <a:srgbClr val="5C5C5C"/>
                 </a:solidFill>
                 <a:latin typeface="Courier New" pitchFamily="34" charset="0"/>
                 <a:ea typeface="Courier New" pitchFamily="34" charset="-122"/>
                 <a:cs typeface="Courier New" pitchFamily="34" charset="-120"/>
               </a:rPr>
-              <a:t>  /* write ONE of the 24 registers */</a:t>
+              <a:t>}</a:t>
             </a:r>
             <a:endParaRPr lang="en-US" sz="1100" dirty="0"/>
           </a:p>
@@ -4703,64 +4601,30 @@
               <a:buNone/>
             </a:pPr>
             <a:r>
-              <a:rPr lang="en-US" sz="1100" dirty="0">
-                <a:solidFill>
-                  <a:srgbClr val="5C5C5C"/>
+              <a:rPr lang="en-US" sz="1100" b="1" dirty="0">
+                <a:solidFill>
+                  <a:srgbClr val="B23A48"/>
                 </a:solidFill>
                 <a:latin typeface="Courier New" pitchFamily="34" charset="0"/>
                 <a:ea typeface="Courier New" pitchFamily="34" charset="-122"/>
                 <a:cs typeface="Courier New" pitchFamily="34" charset="-120"/>
               </a:rPr>
-              <a:t>  setLedChannel(chip, channel, target);</a:t>
+              <a:t>// about 7 to 9 ms with the loop stuck here</a:t>
             </a:r>
             <a:endParaRPr lang="en-US" sz="1100" dirty="0"/>
           </a:p>
-          <a:p>
-            <a:pPr indent="0" marL="0">
-              <a:buNone/>
-            </a:pPr>
-            <a:r>
-              <a:rPr lang="en-US" sz="1100" dirty="0">
-                <a:solidFill>
-                  <a:srgbClr val="5C5C5C"/>
-                </a:solidFill>
-                <a:latin typeface="Courier New" pitchFamily="34" charset="0"/>
-                <a:ea typeface="Courier New" pitchFamily="34" charset="-122"/>
-                <a:cs typeface="Courier New" pitchFamily="34" charset="-120"/>
-              </a:rPr>
-              <a:t>  index = (index + 1) % 24;</a:t>
-            </a:r>
-            <a:endParaRPr lang="en-US" sz="1100" dirty="0"/>
-          </a:p>
-          <a:p>
-            <a:pPr indent="0" marL="0">
-              <a:buNone/>
-            </a:pPr>
-            <a:r>
-              <a:rPr lang="en-US" sz="1100" dirty="0">
-                <a:solidFill>
-                  <a:srgbClr val="5C5C5C"/>
-                </a:solidFill>
-                <a:latin typeface="Courier New" pitchFamily="34" charset="0"/>
-                <a:ea typeface="Courier New" pitchFamily="34" charset="-122"/>
-                <a:cs typeface="Courier New" pitchFamily="34" charset="-120"/>
-              </a:rPr>
-              <a:t>}</a:t>
-            </a:r>
-            <a:endParaRPr lang="en-US" sz="1100" dirty="0"/>
-          </a:p>
-        </p:txBody>
-      </p:sp>
-      <p:sp>
-        <p:nvSpPr>
-          <p:cNvPr id="5" name="service bullets"/>
+        </p:txBody>
+      </p:sp>
+      <p:sp>
+        <p:nvSpPr>
+          <p:cNvPr id="5" name="blocking bullets"/>
           <p:cNvSpPr txBox="1"/>
           <p:nvPr/>
         </p:nvSpPr>
         <p:spPr>
           <a:xfrm>
-            <a:off x="5303520" y="1097280"/>
-            <a:ext cx="3383280" cy="3291840"/>
+            <a:off x="4846320" y="1097280"/>
+            <a:ext cx="3840480" cy="3291840"/>
           </a:xfrm>
           <a:prstGeom prst="rect">
             <a:avLst/>
@@ -4772,6 +4636,23 @@
           <a:bodyPr wrap="square" rtlCol="0" anchor="t"/>
           <a:lstStyle/>
           <a:p>
+            <a:pPr indent="0" marL="0">
+              <a:spcAft>
+                <a:spcPts val="800"/>
+              </a:spcAft>
+              <a:buNone/>
+            </a:pPr>
+            <a:r>
+              <a:rPr lang="en-US" sz="1500" b="1" dirty="0">
+                <a:solidFill>
+                  <a:srgbClr val="000000"/>
+                </a:solidFill>
+              </a:rPr>
+              <a:t>While stuck, the main loop cannot:</a:t>
+            </a:r>
+            <a:endParaRPr lang="en-US" sz="1500" dirty="0"/>
+          </a:p>
+          <a:p>
             <a:pPr marL="342900" indent="-342900">
               <a:spcAft>
                 <a:spcPts val="800"/>
@@ -4785,7 +4666,7 @@
                   <a:srgbClr val="000000"/>
                 </a:solidFill>
               </a:rPr>
-              <a:t>The logic writes the wanted colours into RAM arrays (rgbTarget...): instant.</a:t>
+              <a:t>see a new command or state</a:t>
             </a:r>
             <a:endParaRPr lang="en-US" sz="1500" dirty="0"/>
           </a:p>
@@ -4803,7 +4684,7 @@
                   <a:srgbClr val="000000"/>
                 </a:solidFill>
               </a:rPr>
-              <a:t>serviceRgbOutputs copies them to the chips, at most one register per call.</a:t>
+              <a:t>poll the IR obstacle sensor (an emergency stop!)</a:t>
             </a:r>
             <a:endParaRPr lang="en-US" sz="1500" dirty="0"/>
           </a:p>
@@ -4821,7 +4702,7 @@
                   <a:srgbClr val="000000"/>
                 </a:solidFill>
               </a:rPr>
-              <a:t>Each loop pass pays at most 0.3 ms; a full refresh takes 24 x 1.2 ms = 29 ms, too fast for the eye.</a:t>
+              <a:t>run the state's work or print status</a:t>
             </a:r>
             <a:endParaRPr lang="en-US" sz="1500" dirty="0"/>
           </a:p>
@@ -4834,12 +4715,12 @@
               <a:buChar char="•"/>
             </a:pPr>
             <a:r>
-              <a:rPr lang="en-US" sz="1500" b="1" dirty="0">
+              <a:rPr lang="en-US" sz="1500" dirty="0">
                 <a:solidFill>
                   <a:srgbClr val="1F6E43"/>
                 </a:solidFill>
               </a:rPr>
-              <a:t>What makes it non-blocking is the work per call, not where the call is placed.</a:t>
+              <a:t>Interrupts still run: TIM2 keeps the PWM going and TIM5 still captures the ultrasonic echo.</a:t>
             </a:r>
             <a:endParaRPr lang="en-US" sz="1500" dirty="0"/>
           </a:p>
@@ -4947,6 +4828,399 @@
                   <a:schemeClr val="tx2"/>
                 </a:solidFill>
               </a:rPr>
+              <a:t>Non-blocking: one register per loop pass</a:t>
+            </a:r>
+            <a:endParaRPr lang="en-US" sz="2600" dirty="0"/>
+          </a:p>
+        </p:txBody>
+      </p:sp>
+      <p:sp>
+        <p:nvSpPr>
+          <p:cNvPr id="3" name="service box"/>
+          <p:cNvSpPr/>
+          <p:nvPr/>
+        </p:nvSpPr>
+        <p:spPr>
+          <a:xfrm>
+            <a:off x="457200" y="1097280"/>
+            <a:ext cx="4572000" cy="1828800"/>
+          </a:xfrm>
+          <a:prstGeom prst="roundRect">
+            <a:avLst>
+              <a:gd name="adj" fmla="val 4000"/>
+            </a:avLst>
+          </a:prstGeom>
+          <a:solidFill>
+            <a:srgbClr val="F4F6F4"/>
+          </a:solidFill>
+          <a:ln w="9525">
+            <a:solidFill>
+              <a:srgbClr val="D5DDD6"/>
+            </a:solidFill>
+            <a:prstDash val="solid"/>
+          </a:ln>
+        </p:spPr>
+      </p:sp>
+      <p:sp>
+        <p:nvSpPr>
+          <p:cNvPr id="4" name="service code"/>
+          <p:cNvSpPr txBox="1"/>
+          <p:nvPr/>
+        </p:nvSpPr>
+        <p:spPr>
+          <a:xfrm>
+            <a:off x="594360" y="1188720"/>
+            <a:ext cx="4297680" cy="1645920"/>
+          </a:xfrm>
+          <a:prstGeom prst="rect">
+            <a:avLst/>
+          </a:prstGeom>
+          <a:noFill/>
+          <a:ln/>
+        </p:spPr>
+        <p:txBody>
+          <a:bodyPr wrap="square" lIns="0" tIns="0" rIns="0" bIns="0" rtlCol="0" anchor="t"/>
+          <a:lstStyle/>
+          <a:p>
+            <a:pPr indent="0" marL="0">
+              <a:buNone/>
+            </a:pPr>
+            <a:r>
+              <a:rPr lang="en-US" sz="1100" dirty="0">
+                <a:solidFill>
+                  <a:srgbClr val="5C5C5C"/>
+                </a:solidFill>
+                <a:latin typeface="Courier New" pitchFamily="34" charset="0"/>
+                <a:ea typeface="Courier New" pitchFamily="34" charset="-122"/>
+                <a:cs typeface="Courier New" pitchFamily="34" charset="-120"/>
+              </a:rPr>
+              <a:t>static void serviceRgbOutputs(void)</a:t>
+            </a:r>
+            <a:endParaRPr lang="en-US" sz="1100" dirty="0"/>
+          </a:p>
+          <a:p>
+            <a:pPr indent="0" marL="0">
+              <a:buNone/>
+            </a:pPr>
+            <a:r>
+              <a:rPr lang="en-US" sz="1100" dirty="0">
+                <a:solidFill>
+                  <a:srgbClr val="5C5C5C"/>
+                </a:solidFill>
+                <a:latin typeface="Courier New" pitchFamily="34" charset="0"/>
+                <a:ea typeface="Courier New" pitchFamily="34" charset="-122"/>
+                <a:cs typeface="Courier New" pitchFamily="34" charset="-120"/>
+              </a:rPr>
+              <a:t>{</a:t>
+            </a:r>
+            <a:endParaRPr lang="en-US" sz="1100" dirty="0"/>
+          </a:p>
+          <a:p>
+            <a:pPr indent="0" marL="0">
+              <a:buNone/>
+            </a:pPr>
+            <a:r>
+              <a:rPr lang="en-US" sz="1100" b="1" dirty="0">
+                <a:solidFill>
+                  <a:srgbClr val="1F6E43"/>
+                </a:solidFill>
+                <a:latin typeface="Courier New" pitchFamily="34" charset="0"/>
+                <a:ea typeface="Courier New" pitchFamily="34" charset="-122"/>
+                <a:cs typeface="Courier New" pitchFamily="34" charset="-120"/>
+              </a:rPr>
+              <a:t>  if (micros() - lastUs &lt; 1200) return;</a:t>
+            </a:r>
+            <a:endParaRPr lang="en-US" sz="1100" dirty="0"/>
+          </a:p>
+          <a:p>
+            <a:pPr indent="0" marL="0">
+              <a:buNone/>
+            </a:pPr>
+            <a:r>
+              <a:rPr lang="en-US" sz="1100" dirty="0">
+                <a:solidFill>
+                  <a:srgbClr val="5C5C5C"/>
+                </a:solidFill>
+                <a:latin typeface="Courier New" pitchFamily="34" charset="0"/>
+                <a:ea typeface="Courier New" pitchFamily="34" charset="-122"/>
+                <a:cs typeface="Courier New" pitchFamily="34" charset="-120"/>
+              </a:rPr>
+              <a:t>  lastUs = micros();</a:t>
+            </a:r>
+            <a:endParaRPr lang="en-US" sz="1100" dirty="0"/>
+          </a:p>
+          <a:p>
+            <a:pPr indent="0" marL="0">
+              <a:buNone/>
+            </a:pPr>
+            <a:endParaRPr lang="en-US" sz="1100" dirty="0"/>
+          </a:p>
+          <a:p>
+            <a:pPr indent="0" marL="0">
+              <a:buNone/>
+            </a:pPr>
+            <a:r>
+              <a:rPr lang="en-US" sz="1100" dirty="0">
+                <a:solidFill>
+                  <a:srgbClr val="1F6E43"/>
+                </a:solidFill>
+                <a:latin typeface="Courier New" pitchFamily="34" charset="0"/>
+                <a:ea typeface="Courier New" pitchFamily="34" charset="-122"/>
+                <a:cs typeface="Courier New" pitchFamily="34" charset="-120"/>
+              </a:rPr>
+              <a:t>  /* write ONE of the 24 registers */</a:t>
+            </a:r>
+            <a:endParaRPr lang="en-US" sz="1100" dirty="0"/>
+          </a:p>
+          <a:p>
+            <a:pPr indent="0" marL="0">
+              <a:buNone/>
+            </a:pPr>
+            <a:r>
+              <a:rPr lang="en-US" sz="1100" dirty="0">
+                <a:solidFill>
+                  <a:srgbClr val="5C5C5C"/>
+                </a:solidFill>
+                <a:latin typeface="Courier New" pitchFamily="34" charset="0"/>
+                <a:ea typeface="Courier New" pitchFamily="34" charset="-122"/>
+                <a:cs typeface="Courier New" pitchFamily="34" charset="-120"/>
+              </a:rPr>
+              <a:t>  setLedChannel(chip, channel, target);</a:t>
+            </a:r>
+            <a:endParaRPr lang="en-US" sz="1100" dirty="0"/>
+          </a:p>
+          <a:p>
+            <a:pPr indent="0" marL="0">
+              <a:buNone/>
+            </a:pPr>
+            <a:r>
+              <a:rPr lang="en-US" sz="1100" dirty="0">
+                <a:solidFill>
+                  <a:srgbClr val="5C5C5C"/>
+                </a:solidFill>
+                <a:latin typeface="Courier New" pitchFamily="34" charset="0"/>
+                <a:ea typeface="Courier New" pitchFamily="34" charset="-122"/>
+                <a:cs typeface="Courier New" pitchFamily="34" charset="-120"/>
+              </a:rPr>
+              <a:t>  index = (index + 1) % 24;</a:t>
+            </a:r>
+            <a:endParaRPr lang="en-US" sz="1100" dirty="0"/>
+          </a:p>
+          <a:p>
+            <a:pPr indent="0" marL="0">
+              <a:buNone/>
+            </a:pPr>
+            <a:r>
+              <a:rPr lang="en-US" sz="1100" dirty="0">
+                <a:solidFill>
+                  <a:srgbClr val="5C5C5C"/>
+                </a:solidFill>
+                <a:latin typeface="Courier New" pitchFamily="34" charset="0"/>
+                <a:ea typeface="Courier New" pitchFamily="34" charset="-122"/>
+                <a:cs typeface="Courier New" pitchFamily="34" charset="-120"/>
+              </a:rPr>
+              <a:t>}</a:t>
+            </a:r>
+            <a:endParaRPr lang="en-US" sz="1100" dirty="0"/>
+          </a:p>
+        </p:txBody>
+      </p:sp>
+      <p:sp>
+        <p:nvSpPr>
+          <p:cNvPr id="5" name="service bullets"/>
+          <p:cNvSpPr txBox="1"/>
+          <p:nvPr/>
+        </p:nvSpPr>
+        <p:spPr>
+          <a:xfrm>
+            <a:off x="5303520" y="1097280"/>
+            <a:ext cx="3383280" cy="3291840"/>
+          </a:xfrm>
+          <a:prstGeom prst="rect">
+            <a:avLst/>
+          </a:prstGeom>
+          <a:noFill/>
+          <a:ln/>
+        </p:spPr>
+        <p:txBody>
+          <a:bodyPr wrap="square" rtlCol="0" anchor="t"/>
+          <a:lstStyle/>
+          <a:p>
+            <a:pPr marL="342900" indent="-342900">
+              <a:spcAft>
+                <a:spcPts val="800"/>
+              </a:spcAft>
+              <a:buSzPct val="100000"/>
+              <a:buChar char="•"/>
+            </a:pPr>
+            <a:r>
+              <a:rPr lang="en-US" sz="1500" dirty="0">
+                <a:solidFill>
+                  <a:srgbClr val="000000"/>
+                </a:solidFill>
+              </a:rPr>
+              <a:t>The logic writes the wanted colours into RAM arrays (rgbTarget...): instant.</a:t>
+            </a:r>
+            <a:endParaRPr lang="en-US" sz="1500" dirty="0"/>
+          </a:p>
+          <a:p>
+            <a:pPr marL="342900" indent="-342900">
+              <a:spcAft>
+                <a:spcPts val="800"/>
+              </a:spcAft>
+              <a:buSzPct val="100000"/>
+              <a:buChar char="•"/>
+            </a:pPr>
+            <a:r>
+              <a:rPr lang="en-US" sz="1500" dirty="0">
+                <a:solidFill>
+                  <a:srgbClr val="000000"/>
+                </a:solidFill>
+              </a:rPr>
+              <a:t>serviceRgbOutputs copies them to the chips, at most one register per call.</a:t>
+            </a:r>
+            <a:endParaRPr lang="en-US" sz="1500" dirty="0"/>
+          </a:p>
+          <a:p>
+            <a:pPr marL="342900" indent="-342900">
+              <a:spcAft>
+                <a:spcPts val="800"/>
+              </a:spcAft>
+              <a:buSzPct val="100000"/>
+              <a:buChar char="•"/>
+            </a:pPr>
+            <a:r>
+              <a:rPr lang="en-US" sz="1500" dirty="0">
+                <a:solidFill>
+                  <a:srgbClr val="000000"/>
+                </a:solidFill>
+              </a:rPr>
+              <a:t>Each loop pass pays at most 0.3 ms; a full refresh takes 24 x 1.2 ms = 29 ms, too fast for the eye.</a:t>
+            </a:r>
+            <a:endParaRPr lang="en-US" sz="1500" dirty="0"/>
+          </a:p>
+          <a:p>
+            <a:pPr marL="342900" indent="-342900">
+              <a:spcAft>
+                <a:spcPts val="800"/>
+              </a:spcAft>
+              <a:buSzPct val="100000"/>
+              <a:buChar char="•"/>
+            </a:pPr>
+            <a:r>
+              <a:rPr lang="en-US" sz="1500" b="1" dirty="0">
+                <a:solidFill>
+                  <a:srgbClr val="1F6E43"/>
+                </a:solidFill>
+              </a:rPr>
+              <a:t>What makes it non-blocking is the work per call, not where the call is placed.</a:t>
+            </a:r>
+            <a:endParaRPr lang="en-US" sz="1500" dirty="0"/>
+          </a:p>
+        </p:txBody>
+      </p:sp>
+      <p:sp>
+        <p:nvSpPr>
+          <p:cNvPr id="25" name="Slide Number Placeholder 0"/>
+          <p:cNvSpPr>
+            <a:spLocks noGrp="1"/>
+          </p:cNvSpPr>
+          <p:nvPr>
+            <p:ph type="sldNum" sz="quarter" idx="4294967295"/>
+          </p:nvPr>
+        </p:nvSpPr>
+        <p:spPr>
+          <a:xfrm>
+            <a:off x="8412480" y="4754880"/>
+            <a:ext cx="800000" cy="300000"/>
+          </a:xfrm>
+          <a:prstGeom prst="rect">
+            <a:avLst/>
+          </a:prstGeom>
+          <a:extLst>
+            <a:ext uri="{C572A759-6A51-4108-AA02-DFA0A04FC94B}">
+              <ma14:wrappingTextBoxFlag xmlns:ma14="http://schemas.microsoft.com/office/mac/drawingml/2011/main" val="0"/>
+            </a:ext>
+          </a:extLst>
+        </p:spPr>
+        <p:txBody>
+          <a:bodyPr/>
+          <a:lstStyle>
+            <a:lvl1pPr>
+              <a:defRPr sz="1000">
+                <a:solidFill>
+                  <a:schemeClr val="tx2"/>
+                </a:solidFill>
+              </a:defRPr>
+            </a:lvl1pPr>
+          </a:lstStyle>
+          <a:p>
+            <a:pPr algn="l"/>
+            <a:fld id="{F7021451-1387-4CA6-816F-3879F97B5CBC}" type="slidenum">
+              <a:rPr b="0" lang="en-US"/>
+              <a:t>14</a:t>
+            </a:fld>
+            <a:endParaRPr lang="en-US"/>
+          </a:p>
+        </p:txBody>
+      </p:sp>
+    </p:spTree>
+  </p:cSld>
+  <p:clrMapOvr>
+    <a:masterClrMapping/>
+  </p:clrMapOvr>
+</p:sld>
+</file>
+
+<file path=ppt/slides/slide15.xml><?xml version="1.0" encoding="utf-8"?>
+<p:sld xmlns:a="http://schemas.openxmlformats.org/drawingml/2006/main" xmlns:r="http://schemas.openxmlformats.org/officeDocument/2006/relationships" xmlns:p="http://schemas.openxmlformats.org/presentationml/2006/main">
+  <p:cSld name="Slide 15">
+    <p:spTree>
+      <p:nvGrpSpPr>
+        <p:cNvPr id="1" name=""/>
+        <p:cNvGrpSpPr/>
+        <p:nvPr/>
+      </p:nvGrpSpPr>
+      <p:grpSpPr>
+        <a:xfrm>
+          <a:off x="0" y="0"/>
+          <a:ext cx="0" cy="0"/>
+          <a:chOff x="0" y="0"/>
+          <a:chExt cx="0" cy="0"/>
+        </a:xfrm>
+      </p:grpSpPr>
+      <p:sp>
+        <p:nvSpPr>
+          <p:cNvPr id="2" name="Text 0"/>
+          <p:cNvSpPr/>
+          <p:nvPr>
+            <p:ph idx="100" type="title" hasCustomPrompt="1"/>
+          </p:nvPr>
+        </p:nvSpPr>
+        <p:spPr>
+          <a:xfrm>
+            <a:off x="457200" y="274320"/>
+            <a:ext cx="8229600" cy="640080"/>
+          </a:xfrm>
+          <a:prstGeom prst="rect">
+            <a:avLst/>
+          </a:prstGeom>
+          <a:noFill/>
+          <a:ln/>
+        </p:spPr>
+        <p:txBody>
+          <a:bodyPr wrap="square" rtlCol="0" anchor="ctr"/>
+          <a:lstStyle/>
+          <a:p>
+            <a:pPr algn="l" indent="0" marL="0">
+              <a:buNone/>
+            </a:pPr>
+            <a:r>
+              <a:rPr lang="en-US" sz="2600" b="1" dirty="0">
+                <a:solidFill>
+                  <a:schemeClr val="tx2"/>
+                </a:solidFill>
+              </a:rPr>
               <a:t>Three layers: decide, store, transport</a:t>
             </a:r>
             <a:endParaRPr lang="en-US" sz="2600" dirty="0"/>
@@ -4955,7 +5229,7 @@
       </p:sp>
       <p:graphicFrame>
         <p:nvGraphicFramePr>
-          <p:cNvPr id="15" name="layers table"/>
+          <p:cNvPr id="16" name="layers table"/>
           <p:cNvGraphicFramePr>
             <a:graphicFrameLocks noGrp="1"/>
           </p:cNvGraphicFramePr>
@@ -5799,439 +6073,6 @@
             <a:pPr algn="l"/>
             <a:fld id="{F7021451-1387-4CA6-816F-3879F97B5CBC}" type="slidenum">
               <a:rPr b="0" lang="en-US"/>
-              <a:t>14</a:t>
-            </a:fld>
-            <a:endParaRPr lang="en-US"/>
-          </a:p>
-        </p:txBody>
-      </p:sp>
-    </p:spTree>
-  </p:cSld>
-  <p:clrMapOvr>
-    <a:masterClrMapping/>
-  </p:clrMapOvr>
-</p:sld>
-</file>
-
-<file path=ppt/slides/slide15.xml><?xml version="1.0" encoding="utf-8"?>
-<p:sld xmlns:a="http://schemas.openxmlformats.org/drawingml/2006/main" xmlns:r="http://schemas.openxmlformats.org/officeDocument/2006/relationships" xmlns:p="http://schemas.openxmlformats.org/presentationml/2006/main">
-  <p:cSld name="Slide 15">
-    <p:spTree>
-      <p:nvGrpSpPr>
-        <p:cNvPr id="1" name=""/>
-        <p:cNvGrpSpPr/>
-        <p:nvPr/>
-      </p:nvGrpSpPr>
-      <p:grpSpPr>
-        <a:xfrm>
-          <a:off x="0" y="0"/>
-          <a:ext cx="0" cy="0"/>
-          <a:chOff x="0" y="0"/>
-          <a:chExt cx="0" cy="0"/>
-        </a:xfrm>
-      </p:grpSpPr>
-      <p:sp>
-        <p:nvSpPr>
-          <p:cNvPr id="2" name="Text 0"/>
-          <p:cNvSpPr/>
-          <p:nvPr>
-            <p:ph idx="100" type="title" hasCustomPrompt="1"/>
-          </p:nvPr>
-        </p:nvSpPr>
-        <p:spPr>
-          <a:xfrm>
-            <a:off x="457200" y="274320"/>
-            <a:ext cx="8229600" cy="640080"/>
-          </a:xfrm>
-          <a:prstGeom prst="rect">
-            <a:avLst/>
-          </a:prstGeom>
-          <a:noFill/>
-          <a:ln/>
-        </p:spPr>
-        <p:txBody>
-          <a:bodyPr wrap="square" rtlCol="0" anchor="ctr"/>
-          <a:lstStyle/>
-          <a:p>
-            <a:pPr algn="l" indent="0" marL="0">
-              <a:buNone/>
-            </a:pPr>
-            <a:r>
-              <a:rPr lang="en-US" sz="2600" b="1" dirty="0">
-                <a:solidFill>
-                  <a:schemeClr val="tx2"/>
-                </a:solidFill>
-              </a:rPr>
-              <a:t>The super loop: inputs, logic, services</a:t>
-            </a:r>
-            <a:endParaRPr lang="en-US" sz="2600" dirty="0"/>
-          </a:p>
-        </p:txBody>
-      </p:sp>
-      <p:sp>
-        <p:nvSpPr>
-          <p:cNvPr id="3" name="superloop box"/>
-          <p:cNvSpPr/>
-          <p:nvPr/>
-        </p:nvSpPr>
-        <p:spPr>
-          <a:xfrm>
-            <a:off x="457200" y="1097280"/>
-            <a:ext cx="4572000" cy="2194560"/>
-          </a:xfrm>
-          <a:prstGeom prst="roundRect">
-            <a:avLst>
-              <a:gd name="adj" fmla="val 3333"/>
-            </a:avLst>
-          </a:prstGeom>
-          <a:solidFill>
-            <a:srgbClr val="F4F6F4"/>
-          </a:solidFill>
-          <a:ln w="9525">
-            <a:solidFill>
-              <a:srgbClr val="D5DDD6"/>
-            </a:solidFill>
-            <a:prstDash val="solid"/>
-          </a:ln>
-        </p:spPr>
-      </p:sp>
-      <p:sp>
-        <p:nvSpPr>
-          <p:cNvPr id="4" name="superloop code"/>
-          <p:cNvSpPr txBox="1"/>
-          <p:nvPr/>
-        </p:nvSpPr>
-        <p:spPr>
-          <a:xfrm>
-            <a:off x="594360" y="1188720"/>
-            <a:ext cx="4297680" cy="2011680"/>
-          </a:xfrm>
-          <a:prstGeom prst="rect">
-            <a:avLst/>
-          </a:prstGeom>
-          <a:noFill/>
-          <a:ln/>
-        </p:spPr>
-        <p:txBody>
-          <a:bodyPr wrap="square" lIns="0" tIns="0" rIns="0" bIns="0" rtlCol="0" anchor="t"/>
-          <a:lstStyle/>
-          <a:p>
-            <a:pPr indent="0" marL="0">
-              <a:buNone/>
-            </a:pPr>
-            <a:r>
-              <a:rPr lang="en-US" sz="1100" dirty="0">
-                <a:solidFill>
-                  <a:srgbClr val="5C5C5C"/>
-                </a:solidFill>
-                <a:latin typeface="Courier New" pitchFamily="34" charset="0"/>
-                <a:ea typeface="Courier New" pitchFamily="34" charset="-122"/>
-                <a:cs typeface="Courier New" pitchFamily="34" charset="-120"/>
-              </a:rPr>
-              <a:t>while (1)</a:t>
-            </a:r>
-            <a:endParaRPr lang="en-US" sz="1100" dirty="0"/>
-          </a:p>
-          <a:p>
-            <a:pPr indent="0" marL="0">
-              <a:buNone/>
-            </a:pPr>
-            <a:r>
-              <a:rPr lang="en-US" sz="1100" dirty="0">
-                <a:solidFill>
-                  <a:srgbClr val="5C5C5C"/>
-                </a:solidFill>
-                <a:latin typeface="Courier New" pitchFamily="34" charset="0"/>
-                <a:ea typeface="Courier New" pitchFamily="34" charset="-122"/>
-                <a:cs typeface="Courier New" pitchFamily="34" charset="-120"/>
-              </a:rPr>
-              <a:t>{</a:t>
-            </a:r>
-            <a:endParaRPr lang="en-US" sz="1100" dirty="0"/>
-          </a:p>
-          <a:p>
-            <a:pPr indent="0" marL="0">
-              <a:buNone/>
-            </a:pPr>
-            <a:r>
-              <a:rPr lang="en-US" sz="1100" b="1" dirty="0">
-                <a:solidFill>
-                  <a:srgbClr val="1F6E43"/>
-                </a:solidFill>
-                <a:latin typeface="Courier New" pitchFamily="34" charset="0"/>
-                <a:ea typeface="Courier New" pitchFamily="34" charset="-122"/>
-                <a:cs typeface="Courier New" pitchFamily="34" charset="-120"/>
-              </a:rPr>
-              <a:t>  updateEncoders();      /* 1. inputs   */</a:t>
-            </a:r>
-            <a:endParaRPr lang="en-US" sz="1100" dirty="0"/>
-          </a:p>
-          <a:p>
-            <a:pPr indent="0" marL="0">
-              <a:buNone/>
-            </a:pPr>
-            <a:r>
-              <a:rPr lang="en-US" sz="1100" dirty="0">
-                <a:solidFill>
-                  <a:srgbClr val="5C5C5C"/>
-                </a:solidFill>
-                <a:latin typeface="Courier New" pitchFamily="34" charset="0"/>
-                <a:ea typeface="Courier New" pitchFamily="34" charset="-122"/>
-                <a:cs typeface="Courier New" pitchFamily="34" charset="-120"/>
-              </a:rPr>
-              <a:t>  updateIrSensor();</a:t>
-            </a:r>
-            <a:endParaRPr lang="en-US" sz="1100" dirty="0"/>
-          </a:p>
-          <a:p>
-            <a:pPr indent="0" marL="0">
-              <a:buNone/>
-            </a:pPr>
-            <a:endParaRPr lang="en-US" sz="1100" dirty="0"/>
-          </a:p>
-          <a:p>
-            <a:pPr indent="0" marL="0">
-              <a:buNone/>
-            </a:pPr>
-            <a:r>
-              <a:rPr lang="en-US" sz="1100" b="1" dirty="0">
-                <a:solidFill>
-                  <a:srgbClr val="1F6E43"/>
-                </a:solidFill>
-                <a:latin typeface="Courier New" pitchFamily="34" charset="0"/>
-                <a:ea typeface="Courier New" pitchFamily="34" charset="-122"/>
-                <a:cs typeface="Courier New" pitchFamily="34" charset="-120"/>
-              </a:rPr>
-              <a:t>  if (state != applied)  /* 2. logic    */</a:t>
-            </a:r>
-            <a:endParaRPr lang="en-US" sz="1100" dirty="0"/>
-          </a:p>
-          <a:p>
-            <a:pPr indent="0" marL="0">
-              <a:buNone/>
-            </a:pPr>
-            <a:r>
-              <a:rPr lang="en-US" sz="1100" dirty="0">
-                <a:solidFill>
-                  <a:srgbClr val="5C5C5C"/>
-                </a:solidFill>
-                <a:latin typeface="Courier New" pitchFamily="34" charset="0"/>
-                <a:ea typeface="Courier New" pitchFamily="34" charset="-122"/>
-                <a:cs typeface="Courier New" pitchFamily="34" charset="-120"/>
-              </a:rPr>
-              <a:t>    enterState(state);   /* once        */</a:t>
-            </a:r>
-            <a:endParaRPr lang="en-US" sz="1100" dirty="0"/>
-          </a:p>
-          <a:p>
-            <a:pPr indent="0" marL="0">
-              <a:buNone/>
-            </a:pPr>
-            <a:r>
-              <a:rPr lang="en-US" sz="1100" dirty="0">
-                <a:solidFill>
-                  <a:srgbClr val="5C5C5C"/>
-                </a:solidFill>
-                <a:latin typeface="Courier New" pitchFamily="34" charset="0"/>
-                <a:ea typeface="Courier New" pitchFamily="34" charset="-122"/>
-                <a:cs typeface="Courier New" pitchFamily="34" charset="-120"/>
-              </a:rPr>
-              <a:t>  runStateTick(applied); /* every pass  */</a:t>
-            </a:r>
-            <a:endParaRPr lang="en-US" sz="1100" dirty="0"/>
-          </a:p>
-          <a:p>
-            <a:pPr indent="0" marL="0">
-              <a:buNone/>
-            </a:pPr>
-            <a:endParaRPr lang="en-US" sz="1100" dirty="0"/>
-          </a:p>
-          <a:p>
-            <a:pPr indent="0" marL="0">
-              <a:buNone/>
-            </a:pPr>
-            <a:r>
-              <a:rPr lang="en-US" sz="1100" b="1" dirty="0">
-                <a:solidFill>
-                  <a:srgbClr val="1F6E43"/>
-                </a:solidFill>
-                <a:latin typeface="Courier New" pitchFamily="34" charset="0"/>
-                <a:ea typeface="Courier New" pitchFamily="34" charset="-122"/>
-                <a:cs typeface="Courier New" pitchFamily="34" charset="-120"/>
-              </a:rPr>
-              <a:t>  serviceRgbOutputs();   /* 3. services */</a:t>
-            </a:r>
-            <a:endParaRPr lang="en-US" sz="1100" dirty="0"/>
-          </a:p>
-          <a:p>
-            <a:pPr indent="0" marL="0">
-              <a:buNone/>
-            </a:pPr>
-            <a:r>
-              <a:rPr lang="en-US" sz="1100" dirty="0">
-                <a:solidFill>
-                  <a:srgbClr val="5C5C5C"/>
-                </a:solidFill>
-                <a:latin typeface="Courier New" pitchFamily="34" charset="0"/>
-                <a:ea typeface="Courier New" pitchFamily="34" charset="-122"/>
-                <a:cs typeface="Courier New" pitchFamily="34" charset="-120"/>
-              </a:rPr>
-              <a:t>  printPeriodicStatus();</a:t>
-            </a:r>
-            <a:endParaRPr lang="en-US" sz="1100" dirty="0"/>
-          </a:p>
-          <a:p>
-            <a:pPr indent="0" marL="0">
-              <a:buNone/>
-            </a:pPr>
-            <a:r>
-              <a:rPr lang="en-US" sz="1100" dirty="0">
-                <a:solidFill>
-                  <a:srgbClr val="5C5C5C"/>
-                </a:solidFill>
-                <a:latin typeface="Courier New" pitchFamily="34" charset="0"/>
-                <a:ea typeface="Courier New" pitchFamily="34" charset="-122"/>
-                <a:cs typeface="Courier New" pitchFamily="34" charset="-120"/>
-              </a:rPr>
-              <a:t>}</a:t>
-            </a:r>
-            <a:endParaRPr lang="en-US" sz="1100" dirty="0"/>
-          </a:p>
-        </p:txBody>
-      </p:sp>
-      <p:sp>
-        <p:nvSpPr>
-          <p:cNvPr id="5" name="superloop bullets"/>
-          <p:cNvSpPr txBox="1"/>
-          <p:nvPr/>
-        </p:nvSpPr>
-        <p:spPr>
-          <a:xfrm>
-            <a:off x="5303520" y="1097280"/>
-            <a:ext cx="3383280" cy="3291840"/>
-          </a:xfrm>
-          <a:prstGeom prst="rect">
-            <a:avLst/>
-          </a:prstGeom>
-          <a:noFill/>
-          <a:ln/>
-        </p:spPr>
-        <p:txBody>
-          <a:bodyPr wrap="square" rtlCol="0" anchor="t"/>
-          <a:lstStyle/>
-          <a:p>
-            <a:pPr marL="342900" indent="-342900">
-              <a:spcAft>
-                <a:spcPts val="800"/>
-              </a:spcAft>
-              <a:buSzPct val="100000"/>
-              <a:buChar char="•"/>
-            </a:pPr>
-            <a:r>
-              <a:rPr lang="en-US" sz="1500" dirty="0">
-                <a:solidFill>
-                  <a:srgbClr val="000000"/>
-                </a:solidFill>
-              </a:rPr>
-              <a:t>Keep every pass short, so polled inputs stay responsive.</a:t>
-            </a:r>
-            <a:endParaRPr lang="en-US" sz="1500" dirty="0"/>
-          </a:p>
-          <a:p>
-            <a:pPr marL="342900" indent="-342900">
-              <a:spcAft>
-                <a:spcPts val="800"/>
-              </a:spcAft>
-              <a:buSzPct val="100000"/>
-              <a:buChar char="•"/>
-            </a:pPr>
-            <a:r>
-              <a:rPr lang="en-US" sz="1500" dirty="0">
-                <a:solidFill>
-                  <a:srgbClr val="000000"/>
-                </a:solidFill>
-              </a:rPr>
-              <a:t>runStateTick: what the current state wants.</a:t>
-            </a:r>
-            <a:endParaRPr lang="en-US" sz="1500" dirty="0"/>
-          </a:p>
-          <a:p>
-            <a:pPr marL="342900" indent="-342900">
-              <a:spcAft>
-                <a:spcPts val="800"/>
-              </a:spcAft>
-              <a:buSzPct val="100000"/>
-              <a:buChar char="•"/>
-            </a:pPr>
-            <a:r>
-              <a:rPr lang="en-US" sz="1500" dirty="0">
-                <a:solidFill>
-                  <a:srgbClr val="000000"/>
-                </a:solidFill>
-              </a:rPr>
-              <a:t>Services: make the hardware match, in every state.</a:t>
-            </a:r>
-            <a:endParaRPr lang="en-US" sz="1500" dirty="0"/>
-          </a:p>
-          <a:p>
-            <a:pPr marL="342900" indent="-342900">
-              <a:spcAft>
-                <a:spcPts val="800"/>
-              </a:spcAft>
-              <a:buSzPct val="100000"/>
-              <a:buChar char="•"/>
-            </a:pPr>
-            <a:r>
-              <a:rPr lang="en-US" sz="1500" dirty="0">
-                <a:solidFill>
-                  <a:srgbClr val="B23A48"/>
-                </a:solidFill>
-              </a:rPr>
-              <a:t>Calling a service from inside one state's case would freeze that output in all other states.</a:t>
-            </a:r>
-            <a:endParaRPr lang="en-US" sz="1500" dirty="0"/>
-          </a:p>
-        </p:txBody>
-      </p:sp>
-      <p:sp>
-        <p:nvSpPr>
-          <p:cNvPr id="25" name="Slide Number Placeholder 0"/>
-          <p:cNvSpPr>
-            <a:spLocks noGrp="1"/>
-          </p:cNvSpPr>
-          <p:nvPr>
-            <p:ph type="sldNum" sz="quarter" idx="4294967295"/>
-          </p:nvPr>
-        </p:nvSpPr>
-        <p:spPr>
-          <a:xfrm>
-            <a:off x="8412480" y="4754880"/>
-            <a:ext cx="800000" cy="300000"/>
-          </a:xfrm>
-          <a:prstGeom prst="rect">
-            <a:avLst/>
-          </a:prstGeom>
-          <a:extLst>
-            <a:ext uri="{C572A759-6A51-4108-AA02-DFA0A04FC94B}">
-              <ma14:wrappingTextBoxFlag xmlns:ma14="http://schemas.microsoft.com/office/mac/drawingml/2011/main" val="0"/>
-            </a:ext>
-          </a:extLst>
-        </p:spPr>
-        <p:txBody>
-          <a:bodyPr/>
-          <a:lstStyle>
-            <a:lvl1pPr>
-              <a:defRPr sz="1000">
-                <a:solidFill>
-                  <a:schemeClr val="tx2"/>
-                </a:solidFill>
-              </a:defRPr>
-            </a:lvl1pPr>
-          </a:lstStyle>
-          <a:p>
-            <a:pPr algn="l"/>
-            <a:fld id="{F7021451-1387-4CA6-816F-3879F97B5CBC}" type="slidenum">
-              <a:rPr b="0" lang="en-US"/>
               <a:t>15</a:t>
             </a:fld>
             <a:endParaRPr lang="en-US"/>
@@ -6268,13 +6109,13 @@
           <p:cNvPr id="2" name="Text 0"/>
           <p:cNvSpPr/>
           <p:nvPr>
-            <p:ph idx="100" type="body" hasCustomPrompt="1"/>
+            <p:ph idx="100" type="title" hasCustomPrompt="1"/>
           </p:nvPr>
         </p:nvSpPr>
         <p:spPr>
           <a:xfrm>
-            <a:off x="548640" y="914400"/>
-            <a:ext cx="8046720" cy="457200"/>
+            <a:off x="457200" y="274320"/>
+            <a:ext cx="8229600" cy="640080"/>
           </a:xfrm>
           <a:prstGeom prst="rect">
             <a:avLst/>
@@ -6283,36 +6124,61 @@
           <a:ln/>
         </p:spPr>
         <p:txBody>
-          <a:bodyPr wrap="square" rtlCol="0"/>
+          <a:bodyPr wrap="square" rtlCol="0" anchor="ctr"/>
           <a:lstStyle/>
           <a:p>
             <a:pPr algn="l" indent="0" marL="0">
               <a:buNone/>
             </a:pPr>
             <a:r>
-              <a:rPr lang="en-US" sz="1600" b="1" dirty="0">
-                <a:solidFill>
-                  <a:schemeClr val="bg2"/>
-                </a:solidFill>
-              </a:rPr>
-              <a:t>TUTORIAL 5  ·  30.11.2026</a:t>
-            </a:r>
-            <a:endParaRPr lang="en-US" sz="1600" dirty="0"/>
-          </a:p>
-        </p:txBody>
-      </p:sp>
-      <p:sp>
-        <p:nvSpPr>
-          <p:cNvPr id="3" name="Text 0"/>
+              <a:rPr lang="en-US" sz="2600" b="1" dirty="0">
+                <a:solidFill>
+                  <a:schemeClr val="tx2"/>
+                </a:solidFill>
+              </a:rPr>
+              <a:t>The super loop: inputs, logic, services</a:t>
+            </a:r>
+            <a:endParaRPr lang="en-US" sz="2600" dirty="0"/>
+          </a:p>
+        </p:txBody>
+      </p:sp>
+      <p:sp>
+        <p:nvSpPr>
+          <p:cNvPr id="3" name="superloop box"/>
           <p:cNvSpPr/>
-          <p:nvPr>
-            <p:ph idx="101" type="title" hasCustomPrompt="1"/>
-          </p:nvPr>
+          <p:nvPr/>
         </p:nvSpPr>
         <p:spPr>
           <a:xfrm>
-            <a:off x="548640" y="1371600"/>
-            <a:ext cx="8046720" cy="1097280"/>
+            <a:off x="457200" y="1097280"/>
+            <a:ext cx="4572000" cy="2194560"/>
+          </a:xfrm>
+          <a:prstGeom prst="roundRect">
+            <a:avLst>
+              <a:gd name="adj" fmla="val 3333"/>
+            </a:avLst>
+          </a:prstGeom>
+          <a:solidFill>
+            <a:srgbClr val="F4F6F4"/>
+          </a:solidFill>
+          <a:ln w="9525">
+            <a:solidFill>
+              <a:srgbClr val="D5DDD6"/>
+            </a:solidFill>
+            <a:prstDash val="solid"/>
+          </a:ln>
+        </p:spPr>
+      </p:sp>
+      <p:sp>
+        <p:nvSpPr>
+          <p:cNvPr id="4" name="superloop code"/>
+          <p:cNvSpPr txBox="1"/>
+          <p:nvPr/>
+        </p:nvSpPr>
+        <p:spPr>
+          <a:xfrm>
+            <a:off x="594360" y="1188720"/>
+            <a:ext cx="4297680" cy="2011680"/>
           </a:xfrm>
           <a:prstGeom prst="rect">
             <a:avLst/>
@@ -6321,36 +6187,202 @@
           <a:ln/>
         </p:spPr>
         <p:txBody>
-          <a:bodyPr wrap="square" rtlCol="0" anchor="t"/>
+          <a:bodyPr wrap="square" lIns="0" tIns="0" rIns="0" bIns="0" rtlCol="0" anchor="t"/>
           <a:lstStyle/>
           <a:p>
-            <a:pPr algn="l" indent="0" marL="0">
+            <a:pPr indent="0" marL="0">
               <a:buNone/>
             </a:pPr>
             <a:r>
-              <a:rPr lang="en-US" sz="3600" b="1" dirty="0">
-                <a:solidFill>
-                  <a:schemeClr val="bg1"/>
-                </a:solidFill>
-              </a:rPr>
-              <a:t>Inside the I2C bus</a:t>
-            </a:r>
-            <a:endParaRPr lang="en-US" sz="3600" dirty="0"/>
-          </a:p>
-        </p:txBody>
-      </p:sp>
-      <p:sp>
-        <p:nvSpPr>
-          <p:cNvPr id="4" name="Text 0"/>
-          <p:cNvSpPr/>
-          <p:nvPr>
-            <p:ph idx="102" type="body" hasCustomPrompt="1"/>
-          </p:nvPr>
+              <a:rPr lang="en-US" sz="1100" dirty="0">
+                <a:solidFill>
+                  <a:srgbClr val="5C5C5C"/>
+                </a:solidFill>
+                <a:latin typeface="Courier New" pitchFamily="34" charset="0"/>
+                <a:ea typeface="Courier New" pitchFamily="34" charset="-122"/>
+                <a:cs typeface="Courier New" pitchFamily="34" charset="-120"/>
+              </a:rPr>
+              <a:t>while (1)</a:t>
+            </a:r>
+            <a:endParaRPr lang="en-US" sz="1100" dirty="0"/>
+          </a:p>
+          <a:p>
+            <a:pPr indent="0" marL="0">
+              <a:buNone/>
+            </a:pPr>
+            <a:r>
+              <a:rPr lang="en-US" sz="1100" dirty="0">
+                <a:solidFill>
+                  <a:srgbClr val="5C5C5C"/>
+                </a:solidFill>
+                <a:latin typeface="Courier New" pitchFamily="34" charset="0"/>
+                <a:ea typeface="Courier New" pitchFamily="34" charset="-122"/>
+                <a:cs typeface="Courier New" pitchFamily="34" charset="-120"/>
+              </a:rPr>
+              <a:t>{</a:t>
+            </a:r>
+            <a:endParaRPr lang="en-US" sz="1100" dirty="0"/>
+          </a:p>
+          <a:p>
+            <a:pPr indent="0" marL="0">
+              <a:buNone/>
+            </a:pPr>
+            <a:r>
+              <a:rPr lang="en-US" sz="1100" b="1" dirty="0">
+                <a:solidFill>
+                  <a:srgbClr val="1F6E43"/>
+                </a:solidFill>
+                <a:latin typeface="Courier New" pitchFamily="34" charset="0"/>
+                <a:ea typeface="Courier New" pitchFamily="34" charset="-122"/>
+                <a:cs typeface="Courier New" pitchFamily="34" charset="-120"/>
+              </a:rPr>
+              <a:t>  updateEncoders();      /* 1. inputs   */</a:t>
+            </a:r>
+            <a:endParaRPr lang="en-US" sz="1100" dirty="0"/>
+          </a:p>
+          <a:p>
+            <a:pPr indent="0" marL="0">
+              <a:buNone/>
+            </a:pPr>
+            <a:r>
+              <a:rPr lang="en-US" sz="1100" dirty="0">
+                <a:solidFill>
+                  <a:srgbClr val="5C5C5C"/>
+                </a:solidFill>
+                <a:latin typeface="Courier New" pitchFamily="34" charset="0"/>
+                <a:ea typeface="Courier New" pitchFamily="34" charset="-122"/>
+                <a:cs typeface="Courier New" pitchFamily="34" charset="-120"/>
+              </a:rPr>
+              <a:t>  updateIrSensor();</a:t>
+            </a:r>
+            <a:endParaRPr lang="en-US" sz="1100" dirty="0"/>
+          </a:p>
+          <a:p>
+            <a:pPr indent="0" marL="0">
+              <a:buNone/>
+            </a:pPr>
+            <a:endParaRPr lang="en-US" sz="1100" dirty="0"/>
+          </a:p>
+          <a:p>
+            <a:pPr indent="0" marL="0">
+              <a:buNone/>
+            </a:pPr>
+            <a:r>
+              <a:rPr lang="en-US" sz="1100" b="1" dirty="0">
+                <a:solidFill>
+                  <a:srgbClr val="1F6E43"/>
+                </a:solidFill>
+                <a:latin typeface="Courier New" pitchFamily="34" charset="0"/>
+                <a:ea typeface="Courier New" pitchFamily="34" charset="-122"/>
+                <a:cs typeface="Courier New" pitchFamily="34" charset="-120"/>
+              </a:rPr>
+              <a:t>  if (state != applied)  /* 2. logic    */</a:t>
+            </a:r>
+            <a:endParaRPr lang="en-US" sz="1100" dirty="0"/>
+          </a:p>
+          <a:p>
+            <a:pPr indent="0" marL="0">
+              <a:buNone/>
+            </a:pPr>
+            <a:r>
+              <a:rPr lang="en-US" sz="1100" dirty="0">
+                <a:solidFill>
+                  <a:srgbClr val="5C5C5C"/>
+                </a:solidFill>
+                <a:latin typeface="Courier New" pitchFamily="34" charset="0"/>
+                <a:ea typeface="Courier New" pitchFamily="34" charset="-122"/>
+                <a:cs typeface="Courier New" pitchFamily="34" charset="-120"/>
+              </a:rPr>
+              <a:t>    enterState(state);   /* once        */</a:t>
+            </a:r>
+            <a:endParaRPr lang="en-US" sz="1100" dirty="0"/>
+          </a:p>
+          <a:p>
+            <a:pPr indent="0" marL="0">
+              <a:buNone/>
+            </a:pPr>
+            <a:r>
+              <a:rPr lang="en-US" sz="1100" dirty="0">
+                <a:solidFill>
+                  <a:srgbClr val="5C5C5C"/>
+                </a:solidFill>
+                <a:latin typeface="Courier New" pitchFamily="34" charset="0"/>
+                <a:ea typeface="Courier New" pitchFamily="34" charset="-122"/>
+                <a:cs typeface="Courier New" pitchFamily="34" charset="-120"/>
+              </a:rPr>
+              <a:t>  runStateTick(applied); /* every pass  */</a:t>
+            </a:r>
+            <a:endParaRPr lang="en-US" sz="1100" dirty="0"/>
+          </a:p>
+          <a:p>
+            <a:pPr indent="0" marL="0">
+              <a:buNone/>
+            </a:pPr>
+            <a:endParaRPr lang="en-US" sz="1100" dirty="0"/>
+          </a:p>
+          <a:p>
+            <a:pPr indent="0" marL="0">
+              <a:buNone/>
+            </a:pPr>
+            <a:r>
+              <a:rPr lang="en-US" sz="1100" b="1" dirty="0">
+                <a:solidFill>
+                  <a:srgbClr val="1F6E43"/>
+                </a:solidFill>
+                <a:latin typeface="Courier New" pitchFamily="34" charset="0"/>
+                <a:ea typeface="Courier New" pitchFamily="34" charset="-122"/>
+                <a:cs typeface="Courier New" pitchFamily="34" charset="-120"/>
+              </a:rPr>
+              <a:t>  serviceRgbOutputs();   /* 3. services */</a:t>
+            </a:r>
+            <a:endParaRPr lang="en-US" sz="1100" dirty="0"/>
+          </a:p>
+          <a:p>
+            <a:pPr indent="0" marL="0">
+              <a:buNone/>
+            </a:pPr>
+            <a:r>
+              <a:rPr lang="en-US" sz="1100" dirty="0">
+                <a:solidFill>
+                  <a:srgbClr val="5C5C5C"/>
+                </a:solidFill>
+                <a:latin typeface="Courier New" pitchFamily="34" charset="0"/>
+                <a:ea typeface="Courier New" pitchFamily="34" charset="-122"/>
+                <a:cs typeface="Courier New" pitchFamily="34" charset="-120"/>
+              </a:rPr>
+              <a:t>  printPeriodicStatus();</a:t>
+            </a:r>
+            <a:endParaRPr lang="en-US" sz="1100" dirty="0"/>
+          </a:p>
+          <a:p>
+            <a:pPr indent="0" marL="0">
+              <a:buNone/>
+            </a:pPr>
+            <a:r>
+              <a:rPr lang="en-US" sz="1100" dirty="0">
+                <a:solidFill>
+                  <a:srgbClr val="5C5C5C"/>
+                </a:solidFill>
+                <a:latin typeface="Courier New" pitchFamily="34" charset="0"/>
+                <a:ea typeface="Courier New" pitchFamily="34" charset="-122"/>
+                <a:cs typeface="Courier New" pitchFamily="34" charset="-120"/>
+              </a:rPr>
+              <a:t>}</a:t>
+            </a:r>
+            <a:endParaRPr lang="en-US" sz="1100" dirty="0"/>
+          </a:p>
+        </p:txBody>
+      </p:sp>
+      <p:sp>
+        <p:nvSpPr>
+          <p:cNvPr id="5" name="superloop bullets"/>
+          <p:cNvSpPr txBox="1"/>
+          <p:nvPr/>
         </p:nvSpPr>
         <p:spPr>
           <a:xfrm>
-            <a:off x="548640" y="2743200"/>
-            <a:ext cx="8046720" cy="1737360"/>
+            <a:off x="5303520" y="1097280"/>
+            <a:ext cx="3383280" cy="3291840"/>
           </a:xfrm>
           <a:prstGeom prst="rect">
             <a:avLst/>
@@ -6362,18 +6394,76 @@
           <a:bodyPr wrap="square" rtlCol="0" anchor="t"/>
           <a:lstStyle/>
           <a:p>
-            <a:pPr algn="l" indent="0" marL="0">
-              <a:buNone/>
-            </a:pPr>
-            <a:r>
-              <a:rPr lang="en-US" sz="1600" dirty="0">
-                <a:solidFill>
-                  <a:schemeClr val="bg1"/>
-                </a:solidFill>
-              </a:rPr>
-              <a:t>I2C bus scan: detect the five IO-board chips; set_rgb rewritten on raw HAL_I2C_Mem_Write; servo sweep.</a:t>
-            </a:r>
-            <a:endParaRPr lang="en-US" sz="1600" dirty="0"/>
+            <a:pPr marL="342900" indent="-342900">
+              <a:spcAft>
+                <a:spcPts val="800"/>
+              </a:spcAft>
+              <a:buSzPct val="100000"/>
+              <a:buChar char="•"/>
+            </a:pPr>
+            <a:r>
+              <a:rPr lang="en-US" sz="1500" dirty="0">
+                <a:solidFill>
+                  <a:srgbClr val="000000"/>
+                </a:solidFill>
+              </a:rPr>
+              <a:t>Keep every pass short, so polled inputs stay responsive.</a:t>
+            </a:r>
+            <a:endParaRPr lang="en-US" sz="1500" dirty="0"/>
+          </a:p>
+          <a:p>
+            <a:pPr marL="342900" indent="-342900">
+              <a:spcAft>
+                <a:spcPts val="800"/>
+              </a:spcAft>
+              <a:buSzPct val="100000"/>
+              <a:buChar char="•"/>
+            </a:pPr>
+            <a:r>
+              <a:rPr lang="en-US" sz="1500" dirty="0">
+                <a:solidFill>
+                  <a:srgbClr val="000000"/>
+                </a:solidFill>
+              </a:rPr>
+              <a:t>runStateTick: what the current state wants.</a:t>
+            </a:r>
+            <a:endParaRPr lang="en-US" sz="1500" dirty="0"/>
+          </a:p>
+          <a:p>
+            <a:pPr marL="342900" indent="-342900">
+              <a:spcAft>
+                <a:spcPts val="800"/>
+              </a:spcAft>
+              <a:buSzPct val="100000"/>
+              <a:buChar char="•"/>
+            </a:pPr>
+            <a:r>
+              <a:rPr lang="en-US" sz="1500" dirty="0">
+                <a:solidFill>
+                  <a:srgbClr val="000000"/>
+                </a:solidFill>
+              </a:rPr>
+              <a:t>Services: make the hardware match, in every state.</a:t>
+            </a:r>
+            <a:endParaRPr lang="en-US" sz="1500" dirty="0"/>
+          </a:p>
+          <a:p>
+            <a:pPr marL="342900" indent="-342900">
+              <a:spcAft>
+                <a:spcPts val="800"/>
+              </a:spcAft>
+              <a:buSzPct val="100000"/>
+              <a:buChar char="•"/>
+            </a:pPr>
+            <a:r>
+              <a:rPr lang="en-US" sz="1500" dirty="0">
+                <a:solidFill>
+                  <a:srgbClr val="B23A48"/>
+                </a:solidFill>
+              </a:rPr>
+              <a:t>Calling a service from inside one state's case would freeze that output in all other states.</a:t>
+            </a:r>
+            <a:endParaRPr lang="en-US" sz="1500" dirty="0"/>
           </a:p>
         </p:txBody>
       </p:sp>
@@ -6407,7 +6497,7 @@
             <a:lvl1pPr>
               <a:defRPr sz="1000">
                 <a:solidFill>
-                  <a:schemeClr val="bg2"/>
+                  <a:schemeClr val="tx2"/>
                 </a:solidFill>
               </a:defRPr>
             </a:lvl1pPr>
@@ -6479,7 +6569,7 @@
                   <a:schemeClr val="bg2"/>
                 </a:solidFill>
               </a:rPr>
-              <a:t>TUTORIAL 6  ·  7.12.2026</a:t>
+              <a:t>TUTORIAL 5  ·  30.11.2026</a:t>
             </a:r>
             <a:endParaRPr lang="en-US" sz="1600" dirty="0"/>
           </a:p>
@@ -6517,7 +6607,7 @@
                   <a:schemeClr val="bg1"/>
                 </a:solidFill>
               </a:rPr>
-              <a:t>PWM, input capture and EXTI</a:t>
+              <a:t>Inside the I2C bus</a:t>
             </a:r>
             <a:endParaRPr lang="en-US" sz="3600" dirty="0"/>
           </a:p>
@@ -6555,7 +6645,7 @@
                   <a:schemeClr val="bg1"/>
                 </a:solidFill>
               </a:rPr>
-              <a:t>One ultrasonic distance measurement; an EXTI interrupt with a counter; PWM on one motor channel.</a:t>
+              <a:t>I2C bus scan: detect the five IO-board chips; set_rgb rewritten on raw HAL_I2C_Mem_Write; servo sweep.</a:t>
             </a:r>
             <a:endParaRPr lang="en-US" sz="1600" dirty="0"/>
           </a:p>
@@ -6663,7 +6753,7 @@
                   <a:schemeClr val="bg2"/>
                 </a:solidFill>
               </a:rPr>
-              <a:t>TUTORIAL 7  ·  14.12.2026</a:t>
+              <a:t>TUTORIAL 6  ·  7.12.2026</a:t>
             </a:r>
             <a:endParaRPr lang="en-US" sz="1600" dirty="0"/>
           </a:p>
@@ -6701,7 +6791,7 @@
                   <a:schemeClr val="bg1"/>
                 </a:solidFill>
               </a:rPr>
-              <a:t>One wheel in the air</a:t>
+              <a:t>PWM, input capture and EXTI</a:t>
             </a:r>
             <a:endParaRPr lang="en-US" sz="3600" dirty="0"/>
           </a:p>
@@ -6739,7 +6829,7 @@
                   <a:schemeClr val="bg1"/>
                 </a:solidFill>
               </a:rPr>
-              <a:t>Open-loop PWM; encoder counts to rad/s; record a run and export it to MATLAB.</a:t>
+              <a:t>One ultrasonic distance measurement; an EXTI interrupt with a counter; PWM on one motor channel.</a:t>
             </a:r>
             <a:endParaRPr lang="en-US" sz="1600" dirty="0"/>
           </a:p>
@@ -6847,7 +6937,7 @@
                   <a:schemeClr val="bg2"/>
                 </a:solidFill>
               </a:rPr>
-              <a:t>TUTORIAL 8  ·  21.12.2026</a:t>
+              <a:t>TUTORIAL 7  ·  14.12.2026</a:t>
             </a:r>
             <a:endParaRPr lang="en-US" sz="1600" dirty="0"/>
           </a:p>
@@ -6885,7 +6975,7 @@
                   <a:schemeClr val="bg1"/>
                 </a:solidFill>
               </a:rPr>
-              <a:t>From model to PI controller</a:t>
+              <a:t>One wheel in the air</a:t>
             </a:r>
             <a:endParaRPr lang="en-US" sz="3600" dirty="0"/>
           </a:p>
@@ -6923,7 +7013,7 @@
                   <a:schemeClr val="bg1"/>
                 </a:solidFill>
               </a:rPr>
-              <a:t>Model fit, sisotool, c2d; the difference equation in C; simulated vs. measured step response.</a:t>
+              <a:t>Open-loop PWM; encoder counts to rad/s; record a run and export it to MATLAB.</a:t>
             </a:r>
             <a:endParaRPr lang="en-US" sz="1600" dirty="0"/>
           </a:p>
@@ -7215,7 +7305,7 @@
                   <a:schemeClr val="bg2"/>
                 </a:solidFill>
               </a:rPr>
-              <a:t>TUTORIAL 9  ·  28.12.2026</a:t>
+              <a:t>TUTORIAL 8  ·  21.12.2026</a:t>
             </a:r>
             <a:endParaRPr lang="en-US" sz="1600" dirty="0"/>
           </a:p>
@@ -7253,7 +7343,7 @@
                   <a:schemeClr val="bg1"/>
                 </a:solidFill>
               </a:rPr>
-              <a:t>UART commands and a MATLAB GUI</a:t>
+              <a:t>From model to PI controller</a:t>
             </a:r>
             <a:endParaRPr lang="en-US" sz="3600" dirty="0"/>
           </a:p>
@@ -7291,7 +7381,7 @@
                   <a:schemeClr val="bg1"/>
                 </a:solidFill>
               </a:rPr>
-              <a:t>An interrupt-driven UART command parser; a minimal MATLAB GUI that sends commands and plots telemetry.</a:t>
+              <a:t>Model fit, sisotool, c2d; the difference equation in C; simulated vs. measured step response.</a:t>
             </a:r>
             <a:endParaRPr lang="en-US" sz="1600" dirty="0"/>
           </a:p>
@@ -7399,7 +7489,7 @@
                   <a:schemeClr val="bg2"/>
                 </a:solidFill>
               </a:rPr>
-              <a:t>TUTORIAL 10  ·  4.1.2027</a:t>
+              <a:t>TUTORIAL 9  ·  28.12.2026</a:t>
             </a:r>
             <a:endParaRPr lang="en-US" sz="1600" dirty="0"/>
           </a:p>
@@ -7437,7 +7527,7 @@
                   <a:schemeClr val="bg1"/>
                 </a:solidFill>
               </a:rPr>
-              <a:t>Driving the cart</a:t>
+              <a:t>UART commands and a MATLAB GUI</a:t>
             </a:r>
             <a:endParaRPr lang="en-US" sz="3600" dirty="0"/>
           </a:p>
@@ -7475,7 +7565,7 @@
                   <a:schemeClr val="bg1"/>
                 </a:solidFill>
               </a:rPr>
-              <a:t>Kinematics exercises; driving on the floor; a trajectory array generated in MATLAB and sent to the cart.</a:t>
+              <a:t>An interrupt-driven UART command parser; a minimal MATLAB GUI that sends commands and plots telemetry.</a:t>
             </a:r>
             <a:endParaRPr lang="en-US" sz="1600" dirty="0"/>
           </a:p>
@@ -7583,7 +7673,7 @@
                   <a:schemeClr val="bg2"/>
                 </a:solidFill>
               </a:rPr>
-              <a:t>TUTORIAL 11  ·  11.1.2027</a:t>
+              <a:t>TUTORIAL 10  ·  4.1.2027</a:t>
             </a:r>
             <a:endParaRPr lang="en-US" sz="1600" dirty="0"/>
           </a:p>
@@ -7621,7 +7711,7 @@
                   <a:schemeClr val="bg1"/>
                 </a:solidFill>
               </a:rPr>
-              <a:t>Simulink to C</a:t>
+              <a:t>Driving the cart</a:t>
             </a:r>
             <a:endParaRPr lang="en-US" sz="3600" dirty="0"/>
           </a:p>
@@ -7659,7 +7749,7 @@
                   <a:schemeClr val="bg1"/>
                 </a:solidFill>
               </a:rPr>
-              <a:t>Export a Simulink PI controller or filter to C and run it on the cart.</a:t>
+              <a:t>Kinematics exercises; driving on the floor; a trajectory array generated in MATLAB and sent to the cart.</a:t>
             </a:r>
             <a:endParaRPr lang="en-US" sz="1600" dirty="0"/>
           </a:p>
@@ -7767,7 +7857,7 @@
                   <a:schemeClr val="bg2"/>
                 </a:solidFill>
               </a:rPr>
-              <a:t>TUTORIAL 12  ·  18.1.2027</a:t>
+              <a:t>TUTORIAL 11  ·  11.1.2027</a:t>
             </a:r>
             <a:endParaRPr lang="en-US" sz="1600" dirty="0"/>
           </a:p>
@@ -7805,7 +7895,7 @@
                   <a:schemeClr val="bg1"/>
                 </a:solidFill>
               </a:rPr>
-              <a:t>Project clinic</a:t>
+              <a:t>Simulink to C</a:t>
             </a:r>
             <a:endParaRPr lang="en-US" sz="3600" dirty="0"/>
           </a:p>
@@ -7843,7 +7933,7 @@
                   <a:schemeClr val="bg1"/>
                 </a:solidFill>
               </a:rPr>
-              <a:t>Open session for Assignment 3 questions.</a:t>
+              <a:t>Export a Simulink PI controller or filter to C and run it on the cart.</a:t>
             </a:r>
             <a:endParaRPr lang="en-US" sz="1600" dirty="0"/>
           </a:p>
@@ -7951,7 +8041,7 @@
                   <a:schemeClr val="bg2"/>
                 </a:solidFill>
               </a:rPr>
-              <a:t>SESSION 13  ·  25.1.2027</a:t>
+              <a:t>TUTORIAL 12  ·  18.1.2027</a:t>
             </a:r>
             <a:endParaRPr lang="en-US" sz="1600" dirty="0"/>
           </a:p>
@@ -7989,7 +8079,7 @@
                   <a:schemeClr val="bg1"/>
                 </a:solidFill>
               </a:rPr>
-              <a:t>Lab meeting</a:t>
+              <a:t>Project clinic</a:t>
             </a:r>
             <a:endParaRPr lang="en-US" sz="3600" dirty="0"/>
           </a:p>
@@ -8027,7 +8117,7 @@
                   <a:schemeClr val="bg1"/>
                 </a:solidFill>
               </a:rPr>
-              <a:t>Open questions.</a:t>
+              <a:t>Open session for Assignment 3 questions.</a:t>
             </a:r>
             <a:endParaRPr lang="en-US" sz="1600" dirty="0"/>
           </a:p>
@@ -8073,6 +8163,190 @@
             <a:fld id="{F7021451-1387-4CA6-816F-3879F97B5CBC}" type="slidenum">
               <a:rPr b="0" lang="en-US"/>
               <a:t>24</a:t>
+            </a:fld>
+            <a:endParaRPr lang="en-US"/>
+          </a:p>
+        </p:txBody>
+      </p:sp>
+    </p:spTree>
+  </p:cSld>
+  <p:clrMapOvr>
+    <a:masterClrMapping/>
+  </p:clrMapOvr>
+</p:sld>
+</file>
+
+<file path=ppt/slides/slide25.xml><?xml version="1.0" encoding="utf-8"?>
+<p:sld xmlns:a="http://schemas.openxmlformats.org/drawingml/2006/main" xmlns:r="http://schemas.openxmlformats.org/officeDocument/2006/relationships" xmlns:p="http://schemas.openxmlformats.org/presentationml/2006/main">
+  <p:cSld name="Slide 25">
+    <p:spTree>
+      <p:nvGrpSpPr>
+        <p:cNvPr id="1" name=""/>
+        <p:cNvGrpSpPr/>
+        <p:nvPr/>
+      </p:nvGrpSpPr>
+      <p:grpSpPr>
+        <a:xfrm>
+          <a:off x="0" y="0"/>
+          <a:ext cx="0" cy="0"/>
+          <a:chOff x="0" y="0"/>
+          <a:chExt cx="0" cy="0"/>
+        </a:xfrm>
+      </p:grpSpPr>
+      <p:sp>
+        <p:nvSpPr>
+          <p:cNvPr id="2" name="Text 0"/>
+          <p:cNvSpPr/>
+          <p:nvPr>
+            <p:ph idx="100" type="body" hasCustomPrompt="1"/>
+          </p:nvPr>
+        </p:nvSpPr>
+        <p:spPr>
+          <a:xfrm>
+            <a:off x="548640" y="914400"/>
+            <a:ext cx="8046720" cy="457200"/>
+          </a:xfrm>
+          <a:prstGeom prst="rect">
+            <a:avLst/>
+          </a:prstGeom>
+          <a:noFill/>
+          <a:ln/>
+        </p:spPr>
+        <p:txBody>
+          <a:bodyPr wrap="square" rtlCol="0"/>
+          <a:lstStyle/>
+          <a:p>
+            <a:pPr algn="l" indent="0" marL="0">
+              <a:buNone/>
+            </a:pPr>
+            <a:r>
+              <a:rPr lang="en-US" sz="1600" b="1" dirty="0">
+                <a:solidFill>
+                  <a:schemeClr val="bg2"/>
+                </a:solidFill>
+              </a:rPr>
+              <a:t>SESSION 13  ·  25.1.2027</a:t>
+            </a:r>
+            <a:endParaRPr lang="en-US" sz="1600" dirty="0"/>
+          </a:p>
+        </p:txBody>
+      </p:sp>
+      <p:sp>
+        <p:nvSpPr>
+          <p:cNvPr id="3" name="Text 0"/>
+          <p:cNvSpPr/>
+          <p:nvPr>
+            <p:ph idx="101" type="title" hasCustomPrompt="1"/>
+          </p:nvPr>
+        </p:nvSpPr>
+        <p:spPr>
+          <a:xfrm>
+            <a:off x="548640" y="1371600"/>
+            <a:ext cx="8046720" cy="1097280"/>
+          </a:xfrm>
+          <a:prstGeom prst="rect">
+            <a:avLst/>
+          </a:prstGeom>
+          <a:noFill/>
+          <a:ln/>
+        </p:spPr>
+        <p:txBody>
+          <a:bodyPr wrap="square" rtlCol="0" anchor="t"/>
+          <a:lstStyle/>
+          <a:p>
+            <a:pPr algn="l" indent="0" marL="0">
+              <a:buNone/>
+            </a:pPr>
+            <a:r>
+              <a:rPr lang="en-US" sz="3600" b="1" dirty="0">
+                <a:solidFill>
+                  <a:schemeClr val="bg1"/>
+                </a:solidFill>
+              </a:rPr>
+              <a:t>Lab meeting</a:t>
+            </a:r>
+            <a:endParaRPr lang="en-US" sz="3600" dirty="0"/>
+          </a:p>
+        </p:txBody>
+      </p:sp>
+      <p:sp>
+        <p:nvSpPr>
+          <p:cNvPr id="4" name="Text 0"/>
+          <p:cNvSpPr/>
+          <p:nvPr>
+            <p:ph idx="102" type="body" hasCustomPrompt="1"/>
+          </p:nvPr>
+        </p:nvSpPr>
+        <p:spPr>
+          <a:xfrm>
+            <a:off x="548640" y="2743200"/>
+            <a:ext cx="8046720" cy="1737360"/>
+          </a:xfrm>
+          <a:prstGeom prst="rect">
+            <a:avLst/>
+          </a:prstGeom>
+          <a:noFill/>
+          <a:ln/>
+        </p:spPr>
+        <p:txBody>
+          <a:bodyPr wrap="square" rtlCol="0" anchor="t"/>
+          <a:lstStyle/>
+          <a:p>
+            <a:pPr algn="l" indent="0" marL="0">
+              <a:buNone/>
+            </a:pPr>
+            <a:r>
+              <a:rPr lang="en-US" sz="1600" dirty="0">
+                <a:solidFill>
+                  <a:schemeClr val="bg1"/>
+                </a:solidFill>
+              </a:rPr>
+              <a:t>Open questions.</a:t>
+            </a:r>
+            <a:endParaRPr lang="en-US" sz="1600" dirty="0"/>
+          </a:p>
+        </p:txBody>
+      </p:sp>
+      <p:sp>
+        <p:nvSpPr>
+          <p:cNvPr id="25" name="Slide Number Placeholder 0"/>
+          <p:cNvSpPr>
+            <a:spLocks noGrp="1"/>
+          </p:cNvSpPr>
+          <p:nvPr>
+            <p:ph type="sldNum" sz="quarter" idx="4294967295"/>
+          </p:nvPr>
+        </p:nvSpPr>
+        <p:spPr>
+          <a:xfrm>
+            <a:off x="8412480" y="4754880"/>
+            <a:ext cx="800000" cy="300000"/>
+          </a:xfrm>
+          <a:prstGeom prst="rect">
+            <a:avLst/>
+          </a:prstGeom>
+          <a:extLst>
+            <a:ext uri="{C572A759-6A51-4108-AA02-DFA0A04FC94B}">
+              <ma14:wrappingTextBoxFlag xmlns:ma14="http://schemas.microsoft.com/office/mac/drawingml/2011/main" val="0"/>
+            </a:ext>
+          </a:extLst>
+        </p:spPr>
+        <p:txBody>
+          <a:bodyPr/>
+          <a:lstStyle>
+            <a:lvl1pPr>
+              <a:defRPr sz="1000">
+                <a:solidFill>
+                  <a:schemeClr val="bg2"/>
+                </a:solidFill>
+              </a:defRPr>
+            </a:lvl1pPr>
+          </a:lstStyle>
+          <a:p>
+            <a:pPr algn="l"/>
+            <a:fld id="{F7021451-1387-4CA6-816F-3879F97B5CBC}" type="slidenum">
+              <a:rPr b="0" lang="en-US"/>
+              <a:t>25</a:t>
             </a:fld>
             <a:endParaRPr lang="en-US"/>
           </a:p>
@@ -12706,7 +12980,7 @@
                   <a:schemeClr val="tx2"/>
                 </a:solidFill>
               </a:rPr>
-              <a:t>The same rule in the other generated files</a:t>
+              <a:t>Header (.h) and source (.c): the same idea across files</a:t>
             </a:r>
             <a:endParaRPr lang="en-US" sz="2600" dirty="0"/>
           </a:p>
@@ -12714,18 +12988,18 @@
       </p:sp>
       <p:sp>
         <p:nvSpPr>
-          <p:cNvPr id="3" name="card 1"/>
+          <p:cNvPr id="3" name="file card 1"/>
           <p:cNvSpPr/>
           <p:nvPr/>
         </p:nvSpPr>
         <p:spPr>
           <a:xfrm>
-            <a:off x="457200" y="1143000"/>
-            <a:ext cx="2606040" cy="2377440"/>
+            <a:off x="457200" y="1097280"/>
+            <a:ext cx="3977640" cy="2011680"/>
           </a:xfrm>
           <a:prstGeom prst="roundRect">
             <a:avLst>
-              <a:gd name="adj" fmla="val 3846"/>
+              <a:gd name="adj" fmla="val 4545"/>
             </a:avLst>
           </a:prstGeom>
           <a:solidFill>
@@ -12741,14 +13015,14 @@
       </p:sp>
       <p:sp>
         <p:nvSpPr>
-          <p:cNvPr id="4" name="card 1 title"/>
+          <p:cNvPr id="4" name="file card 1 title"/>
           <p:cNvSpPr txBox="1"/>
           <p:nvPr/>
         </p:nvSpPr>
         <p:spPr>
           <a:xfrm>
-            <a:off x="640080" y="1280160"/>
-            <a:ext cx="2240280" cy="457200"/>
+            <a:off x="640080" y="1188720"/>
+            <a:ext cx="3611880" cy="365760"/>
           </a:xfrm>
           <a:prstGeom prst="rect">
             <a:avLst/>
@@ -12772,7 +13046,7 @@
                 <a:ea typeface="Courier New" pitchFamily="34" charset="-122"/>
                 <a:cs typeface="Courier New" pitchFamily="34" charset="-120"/>
               </a:rPr>
-              <a:t>main.h</a:t>
+              <a:t>io_board.h</a:t>
             </a:r>
             <a:endParaRPr lang="en-US" sz="1600" dirty="0"/>
           </a:p>
@@ -12780,14 +13054,14 @@
       </p:sp>
       <p:sp>
         <p:nvSpPr>
-          <p:cNvPr id="5" name="card 1 text"/>
+          <p:cNvPr id="5" name="file card 1 sub"/>
           <p:cNvSpPr txBox="1"/>
           <p:nvPr/>
         </p:nvSpPr>
         <p:spPr>
           <a:xfrm>
-            <a:off x="640080" y="1783080"/>
-            <a:ext cx="2240280" cy="1645920"/>
+            <a:off x="640080" y="1554480"/>
+            <a:ext cx="3611880" cy="320040"/>
           </a:xfrm>
           <a:prstGeom prst="rect">
             <a:avLst/>
@@ -12796,6 +13070,42 @@
           <a:ln/>
         </p:spPr>
         <p:txBody>
+          <a:bodyPr wrap="square" lIns="0" tIns="0" rIns="0" bIns="0" rtlCol="0" anchor="ctr"/>
+          <a:lstStyle/>
+          <a:p>
+            <a:pPr indent="0" marL="0">
+              <a:buNone/>
+            </a:pPr>
+            <a:r>
+              <a:rPr lang="en-US" sz="1300" i="1" dirty="0">
+                <a:solidFill>
+                  <a:srgbClr val="5C5C5C"/>
+                </a:solidFill>
+              </a:rPr>
+              <a:t>Declarations: what exists, how to call it</a:t>
+            </a:r>
+            <a:endParaRPr lang="en-US" sz="1300" dirty="0"/>
+          </a:p>
+        </p:txBody>
+      </p:sp>
+      <p:sp>
+        <p:nvSpPr>
+          <p:cNvPr id="6" name="file card 1 code"/>
+          <p:cNvSpPr txBox="1"/>
+          <p:nvPr/>
+        </p:nvSpPr>
+        <p:spPr>
+          <a:xfrm>
+            <a:off x="640080" y="1920240"/>
+            <a:ext cx="3611880" cy="1097280"/>
+          </a:xfrm>
+          <a:prstGeom prst="rect">
+            <a:avLst/>
+          </a:prstGeom>
+          <a:noFill/>
+          <a:ln/>
+        </p:spPr>
+        <p:txBody>
           <a:bodyPr wrap="square" lIns="0" tIns="0" rIns="0" bIns="0" rtlCol="0" anchor="t"/>
           <a:lstStyle/>
           <a:p>
@@ -12803,31 +13113,51 @@
               <a:buNone/>
             </a:pPr>
             <a:r>
-              <a:rPr lang="en-US" sz="1400" dirty="0">
-                <a:solidFill>
-                  <a:srgbClr val="1C1C1C"/>
-                </a:solidFill>
-              </a:rPr>
-              <a:t>Includes, ET (exported types), EC (constants), EM (macros), EFP (function prototypes), Private defines. Things other .c files need to see.</a:t>
-            </a:r>
-            <a:endParaRPr lang="en-US" sz="1400" dirty="0"/>
-          </a:p>
-        </p:txBody>
-      </p:sp>
-      <p:sp>
-        <p:nvSpPr>
-          <p:cNvPr id="6" name="card 2"/>
+              <a:rPr lang="en-US" sz="1100" dirty="0">
+                <a:solidFill>
+                  <a:srgbClr val="123524"/>
+                </a:solidFill>
+                <a:latin typeface="Courier New" pitchFamily="34" charset="0"/>
+                <a:ea typeface="Courier New" pitchFamily="34" charset="-122"/>
+                <a:cs typeface="Courier New" pitchFamily="34" charset="-120"/>
+              </a:rPr>
+              <a:t>uint8_t readButtonsRaw(void);</a:t>
+            </a:r>
+            <a:endParaRPr lang="en-US" sz="1100" dirty="0"/>
+          </a:p>
+          <a:p>
+            <a:pPr indent="0" marL="0">
+              <a:buNone/>
+            </a:pPr>
+            <a:r>
+              <a:rPr lang="en-US" sz="1100" dirty="0">
+                <a:solidFill>
+                  <a:srgbClr val="123524"/>
+                </a:solidFill>
+                <a:latin typeface="Courier New" pitchFamily="34" charset="0"/>
+                <a:ea typeface="Courier New" pitchFamily="34" charset="-122"/>
+                <a:cs typeface="Courier New" pitchFamily="34" charset="-120"/>
+              </a:rPr>
+              <a:t>void    allRgbOff(void);</a:t>
+            </a:r>
+            <a:endParaRPr lang="en-US" sz="1100" dirty="0"/>
+          </a:p>
+        </p:txBody>
+      </p:sp>
+      <p:sp>
+        <p:nvSpPr>
+          <p:cNvPr id="7" name="file card 2"/>
           <p:cNvSpPr/>
           <p:nvPr/>
         </p:nvSpPr>
         <p:spPr>
           <a:xfrm>
-            <a:off x="3246120" y="1143000"/>
-            <a:ext cx="2606040" cy="2377440"/>
+            <a:off x="4709160" y="1097280"/>
+            <a:ext cx="3977640" cy="2011680"/>
           </a:xfrm>
           <a:prstGeom prst="roundRect">
             <a:avLst>
-              <a:gd name="adj" fmla="val 3846"/>
+              <a:gd name="adj" fmla="val 4545"/>
             </a:avLst>
           </a:prstGeom>
           <a:solidFill>
@@ -12843,14 +13173,14 @@
       </p:sp>
       <p:sp>
         <p:nvSpPr>
-          <p:cNvPr id="7" name="card 2 title"/>
+          <p:cNvPr id="8" name="file card 2 title"/>
           <p:cNvSpPr txBox="1"/>
           <p:nvPr/>
         </p:nvSpPr>
         <p:spPr>
           <a:xfrm>
-            <a:off x="3429000" y="1280160"/>
-            <a:ext cx="2240280" cy="457200"/>
+            <a:off x="4892040" y="1188720"/>
+            <a:ext cx="3611880" cy="365760"/>
           </a:xfrm>
           <a:prstGeom prst="rect">
             <a:avLst/>
@@ -12874,7 +13204,7 @@
                 <a:ea typeface="Courier New" pitchFamily="34" charset="-122"/>
                 <a:cs typeface="Courier New" pitchFamily="34" charset="-120"/>
               </a:rPr>
-              <a:t>stm32g4xx_it.c</a:t>
+              <a:t>io_board.c</a:t>
             </a:r>
             <a:endParaRPr lang="en-US" sz="1600" dirty="0"/>
           </a:p>
@@ -12882,14 +13212,14 @@
       </p:sp>
       <p:sp>
         <p:nvSpPr>
-          <p:cNvPr id="8" name="card 2 text"/>
+          <p:cNvPr id="9" name="file card 2 sub"/>
           <p:cNvSpPr txBox="1"/>
           <p:nvPr/>
         </p:nvSpPr>
         <p:spPr>
           <a:xfrm>
-            <a:off x="3429000" y="1783080"/>
-            <a:ext cx="2240280" cy="1645920"/>
+            <a:off x="4892040" y="1554480"/>
+            <a:ext cx="3611880" cy="320040"/>
           </a:xfrm>
           <a:prstGeom prst="rect">
             <a:avLst/>
@@ -12898,61 +13228,34 @@
           <a:ln/>
         </p:spPr>
         <p:txBody>
-          <a:bodyPr wrap="square" lIns="0" tIns="0" rIns="0" bIns="0" rtlCol="0" anchor="t"/>
+          <a:bodyPr wrap="square" lIns="0" tIns="0" rIns="0" bIns="0" rtlCol="0" anchor="ctr"/>
           <a:lstStyle/>
           <a:p>
             <a:pPr indent="0" marL="0">
               <a:buNone/>
             </a:pPr>
             <a:r>
-              <a:rPr lang="en-US" sz="1400" dirty="0">
-                <a:solidFill>
-                  <a:srgbClr val="1C1C1C"/>
-                </a:solidFill>
-              </a:rPr>
-              <a:t>Interrupt handlers. Each has sections 0 (before the HAL handler) and 1 (after it). Usually leave them alone and use the HAL callbacks.</a:t>
-            </a:r>
-            <a:endParaRPr lang="en-US" sz="1400" dirty="0"/>
-          </a:p>
-        </p:txBody>
-      </p:sp>
-      <p:sp>
-        <p:nvSpPr>
-          <p:cNvPr id="9" name="card 3"/>
-          <p:cNvSpPr/>
+              <a:rPr lang="en-US" sz="1300" i="1" dirty="0">
+                <a:solidFill>
+                  <a:srgbClr val="5C5C5C"/>
+                </a:solidFill>
+              </a:rPr>
+              <a:t>Definitions: the code itself</a:t>
+            </a:r>
+            <a:endParaRPr lang="en-US" sz="1300" dirty="0"/>
+          </a:p>
+        </p:txBody>
+      </p:sp>
+      <p:sp>
+        <p:nvSpPr>
+          <p:cNvPr id="10" name="file card 2 code"/>
+          <p:cNvSpPr txBox="1"/>
           <p:nvPr/>
         </p:nvSpPr>
         <p:spPr>
           <a:xfrm>
-            <a:off x="6035040" y="1143000"/>
-            <a:ext cx="2606040" cy="2377440"/>
-          </a:xfrm>
-          <a:prstGeom prst="roundRect">
-            <a:avLst>
-              <a:gd name="adj" fmla="val 3846"/>
-            </a:avLst>
-          </a:prstGeom>
-          <a:solidFill>
-            <a:srgbClr val="EEF3EF"/>
-          </a:solidFill>
-          <a:ln w="12700">
-            <a:solidFill>
-              <a:srgbClr val="EEF3EF"/>
-            </a:solidFill>
-            <a:prstDash val="solid"/>
-          </a:ln>
-        </p:spPr>
-      </p:sp>
-      <p:sp>
-        <p:nvSpPr>
-          <p:cNvPr id="10" name="card 3 title"/>
-          <p:cNvSpPr txBox="1"/>
-          <p:nvPr/>
-        </p:nvSpPr>
-        <p:spPr>
-          <a:xfrm>
-            <a:off x="6217920" y="1280160"/>
-            <a:ext cx="2240280" cy="457200"/>
+            <a:off x="4892040" y="1920240"/>
+            <a:ext cx="3611880" cy="1097280"/>
           </a:xfrm>
           <a:prstGeom prst="rect">
             <a:avLst/>
@@ -12961,37 +13264,88 @@
           <a:ln/>
         </p:spPr>
         <p:txBody>
-          <a:bodyPr wrap="square" lIns="0" tIns="0" rIns="0" bIns="0" rtlCol="0" anchor="ctr"/>
+          <a:bodyPr wrap="square" lIns="0" tIns="0" rIns="0" bIns="0" rtlCol="0" anchor="t"/>
           <a:lstStyle/>
           <a:p>
             <a:pPr indent="0" marL="0">
               <a:buNone/>
             </a:pPr>
             <a:r>
-              <a:rPr lang="en-US" sz="1600" b="1" dirty="0">
-                <a:solidFill>
-                  <a:srgbClr val="1F6E43"/>
+              <a:rPr lang="en-US" sz="1100" dirty="0">
+                <a:solidFill>
+                  <a:srgbClr val="123524"/>
                 </a:solidFill>
                 <a:latin typeface="Courier New" pitchFamily="34" charset="0"/>
                 <a:ea typeface="Courier New" pitchFamily="34" charset="-122"/>
                 <a:cs typeface="Courier New" pitchFamily="34" charset="-120"/>
               </a:rPr>
-              <a:t>Your own files</a:t>
-            </a:r>
-            <a:endParaRPr lang="en-US" sz="1600" dirty="0"/>
-          </a:p>
-        </p:txBody>
-      </p:sp>
-      <p:sp>
-        <p:nvSpPr>
-          <p:cNvPr id="11" name="card 3 text"/>
+              <a:t>uint8_t readButtonsRaw(void)</a:t>
+            </a:r>
+            <a:endParaRPr lang="en-US" sz="1100" dirty="0"/>
+          </a:p>
+          <a:p>
+            <a:pPr indent="0" marL="0">
+              <a:buNone/>
+            </a:pPr>
+            <a:r>
+              <a:rPr lang="en-US" sz="1100" dirty="0">
+                <a:solidFill>
+                  <a:srgbClr val="123524"/>
+                </a:solidFill>
+                <a:latin typeface="Courier New" pitchFamily="34" charset="0"/>
+                <a:ea typeface="Courier New" pitchFamily="34" charset="-122"/>
+                <a:cs typeface="Courier New" pitchFamily="34" charset="-120"/>
+              </a:rPr>
+              <a:t>{</a:t>
+            </a:r>
+            <a:endParaRPr lang="en-US" sz="1100" dirty="0"/>
+          </a:p>
+          <a:p>
+            <a:pPr indent="0" marL="0">
+              <a:buNone/>
+            </a:pPr>
+            <a:r>
+              <a:rPr lang="en-US" sz="1100" dirty="0">
+                <a:solidFill>
+                  <a:srgbClr val="5C5C5C"/>
+                </a:solidFill>
+                <a:latin typeface="Courier New" pitchFamily="34" charset="0"/>
+                <a:ea typeface="Courier New" pitchFamily="34" charset="-122"/>
+                <a:cs typeface="Courier New" pitchFamily="34" charset="-120"/>
+              </a:rPr>
+              <a:t>    /* ... HAL_I2C_Mem_Read ... */</a:t>
+            </a:r>
+            <a:endParaRPr lang="en-US" sz="1100" dirty="0"/>
+          </a:p>
+          <a:p>
+            <a:pPr indent="0" marL="0">
+              <a:buNone/>
+            </a:pPr>
+            <a:r>
+              <a:rPr lang="en-US" sz="1100" dirty="0">
+                <a:solidFill>
+                  <a:srgbClr val="123524"/>
+                </a:solidFill>
+                <a:latin typeface="Courier New" pitchFamily="34" charset="0"/>
+                <a:ea typeface="Courier New" pitchFamily="34" charset="-122"/>
+                <a:cs typeface="Courier New" pitchFamily="34" charset="-120"/>
+              </a:rPr>
+              <a:t>}</a:t>
+            </a:r>
+            <a:endParaRPr lang="en-US" sz="1100" dirty="0"/>
+          </a:p>
+        </p:txBody>
+      </p:sp>
+      <p:sp>
+        <p:nvSpPr>
+          <p:cNvPr id="11" name="split bullets"/>
           <p:cNvSpPr txBox="1"/>
           <p:nvPr/>
         </p:nvSpPr>
         <p:spPr>
           <a:xfrm>
-            <a:off x="6217920" y="1783080"/>
-            <a:ext cx="2240280" cy="1645920"/>
+            <a:off x="457200" y="3291840"/>
+            <a:ext cx="8229600" cy="1280160"/>
           </a:xfrm>
           <a:prstGeom prst="rect">
             <a:avLst/>
@@ -13000,21 +13354,61 @@
           <a:ln/>
         </p:spPr>
         <p:txBody>
-          <a:bodyPr wrap="square" lIns="0" tIns="0" rIns="0" bIns="0" rtlCol="0" anchor="t"/>
+          <a:bodyPr wrap="square" rtlCol="0" anchor="t"/>
           <a:lstStyle/>
           <a:p>
-            <a:pPr indent="0" marL="0">
-              <a:buNone/>
-            </a:pPr>
-            <a:r>
-              <a:rPr lang="en-US" sz="1400" dirty="0">
-                <a:solidFill>
-                  <a:srgbClr val="1C1C1C"/>
-                </a:solidFill>
-              </a:rPr>
-              <a:t>New .c files in Core/Src and .h files in Core/Inc are never touched by CubeMX. The safest place for larger code.</a:t>
-            </a:r>
-            <a:endParaRPr lang="en-US" sz="1400" dirty="0"/>
+            <a:pPr marL="342900" indent="-342900">
+              <a:spcAft>
+                <a:spcPts val="800"/>
+              </a:spcAft>
+              <a:buSzPct val="100000"/>
+              <a:buChar char="•"/>
+            </a:pPr>
+            <a:r>
+              <a:rPr lang="en-US" sz="1500" b="1" dirty="0">
+                <a:solidFill>
+                  <a:srgbClr val="1F6E43"/>
+                </a:solidFill>
+              </a:rPr>
+              <a:t>main.c: #include "io_board.h", the .h only, never the .c</a:t>
+            </a:r>
+            <a:endParaRPr lang="en-US" sz="1500" dirty="0"/>
+          </a:p>
+          <a:p>
+            <a:pPr marL="342900" indent="-342900">
+              <a:spcAft>
+                <a:spcPts val="800"/>
+              </a:spcAft>
+              <a:buSzPct val="100000"/>
+              <a:buChar char="•"/>
+            </a:pPr>
+            <a:r>
+              <a:rPr lang="en-US" sz="1500" dirty="0">
+                <a:solidFill>
+                  <a:srgbClr val="000000"/>
+                </a:solidFill>
+              </a:rPr>
+              <a:t>CubeIDE compiles every .c in Core/Src by itself; the linker joins main.o and io_board.o</a:t>
+            </a:r>
+            <a:endParaRPr lang="en-US" sz="1500" dirty="0"/>
+          </a:p>
+          <a:p>
+            <a:pPr marL="342900" indent="-342900">
+              <a:spcAft>
+                <a:spcPts val="800"/>
+              </a:spcAft>
+              <a:buSzPct val="100000"/>
+              <a:buChar char="•"/>
+            </a:pPr>
+            <a:r>
+              <a:rPr lang="en-US" sz="1500" dirty="0">
+                <a:solidFill>
+                  <a:srgbClr val="B23A48"/>
+                </a:solidFill>
+              </a:rPr>
+              <a:t>Including the .c compiles its functions twice: "multiple definition" error</a:t>
+            </a:r>
+            <a:endParaRPr lang="en-US" sz="1500" dirty="0"/>
           </a:p>
         </p:txBody>
       </p:sp>
@@ -13093,13 +13487,13 @@
           <p:cNvPr id="2" name="Text 0"/>
           <p:cNvSpPr/>
           <p:nvPr>
-            <p:ph idx="100" type="body" hasCustomPrompt="1"/>
+            <p:ph idx="100" type="title" hasCustomPrompt="1"/>
           </p:nvPr>
         </p:nvSpPr>
         <p:spPr>
           <a:xfrm>
-            <a:off x="548640" y="914400"/>
-            <a:ext cx="8046720" cy="457200"/>
+            <a:off x="457200" y="274320"/>
+            <a:ext cx="8229600" cy="640080"/>
           </a:xfrm>
           <a:prstGeom prst="rect">
             <a:avLst/>
@@ -13108,36 +13502,61 @@
           <a:ln/>
         </p:spPr>
         <p:txBody>
-          <a:bodyPr wrap="square" rtlCol="0"/>
+          <a:bodyPr wrap="square" rtlCol="0" anchor="ctr"/>
           <a:lstStyle/>
           <a:p>
             <a:pPr algn="l" indent="0" marL="0">
               <a:buNone/>
             </a:pPr>
             <a:r>
-              <a:rPr lang="en-US" sz="1600" b="1" dirty="0">
-                <a:solidFill>
-                  <a:schemeClr val="bg2"/>
-                </a:solidFill>
-              </a:rPr>
-              <a:t>TUTORIAL 2  ·  9.11.2026</a:t>
-            </a:r>
-            <a:endParaRPr lang="en-US" sz="1600" dirty="0"/>
-          </a:p>
-        </p:txBody>
-      </p:sp>
-      <p:sp>
-        <p:nvSpPr>
-          <p:cNvPr id="3" name="Text 0"/>
+              <a:rPr lang="en-US" sz="2600" b="1" dirty="0">
+                <a:solidFill>
+                  <a:schemeClr val="tx2"/>
+                </a:solidFill>
+              </a:rPr>
+              <a:t>The same rule in the other generated files</a:t>
+            </a:r>
+            <a:endParaRPr lang="en-US" sz="2600" dirty="0"/>
+          </a:p>
+        </p:txBody>
+      </p:sp>
+      <p:sp>
+        <p:nvSpPr>
+          <p:cNvPr id="3" name="card 1"/>
           <p:cNvSpPr/>
-          <p:nvPr>
-            <p:ph idx="101" type="title" hasCustomPrompt="1"/>
-          </p:nvPr>
+          <p:nvPr/>
         </p:nvSpPr>
         <p:spPr>
           <a:xfrm>
-            <a:off x="548640" y="1371600"/>
-            <a:ext cx="8046720" cy="1097280"/>
+            <a:off x="457200" y="1143000"/>
+            <a:ext cx="2606040" cy="2377440"/>
+          </a:xfrm>
+          <a:prstGeom prst="roundRect">
+            <a:avLst>
+              <a:gd name="adj" fmla="val 3846"/>
+            </a:avLst>
+          </a:prstGeom>
+          <a:solidFill>
+            <a:srgbClr val="EEF3EF"/>
+          </a:solidFill>
+          <a:ln w="12700">
+            <a:solidFill>
+              <a:srgbClr val="EEF3EF"/>
+            </a:solidFill>
+            <a:prstDash val="solid"/>
+          </a:ln>
+        </p:spPr>
+      </p:sp>
+      <p:sp>
+        <p:nvSpPr>
+          <p:cNvPr id="4" name="card 1 title"/>
+          <p:cNvSpPr txBox="1"/>
+          <p:nvPr/>
+        </p:nvSpPr>
+        <p:spPr>
+          <a:xfrm>
+            <a:off x="640080" y="1280160"/>
+            <a:ext cx="2240280" cy="457200"/>
           </a:xfrm>
           <a:prstGeom prst="rect">
             <a:avLst/>
@@ -13146,36 +13565,37 @@
           <a:ln/>
         </p:spPr>
         <p:txBody>
-          <a:bodyPr wrap="square" rtlCol="0" anchor="t"/>
+          <a:bodyPr wrap="square" lIns="0" tIns="0" rIns="0" bIns="0" rtlCol="0" anchor="ctr"/>
           <a:lstStyle/>
           <a:p>
-            <a:pPr algn="l" indent="0" marL="0">
+            <a:pPr indent="0" marL="0">
               <a:buNone/>
             </a:pPr>
             <a:r>
-              <a:rPr lang="en-US" sz="3600" b="1" dirty="0">
-                <a:solidFill>
-                  <a:schemeClr val="bg1"/>
-                </a:solidFill>
-              </a:rPr>
-              <a:t>Numbers and bits on the board</a:t>
-            </a:r>
-            <a:endParaRPr lang="en-US" sz="3600" dirty="0"/>
-          </a:p>
-        </p:txBody>
-      </p:sp>
-      <p:sp>
-        <p:nvSpPr>
-          <p:cNvPr id="4" name="Text 0"/>
-          <p:cNvSpPr/>
-          <p:nvPr>
-            <p:ph idx="102" type="body" hasCustomPrompt="1"/>
-          </p:nvPr>
+              <a:rPr lang="en-US" sz="1600" b="1" dirty="0">
+                <a:solidFill>
+                  <a:srgbClr val="1F6E43"/>
+                </a:solidFill>
+                <a:latin typeface="Courier New" pitchFamily="34" charset="0"/>
+                <a:ea typeface="Courier New" pitchFamily="34" charset="-122"/>
+                <a:cs typeface="Courier New" pitchFamily="34" charset="-120"/>
+              </a:rPr>
+              <a:t>main.h</a:t>
+            </a:r>
+            <a:endParaRPr lang="en-US" sz="1600" dirty="0"/>
+          </a:p>
+        </p:txBody>
+      </p:sp>
+      <p:sp>
+        <p:nvSpPr>
+          <p:cNvPr id="5" name="card 1 text"/>
+          <p:cNvSpPr txBox="1"/>
+          <p:nvPr/>
         </p:nvSpPr>
         <p:spPr>
           <a:xfrm>
-            <a:off x="548640" y="2743200"/>
-            <a:ext cx="8046720" cy="1737360"/>
+            <a:off x="640080" y="1783080"/>
+            <a:ext cx="2240280" cy="1645920"/>
           </a:xfrm>
           <a:prstGeom prst="rect">
             <a:avLst/>
@@ -13184,21 +13604,225 @@
           <a:ln/>
         </p:spPr>
         <p:txBody>
-          <a:bodyPr wrap="square" rtlCol="0" anchor="t"/>
+          <a:bodyPr wrap="square" lIns="0" tIns="0" rIns="0" bIns="0" rtlCol="0" anchor="t"/>
           <a:lstStyle/>
           <a:p>
-            <a:pPr algn="l" indent="0" marL="0">
+            <a:pPr indent="0" marL="0">
               <a:buNone/>
             </a:pPr>
             <a:r>
-              <a:rPr lang="en-US" sz="1600" dirty="0">
-                <a:solidFill>
-                  <a:schemeClr val="bg1"/>
-                </a:solidFill>
-              </a:rPr>
-              <a:t>Predict-then-run wrap-around; signed and unsigned in the debugger; a binary printer; the four bit idioms: set, clear, toggle, test.</a:t>
+              <a:rPr lang="en-US" sz="1400" dirty="0">
+                <a:solidFill>
+                  <a:srgbClr val="1C1C1C"/>
+                </a:solidFill>
+              </a:rPr>
+              <a:t>Includes, ET (exported types), EC (constants), EM (macros), EFP (function prototypes), Private defines. Things other .c files need to see.</a:t>
+            </a:r>
+            <a:endParaRPr lang="en-US" sz="1400" dirty="0"/>
+          </a:p>
+        </p:txBody>
+      </p:sp>
+      <p:sp>
+        <p:nvSpPr>
+          <p:cNvPr id="6" name="card 2"/>
+          <p:cNvSpPr/>
+          <p:nvPr/>
+        </p:nvSpPr>
+        <p:spPr>
+          <a:xfrm>
+            <a:off x="3246120" y="1143000"/>
+            <a:ext cx="2606040" cy="2377440"/>
+          </a:xfrm>
+          <a:prstGeom prst="roundRect">
+            <a:avLst>
+              <a:gd name="adj" fmla="val 3846"/>
+            </a:avLst>
+          </a:prstGeom>
+          <a:solidFill>
+            <a:srgbClr val="EEF3EF"/>
+          </a:solidFill>
+          <a:ln w="12700">
+            <a:solidFill>
+              <a:srgbClr val="EEF3EF"/>
+            </a:solidFill>
+            <a:prstDash val="solid"/>
+          </a:ln>
+        </p:spPr>
+      </p:sp>
+      <p:sp>
+        <p:nvSpPr>
+          <p:cNvPr id="7" name="card 2 title"/>
+          <p:cNvSpPr txBox="1"/>
+          <p:nvPr/>
+        </p:nvSpPr>
+        <p:spPr>
+          <a:xfrm>
+            <a:off x="3429000" y="1280160"/>
+            <a:ext cx="2240280" cy="457200"/>
+          </a:xfrm>
+          <a:prstGeom prst="rect">
+            <a:avLst/>
+          </a:prstGeom>
+          <a:noFill/>
+          <a:ln/>
+        </p:spPr>
+        <p:txBody>
+          <a:bodyPr wrap="square" lIns="0" tIns="0" rIns="0" bIns="0" rtlCol="0" anchor="ctr"/>
+          <a:lstStyle/>
+          <a:p>
+            <a:pPr indent="0" marL="0">
+              <a:buNone/>
+            </a:pPr>
+            <a:r>
+              <a:rPr lang="en-US" sz="1600" b="1" dirty="0">
+                <a:solidFill>
+                  <a:srgbClr val="1F6E43"/>
+                </a:solidFill>
+                <a:latin typeface="Courier New" pitchFamily="34" charset="0"/>
+                <a:ea typeface="Courier New" pitchFamily="34" charset="-122"/>
+                <a:cs typeface="Courier New" pitchFamily="34" charset="-120"/>
+              </a:rPr>
+              <a:t>stm32g4xx_it.c</a:t>
             </a:r>
             <a:endParaRPr lang="en-US" sz="1600" dirty="0"/>
+          </a:p>
+        </p:txBody>
+      </p:sp>
+      <p:sp>
+        <p:nvSpPr>
+          <p:cNvPr id="8" name="card 2 text"/>
+          <p:cNvSpPr txBox="1"/>
+          <p:nvPr/>
+        </p:nvSpPr>
+        <p:spPr>
+          <a:xfrm>
+            <a:off x="3429000" y="1783080"/>
+            <a:ext cx="2240280" cy="1645920"/>
+          </a:xfrm>
+          <a:prstGeom prst="rect">
+            <a:avLst/>
+          </a:prstGeom>
+          <a:noFill/>
+          <a:ln/>
+        </p:spPr>
+        <p:txBody>
+          <a:bodyPr wrap="square" lIns="0" tIns="0" rIns="0" bIns="0" rtlCol="0" anchor="t"/>
+          <a:lstStyle/>
+          <a:p>
+            <a:pPr indent="0" marL="0">
+              <a:buNone/>
+            </a:pPr>
+            <a:r>
+              <a:rPr lang="en-US" sz="1400" dirty="0">
+                <a:solidFill>
+                  <a:srgbClr val="1C1C1C"/>
+                </a:solidFill>
+              </a:rPr>
+              <a:t>Interrupt handlers. Each has sections 0 (before the HAL handler) and 1 (after it). Usually leave them alone and use the HAL callbacks.</a:t>
+            </a:r>
+            <a:endParaRPr lang="en-US" sz="1400" dirty="0"/>
+          </a:p>
+        </p:txBody>
+      </p:sp>
+      <p:sp>
+        <p:nvSpPr>
+          <p:cNvPr id="9" name="card 3"/>
+          <p:cNvSpPr/>
+          <p:nvPr/>
+        </p:nvSpPr>
+        <p:spPr>
+          <a:xfrm>
+            <a:off x="6035040" y="1143000"/>
+            <a:ext cx="2606040" cy="2377440"/>
+          </a:xfrm>
+          <a:prstGeom prst="roundRect">
+            <a:avLst>
+              <a:gd name="adj" fmla="val 3846"/>
+            </a:avLst>
+          </a:prstGeom>
+          <a:solidFill>
+            <a:srgbClr val="EEF3EF"/>
+          </a:solidFill>
+          <a:ln w="12700">
+            <a:solidFill>
+              <a:srgbClr val="EEF3EF"/>
+            </a:solidFill>
+            <a:prstDash val="solid"/>
+          </a:ln>
+        </p:spPr>
+      </p:sp>
+      <p:sp>
+        <p:nvSpPr>
+          <p:cNvPr id="10" name="card 3 title"/>
+          <p:cNvSpPr txBox="1"/>
+          <p:nvPr/>
+        </p:nvSpPr>
+        <p:spPr>
+          <a:xfrm>
+            <a:off x="6217920" y="1280160"/>
+            <a:ext cx="2240280" cy="457200"/>
+          </a:xfrm>
+          <a:prstGeom prst="rect">
+            <a:avLst/>
+          </a:prstGeom>
+          <a:noFill/>
+          <a:ln/>
+        </p:spPr>
+        <p:txBody>
+          <a:bodyPr wrap="square" lIns="0" tIns="0" rIns="0" bIns="0" rtlCol="0" anchor="ctr"/>
+          <a:lstStyle/>
+          <a:p>
+            <a:pPr indent="0" marL="0">
+              <a:buNone/>
+            </a:pPr>
+            <a:r>
+              <a:rPr lang="en-US" sz="1600" b="1" dirty="0">
+                <a:solidFill>
+                  <a:srgbClr val="1F6E43"/>
+                </a:solidFill>
+                <a:latin typeface="Courier New" pitchFamily="34" charset="0"/>
+                <a:ea typeface="Courier New" pitchFamily="34" charset="-122"/>
+                <a:cs typeface="Courier New" pitchFamily="34" charset="-120"/>
+              </a:rPr>
+              <a:t>Your own files</a:t>
+            </a:r>
+            <a:endParaRPr lang="en-US" sz="1600" dirty="0"/>
+          </a:p>
+        </p:txBody>
+      </p:sp>
+      <p:sp>
+        <p:nvSpPr>
+          <p:cNvPr id="11" name="card 3 text"/>
+          <p:cNvSpPr txBox="1"/>
+          <p:nvPr/>
+        </p:nvSpPr>
+        <p:spPr>
+          <a:xfrm>
+            <a:off x="6217920" y="1783080"/>
+            <a:ext cx="2240280" cy="1645920"/>
+          </a:xfrm>
+          <a:prstGeom prst="rect">
+            <a:avLst/>
+          </a:prstGeom>
+          <a:noFill/>
+          <a:ln/>
+        </p:spPr>
+        <p:txBody>
+          <a:bodyPr wrap="square" lIns="0" tIns="0" rIns="0" bIns="0" rtlCol="0" anchor="t"/>
+          <a:lstStyle/>
+          <a:p>
+            <a:pPr indent="0" marL="0">
+              <a:buNone/>
+            </a:pPr>
+            <a:r>
+              <a:rPr lang="en-US" sz="1400" dirty="0">
+                <a:solidFill>
+                  <a:srgbClr val="1C1C1C"/>
+                </a:solidFill>
+              </a:rPr>
+              <a:t>New .c files in Core/Src and .h files in Core/Inc are never touched by CubeMX. The safest place for larger code.</a:t>
+            </a:r>
+            <a:endParaRPr lang="en-US" sz="1400" dirty="0"/>
           </a:p>
         </p:txBody>
       </p:sp>
@@ -13232,7 +13856,7 @@
             <a:lvl1pPr>
               <a:defRPr sz="1000">
                 <a:solidFill>
-                  <a:schemeClr val="bg2"/>
+                  <a:schemeClr val="tx2"/>
                 </a:solidFill>
               </a:defRPr>
             </a:lvl1pPr>
@@ -13304,7 +13928,7 @@
                   <a:schemeClr val="bg2"/>
                 </a:solidFill>
               </a:rPr>
-              <a:t>TUTORIAL 3  ·  16.11.2026</a:t>
+              <a:t>TUTORIAL 2  ·  9.11.2026</a:t>
             </a:r>
             <a:endParaRPr lang="en-US" sz="1600" dirty="0"/>
           </a:p>
@@ -13342,7 +13966,7 @@
                   <a:schemeClr val="bg1"/>
                 </a:solidFill>
               </a:rPr>
-              <a:t>RGB LEDs and buttons</a:t>
+              <a:t>Numbers and bits on the board</a:t>
             </a:r>
             <a:endParaRPr lang="en-US" sz="3600" dirty="0"/>
           </a:p>
@@ -13380,7 +14004,7 @@
                   <a:schemeClr val="bg1"/>
                 </a:solidFill>
               </a:rPr>
-              <a:t>A set_rgb helper; a walking dot with masks; saturating brightness up and down; one press = one action.</a:t>
+              <a:t>Predict-then-run wrap-around; signed and unsigned in the debugger; a binary printer; the four bit idioms: set, clear, toggle, test.</a:t>
             </a:r>
             <a:endParaRPr lang="en-US" sz="1600" dirty="0"/>
           </a:p>

</xml_diff>

<commit_message>
Tutorial 1: moving a project slide; checkBounce instructions: B1 vs reset button
Co-Authored-By: Claude Opus 5.5 <noreply@anthropic.com>
</commit_message>
<xml_diff>
--- a/tutorials/MP_tutorials_2026.pptx
+++ b/tutorials/MP_tutorials_2026.pptx
@@ -30,9 +30,10 @@
     <p:sldId id="278" r:id="rId24"/>
     <p:sldId id="279" r:id="rId25"/>
     <p:sldId id="280" r:id="rId26"/>
+    <p:sldId id="281" r:id="rId27"/>
   </p:sldIdLst>
   <p:notesMasterIdLst>
-    <p:notesMasterId r:id="rId27"/>
+    <p:notesMasterId r:id="rId28"/>
   </p:notesMasterIdLst>
   <p:sldSz cx="9144000" cy="5143500"/>
   <p:notesSz cx="5143500" cy="9144000"/>
@@ -131,7 +132,7 @@
   <p:extLst>
     <p:ext uri="{521415D9-36F7-43E2-AB2F-B90AF26B5E84}">
       <p14:sectionLst xmlns:p14="http://schemas.microsoft.com/office/powerpoint/2010/main">
-        <p14:section name="Tutorial 1: Your first STM32 application" id="{21852f4d-8d07-89b6-eb29-170220c8d091}">
+        <p14:section name="Tutorial 1: Your first STM32 application" id="{e6b4c9aa-78c9-c597-0af6-f54424bc4b2f}">
           <p14:sldIdLst>
             <p14:sldId id="257"/>
             <p14:sldId id="258"/>
@@ -140,71 +141,72 @@
             <p14:sldId id="261"/>
             <p14:sldId id="262"/>
             <p14:sldId id="263"/>
-          </p14:sldIdLst>
-        </p14:section>
-        <p14:section name="Tutorial 2: Numbers and bits on the board" id="{81abeccf-daea-5e57-0c8a-f263c913ee52}">
-          <p14:sldIdLst>
             <p14:sldId id="264"/>
           </p14:sldIdLst>
         </p14:section>
-        <p14:section name="Tutorial 3: RGB LEDs and buttons" id="{6c23e798-5a8c-637a-a5ff-c04b23936a69}">
+        <p14:section name="Tutorial 2: Numbers and bits on the board" id="{c15f6201-075d-2e97-6e8b-8beb0dc12395}">
           <p14:sldIdLst>
             <p14:sldId id="265"/>
           </p14:sldIdLst>
         </p14:section>
-        <p14:section name="Tutorial 4: Timer interrupts and state machines" id="{da6a7aea-7eb3-59ac-9d17-ae34229a1c57}">
+        <p14:section name="Tutorial 3: RGB LEDs and buttons" id="{bccff75b-a899-9a0a-bd45-ed6e16cab61d}">
           <p14:sldIdLst>
             <p14:sldId id="266"/>
+          </p14:sldIdLst>
+        </p14:section>
+        <p14:section name="Tutorial 4: Timer interrupts and state machines" id="{407214bd-1516-b47b-92d2-14a673110772}">
+          <p14:sldIdLst>
             <p14:sldId id="267"/>
             <p14:sldId id="268"/>
             <p14:sldId id="269"/>
             <p14:sldId id="270"/>
             <p14:sldId id="271"/>
-          </p14:sldIdLst>
-        </p14:section>
-        <p14:section name="Tutorial 5: Inside the I2C bus" id="{8b5bd772-d041-1bc7-1881-0e7c1e314f69}">
-          <p14:sldIdLst>
             <p14:sldId id="272"/>
           </p14:sldIdLst>
         </p14:section>
-        <p14:section name="Tutorial 6: PWM, input capture and EXTI" id="{849e91d2-3af2-ca64-266a-33033f532278}">
+        <p14:section name="Tutorial 5: Inside the I2C bus" id="{cdafa046-4960-08d9-dade-13722ea2c76e}">
           <p14:sldIdLst>
             <p14:sldId id="273"/>
           </p14:sldIdLst>
         </p14:section>
-        <p14:section name="Tutorial 7: One wheel in the air" id="{c24085cd-2cd8-eddc-9058-d02a689da798}">
+        <p14:section name="Tutorial 6: PWM, input capture and EXTI" id="{22b1a7f2-0b5c-f1e2-f58f-3b4012e84f69}">
           <p14:sldIdLst>
             <p14:sldId id="274"/>
           </p14:sldIdLst>
         </p14:section>
-        <p14:section name="Tutorial 8: From model to PI controller" id="{065b6652-cad1-a652-bec0-04c56f9e9267}">
+        <p14:section name="Tutorial 7: One wheel in the air" id="{15a4c756-5aad-b6f4-4b54-3ae35a79c2d0}">
           <p14:sldIdLst>
             <p14:sldId id="275"/>
           </p14:sldIdLst>
         </p14:section>
-        <p14:section name="Tutorial 9: UART commands and a MATLAB GUI" id="{63dcb04d-2deb-c2be-8ab0-594d7cfb6e3c}">
+        <p14:section name="Tutorial 8: From model to PI controller" id="{f0a30eb0-0238-282e-bfb9-8077164d9b37}">
           <p14:sldIdLst>
             <p14:sldId id="276"/>
           </p14:sldIdLst>
         </p14:section>
-        <p14:section name="Tutorial 10: Driving the cart" id="{5d1d97ab-b8a1-beaa-b805-96a8caeb2dcb}">
+        <p14:section name="Tutorial 9: UART commands and a MATLAB GUI" id="{5034ba26-1181-15a1-324d-6297c420e1c5}">
           <p14:sldIdLst>
             <p14:sldId id="277"/>
           </p14:sldIdLst>
         </p14:section>
-        <p14:section name="Tutorial 11: Simulink to C" id="{a5c0355f-7040-414c-151b-c4f6be01b350}">
+        <p14:section name="Tutorial 10: Driving the cart" id="{133b27ce-88cd-963a-fe03-1a971fcab7c4}">
           <p14:sldIdLst>
             <p14:sldId id="278"/>
           </p14:sldIdLst>
         </p14:section>
-        <p14:section name="Tutorial 12: Project clinic" id="{4a30cbd3-6d52-1f0c-ca1c-9014489b045d}">
+        <p14:section name="Tutorial 11: Simulink to C" id="{e4a56d23-8994-95f3-95f2-d791053739ae}">
           <p14:sldIdLst>
             <p14:sldId id="279"/>
           </p14:sldIdLst>
         </p14:section>
-        <p14:section name="Session 13" id="{8e310e0f-46c6-3f0a-de7b-fe25a9c4335b}">
+        <p14:section name="Tutorial 12: Project clinic" id="{1ab8d8b8-50ab-fd7e-3bc3-610a4896cc9c}">
           <p14:sldIdLst>
             <p14:sldId id="280"/>
+          </p14:sldIdLst>
+        </p14:section>
+        <p14:section name="Session 13" id="{01631e87-6dbf-b331-4ea6-570b30e763d1}">
+          <p14:sldIdLst>
+            <p14:sldId id="281"/>
           </p14:sldIdLst>
         </p14:section>
       </p14:sectionLst>
@@ -2131,6 +2133,94 @@
             <a:fld id="{F7021451-1387-4CA6-816F-3879F97B5CBC}" type="slidenum">
               <a:rPr lang="en-US"/>
               <a:t>25</a:t>
+            </a:fld>
+            <a:endParaRPr lang="en-US"/>
+          </a:p>
+        </p:txBody>
+      </p:sp>
+    </p:spTree>
+    <p:extLst>
+      <p:ext uri="{BB962C8B-B14F-4D97-AF65-F5344CB8AC3E}">
+        <p14:creationId xmlns:p14="http://schemas.microsoft.com/office/powerpoint/2010/main" val="1024086991"/>
+      </p:ext>
+    </p:extLst>
+  </p:cSld>
+  <p:clrMapOvr>
+    <a:masterClrMapping/>
+  </p:clrMapOvr>
+</p:notes>
+</file>
+
+<file path=ppt/notesSlides/notesSlide26.xml><?xml version="1.0" encoding="utf-8"?>
+<p:notes xmlns:a="http://schemas.openxmlformats.org/drawingml/2006/main" xmlns:r="http://schemas.openxmlformats.org/officeDocument/2006/relationships" xmlns:p="http://schemas.openxmlformats.org/presentationml/2006/main">
+  <p:cSld>
+    <p:spTree>
+      <p:nvGrpSpPr>
+        <p:cNvPr id="1" name=""/>
+        <p:cNvGrpSpPr/>
+        <p:nvPr/>
+      </p:nvGrpSpPr>
+      <p:grpSpPr>
+        <a:xfrm>
+          <a:off x="0" y="0"/>
+          <a:ext cx="0" cy="0"/>
+          <a:chOff x="0" y="0"/>
+          <a:chExt cx="0" cy="0"/>
+        </a:xfrm>
+      </p:grpSpPr>
+      <p:sp>
+        <p:nvSpPr>
+          <p:cNvPr id="2" name="Slide Image Placeholder 1"/>
+          <p:cNvSpPr>
+            <a:spLocks noGrp="1" noRot="1" noChangeAspect="1"/>
+          </p:cNvSpPr>
+          <p:nvPr>
+            <p:ph type="sldImg"/>
+          </p:nvPr>
+        </p:nvSpPr>
+        <p:spPr/>
+      </p:sp>
+      <p:sp>
+        <p:nvSpPr>
+          <p:cNvPr id="3" name="Notes Placeholder 2"/>
+          <p:cNvSpPr>
+            <a:spLocks noGrp="1"/>
+          </p:cNvSpPr>
+          <p:nvPr>
+            <p:ph type="body" idx="1"/>
+          </p:nvPr>
+        </p:nvSpPr>
+        <p:spPr/>
+        <p:txBody>
+          <a:bodyPr/>
+          <a:lstStyle/>
+          <a:p>
+            <a:r>
+              <a:rPr lang="en-US" dirty="0"/>
+              <a:t/>
+            </a:r>
+            <a:endParaRPr lang="en-US" dirty="0"/>
+          </a:p>
+        </p:txBody>
+      </p:sp>
+      <p:sp>
+        <p:nvSpPr>
+          <p:cNvPr id="4" name="Slide Number Placeholder 3"/>
+          <p:cNvSpPr>
+            <a:spLocks noGrp="1"/>
+          </p:cNvSpPr>
+          <p:nvPr>
+            <p:ph type="sldNum" sz="quarter" idx="10"/>
+          </p:nvPr>
+        </p:nvSpPr>
+        <p:spPr/>
+        <p:txBody>
+          <a:bodyPr/>
+          <a:lstStyle/>
+          <a:p>
+            <a:fld id="{F7021451-1387-4CA6-816F-3879F97B5CBC}" type="slidenum">
+              <a:rPr lang="en-US"/>
+              <a:t>26</a:t>
             </a:fld>
             <a:endParaRPr lang="en-US"/>
           </a:p>
@@ -3690,7 +3780,7 @@
                   <a:schemeClr val="bg2"/>
                 </a:solidFill>
               </a:rPr>
-              <a:t>TUTORIAL 3  ·  16.11.2026</a:t>
+              <a:t>TUTORIAL 2  ·  9.11.2026</a:t>
             </a:r>
             <a:endParaRPr lang="en-US" sz="1600" dirty="0"/>
           </a:p>
@@ -3728,7 +3818,7 @@
                   <a:schemeClr val="bg1"/>
                 </a:solidFill>
               </a:rPr>
-              <a:t>RGB LEDs and buttons</a:t>
+              <a:t>Numbers and bits on the board</a:t>
             </a:r>
             <a:endParaRPr lang="en-US" sz="3600" dirty="0"/>
           </a:p>
@@ -3766,7 +3856,7 @@
                   <a:schemeClr val="bg1"/>
                 </a:solidFill>
               </a:rPr>
-              <a:t>A set_rgb helper; a walking dot with masks; saturating brightness up and down; one press = one action.</a:t>
+              <a:t>Predict-then-run wrap-around; signed and unsigned in the debugger; a binary printer; the four bit idioms: set, clear, toggle, test.</a:t>
             </a:r>
             <a:endParaRPr lang="en-US" sz="1600" dirty="0"/>
           </a:p>
@@ -3874,7 +3964,7 @@
                   <a:schemeClr val="bg2"/>
                 </a:solidFill>
               </a:rPr>
-              <a:t>TUTORIAL 4  ·  23.11.2026</a:t>
+              <a:t>TUTORIAL 3  ·  16.11.2026</a:t>
             </a:r>
             <a:endParaRPr lang="en-US" sz="1600" dirty="0"/>
           </a:p>
@@ -3912,7 +4002,7 @@
                   <a:schemeClr val="bg1"/>
                 </a:solidFill>
               </a:rPr>
-              <a:t>Timer interrupts and state machines</a:t>
+              <a:t>RGB LEDs and buttons</a:t>
             </a:r>
             <a:endParaRPr lang="en-US" sz="3600" dirty="0"/>
           </a:p>
@@ -3950,7 +4040,7 @@
                   <a:schemeClr val="bg1"/>
                 </a:solidFill>
               </a:rPr>
-              <a:t>Multi-rate blinking from a timer interrupt (no HAL_Delay); a state-machine skeleton with enum and switch.</a:t>
+              <a:t>A set_rgb helper; a walking dot with masks; saturating brightness up and down; one press = one action.</a:t>
             </a:r>
             <a:endParaRPr lang="en-US" sz="1600" dirty="0"/>
           </a:p>
@@ -4031,13 +4121,13 @@
           <p:cNvPr id="2" name="Text 0"/>
           <p:cNvSpPr/>
           <p:nvPr>
-            <p:ph idx="100" type="title" hasCustomPrompt="1"/>
+            <p:ph idx="100" type="body" hasCustomPrompt="1"/>
           </p:nvPr>
         </p:nvSpPr>
         <p:spPr>
           <a:xfrm>
-            <a:off x="457200" y="274320"/>
-            <a:ext cx="8229600" cy="640080"/>
+            <a:off x="548640" y="914400"/>
+            <a:ext cx="8046720" cy="457200"/>
           </a:xfrm>
           <a:prstGeom prst="rect">
             <a:avLst/>
@@ -4046,61 +4136,36 @@
           <a:ln/>
         </p:spPr>
         <p:txBody>
-          <a:bodyPr wrap="square" rtlCol="0" anchor="ctr"/>
+          <a:bodyPr wrap="square" rtlCol="0"/>
           <a:lstStyle/>
           <a:p>
             <a:pPr algn="l" indent="0" marL="0">
               <a:buNone/>
             </a:pPr>
             <a:r>
-              <a:rPr lang="en-US" sz="2600" b="1" dirty="0">
-                <a:solidFill>
-                  <a:schemeClr val="tx2"/>
-                </a:solidFill>
-              </a:rPr>
-              <a:t>Why some outputs are fast and others slow</a:t>
-            </a:r>
-            <a:endParaRPr lang="en-US" sz="2600" dirty="0"/>
-          </a:p>
-        </p:txBody>
-      </p:sp>
-      <p:sp>
-        <p:nvSpPr>
-          <p:cNvPr id="3" name="speed card 1"/>
+              <a:rPr lang="en-US" sz="1600" b="1" dirty="0">
+                <a:solidFill>
+                  <a:schemeClr val="bg2"/>
+                </a:solidFill>
+              </a:rPr>
+              <a:t>TUTORIAL 4  ·  23.11.2026</a:t>
+            </a:r>
+            <a:endParaRPr lang="en-US" sz="1600" dirty="0"/>
+          </a:p>
+        </p:txBody>
+      </p:sp>
+      <p:sp>
+        <p:nvSpPr>
+          <p:cNvPr id="3" name="Text 0"/>
           <p:cNvSpPr/>
-          <p:nvPr/>
+          <p:nvPr>
+            <p:ph idx="101" type="title" hasCustomPrompt="1"/>
+          </p:nvPr>
         </p:nvSpPr>
         <p:spPr>
           <a:xfrm>
-            <a:off x="457200" y="1097280"/>
-            <a:ext cx="3977640" cy="2606040"/>
-          </a:xfrm>
-          <a:prstGeom prst="roundRect">
-            <a:avLst>
-              <a:gd name="adj" fmla="val 3509"/>
-            </a:avLst>
-          </a:prstGeom>
-          <a:solidFill>
-            <a:srgbClr val="EEF3EF"/>
-          </a:solidFill>
-          <a:ln w="12700">
-            <a:solidFill>
-              <a:srgbClr val="EEF3EF"/>
-            </a:solidFill>
-            <a:prstDash val="solid"/>
-          </a:ln>
-        </p:spPr>
-      </p:sp>
-      <p:sp>
-        <p:nvSpPr>
-          <p:cNvPr id="4" name="speed card 1 head"/>
-          <p:cNvSpPr txBox="1"/>
-          <p:nvPr/>
-        </p:nvSpPr>
-        <p:spPr>
-          <a:xfrm>
-            <a:off x="685800" y="1234440"/>
-            <a:ext cx="3520440" cy="411480"/>
+            <a:off x="548640" y="1371600"/>
+            <a:ext cx="8046720" cy="1097280"/>
           </a:xfrm>
           <a:prstGeom prst="rect">
             <a:avLst/>
@@ -4109,34 +4174,36 @@
           <a:ln/>
         </p:spPr>
         <p:txBody>
-          <a:bodyPr wrap="square" lIns="0" tIns="0" rIns="0" bIns="0" rtlCol="0" anchor="ctr"/>
+          <a:bodyPr wrap="square" rtlCol="0" anchor="t"/>
           <a:lstStyle/>
           <a:p>
-            <a:pPr indent="0" marL="0">
+            <a:pPr algn="l" indent="0" marL="0">
               <a:buNone/>
             </a:pPr>
             <a:r>
-              <a:rPr lang="en-US" sz="1600" b="1" dirty="0">
-                <a:solidFill>
-                  <a:srgbClr val="123524"/>
-                </a:solidFill>
-              </a:rPr>
-              <a:t>Wheel PWM: TIM2-&gt;CCR1 = value;</a:t>
-            </a:r>
-            <a:endParaRPr lang="en-US" sz="1600" dirty="0"/>
-          </a:p>
-        </p:txBody>
-      </p:sp>
-      <p:sp>
-        <p:nvSpPr>
-          <p:cNvPr id="5" name="speed card 1 stat"/>
-          <p:cNvSpPr txBox="1"/>
-          <p:nvPr/>
+              <a:rPr lang="en-US" sz="3600" b="1" dirty="0">
+                <a:solidFill>
+                  <a:schemeClr val="bg1"/>
+                </a:solidFill>
+              </a:rPr>
+              <a:t>Timer interrupts and state machines</a:t>
+            </a:r>
+            <a:endParaRPr lang="en-US" sz="3600" dirty="0"/>
+          </a:p>
+        </p:txBody>
+      </p:sp>
+      <p:sp>
+        <p:nvSpPr>
+          <p:cNvPr id="4" name="Text 0"/>
+          <p:cNvSpPr/>
+          <p:nvPr>
+            <p:ph idx="102" type="body" hasCustomPrompt="1"/>
+          </p:nvPr>
         </p:nvSpPr>
         <p:spPr>
           <a:xfrm>
-            <a:off x="685800" y="1691640"/>
-            <a:ext cx="3520440" cy="777240"/>
+            <a:off x="548640" y="2743200"/>
+            <a:ext cx="8046720" cy="1737360"/>
           </a:xfrm>
           <a:prstGeom prst="rect">
             <a:avLst/>
@@ -4145,214 +4212,21 @@
           <a:ln/>
         </p:spPr>
         <p:txBody>
-          <a:bodyPr wrap="square" lIns="0" tIns="0" rIns="0" bIns="0" rtlCol="0" anchor="ctr"/>
+          <a:bodyPr wrap="square" rtlCol="0" anchor="t"/>
           <a:lstStyle/>
           <a:p>
-            <a:pPr indent="0" marL="0">
+            <a:pPr algn="l" indent="0" marL="0">
               <a:buNone/>
             </a:pPr>
             <a:r>
-              <a:rPr lang="en-US" sz="4400" b="1" dirty="0">
-                <a:solidFill>
-                  <a:srgbClr val="1F6E43"/>
-                </a:solidFill>
-              </a:rPr>
-              <a:t>~20</a:t>
-            </a:r>
-            <a:pPr indent="0" marL="0">
-              <a:buNone/>
-            </a:pPr>
-            <a:r>
-              <a:rPr lang="en-US" sz="1800" dirty="0">
-                <a:solidFill>
-                  <a:srgbClr val="1F6E43"/>
-                </a:solidFill>
-              </a:rPr>
-              <a:t>  ns</a:t>
-            </a:r>
-            <a:endParaRPr lang="en-US" sz="4400" dirty="0"/>
-          </a:p>
-        </p:txBody>
-      </p:sp>
-      <p:sp>
-        <p:nvSpPr>
-          <p:cNvPr id="6" name="speed card 1 body"/>
-          <p:cNvSpPr txBox="1"/>
-          <p:nvPr/>
-        </p:nvSpPr>
-        <p:spPr>
-          <a:xfrm>
-            <a:off x="685800" y="2560320"/>
-            <a:ext cx="3520440" cy="1645920"/>
-          </a:xfrm>
-          <a:prstGeom prst="rect">
-            <a:avLst/>
-          </a:prstGeom>
-          <a:noFill/>
-          <a:ln/>
-        </p:spPr>
-        <p:txBody>
-          <a:bodyPr wrap="square" lIns="0" tIns="0" rIns="0" bIns="0" rtlCol="0" anchor="t"/>
-          <a:lstStyle/>
-          <a:p>
-            <a:pPr indent="0" marL="0">
-              <a:buNone/>
-            </a:pPr>
-            <a:r>
-              <a:rPr lang="en-US" sz="1300" dirty="0">
-                <a:solidFill>
-                  <a:srgbClr val="1C1C1C"/>
-                </a:solidFill>
-              </a:rPr>
-              <a:t>The register is inside the STM32. It has a memory address, so one store instruction over the internal bus writes it: a few clock cycles at 170 MHz (1 cycle = 5.9 ns). TIM2 then makes the PWM by itself.</a:t>
-            </a:r>
-            <a:endParaRPr lang="en-US" sz="1300" dirty="0"/>
-          </a:p>
-        </p:txBody>
-      </p:sp>
-      <p:sp>
-        <p:nvSpPr>
-          <p:cNvPr id="7" name="speed card 2"/>
-          <p:cNvSpPr/>
-          <p:nvPr/>
-        </p:nvSpPr>
-        <p:spPr>
-          <a:xfrm>
-            <a:off x="4709160" y="1097280"/>
-            <a:ext cx="3977640" cy="2606040"/>
-          </a:xfrm>
-          <a:prstGeom prst="roundRect">
-            <a:avLst>
-              <a:gd name="adj" fmla="val 3509"/>
-            </a:avLst>
-          </a:prstGeom>
-          <a:solidFill>
-            <a:srgbClr val="EEF3EF"/>
-          </a:solidFill>
-          <a:ln w="12700">
-            <a:solidFill>
-              <a:srgbClr val="EEF3EF"/>
-            </a:solidFill>
-            <a:prstDash val="solid"/>
-          </a:ln>
-        </p:spPr>
-      </p:sp>
-      <p:sp>
-        <p:nvSpPr>
-          <p:cNvPr id="8" name="speed card 2 head"/>
-          <p:cNvSpPr txBox="1"/>
-          <p:nvPr/>
-        </p:nvSpPr>
-        <p:spPr>
-          <a:xfrm>
-            <a:off x="4937760" y="1234440"/>
-            <a:ext cx="3520440" cy="411480"/>
-          </a:xfrm>
-          <a:prstGeom prst="rect">
-            <a:avLst/>
-          </a:prstGeom>
-          <a:noFill/>
-          <a:ln/>
-        </p:spPr>
-        <p:txBody>
-          <a:bodyPr wrap="square" lIns="0" tIns="0" rIns="0" bIns="0" rtlCol="0" anchor="ctr"/>
-          <a:lstStyle/>
-          <a:p>
-            <a:pPr indent="0" marL="0">
-              <a:buNone/>
-            </a:pPr>
-            <a:r>
-              <a:rPr lang="en-US" sz="1600" b="1" dirty="0">
-                <a:solidFill>
-                  <a:srgbClr val="123524"/>
-                </a:solidFill>
-              </a:rPr>
-              <a:t>LED brightness: HAL_I2C_Mem_Write</a:t>
+              <a:rPr lang="en-US" sz="1600" dirty="0">
+                <a:solidFill>
+                  <a:schemeClr val="bg1"/>
+                </a:solidFill>
+              </a:rPr>
+              <a:t>Multi-rate blinking from a timer interrupt (no HAL_Delay); a state-machine skeleton with enum and switch.</a:t>
             </a:r>
             <a:endParaRPr lang="en-US" sz="1600" dirty="0"/>
-          </a:p>
-        </p:txBody>
-      </p:sp>
-      <p:sp>
-        <p:nvSpPr>
-          <p:cNvPr id="9" name="speed card 2 stat"/>
-          <p:cNvSpPr txBox="1"/>
-          <p:nvPr/>
-        </p:nvSpPr>
-        <p:spPr>
-          <a:xfrm>
-            <a:off x="4937760" y="1691640"/>
-            <a:ext cx="3520440" cy="777240"/>
-          </a:xfrm>
-          <a:prstGeom prst="rect">
-            <a:avLst/>
-          </a:prstGeom>
-          <a:noFill/>
-          <a:ln/>
-        </p:spPr>
-        <p:txBody>
-          <a:bodyPr wrap="square" lIns="0" tIns="0" rIns="0" bIns="0" rtlCol="0" anchor="ctr"/>
-          <a:lstStyle/>
-          <a:p>
-            <a:pPr indent="0" marL="0">
-              <a:buNone/>
-            </a:pPr>
-            <a:r>
-              <a:rPr lang="en-US" sz="4400" b="1" dirty="0">
-                <a:solidFill>
-                  <a:srgbClr val="B23A48"/>
-                </a:solidFill>
-              </a:rPr>
-              <a:t>~0.3</a:t>
-            </a:r>
-            <a:pPr indent="0" marL="0">
-              <a:buNone/>
-            </a:pPr>
-            <a:r>
-              <a:rPr lang="en-US" sz="1800" dirty="0">
-                <a:solidFill>
-                  <a:srgbClr val="B23A48"/>
-                </a:solidFill>
-              </a:rPr>
-              <a:t>  ms</a:t>
-            </a:r>
-            <a:endParaRPr lang="en-US" sz="4400" dirty="0"/>
-          </a:p>
-        </p:txBody>
-      </p:sp>
-      <p:sp>
-        <p:nvSpPr>
-          <p:cNvPr id="10" name="speed card 2 body"/>
-          <p:cNvSpPr txBox="1"/>
-          <p:nvPr/>
-        </p:nvSpPr>
-        <p:spPr>
-          <a:xfrm>
-            <a:off x="4937760" y="2560320"/>
-            <a:ext cx="3520440" cy="1645920"/>
-          </a:xfrm>
-          <a:prstGeom prst="rect">
-            <a:avLst/>
-          </a:prstGeom>
-          <a:noFill/>
-          <a:ln/>
-        </p:spPr>
-        <p:txBody>
-          <a:bodyPr wrap="square" lIns="0" tIns="0" rIns="0" bIns="0" rtlCol="0" anchor="t"/>
-          <a:lstStyle/>
-          <a:p>
-            <a:pPr indent="0" marL="0">
-              <a:buNone/>
-            </a:pPr>
-            <a:r>
-              <a:rPr lang="en-US" sz="1300" dirty="0">
-                <a:solidFill>
-                  <a:srgbClr val="1C1C1C"/>
-                </a:solidFill>
-              </a:rPr>
-              <a:t>The register is inside the PCA9634, another chip. The only way in is the I2C bus at 100 kHz: 10 µs per bit. Address + register + data, each with an ACK, is about 29 bits. The CPU waits all that time.</a:t>
-            </a:r>
-            <a:endParaRPr lang="en-US" sz="1300" dirty="0"/>
           </a:p>
         </p:txBody>
       </p:sp>
@@ -4386,7 +4260,7 @@
             <a:lvl1pPr>
               <a:defRPr sz="1000">
                 <a:solidFill>
-                  <a:schemeClr val="tx2"/>
+                  <a:schemeClr val="bg2"/>
                 </a:solidFill>
               </a:defRPr>
             </a:lvl1pPr>
@@ -4458,7 +4332,7 @@
                   <a:schemeClr val="tx2"/>
                 </a:solidFill>
               </a:rPr>
-              <a:t>Blocking: updating all 24 LED registers at once</a:t>
+              <a:t>Why some outputs are fast and others slow</a:t>
             </a:r>
             <a:endParaRPr lang="en-US" sz="2600" dirty="0"/>
           </a:p>
@@ -4466,26 +4340,26 @@
       </p:sp>
       <p:sp>
         <p:nvSpPr>
-          <p:cNvPr id="3" name="blocking box"/>
+          <p:cNvPr id="3" name="speed card 1"/>
           <p:cNvSpPr/>
           <p:nvPr/>
         </p:nvSpPr>
         <p:spPr>
           <a:xfrm>
             <a:off x="457200" y="1097280"/>
-            <a:ext cx="4114800" cy="1508760"/>
+            <a:ext cx="3977640" cy="2606040"/>
           </a:xfrm>
           <a:prstGeom prst="roundRect">
             <a:avLst>
-              <a:gd name="adj" fmla="val 4848"/>
+              <a:gd name="adj" fmla="val 3509"/>
             </a:avLst>
           </a:prstGeom>
           <a:solidFill>
-            <a:srgbClr val="F4F6F4"/>
+            <a:srgbClr val="EEF3EF"/>
           </a:solidFill>
-          <a:ln w="9525">
+          <a:ln w="12700">
             <a:solidFill>
-              <a:srgbClr val="D5DDD6"/>
+              <a:srgbClr val="EEF3EF"/>
             </a:solidFill>
             <a:prstDash val="solid"/>
           </a:ln>
@@ -4493,14 +4367,14 @@
       </p:sp>
       <p:sp>
         <p:nvSpPr>
-          <p:cNvPr id="4" name="blocking code"/>
+          <p:cNvPr id="4" name="speed card 1 head"/>
           <p:cNvSpPr txBox="1"/>
           <p:nvPr/>
         </p:nvSpPr>
         <p:spPr>
           <a:xfrm>
-            <a:off x="594360" y="1188720"/>
-            <a:ext cx="3840480" cy="1325880"/>
+            <a:off x="685800" y="1234440"/>
+            <a:ext cx="3520440" cy="411480"/>
           </a:xfrm>
           <a:prstGeom prst="rect">
             <a:avLst/>
@@ -4509,122 +4383,34 @@
           <a:ln/>
         </p:spPr>
         <p:txBody>
-          <a:bodyPr wrap="square" lIns="0" tIns="0" rIns="0" bIns="0" rtlCol="0" anchor="t"/>
+          <a:bodyPr wrap="square" lIns="0" tIns="0" rIns="0" bIns="0" rtlCol="0" anchor="ctr"/>
           <a:lstStyle/>
           <a:p>
             <a:pPr indent="0" marL="0">
               <a:buNone/>
             </a:pPr>
             <a:r>
-              <a:rPr lang="en-US" sz="1100" dirty="0">
-                <a:solidFill>
-                  <a:srgbClr val="5C5C5C"/>
-                </a:solidFill>
-                <a:latin typeface="Courier New" pitchFamily="34" charset="0"/>
-                <a:ea typeface="Courier New" pitchFamily="34" charset="-122"/>
-                <a:cs typeface="Courier New" pitchFamily="34" charset="-120"/>
-              </a:rPr>
-              <a:t>for (ch = 0; ch &lt; 8; ch++) {</a:t>
-            </a:r>
-            <a:endParaRPr lang="en-US" sz="1100" dirty="0"/>
-          </a:p>
-          <a:p>
-            <a:pPr indent="0" marL="0">
-              <a:buNone/>
-            </a:pPr>
-            <a:r>
-              <a:rPr lang="en-US" sz="1100" dirty="0">
-                <a:solidFill>
-                  <a:srgbClr val="B23A48"/>
-                </a:solidFill>
-                <a:latin typeface="Courier New" pitchFamily="34" charset="0"/>
-                <a:ea typeface="Courier New" pitchFamily="34" charset="-122"/>
-                <a:cs typeface="Courier New" pitchFamily="34" charset="-120"/>
-              </a:rPr>
-              <a:t>  setLedChannel(RED,   ch, r);  // 0.3 ms</a:t>
-            </a:r>
-            <a:endParaRPr lang="en-US" sz="1100" dirty="0"/>
-          </a:p>
-          <a:p>
-            <a:pPr indent="0" marL="0">
-              <a:buNone/>
-            </a:pPr>
-            <a:r>
-              <a:rPr lang="en-US" sz="1100" dirty="0">
-                <a:solidFill>
-                  <a:srgbClr val="B23A48"/>
-                </a:solidFill>
-                <a:latin typeface="Courier New" pitchFamily="34" charset="0"/>
-                <a:ea typeface="Courier New" pitchFamily="34" charset="-122"/>
-                <a:cs typeface="Courier New" pitchFamily="34" charset="-120"/>
-              </a:rPr>
-              <a:t>  setLedChannel(GREEN, ch, g);  // 0.3 ms</a:t>
-            </a:r>
-            <a:endParaRPr lang="en-US" sz="1100" dirty="0"/>
-          </a:p>
-          <a:p>
-            <a:pPr indent="0" marL="0">
-              <a:buNone/>
-            </a:pPr>
-            <a:r>
-              <a:rPr lang="en-US" sz="1100" dirty="0">
-                <a:solidFill>
-                  <a:srgbClr val="B23A48"/>
-                </a:solidFill>
-                <a:latin typeface="Courier New" pitchFamily="34" charset="0"/>
-                <a:ea typeface="Courier New" pitchFamily="34" charset="-122"/>
-                <a:cs typeface="Courier New" pitchFamily="34" charset="-120"/>
-              </a:rPr>
-              <a:t>  setLedChannel(BLUE,  ch, b);  // 0.3 ms</a:t>
-            </a:r>
-            <a:endParaRPr lang="en-US" sz="1100" dirty="0"/>
-          </a:p>
-          <a:p>
-            <a:pPr indent="0" marL="0">
-              <a:buNone/>
-            </a:pPr>
-            <a:r>
-              <a:rPr lang="en-US" sz="1100" dirty="0">
-                <a:solidFill>
-                  <a:srgbClr val="5C5C5C"/>
-                </a:solidFill>
-                <a:latin typeface="Courier New" pitchFamily="34" charset="0"/>
-                <a:ea typeface="Courier New" pitchFamily="34" charset="-122"/>
-                <a:cs typeface="Courier New" pitchFamily="34" charset="-120"/>
-              </a:rPr>
-              <a:t>}</a:t>
-            </a:r>
-            <a:endParaRPr lang="en-US" sz="1100" dirty="0"/>
-          </a:p>
-          <a:p>
-            <a:pPr indent="0" marL="0">
-              <a:buNone/>
-            </a:pPr>
-            <a:r>
-              <a:rPr lang="en-US" sz="1100" b="1" dirty="0">
-                <a:solidFill>
-                  <a:srgbClr val="B23A48"/>
-                </a:solidFill>
-                <a:latin typeface="Courier New" pitchFamily="34" charset="0"/>
-                <a:ea typeface="Courier New" pitchFamily="34" charset="-122"/>
-                <a:cs typeface="Courier New" pitchFamily="34" charset="-120"/>
-              </a:rPr>
-              <a:t>// about 7 to 9 ms with the loop stuck here</a:t>
-            </a:r>
-            <a:endParaRPr lang="en-US" sz="1100" dirty="0"/>
-          </a:p>
-        </p:txBody>
-      </p:sp>
-      <p:sp>
-        <p:nvSpPr>
-          <p:cNvPr id="5" name="blocking bullets"/>
+              <a:rPr lang="en-US" sz="1600" b="1" dirty="0">
+                <a:solidFill>
+                  <a:srgbClr val="123524"/>
+                </a:solidFill>
+              </a:rPr>
+              <a:t>Wheel PWM: TIM2-&gt;CCR1 = value;</a:t>
+            </a:r>
+            <a:endParaRPr lang="en-US" sz="1600" dirty="0"/>
+          </a:p>
+        </p:txBody>
+      </p:sp>
+      <p:sp>
+        <p:nvSpPr>
+          <p:cNvPr id="5" name="speed card 1 stat"/>
           <p:cNvSpPr txBox="1"/>
           <p:nvPr/>
         </p:nvSpPr>
         <p:spPr>
           <a:xfrm>
-            <a:off x="4846320" y="1097280"/>
-            <a:ext cx="3840480" cy="3291840"/>
+            <a:off x="685800" y="1691640"/>
+            <a:ext cx="3520440" cy="777240"/>
           </a:xfrm>
           <a:prstGeom prst="rect">
             <a:avLst/>
@@ -4633,96 +4419,214 @@
           <a:ln/>
         </p:spPr>
         <p:txBody>
-          <a:bodyPr wrap="square" rtlCol="0" anchor="t"/>
+          <a:bodyPr wrap="square" lIns="0" tIns="0" rIns="0" bIns="0" rtlCol="0" anchor="ctr"/>
           <a:lstStyle/>
           <a:p>
             <a:pPr indent="0" marL="0">
-              <a:spcAft>
-                <a:spcPts val="800"/>
-              </a:spcAft>
               <a:buNone/>
             </a:pPr>
             <a:r>
-              <a:rPr lang="en-US" sz="1500" b="1" dirty="0">
-                <a:solidFill>
-                  <a:srgbClr val="000000"/>
-                </a:solidFill>
-              </a:rPr>
-              <a:t>While stuck, the main loop cannot:</a:t>
-            </a:r>
-            <a:endParaRPr lang="en-US" sz="1500" dirty="0"/>
-          </a:p>
-          <a:p>
-            <a:pPr marL="342900" indent="-342900">
-              <a:spcAft>
-                <a:spcPts val="800"/>
-              </a:spcAft>
-              <a:buSzPct val="100000"/>
-              <a:buChar char="•"/>
-            </a:pPr>
-            <a:r>
-              <a:rPr lang="en-US" sz="1500" dirty="0">
-                <a:solidFill>
-                  <a:srgbClr val="000000"/>
-                </a:solidFill>
-              </a:rPr>
-              <a:t>see a new command or state</a:t>
-            </a:r>
-            <a:endParaRPr lang="en-US" sz="1500" dirty="0"/>
-          </a:p>
-          <a:p>
-            <a:pPr marL="342900" indent="-342900">
-              <a:spcAft>
-                <a:spcPts val="800"/>
-              </a:spcAft>
-              <a:buSzPct val="100000"/>
-              <a:buChar char="•"/>
-            </a:pPr>
-            <a:r>
-              <a:rPr lang="en-US" sz="1500" dirty="0">
-                <a:solidFill>
-                  <a:srgbClr val="000000"/>
-                </a:solidFill>
-              </a:rPr>
-              <a:t>poll the IR obstacle sensor (an emergency stop!)</a:t>
-            </a:r>
-            <a:endParaRPr lang="en-US" sz="1500" dirty="0"/>
-          </a:p>
-          <a:p>
-            <a:pPr marL="342900" indent="-342900">
-              <a:spcAft>
-                <a:spcPts val="800"/>
-              </a:spcAft>
-              <a:buSzPct val="100000"/>
-              <a:buChar char="•"/>
-            </a:pPr>
-            <a:r>
-              <a:rPr lang="en-US" sz="1500" dirty="0">
-                <a:solidFill>
-                  <a:srgbClr val="000000"/>
-                </a:solidFill>
-              </a:rPr>
-              <a:t>run the state's work or print status</a:t>
-            </a:r>
-            <a:endParaRPr lang="en-US" sz="1500" dirty="0"/>
-          </a:p>
-          <a:p>
-            <a:pPr marL="342900" indent="-342900">
-              <a:spcAft>
-                <a:spcPts val="800"/>
-              </a:spcAft>
-              <a:buSzPct val="100000"/>
-              <a:buChar char="•"/>
-            </a:pPr>
-            <a:r>
-              <a:rPr lang="en-US" sz="1500" dirty="0">
+              <a:rPr lang="en-US" sz="4400" b="1" dirty="0">
                 <a:solidFill>
                   <a:srgbClr val="1F6E43"/>
                 </a:solidFill>
               </a:rPr>
-              <a:t>Interrupts still run: TIM2 keeps the PWM going and TIM5 still captures the ultrasonic echo.</a:t>
-            </a:r>
-            <a:endParaRPr lang="en-US" sz="1500" dirty="0"/>
+              <a:t>~20</a:t>
+            </a:r>
+            <a:pPr indent="0" marL="0">
+              <a:buNone/>
+            </a:pPr>
+            <a:r>
+              <a:rPr lang="en-US" sz="1800" dirty="0">
+                <a:solidFill>
+                  <a:srgbClr val="1F6E43"/>
+                </a:solidFill>
+              </a:rPr>
+              <a:t>  ns</a:t>
+            </a:r>
+            <a:endParaRPr lang="en-US" sz="4400" dirty="0"/>
+          </a:p>
+        </p:txBody>
+      </p:sp>
+      <p:sp>
+        <p:nvSpPr>
+          <p:cNvPr id="6" name="speed card 1 body"/>
+          <p:cNvSpPr txBox="1"/>
+          <p:nvPr/>
+        </p:nvSpPr>
+        <p:spPr>
+          <a:xfrm>
+            <a:off x="685800" y="2560320"/>
+            <a:ext cx="3520440" cy="1645920"/>
+          </a:xfrm>
+          <a:prstGeom prst="rect">
+            <a:avLst/>
+          </a:prstGeom>
+          <a:noFill/>
+          <a:ln/>
+        </p:spPr>
+        <p:txBody>
+          <a:bodyPr wrap="square" lIns="0" tIns="0" rIns="0" bIns="0" rtlCol="0" anchor="t"/>
+          <a:lstStyle/>
+          <a:p>
+            <a:pPr indent="0" marL="0">
+              <a:buNone/>
+            </a:pPr>
+            <a:r>
+              <a:rPr lang="en-US" sz="1300" dirty="0">
+                <a:solidFill>
+                  <a:srgbClr val="1C1C1C"/>
+                </a:solidFill>
+              </a:rPr>
+              <a:t>The register is inside the STM32. It has a memory address, so one store instruction over the internal bus writes it: a few clock cycles at 170 MHz (1 cycle = 5.9 ns). TIM2 then makes the PWM by itself.</a:t>
+            </a:r>
+            <a:endParaRPr lang="en-US" sz="1300" dirty="0"/>
+          </a:p>
+        </p:txBody>
+      </p:sp>
+      <p:sp>
+        <p:nvSpPr>
+          <p:cNvPr id="7" name="speed card 2"/>
+          <p:cNvSpPr/>
+          <p:nvPr/>
+        </p:nvSpPr>
+        <p:spPr>
+          <a:xfrm>
+            <a:off x="4709160" y="1097280"/>
+            <a:ext cx="3977640" cy="2606040"/>
+          </a:xfrm>
+          <a:prstGeom prst="roundRect">
+            <a:avLst>
+              <a:gd name="adj" fmla="val 3509"/>
+            </a:avLst>
+          </a:prstGeom>
+          <a:solidFill>
+            <a:srgbClr val="EEF3EF"/>
+          </a:solidFill>
+          <a:ln w="12700">
+            <a:solidFill>
+              <a:srgbClr val="EEF3EF"/>
+            </a:solidFill>
+            <a:prstDash val="solid"/>
+          </a:ln>
+        </p:spPr>
+      </p:sp>
+      <p:sp>
+        <p:nvSpPr>
+          <p:cNvPr id="8" name="speed card 2 head"/>
+          <p:cNvSpPr txBox="1"/>
+          <p:nvPr/>
+        </p:nvSpPr>
+        <p:spPr>
+          <a:xfrm>
+            <a:off x="4937760" y="1234440"/>
+            <a:ext cx="3520440" cy="411480"/>
+          </a:xfrm>
+          <a:prstGeom prst="rect">
+            <a:avLst/>
+          </a:prstGeom>
+          <a:noFill/>
+          <a:ln/>
+        </p:spPr>
+        <p:txBody>
+          <a:bodyPr wrap="square" lIns="0" tIns="0" rIns="0" bIns="0" rtlCol="0" anchor="ctr"/>
+          <a:lstStyle/>
+          <a:p>
+            <a:pPr indent="0" marL="0">
+              <a:buNone/>
+            </a:pPr>
+            <a:r>
+              <a:rPr lang="en-US" sz="1600" b="1" dirty="0">
+                <a:solidFill>
+                  <a:srgbClr val="123524"/>
+                </a:solidFill>
+              </a:rPr>
+              <a:t>LED brightness: HAL_I2C_Mem_Write</a:t>
+            </a:r>
+            <a:endParaRPr lang="en-US" sz="1600" dirty="0"/>
+          </a:p>
+        </p:txBody>
+      </p:sp>
+      <p:sp>
+        <p:nvSpPr>
+          <p:cNvPr id="9" name="speed card 2 stat"/>
+          <p:cNvSpPr txBox="1"/>
+          <p:nvPr/>
+        </p:nvSpPr>
+        <p:spPr>
+          <a:xfrm>
+            <a:off x="4937760" y="1691640"/>
+            <a:ext cx="3520440" cy="777240"/>
+          </a:xfrm>
+          <a:prstGeom prst="rect">
+            <a:avLst/>
+          </a:prstGeom>
+          <a:noFill/>
+          <a:ln/>
+        </p:spPr>
+        <p:txBody>
+          <a:bodyPr wrap="square" lIns="0" tIns="0" rIns="0" bIns="0" rtlCol="0" anchor="ctr"/>
+          <a:lstStyle/>
+          <a:p>
+            <a:pPr indent="0" marL="0">
+              <a:buNone/>
+            </a:pPr>
+            <a:r>
+              <a:rPr lang="en-US" sz="4400" b="1" dirty="0">
+                <a:solidFill>
+                  <a:srgbClr val="B23A48"/>
+                </a:solidFill>
+              </a:rPr>
+              <a:t>~0.3</a:t>
+            </a:r>
+            <a:pPr indent="0" marL="0">
+              <a:buNone/>
+            </a:pPr>
+            <a:r>
+              <a:rPr lang="en-US" sz="1800" dirty="0">
+                <a:solidFill>
+                  <a:srgbClr val="B23A48"/>
+                </a:solidFill>
+              </a:rPr>
+              <a:t>  ms</a:t>
+            </a:r>
+            <a:endParaRPr lang="en-US" sz="4400" dirty="0"/>
+          </a:p>
+        </p:txBody>
+      </p:sp>
+      <p:sp>
+        <p:nvSpPr>
+          <p:cNvPr id="10" name="speed card 2 body"/>
+          <p:cNvSpPr txBox="1"/>
+          <p:nvPr/>
+        </p:nvSpPr>
+        <p:spPr>
+          <a:xfrm>
+            <a:off x="4937760" y="2560320"/>
+            <a:ext cx="3520440" cy="1645920"/>
+          </a:xfrm>
+          <a:prstGeom prst="rect">
+            <a:avLst/>
+          </a:prstGeom>
+          <a:noFill/>
+          <a:ln/>
+        </p:spPr>
+        <p:txBody>
+          <a:bodyPr wrap="square" lIns="0" tIns="0" rIns="0" bIns="0" rtlCol="0" anchor="t"/>
+          <a:lstStyle/>
+          <a:p>
+            <a:pPr indent="0" marL="0">
+              <a:buNone/>
+            </a:pPr>
+            <a:r>
+              <a:rPr lang="en-US" sz="1300" dirty="0">
+                <a:solidFill>
+                  <a:srgbClr val="1C1C1C"/>
+                </a:solidFill>
+              </a:rPr>
+              <a:t>The register is inside the PCA9634, another chip. The only way in is the I2C bus at 100 kHz: 10 µs per bit. Address + register + data, each with an ACK, is about 29 bits. The CPU waits all that time.</a:t>
+            </a:r>
+            <a:endParaRPr lang="en-US" sz="1300" dirty="0"/>
           </a:p>
         </p:txBody>
       </p:sp>
@@ -4828,7 +4732,7 @@
                   <a:schemeClr val="tx2"/>
                 </a:solidFill>
               </a:rPr>
-              <a:t>Non-blocking: one register per loop pass</a:t>
+              <a:t>Blocking: updating all 24 LED registers at once</a:t>
             </a:r>
             <a:endParaRPr lang="en-US" sz="2600" dirty="0"/>
           </a:p>
@@ -4836,18 +4740,18 @@
       </p:sp>
       <p:sp>
         <p:nvSpPr>
-          <p:cNvPr id="3" name="service box"/>
+          <p:cNvPr id="3" name="blocking box"/>
           <p:cNvSpPr/>
           <p:nvPr/>
         </p:nvSpPr>
         <p:spPr>
           <a:xfrm>
             <a:off x="457200" y="1097280"/>
-            <a:ext cx="4572000" cy="1828800"/>
+            <a:ext cx="4114800" cy="1508760"/>
           </a:xfrm>
           <a:prstGeom prst="roundRect">
             <a:avLst>
-              <a:gd name="adj" fmla="val 4000"/>
+              <a:gd name="adj" fmla="val 4848"/>
             </a:avLst>
           </a:prstGeom>
           <a:solidFill>
@@ -4863,14 +4767,14 @@
       </p:sp>
       <p:sp>
         <p:nvSpPr>
-          <p:cNvPr id="4" name="service code"/>
+          <p:cNvPr id="4" name="blocking code"/>
           <p:cNvSpPr txBox="1"/>
           <p:nvPr/>
         </p:nvSpPr>
         <p:spPr>
           <a:xfrm>
             <a:off x="594360" y="1188720"/>
-            <a:ext cx="4297680" cy="1645920"/>
+            <a:ext cx="3840480" cy="1325880"/>
           </a:xfrm>
           <a:prstGeom prst="rect">
             <a:avLst/>
@@ -4894,7 +4798,7 @@
                 <a:ea typeface="Courier New" pitchFamily="34" charset="-122"/>
                 <a:cs typeface="Courier New" pitchFamily="34" charset="-120"/>
               </a:rPr>
-              <a:t>static void serviceRgbOutputs(void)</a:t>
+              <a:t>for (ch = 0; ch &lt; 8; ch++) {</a:t>
             </a:r>
             <a:endParaRPr lang="en-US" sz="1100" dirty="0"/>
           </a:p>
@@ -4905,13 +4809,13 @@
             <a:r>
               <a:rPr lang="en-US" sz="1100" dirty="0">
                 <a:solidFill>
-                  <a:srgbClr val="5C5C5C"/>
+                  <a:srgbClr val="B23A48"/>
                 </a:solidFill>
                 <a:latin typeface="Courier New" pitchFamily="34" charset="0"/>
                 <a:ea typeface="Courier New" pitchFamily="34" charset="-122"/>
                 <a:cs typeface="Courier New" pitchFamily="34" charset="-120"/>
               </a:rPr>
-              <a:t>{</a:t>
+              <a:t>  setLedChannel(RED,   ch, r);  // 0.3 ms</a:t>
             </a:r>
             <a:endParaRPr lang="en-US" sz="1100" dirty="0"/>
           </a:p>
@@ -4920,15 +4824,15 @@
               <a:buNone/>
             </a:pPr>
             <a:r>
-              <a:rPr lang="en-US" sz="1100" b="1" dirty="0">
-                <a:solidFill>
-                  <a:srgbClr val="1F6E43"/>
+              <a:rPr lang="en-US" sz="1100" dirty="0">
+                <a:solidFill>
+                  <a:srgbClr val="B23A48"/>
                 </a:solidFill>
                 <a:latin typeface="Courier New" pitchFamily="34" charset="0"/>
                 <a:ea typeface="Courier New" pitchFamily="34" charset="-122"/>
                 <a:cs typeface="Courier New" pitchFamily="34" charset="-120"/>
               </a:rPr>
-              <a:t>  if (micros() - lastUs &lt; 1200) return;</a:t>
+              <a:t>  setLedChannel(GREEN, ch, g);  // 0.3 ms</a:t>
             </a:r>
             <a:endParaRPr lang="en-US" sz="1100" dirty="0"/>
           </a:p>
@@ -4939,13 +4843,13 @@
             <a:r>
               <a:rPr lang="en-US" sz="1100" dirty="0">
                 <a:solidFill>
-                  <a:srgbClr val="5C5C5C"/>
+                  <a:srgbClr val="B23A48"/>
                 </a:solidFill>
                 <a:latin typeface="Courier New" pitchFamily="34" charset="0"/>
                 <a:ea typeface="Courier New" pitchFamily="34" charset="-122"/>
                 <a:cs typeface="Courier New" pitchFamily="34" charset="-120"/>
               </a:rPr>
-              <a:t>  lastUs = micros();</a:t>
+              <a:t>  setLedChannel(BLUE,  ch, b);  // 0.3 ms</a:t>
             </a:r>
             <a:endParaRPr lang="en-US" sz="1100" dirty="0"/>
           </a:p>
@@ -4953,22 +4857,16 @@
             <a:pPr indent="0" marL="0">
               <a:buNone/>
             </a:pPr>
-            <a:endParaRPr lang="en-US" sz="1100" dirty="0"/>
-          </a:p>
-          <a:p>
-            <a:pPr indent="0" marL="0">
-              <a:buNone/>
-            </a:pPr>
             <a:r>
               <a:rPr lang="en-US" sz="1100" dirty="0">
                 <a:solidFill>
-                  <a:srgbClr val="1F6E43"/>
+                  <a:srgbClr val="5C5C5C"/>
                 </a:solidFill>
                 <a:latin typeface="Courier New" pitchFamily="34" charset="0"/>
                 <a:ea typeface="Courier New" pitchFamily="34" charset="-122"/>
                 <a:cs typeface="Courier New" pitchFamily="34" charset="-120"/>
               </a:rPr>
-              <a:t>  /* write ONE of the 24 registers */</a:t>
+              <a:t>}</a:t>
             </a:r>
             <a:endParaRPr lang="en-US" sz="1100" dirty="0"/>
           </a:p>
@@ -4977,64 +4875,30 @@
               <a:buNone/>
             </a:pPr>
             <a:r>
-              <a:rPr lang="en-US" sz="1100" dirty="0">
-                <a:solidFill>
-                  <a:srgbClr val="5C5C5C"/>
+              <a:rPr lang="en-US" sz="1100" b="1" dirty="0">
+                <a:solidFill>
+                  <a:srgbClr val="B23A48"/>
                 </a:solidFill>
                 <a:latin typeface="Courier New" pitchFamily="34" charset="0"/>
                 <a:ea typeface="Courier New" pitchFamily="34" charset="-122"/>
                 <a:cs typeface="Courier New" pitchFamily="34" charset="-120"/>
               </a:rPr>
-              <a:t>  setLedChannel(chip, channel, target);</a:t>
+              <a:t>// about 7 to 9 ms with the loop stuck here</a:t>
             </a:r>
             <a:endParaRPr lang="en-US" sz="1100" dirty="0"/>
           </a:p>
-          <a:p>
-            <a:pPr indent="0" marL="0">
-              <a:buNone/>
-            </a:pPr>
-            <a:r>
-              <a:rPr lang="en-US" sz="1100" dirty="0">
-                <a:solidFill>
-                  <a:srgbClr val="5C5C5C"/>
-                </a:solidFill>
-                <a:latin typeface="Courier New" pitchFamily="34" charset="0"/>
-                <a:ea typeface="Courier New" pitchFamily="34" charset="-122"/>
-                <a:cs typeface="Courier New" pitchFamily="34" charset="-120"/>
-              </a:rPr>
-              <a:t>  index = (index + 1) % 24;</a:t>
-            </a:r>
-            <a:endParaRPr lang="en-US" sz="1100" dirty="0"/>
-          </a:p>
-          <a:p>
-            <a:pPr indent="0" marL="0">
-              <a:buNone/>
-            </a:pPr>
-            <a:r>
-              <a:rPr lang="en-US" sz="1100" dirty="0">
-                <a:solidFill>
-                  <a:srgbClr val="5C5C5C"/>
-                </a:solidFill>
-                <a:latin typeface="Courier New" pitchFamily="34" charset="0"/>
-                <a:ea typeface="Courier New" pitchFamily="34" charset="-122"/>
-                <a:cs typeface="Courier New" pitchFamily="34" charset="-120"/>
-              </a:rPr>
-              <a:t>}</a:t>
-            </a:r>
-            <a:endParaRPr lang="en-US" sz="1100" dirty="0"/>
-          </a:p>
-        </p:txBody>
-      </p:sp>
-      <p:sp>
-        <p:nvSpPr>
-          <p:cNvPr id="5" name="service bullets"/>
+        </p:txBody>
+      </p:sp>
+      <p:sp>
+        <p:nvSpPr>
+          <p:cNvPr id="5" name="blocking bullets"/>
           <p:cNvSpPr txBox="1"/>
           <p:nvPr/>
         </p:nvSpPr>
         <p:spPr>
           <a:xfrm>
-            <a:off x="5303520" y="1097280"/>
-            <a:ext cx="3383280" cy="3291840"/>
+            <a:off x="4846320" y="1097280"/>
+            <a:ext cx="3840480" cy="3291840"/>
           </a:xfrm>
           <a:prstGeom prst="rect">
             <a:avLst/>
@@ -5046,6 +4910,23 @@
           <a:bodyPr wrap="square" rtlCol="0" anchor="t"/>
           <a:lstStyle/>
           <a:p>
+            <a:pPr indent="0" marL="0">
+              <a:spcAft>
+                <a:spcPts val="800"/>
+              </a:spcAft>
+              <a:buNone/>
+            </a:pPr>
+            <a:r>
+              <a:rPr lang="en-US" sz="1500" b="1" dirty="0">
+                <a:solidFill>
+                  <a:srgbClr val="000000"/>
+                </a:solidFill>
+              </a:rPr>
+              <a:t>While stuck, the main loop cannot:</a:t>
+            </a:r>
+            <a:endParaRPr lang="en-US" sz="1500" dirty="0"/>
+          </a:p>
+          <a:p>
             <a:pPr marL="342900" indent="-342900">
               <a:spcAft>
                 <a:spcPts val="800"/>
@@ -5059,7 +4940,7 @@
                   <a:srgbClr val="000000"/>
                 </a:solidFill>
               </a:rPr>
-              <a:t>The logic writes the wanted colours into RAM arrays (rgbTarget...): instant.</a:t>
+              <a:t>see a new command or state</a:t>
             </a:r>
             <a:endParaRPr lang="en-US" sz="1500" dirty="0"/>
           </a:p>
@@ -5077,7 +4958,7 @@
                   <a:srgbClr val="000000"/>
                 </a:solidFill>
               </a:rPr>
-              <a:t>serviceRgbOutputs copies them to the chips, at most one register per call.</a:t>
+              <a:t>poll the IR obstacle sensor (an emergency stop!)</a:t>
             </a:r>
             <a:endParaRPr lang="en-US" sz="1500" dirty="0"/>
           </a:p>
@@ -5095,7 +4976,7 @@
                   <a:srgbClr val="000000"/>
                 </a:solidFill>
               </a:rPr>
-              <a:t>Each loop pass pays at most 0.3 ms; a full refresh takes 24 x 1.2 ms = 29 ms, too fast for the eye.</a:t>
+              <a:t>run the state's work or print status</a:t>
             </a:r>
             <a:endParaRPr lang="en-US" sz="1500" dirty="0"/>
           </a:p>
@@ -5108,12 +4989,12 @@
               <a:buChar char="•"/>
             </a:pPr>
             <a:r>
-              <a:rPr lang="en-US" sz="1500" b="1" dirty="0">
+              <a:rPr lang="en-US" sz="1500" dirty="0">
                 <a:solidFill>
                   <a:srgbClr val="1F6E43"/>
                 </a:solidFill>
               </a:rPr>
-              <a:t>What makes it non-blocking is the work per call, not where the call is placed.</a:t>
+              <a:t>Interrupts still run: TIM2 keeps the PWM going and TIM5 still captures the ultrasonic echo.</a:t>
             </a:r>
             <a:endParaRPr lang="en-US" sz="1500" dirty="0"/>
           </a:p>
@@ -5221,6 +5102,399 @@
                   <a:schemeClr val="tx2"/>
                 </a:solidFill>
               </a:rPr>
+              <a:t>Non-blocking: one register per loop pass</a:t>
+            </a:r>
+            <a:endParaRPr lang="en-US" sz="2600" dirty="0"/>
+          </a:p>
+        </p:txBody>
+      </p:sp>
+      <p:sp>
+        <p:nvSpPr>
+          <p:cNvPr id="3" name="service box"/>
+          <p:cNvSpPr/>
+          <p:nvPr/>
+        </p:nvSpPr>
+        <p:spPr>
+          <a:xfrm>
+            <a:off x="457200" y="1097280"/>
+            <a:ext cx="4572000" cy="1828800"/>
+          </a:xfrm>
+          <a:prstGeom prst="roundRect">
+            <a:avLst>
+              <a:gd name="adj" fmla="val 4000"/>
+            </a:avLst>
+          </a:prstGeom>
+          <a:solidFill>
+            <a:srgbClr val="F4F6F4"/>
+          </a:solidFill>
+          <a:ln w="9525">
+            <a:solidFill>
+              <a:srgbClr val="D5DDD6"/>
+            </a:solidFill>
+            <a:prstDash val="solid"/>
+          </a:ln>
+        </p:spPr>
+      </p:sp>
+      <p:sp>
+        <p:nvSpPr>
+          <p:cNvPr id="4" name="service code"/>
+          <p:cNvSpPr txBox="1"/>
+          <p:nvPr/>
+        </p:nvSpPr>
+        <p:spPr>
+          <a:xfrm>
+            <a:off x="594360" y="1188720"/>
+            <a:ext cx="4297680" cy="1645920"/>
+          </a:xfrm>
+          <a:prstGeom prst="rect">
+            <a:avLst/>
+          </a:prstGeom>
+          <a:noFill/>
+          <a:ln/>
+        </p:spPr>
+        <p:txBody>
+          <a:bodyPr wrap="square" lIns="0" tIns="0" rIns="0" bIns="0" rtlCol="0" anchor="t"/>
+          <a:lstStyle/>
+          <a:p>
+            <a:pPr indent="0" marL="0">
+              <a:buNone/>
+            </a:pPr>
+            <a:r>
+              <a:rPr lang="en-US" sz="1100" dirty="0">
+                <a:solidFill>
+                  <a:srgbClr val="5C5C5C"/>
+                </a:solidFill>
+                <a:latin typeface="Courier New" pitchFamily="34" charset="0"/>
+                <a:ea typeface="Courier New" pitchFamily="34" charset="-122"/>
+                <a:cs typeface="Courier New" pitchFamily="34" charset="-120"/>
+              </a:rPr>
+              <a:t>static void serviceRgbOutputs(void)</a:t>
+            </a:r>
+            <a:endParaRPr lang="en-US" sz="1100" dirty="0"/>
+          </a:p>
+          <a:p>
+            <a:pPr indent="0" marL="0">
+              <a:buNone/>
+            </a:pPr>
+            <a:r>
+              <a:rPr lang="en-US" sz="1100" dirty="0">
+                <a:solidFill>
+                  <a:srgbClr val="5C5C5C"/>
+                </a:solidFill>
+                <a:latin typeface="Courier New" pitchFamily="34" charset="0"/>
+                <a:ea typeface="Courier New" pitchFamily="34" charset="-122"/>
+                <a:cs typeface="Courier New" pitchFamily="34" charset="-120"/>
+              </a:rPr>
+              <a:t>{</a:t>
+            </a:r>
+            <a:endParaRPr lang="en-US" sz="1100" dirty="0"/>
+          </a:p>
+          <a:p>
+            <a:pPr indent="0" marL="0">
+              <a:buNone/>
+            </a:pPr>
+            <a:r>
+              <a:rPr lang="en-US" sz="1100" b="1" dirty="0">
+                <a:solidFill>
+                  <a:srgbClr val="1F6E43"/>
+                </a:solidFill>
+                <a:latin typeface="Courier New" pitchFamily="34" charset="0"/>
+                <a:ea typeface="Courier New" pitchFamily="34" charset="-122"/>
+                <a:cs typeface="Courier New" pitchFamily="34" charset="-120"/>
+              </a:rPr>
+              <a:t>  if (micros() - lastUs &lt; 1200) return;</a:t>
+            </a:r>
+            <a:endParaRPr lang="en-US" sz="1100" dirty="0"/>
+          </a:p>
+          <a:p>
+            <a:pPr indent="0" marL="0">
+              <a:buNone/>
+            </a:pPr>
+            <a:r>
+              <a:rPr lang="en-US" sz="1100" dirty="0">
+                <a:solidFill>
+                  <a:srgbClr val="5C5C5C"/>
+                </a:solidFill>
+                <a:latin typeface="Courier New" pitchFamily="34" charset="0"/>
+                <a:ea typeface="Courier New" pitchFamily="34" charset="-122"/>
+                <a:cs typeface="Courier New" pitchFamily="34" charset="-120"/>
+              </a:rPr>
+              <a:t>  lastUs = micros();</a:t>
+            </a:r>
+            <a:endParaRPr lang="en-US" sz="1100" dirty="0"/>
+          </a:p>
+          <a:p>
+            <a:pPr indent="0" marL="0">
+              <a:buNone/>
+            </a:pPr>
+            <a:endParaRPr lang="en-US" sz="1100" dirty="0"/>
+          </a:p>
+          <a:p>
+            <a:pPr indent="0" marL="0">
+              <a:buNone/>
+            </a:pPr>
+            <a:r>
+              <a:rPr lang="en-US" sz="1100" dirty="0">
+                <a:solidFill>
+                  <a:srgbClr val="1F6E43"/>
+                </a:solidFill>
+                <a:latin typeface="Courier New" pitchFamily="34" charset="0"/>
+                <a:ea typeface="Courier New" pitchFamily="34" charset="-122"/>
+                <a:cs typeface="Courier New" pitchFamily="34" charset="-120"/>
+              </a:rPr>
+              <a:t>  /* write ONE of the 24 registers */</a:t>
+            </a:r>
+            <a:endParaRPr lang="en-US" sz="1100" dirty="0"/>
+          </a:p>
+          <a:p>
+            <a:pPr indent="0" marL="0">
+              <a:buNone/>
+            </a:pPr>
+            <a:r>
+              <a:rPr lang="en-US" sz="1100" dirty="0">
+                <a:solidFill>
+                  <a:srgbClr val="5C5C5C"/>
+                </a:solidFill>
+                <a:latin typeface="Courier New" pitchFamily="34" charset="0"/>
+                <a:ea typeface="Courier New" pitchFamily="34" charset="-122"/>
+                <a:cs typeface="Courier New" pitchFamily="34" charset="-120"/>
+              </a:rPr>
+              <a:t>  setLedChannel(chip, channel, target);</a:t>
+            </a:r>
+            <a:endParaRPr lang="en-US" sz="1100" dirty="0"/>
+          </a:p>
+          <a:p>
+            <a:pPr indent="0" marL="0">
+              <a:buNone/>
+            </a:pPr>
+            <a:r>
+              <a:rPr lang="en-US" sz="1100" dirty="0">
+                <a:solidFill>
+                  <a:srgbClr val="5C5C5C"/>
+                </a:solidFill>
+                <a:latin typeface="Courier New" pitchFamily="34" charset="0"/>
+                <a:ea typeface="Courier New" pitchFamily="34" charset="-122"/>
+                <a:cs typeface="Courier New" pitchFamily="34" charset="-120"/>
+              </a:rPr>
+              <a:t>  index = (index + 1) % 24;</a:t>
+            </a:r>
+            <a:endParaRPr lang="en-US" sz="1100" dirty="0"/>
+          </a:p>
+          <a:p>
+            <a:pPr indent="0" marL="0">
+              <a:buNone/>
+            </a:pPr>
+            <a:r>
+              <a:rPr lang="en-US" sz="1100" dirty="0">
+                <a:solidFill>
+                  <a:srgbClr val="5C5C5C"/>
+                </a:solidFill>
+                <a:latin typeface="Courier New" pitchFamily="34" charset="0"/>
+                <a:ea typeface="Courier New" pitchFamily="34" charset="-122"/>
+                <a:cs typeface="Courier New" pitchFamily="34" charset="-120"/>
+              </a:rPr>
+              <a:t>}</a:t>
+            </a:r>
+            <a:endParaRPr lang="en-US" sz="1100" dirty="0"/>
+          </a:p>
+        </p:txBody>
+      </p:sp>
+      <p:sp>
+        <p:nvSpPr>
+          <p:cNvPr id="5" name="service bullets"/>
+          <p:cNvSpPr txBox="1"/>
+          <p:nvPr/>
+        </p:nvSpPr>
+        <p:spPr>
+          <a:xfrm>
+            <a:off x="5303520" y="1097280"/>
+            <a:ext cx="3383280" cy="3291840"/>
+          </a:xfrm>
+          <a:prstGeom prst="rect">
+            <a:avLst/>
+          </a:prstGeom>
+          <a:noFill/>
+          <a:ln/>
+        </p:spPr>
+        <p:txBody>
+          <a:bodyPr wrap="square" rtlCol="0" anchor="t"/>
+          <a:lstStyle/>
+          <a:p>
+            <a:pPr marL="342900" indent="-342900">
+              <a:spcAft>
+                <a:spcPts val="800"/>
+              </a:spcAft>
+              <a:buSzPct val="100000"/>
+              <a:buChar char="•"/>
+            </a:pPr>
+            <a:r>
+              <a:rPr lang="en-US" sz="1500" dirty="0">
+                <a:solidFill>
+                  <a:srgbClr val="000000"/>
+                </a:solidFill>
+              </a:rPr>
+              <a:t>The logic writes the wanted colours into RAM arrays (rgbTarget...): instant.</a:t>
+            </a:r>
+            <a:endParaRPr lang="en-US" sz="1500" dirty="0"/>
+          </a:p>
+          <a:p>
+            <a:pPr marL="342900" indent="-342900">
+              <a:spcAft>
+                <a:spcPts val="800"/>
+              </a:spcAft>
+              <a:buSzPct val="100000"/>
+              <a:buChar char="•"/>
+            </a:pPr>
+            <a:r>
+              <a:rPr lang="en-US" sz="1500" dirty="0">
+                <a:solidFill>
+                  <a:srgbClr val="000000"/>
+                </a:solidFill>
+              </a:rPr>
+              <a:t>serviceRgbOutputs copies them to the chips, at most one register per call.</a:t>
+            </a:r>
+            <a:endParaRPr lang="en-US" sz="1500" dirty="0"/>
+          </a:p>
+          <a:p>
+            <a:pPr marL="342900" indent="-342900">
+              <a:spcAft>
+                <a:spcPts val="800"/>
+              </a:spcAft>
+              <a:buSzPct val="100000"/>
+              <a:buChar char="•"/>
+            </a:pPr>
+            <a:r>
+              <a:rPr lang="en-US" sz="1500" dirty="0">
+                <a:solidFill>
+                  <a:srgbClr val="000000"/>
+                </a:solidFill>
+              </a:rPr>
+              <a:t>Each loop pass pays at most 0.3 ms; a full refresh takes 24 x 1.2 ms = 29 ms, too fast for the eye.</a:t>
+            </a:r>
+            <a:endParaRPr lang="en-US" sz="1500" dirty="0"/>
+          </a:p>
+          <a:p>
+            <a:pPr marL="342900" indent="-342900">
+              <a:spcAft>
+                <a:spcPts val="800"/>
+              </a:spcAft>
+              <a:buSzPct val="100000"/>
+              <a:buChar char="•"/>
+            </a:pPr>
+            <a:r>
+              <a:rPr lang="en-US" sz="1500" b="1" dirty="0">
+                <a:solidFill>
+                  <a:srgbClr val="1F6E43"/>
+                </a:solidFill>
+              </a:rPr>
+              <a:t>What makes it non-blocking is the work per call, not where the call is placed.</a:t>
+            </a:r>
+            <a:endParaRPr lang="en-US" sz="1500" dirty="0"/>
+          </a:p>
+        </p:txBody>
+      </p:sp>
+      <p:sp>
+        <p:nvSpPr>
+          <p:cNvPr id="25" name="Slide Number Placeholder 0"/>
+          <p:cNvSpPr>
+            <a:spLocks noGrp="1"/>
+          </p:cNvSpPr>
+          <p:nvPr>
+            <p:ph type="sldNum" sz="quarter" idx="4294967295"/>
+          </p:nvPr>
+        </p:nvSpPr>
+        <p:spPr>
+          <a:xfrm>
+            <a:off x="8412480" y="4754880"/>
+            <a:ext cx="800000" cy="300000"/>
+          </a:xfrm>
+          <a:prstGeom prst="rect">
+            <a:avLst/>
+          </a:prstGeom>
+          <a:extLst>
+            <a:ext uri="{C572A759-6A51-4108-AA02-DFA0A04FC94B}">
+              <ma14:wrappingTextBoxFlag xmlns:ma14="http://schemas.microsoft.com/office/mac/drawingml/2011/main" val="0"/>
+            </a:ext>
+          </a:extLst>
+        </p:spPr>
+        <p:txBody>
+          <a:bodyPr/>
+          <a:lstStyle>
+            <a:lvl1pPr>
+              <a:defRPr sz="1000">
+                <a:solidFill>
+                  <a:schemeClr val="tx2"/>
+                </a:solidFill>
+              </a:defRPr>
+            </a:lvl1pPr>
+          </a:lstStyle>
+          <a:p>
+            <a:pPr algn="l"/>
+            <a:fld id="{F7021451-1387-4CA6-816F-3879F97B5CBC}" type="slidenum">
+              <a:rPr b="0" lang="en-US"/>
+              <a:t>15</a:t>
+            </a:fld>
+            <a:endParaRPr lang="en-US"/>
+          </a:p>
+        </p:txBody>
+      </p:sp>
+    </p:spTree>
+  </p:cSld>
+  <p:clrMapOvr>
+    <a:masterClrMapping/>
+  </p:clrMapOvr>
+</p:sld>
+</file>
+
+<file path=ppt/slides/slide16.xml><?xml version="1.0" encoding="utf-8"?>
+<p:sld xmlns:a="http://schemas.openxmlformats.org/drawingml/2006/main" xmlns:r="http://schemas.openxmlformats.org/officeDocument/2006/relationships" xmlns:p="http://schemas.openxmlformats.org/presentationml/2006/main">
+  <p:cSld name="Slide 16">
+    <p:spTree>
+      <p:nvGrpSpPr>
+        <p:cNvPr id="1" name=""/>
+        <p:cNvGrpSpPr/>
+        <p:nvPr/>
+      </p:nvGrpSpPr>
+      <p:grpSpPr>
+        <a:xfrm>
+          <a:off x="0" y="0"/>
+          <a:ext cx="0" cy="0"/>
+          <a:chOff x="0" y="0"/>
+          <a:chExt cx="0" cy="0"/>
+        </a:xfrm>
+      </p:grpSpPr>
+      <p:sp>
+        <p:nvSpPr>
+          <p:cNvPr id="2" name="Text 0"/>
+          <p:cNvSpPr/>
+          <p:nvPr>
+            <p:ph idx="100" type="title" hasCustomPrompt="1"/>
+          </p:nvPr>
+        </p:nvSpPr>
+        <p:spPr>
+          <a:xfrm>
+            <a:off x="457200" y="274320"/>
+            <a:ext cx="8229600" cy="640080"/>
+          </a:xfrm>
+          <a:prstGeom prst="rect">
+            <a:avLst/>
+          </a:prstGeom>
+          <a:noFill/>
+          <a:ln/>
+        </p:spPr>
+        <p:txBody>
+          <a:bodyPr wrap="square" rtlCol="0" anchor="ctr"/>
+          <a:lstStyle/>
+          <a:p>
+            <a:pPr algn="l" indent="0" marL="0">
+              <a:buNone/>
+            </a:pPr>
+            <a:r>
+              <a:rPr lang="en-US" sz="2600" b="1" dirty="0">
+                <a:solidFill>
+                  <a:schemeClr val="tx2"/>
+                </a:solidFill>
+              </a:rPr>
               <a:t>Three layers: decide, store, transport</a:t>
             </a:r>
             <a:endParaRPr lang="en-US" sz="2600" dirty="0"/>
@@ -5229,7 +5503,7 @@
       </p:sp>
       <p:graphicFrame>
         <p:nvGraphicFramePr>
-          <p:cNvPr id="16" name="layers table"/>
+          <p:cNvPr id="17" name="layers table"/>
           <p:cNvGraphicFramePr>
             <a:graphicFrameLocks noGrp="1"/>
           </p:cNvGraphicFramePr>
@@ -6073,439 +6347,6 @@
             <a:pPr algn="l"/>
             <a:fld id="{F7021451-1387-4CA6-816F-3879F97B5CBC}" type="slidenum">
               <a:rPr b="0" lang="en-US"/>
-              <a:t>15</a:t>
-            </a:fld>
-            <a:endParaRPr lang="en-US"/>
-          </a:p>
-        </p:txBody>
-      </p:sp>
-    </p:spTree>
-  </p:cSld>
-  <p:clrMapOvr>
-    <a:masterClrMapping/>
-  </p:clrMapOvr>
-</p:sld>
-</file>
-
-<file path=ppt/slides/slide16.xml><?xml version="1.0" encoding="utf-8"?>
-<p:sld xmlns:a="http://schemas.openxmlformats.org/drawingml/2006/main" xmlns:r="http://schemas.openxmlformats.org/officeDocument/2006/relationships" xmlns:p="http://schemas.openxmlformats.org/presentationml/2006/main">
-  <p:cSld name="Slide 16">
-    <p:spTree>
-      <p:nvGrpSpPr>
-        <p:cNvPr id="1" name=""/>
-        <p:cNvGrpSpPr/>
-        <p:nvPr/>
-      </p:nvGrpSpPr>
-      <p:grpSpPr>
-        <a:xfrm>
-          <a:off x="0" y="0"/>
-          <a:ext cx="0" cy="0"/>
-          <a:chOff x="0" y="0"/>
-          <a:chExt cx="0" cy="0"/>
-        </a:xfrm>
-      </p:grpSpPr>
-      <p:sp>
-        <p:nvSpPr>
-          <p:cNvPr id="2" name="Text 0"/>
-          <p:cNvSpPr/>
-          <p:nvPr>
-            <p:ph idx="100" type="title" hasCustomPrompt="1"/>
-          </p:nvPr>
-        </p:nvSpPr>
-        <p:spPr>
-          <a:xfrm>
-            <a:off x="457200" y="274320"/>
-            <a:ext cx="8229600" cy="640080"/>
-          </a:xfrm>
-          <a:prstGeom prst="rect">
-            <a:avLst/>
-          </a:prstGeom>
-          <a:noFill/>
-          <a:ln/>
-        </p:spPr>
-        <p:txBody>
-          <a:bodyPr wrap="square" rtlCol="0" anchor="ctr"/>
-          <a:lstStyle/>
-          <a:p>
-            <a:pPr algn="l" indent="0" marL="0">
-              <a:buNone/>
-            </a:pPr>
-            <a:r>
-              <a:rPr lang="en-US" sz="2600" b="1" dirty="0">
-                <a:solidFill>
-                  <a:schemeClr val="tx2"/>
-                </a:solidFill>
-              </a:rPr>
-              <a:t>The super loop: inputs, logic, services</a:t>
-            </a:r>
-            <a:endParaRPr lang="en-US" sz="2600" dirty="0"/>
-          </a:p>
-        </p:txBody>
-      </p:sp>
-      <p:sp>
-        <p:nvSpPr>
-          <p:cNvPr id="3" name="superloop box"/>
-          <p:cNvSpPr/>
-          <p:nvPr/>
-        </p:nvSpPr>
-        <p:spPr>
-          <a:xfrm>
-            <a:off x="457200" y="1097280"/>
-            <a:ext cx="4572000" cy="2194560"/>
-          </a:xfrm>
-          <a:prstGeom prst="roundRect">
-            <a:avLst>
-              <a:gd name="adj" fmla="val 3333"/>
-            </a:avLst>
-          </a:prstGeom>
-          <a:solidFill>
-            <a:srgbClr val="F4F6F4"/>
-          </a:solidFill>
-          <a:ln w="9525">
-            <a:solidFill>
-              <a:srgbClr val="D5DDD6"/>
-            </a:solidFill>
-            <a:prstDash val="solid"/>
-          </a:ln>
-        </p:spPr>
-      </p:sp>
-      <p:sp>
-        <p:nvSpPr>
-          <p:cNvPr id="4" name="superloop code"/>
-          <p:cNvSpPr txBox="1"/>
-          <p:nvPr/>
-        </p:nvSpPr>
-        <p:spPr>
-          <a:xfrm>
-            <a:off x="594360" y="1188720"/>
-            <a:ext cx="4297680" cy="2011680"/>
-          </a:xfrm>
-          <a:prstGeom prst="rect">
-            <a:avLst/>
-          </a:prstGeom>
-          <a:noFill/>
-          <a:ln/>
-        </p:spPr>
-        <p:txBody>
-          <a:bodyPr wrap="square" lIns="0" tIns="0" rIns="0" bIns="0" rtlCol="0" anchor="t"/>
-          <a:lstStyle/>
-          <a:p>
-            <a:pPr indent="0" marL="0">
-              <a:buNone/>
-            </a:pPr>
-            <a:r>
-              <a:rPr lang="en-US" sz="1100" dirty="0">
-                <a:solidFill>
-                  <a:srgbClr val="5C5C5C"/>
-                </a:solidFill>
-                <a:latin typeface="Courier New" pitchFamily="34" charset="0"/>
-                <a:ea typeface="Courier New" pitchFamily="34" charset="-122"/>
-                <a:cs typeface="Courier New" pitchFamily="34" charset="-120"/>
-              </a:rPr>
-              <a:t>while (1)</a:t>
-            </a:r>
-            <a:endParaRPr lang="en-US" sz="1100" dirty="0"/>
-          </a:p>
-          <a:p>
-            <a:pPr indent="0" marL="0">
-              <a:buNone/>
-            </a:pPr>
-            <a:r>
-              <a:rPr lang="en-US" sz="1100" dirty="0">
-                <a:solidFill>
-                  <a:srgbClr val="5C5C5C"/>
-                </a:solidFill>
-                <a:latin typeface="Courier New" pitchFamily="34" charset="0"/>
-                <a:ea typeface="Courier New" pitchFamily="34" charset="-122"/>
-                <a:cs typeface="Courier New" pitchFamily="34" charset="-120"/>
-              </a:rPr>
-              <a:t>{</a:t>
-            </a:r>
-            <a:endParaRPr lang="en-US" sz="1100" dirty="0"/>
-          </a:p>
-          <a:p>
-            <a:pPr indent="0" marL="0">
-              <a:buNone/>
-            </a:pPr>
-            <a:r>
-              <a:rPr lang="en-US" sz="1100" b="1" dirty="0">
-                <a:solidFill>
-                  <a:srgbClr val="1F6E43"/>
-                </a:solidFill>
-                <a:latin typeface="Courier New" pitchFamily="34" charset="0"/>
-                <a:ea typeface="Courier New" pitchFamily="34" charset="-122"/>
-                <a:cs typeface="Courier New" pitchFamily="34" charset="-120"/>
-              </a:rPr>
-              <a:t>  updateEncoders();      /* 1. inputs   */</a:t>
-            </a:r>
-            <a:endParaRPr lang="en-US" sz="1100" dirty="0"/>
-          </a:p>
-          <a:p>
-            <a:pPr indent="0" marL="0">
-              <a:buNone/>
-            </a:pPr>
-            <a:r>
-              <a:rPr lang="en-US" sz="1100" dirty="0">
-                <a:solidFill>
-                  <a:srgbClr val="5C5C5C"/>
-                </a:solidFill>
-                <a:latin typeface="Courier New" pitchFamily="34" charset="0"/>
-                <a:ea typeface="Courier New" pitchFamily="34" charset="-122"/>
-                <a:cs typeface="Courier New" pitchFamily="34" charset="-120"/>
-              </a:rPr>
-              <a:t>  updateIrSensor();</a:t>
-            </a:r>
-            <a:endParaRPr lang="en-US" sz="1100" dirty="0"/>
-          </a:p>
-          <a:p>
-            <a:pPr indent="0" marL="0">
-              <a:buNone/>
-            </a:pPr>
-            <a:endParaRPr lang="en-US" sz="1100" dirty="0"/>
-          </a:p>
-          <a:p>
-            <a:pPr indent="0" marL="0">
-              <a:buNone/>
-            </a:pPr>
-            <a:r>
-              <a:rPr lang="en-US" sz="1100" b="1" dirty="0">
-                <a:solidFill>
-                  <a:srgbClr val="1F6E43"/>
-                </a:solidFill>
-                <a:latin typeface="Courier New" pitchFamily="34" charset="0"/>
-                <a:ea typeface="Courier New" pitchFamily="34" charset="-122"/>
-                <a:cs typeface="Courier New" pitchFamily="34" charset="-120"/>
-              </a:rPr>
-              <a:t>  if (state != applied)  /* 2. logic    */</a:t>
-            </a:r>
-            <a:endParaRPr lang="en-US" sz="1100" dirty="0"/>
-          </a:p>
-          <a:p>
-            <a:pPr indent="0" marL="0">
-              <a:buNone/>
-            </a:pPr>
-            <a:r>
-              <a:rPr lang="en-US" sz="1100" dirty="0">
-                <a:solidFill>
-                  <a:srgbClr val="5C5C5C"/>
-                </a:solidFill>
-                <a:latin typeface="Courier New" pitchFamily="34" charset="0"/>
-                <a:ea typeface="Courier New" pitchFamily="34" charset="-122"/>
-                <a:cs typeface="Courier New" pitchFamily="34" charset="-120"/>
-              </a:rPr>
-              <a:t>    enterState(state);   /* once        */</a:t>
-            </a:r>
-            <a:endParaRPr lang="en-US" sz="1100" dirty="0"/>
-          </a:p>
-          <a:p>
-            <a:pPr indent="0" marL="0">
-              <a:buNone/>
-            </a:pPr>
-            <a:r>
-              <a:rPr lang="en-US" sz="1100" dirty="0">
-                <a:solidFill>
-                  <a:srgbClr val="5C5C5C"/>
-                </a:solidFill>
-                <a:latin typeface="Courier New" pitchFamily="34" charset="0"/>
-                <a:ea typeface="Courier New" pitchFamily="34" charset="-122"/>
-                <a:cs typeface="Courier New" pitchFamily="34" charset="-120"/>
-              </a:rPr>
-              <a:t>  runStateTick(applied); /* every pass  */</a:t>
-            </a:r>
-            <a:endParaRPr lang="en-US" sz="1100" dirty="0"/>
-          </a:p>
-          <a:p>
-            <a:pPr indent="0" marL="0">
-              <a:buNone/>
-            </a:pPr>
-            <a:endParaRPr lang="en-US" sz="1100" dirty="0"/>
-          </a:p>
-          <a:p>
-            <a:pPr indent="0" marL="0">
-              <a:buNone/>
-            </a:pPr>
-            <a:r>
-              <a:rPr lang="en-US" sz="1100" b="1" dirty="0">
-                <a:solidFill>
-                  <a:srgbClr val="1F6E43"/>
-                </a:solidFill>
-                <a:latin typeface="Courier New" pitchFamily="34" charset="0"/>
-                <a:ea typeface="Courier New" pitchFamily="34" charset="-122"/>
-                <a:cs typeface="Courier New" pitchFamily="34" charset="-120"/>
-              </a:rPr>
-              <a:t>  serviceRgbOutputs();   /* 3. services */</a:t>
-            </a:r>
-            <a:endParaRPr lang="en-US" sz="1100" dirty="0"/>
-          </a:p>
-          <a:p>
-            <a:pPr indent="0" marL="0">
-              <a:buNone/>
-            </a:pPr>
-            <a:r>
-              <a:rPr lang="en-US" sz="1100" dirty="0">
-                <a:solidFill>
-                  <a:srgbClr val="5C5C5C"/>
-                </a:solidFill>
-                <a:latin typeface="Courier New" pitchFamily="34" charset="0"/>
-                <a:ea typeface="Courier New" pitchFamily="34" charset="-122"/>
-                <a:cs typeface="Courier New" pitchFamily="34" charset="-120"/>
-              </a:rPr>
-              <a:t>  printPeriodicStatus();</a:t>
-            </a:r>
-            <a:endParaRPr lang="en-US" sz="1100" dirty="0"/>
-          </a:p>
-          <a:p>
-            <a:pPr indent="0" marL="0">
-              <a:buNone/>
-            </a:pPr>
-            <a:r>
-              <a:rPr lang="en-US" sz="1100" dirty="0">
-                <a:solidFill>
-                  <a:srgbClr val="5C5C5C"/>
-                </a:solidFill>
-                <a:latin typeface="Courier New" pitchFamily="34" charset="0"/>
-                <a:ea typeface="Courier New" pitchFamily="34" charset="-122"/>
-                <a:cs typeface="Courier New" pitchFamily="34" charset="-120"/>
-              </a:rPr>
-              <a:t>}</a:t>
-            </a:r>
-            <a:endParaRPr lang="en-US" sz="1100" dirty="0"/>
-          </a:p>
-        </p:txBody>
-      </p:sp>
-      <p:sp>
-        <p:nvSpPr>
-          <p:cNvPr id="5" name="superloop bullets"/>
-          <p:cNvSpPr txBox="1"/>
-          <p:nvPr/>
-        </p:nvSpPr>
-        <p:spPr>
-          <a:xfrm>
-            <a:off x="5303520" y="1097280"/>
-            <a:ext cx="3383280" cy="3291840"/>
-          </a:xfrm>
-          <a:prstGeom prst="rect">
-            <a:avLst/>
-          </a:prstGeom>
-          <a:noFill/>
-          <a:ln/>
-        </p:spPr>
-        <p:txBody>
-          <a:bodyPr wrap="square" rtlCol="0" anchor="t"/>
-          <a:lstStyle/>
-          <a:p>
-            <a:pPr marL="342900" indent="-342900">
-              <a:spcAft>
-                <a:spcPts val="800"/>
-              </a:spcAft>
-              <a:buSzPct val="100000"/>
-              <a:buChar char="•"/>
-            </a:pPr>
-            <a:r>
-              <a:rPr lang="en-US" sz="1500" dirty="0">
-                <a:solidFill>
-                  <a:srgbClr val="000000"/>
-                </a:solidFill>
-              </a:rPr>
-              <a:t>Keep every pass short, so polled inputs stay responsive.</a:t>
-            </a:r>
-            <a:endParaRPr lang="en-US" sz="1500" dirty="0"/>
-          </a:p>
-          <a:p>
-            <a:pPr marL="342900" indent="-342900">
-              <a:spcAft>
-                <a:spcPts val="800"/>
-              </a:spcAft>
-              <a:buSzPct val="100000"/>
-              <a:buChar char="•"/>
-            </a:pPr>
-            <a:r>
-              <a:rPr lang="en-US" sz="1500" dirty="0">
-                <a:solidFill>
-                  <a:srgbClr val="000000"/>
-                </a:solidFill>
-              </a:rPr>
-              <a:t>runStateTick: what the current state wants.</a:t>
-            </a:r>
-            <a:endParaRPr lang="en-US" sz="1500" dirty="0"/>
-          </a:p>
-          <a:p>
-            <a:pPr marL="342900" indent="-342900">
-              <a:spcAft>
-                <a:spcPts val="800"/>
-              </a:spcAft>
-              <a:buSzPct val="100000"/>
-              <a:buChar char="•"/>
-            </a:pPr>
-            <a:r>
-              <a:rPr lang="en-US" sz="1500" dirty="0">
-                <a:solidFill>
-                  <a:srgbClr val="000000"/>
-                </a:solidFill>
-              </a:rPr>
-              <a:t>Services: make the hardware match, in every state.</a:t>
-            </a:r>
-            <a:endParaRPr lang="en-US" sz="1500" dirty="0"/>
-          </a:p>
-          <a:p>
-            <a:pPr marL="342900" indent="-342900">
-              <a:spcAft>
-                <a:spcPts val="800"/>
-              </a:spcAft>
-              <a:buSzPct val="100000"/>
-              <a:buChar char="•"/>
-            </a:pPr>
-            <a:r>
-              <a:rPr lang="en-US" sz="1500" dirty="0">
-                <a:solidFill>
-                  <a:srgbClr val="B23A48"/>
-                </a:solidFill>
-              </a:rPr>
-              <a:t>Calling a service from inside one state's case would freeze that output in all other states.</a:t>
-            </a:r>
-            <a:endParaRPr lang="en-US" sz="1500" dirty="0"/>
-          </a:p>
-        </p:txBody>
-      </p:sp>
-      <p:sp>
-        <p:nvSpPr>
-          <p:cNvPr id="25" name="Slide Number Placeholder 0"/>
-          <p:cNvSpPr>
-            <a:spLocks noGrp="1"/>
-          </p:cNvSpPr>
-          <p:nvPr>
-            <p:ph type="sldNum" sz="quarter" idx="4294967295"/>
-          </p:nvPr>
-        </p:nvSpPr>
-        <p:spPr>
-          <a:xfrm>
-            <a:off x="8412480" y="4754880"/>
-            <a:ext cx="800000" cy="300000"/>
-          </a:xfrm>
-          <a:prstGeom prst="rect">
-            <a:avLst/>
-          </a:prstGeom>
-          <a:extLst>
-            <a:ext uri="{C572A759-6A51-4108-AA02-DFA0A04FC94B}">
-              <ma14:wrappingTextBoxFlag xmlns:ma14="http://schemas.microsoft.com/office/mac/drawingml/2011/main" val="0"/>
-            </a:ext>
-          </a:extLst>
-        </p:spPr>
-        <p:txBody>
-          <a:bodyPr/>
-          <a:lstStyle>
-            <a:lvl1pPr>
-              <a:defRPr sz="1000">
-                <a:solidFill>
-                  <a:schemeClr val="tx2"/>
-                </a:solidFill>
-              </a:defRPr>
-            </a:lvl1pPr>
-          </a:lstStyle>
-          <a:p>
-            <a:pPr algn="l"/>
-            <a:fld id="{F7021451-1387-4CA6-816F-3879F97B5CBC}" type="slidenum">
-              <a:rPr b="0" lang="en-US"/>
               <a:t>16</a:t>
             </a:fld>
             <a:endParaRPr lang="en-US"/>
@@ -6542,13 +6383,13 @@
           <p:cNvPr id="2" name="Text 0"/>
           <p:cNvSpPr/>
           <p:nvPr>
-            <p:ph idx="100" type="body" hasCustomPrompt="1"/>
+            <p:ph idx="100" type="title" hasCustomPrompt="1"/>
           </p:nvPr>
         </p:nvSpPr>
         <p:spPr>
           <a:xfrm>
-            <a:off x="548640" y="914400"/>
-            <a:ext cx="8046720" cy="457200"/>
+            <a:off x="457200" y="274320"/>
+            <a:ext cx="8229600" cy="640080"/>
           </a:xfrm>
           <a:prstGeom prst="rect">
             <a:avLst/>
@@ -6557,36 +6398,61 @@
           <a:ln/>
         </p:spPr>
         <p:txBody>
-          <a:bodyPr wrap="square" rtlCol="0"/>
+          <a:bodyPr wrap="square" rtlCol="0" anchor="ctr"/>
           <a:lstStyle/>
           <a:p>
             <a:pPr algn="l" indent="0" marL="0">
               <a:buNone/>
             </a:pPr>
             <a:r>
-              <a:rPr lang="en-US" sz="1600" b="1" dirty="0">
-                <a:solidFill>
-                  <a:schemeClr val="bg2"/>
-                </a:solidFill>
-              </a:rPr>
-              <a:t>TUTORIAL 5  ·  30.11.2026</a:t>
-            </a:r>
-            <a:endParaRPr lang="en-US" sz="1600" dirty="0"/>
-          </a:p>
-        </p:txBody>
-      </p:sp>
-      <p:sp>
-        <p:nvSpPr>
-          <p:cNvPr id="3" name="Text 0"/>
+              <a:rPr lang="en-US" sz="2600" b="1" dirty="0">
+                <a:solidFill>
+                  <a:schemeClr val="tx2"/>
+                </a:solidFill>
+              </a:rPr>
+              <a:t>The super loop: inputs, logic, services</a:t>
+            </a:r>
+            <a:endParaRPr lang="en-US" sz="2600" dirty="0"/>
+          </a:p>
+        </p:txBody>
+      </p:sp>
+      <p:sp>
+        <p:nvSpPr>
+          <p:cNvPr id="3" name="superloop box"/>
           <p:cNvSpPr/>
-          <p:nvPr>
-            <p:ph idx="101" type="title" hasCustomPrompt="1"/>
-          </p:nvPr>
+          <p:nvPr/>
         </p:nvSpPr>
         <p:spPr>
           <a:xfrm>
-            <a:off x="548640" y="1371600"/>
-            <a:ext cx="8046720" cy="1097280"/>
+            <a:off x="457200" y="1097280"/>
+            <a:ext cx="4572000" cy="2194560"/>
+          </a:xfrm>
+          <a:prstGeom prst="roundRect">
+            <a:avLst>
+              <a:gd name="adj" fmla="val 3333"/>
+            </a:avLst>
+          </a:prstGeom>
+          <a:solidFill>
+            <a:srgbClr val="F4F6F4"/>
+          </a:solidFill>
+          <a:ln w="9525">
+            <a:solidFill>
+              <a:srgbClr val="D5DDD6"/>
+            </a:solidFill>
+            <a:prstDash val="solid"/>
+          </a:ln>
+        </p:spPr>
+      </p:sp>
+      <p:sp>
+        <p:nvSpPr>
+          <p:cNvPr id="4" name="superloop code"/>
+          <p:cNvSpPr txBox="1"/>
+          <p:nvPr/>
+        </p:nvSpPr>
+        <p:spPr>
+          <a:xfrm>
+            <a:off x="594360" y="1188720"/>
+            <a:ext cx="4297680" cy="2011680"/>
           </a:xfrm>
           <a:prstGeom prst="rect">
             <a:avLst/>
@@ -6595,36 +6461,202 @@
           <a:ln/>
         </p:spPr>
         <p:txBody>
-          <a:bodyPr wrap="square" rtlCol="0" anchor="t"/>
+          <a:bodyPr wrap="square" lIns="0" tIns="0" rIns="0" bIns="0" rtlCol="0" anchor="t"/>
           <a:lstStyle/>
           <a:p>
-            <a:pPr algn="l" indent="0" marL="0">
+            <a:pPr indent="0" marL="0">
               <a:buNone/>
             </a:pPr>
             <a:r>
-              <a:rPr lang="en-US" sz="3600" b="1" dirty="0">
-                <a:solidFill>
-                  <a:schemeClr val="bg1"/>
-                </a:solidFill>
-              </a:rPr>
-              <a:t>Inside the I2C bus</a:t>
-            </a:r>
-            <a:endParaRPr lang="en-US" sz="3600" dirty="0"/>
-          </a:p>
-        </p:txBody>
-      </p:sp>
-      <p:sp>
-        <p:nvSpPr>
-          <p:cNvPr id="4" name="Text 0"/>
-          <p:cNvSpPr/>
-          <p:nvPr>
-            <p:ph idx="102" type="body" hasCustomPrompt="1"/>
-          </p:nvPr>
+              <a:rPr lang="en-US" sz="1100" dirty="0">
+                <a:solidFill>
+                  <a:srgbClr val="5C5C5C"/>
+                </a:solidFill>
+                <a:latin typeface="Courier New" pitchFamily="34" charset="0"/>
+                <a:ea typeface="Courier New" pitchFamily="34" charset="-122"/>
+                <a:cs typeface="Courier New" pitchFamily="34" charset="-120"/>
+              </a:rPr>
+              <a:t>while (1)</a:t>
+            </a:r>
+            <a:endParaRPr lang="en-US" sz="1100" dirty="0"/>
+          </a:p>
+          <a:p>
+            <a:pPr indent="0" marL="0">
+              <a:buNone/>
+            </a:pPr>
+            <a:r>
+              <a:rPr lang="en-US" sz="1100" dirty="0">
+                <a:solidFill>
+                  <a:srgbClr val="5C5C5C"/>
+                </a:solidFill>
+                <a:latin typeface="Courier New" pitchFamily="34" charset="0"/>
+                <a:ea typeface="Courier New" pitchFamily="34" charset="-122"/>
+                <a:cs typeface="Courier New" pitchFamily="34" charset="-120"/>
+              </a:rPr>
+              <a:t>{</a:t>
+            </a:r>
+            <a:endParaRPr lang="en-US" sz="1100" dirty="0"/>
+          </a:p>
+          <a:p>
+            <a:pPr indent="0" marL="0">
+              <a:buNone/>
+            </a:pPr>
+            <a:r>
+              <a:rPr lang="en-US" sz="1100" b="1" dirty="0">
+                <a:solidFill>
+                  <a:srgbClr val="1F6E43"/>
+                </a:solidFill>
+                <a:latin typeface="Courier New" pitchFamily="34" charset="0"/>
+                <a:ea typeface="Courier New" pitchFamily="34" charset="-122"/>
+                <a:cs typeface="Courier New" pitchFamily="34" charset="-120"/>
+              </a:rPr>
+              <a:t>  updateEncoders();      /* 1. inputs   */</a:t>
+            </a:r>
+            <a:endParaRPr lang="en-US" sz="1100" dirty="0"/>
+          </a:p>
+          <a:p>
+            <a:pPr indent="0" marL="0">
+              <a:buNone/>
+            </a:pPr>
+            <a:r>
+              <a:rPr lang="en-US" sz="1100" dirty="0">
+                <a:solidFill>
+                  <a:srgbClr val="5C5C5C"/>
+                </a:solidFill>
+                <a:latin typeface="Courier New" pitchFamily="34" charset="0"/>
+                <a:ea typeface="Courier New" pitchFamily="34" charset="-122"/>
+                <a:cs typeface="Courier New" pitchFamily="34" charset="-120"/>
+              </a:rPr>
+              <a:t>  updateIrSensor();</a:t>
+            </a:r>
+            <a:endParaRPr lang="en-US" sz="1100" dirty="0"/>
+          </a:p>
+          <a:p>
+            <a:pPr indent="0" marL="0">
+              <a:buNone/>
+            </a:pPr>
+            <a:endParaRPr lang="en-US" sz="1100" dirty="0"/>
+          </a:p>
+          <a:p>
+            <a:pPr indent="0" marL="0">
+              <a:buNone/>
+            </a:pPr>
+            <a:r>
+              <a:rPr lang="en-US" sz="1100" b="1" dirty="0">
+                <a:solidFill>
+                  <a:srgbClr val="1F6E43"/>
+                </a:solidFill>
+                <a:latin typeface="Courier New" pitchFamily="34" charset="0"/>
+                <a:ea typeface="Courier New" pitchFamily="34" charset="-122"/>
+                <a:cs typeface="Courier New" pitchFamily="34" charset="-120"/>
+              </a:rPr>
+              <a:t>  if (state != applied)  /* 2. logic    */</a:t>
+            </a:r>
+            <a:endParaRPr lang="en-US" sz="1100" dirty="0"/>
+          </a:p>
+          <a:p>
+            <a:pPr indent="0" marL="0">
+              <a:buNone/>
+            </a:pPr>
+            <a:r>
+              <a:rPr lang="en-US" sz="1100" dirty="0">
+                <a:solidFill>
+                  <a:srgbClr val="5C5C5C"/>
+                </a:solidFill>
+                <a:latin typeface="Courier New" pitchFamily="34" charset="0"/>
+                <a:ea typeface="Courier New" pitchFamily="34" charset="-122"/>
+                <a:cs typeface="Courier New" pitchFamily="34" charset="-120"/>
+              </a:rPr>
+              <a:t>    enterState(state);   /* once        */</a:t>
+            </a:r>
+            <a:endParaRPr lang="en-US" sz="1100" dirty="0"/>
+          </a:p>
+          <a:p>
+            <a:pPr indent="0" marL="0">
+              <a:buNone/>
+            </a:pPr>
+            <a:r>
+              <a:rPr lang="en-US" sz="1100" dirty="0">
+                <a:solidFill>
+                  <a:srgbClr val="5C5C5C"/>
+                </a:solidFill>
+                <a:latin typeface="Courier New" pitchFamily="34" charset="0"/>
+                <a:ea typeface="Courier New" pitchFamily="34" charset="-122"/>
+                <a:cs typeface="Courier New" pitchFamily="34" charset="-120"/>
+              </a:rPr>
+              <a:t>  runStateTick(applied); /* every pass  */</a:t>
+            </a:r>
+            <a:endParaRPr lang="en-US" sz="1100" dirty="0"/>
+          </a:p>
+          <a:p>
+            <a:pPr indent="0" marL="0">
+              <a:buNone/>
+            </a:pPr>
+            <a:endParaRPr lang="en-US" sz="1100" dirty="0"/>
+          </a:p>
+          <a:p>
+            <a:pPr indent="0" marL="0">
+              <a:buNone/>
+            </a:pPr>
+            <a:r>
+              <a:rPr lang="en-US" sz="1100" b="1" dirty="0">
+                <a:solidFill>
+                  <a:srgbClr val="1F6E43"/>
+                </a:solidFill>
+                <a:latin typeface="Courier New" pitchFamily="34" charset="0"/>
+                <a:ea typeface="Courier New" pitchFamily="34" charset="-122"/>
+                <a:cs typeface="Courier New" pitchFamily="34" charset="-120"/>
+              </a:rPr>
+              <a:t>  serviceRgbOutputs();   /* 3. services */</a:t>
+            </a:r>
+            <a:endParaRPr lang="en-US" sz="1100" dirty="0"/>
+          </a:p>
+          <a:p>
+            <a:pPr indent="0" marL="0">
+              <a:buNone/>
+            </a:pPr>
+            <a:r>
+              <a:rPr lang="en-US" sz="1100" dirty="0">
+                <a:solidFill>
+                  <a:srgbClr val="5C5C5C"/>
+                </a:solidFill>
+                <a:latin typeface="Courier New" pitchFamily="34" charset="0"/>
+                <a:ea typeface="Courier New" pitchFamily="34" charset="-122"/>
+                <a:cs typeface="Courier New" pitchFamily="34" charset="-120"/>
+              </a:rPr>
+              <a:t>  printPeriodicStatus();</a:t>
+            </a:r>
+            <a:endParaRPr lang="en-US" sz="1100" dirty="0"/>
+          </a:p>
+          <a:p>
+            <a:pPr indent="0" marL="0">
+              <a:buNone/>
+            </a:pPr>
+            <a:r>
+              <a:rPr lang="en-US" sz="1100" dirty="0">
+                <a:solidFill>
+                  <a:srgbClr val="5C5C5C"/>
+                </a:solidFill>
+                <a:latin typeface="Courier New" pitchFamily="34" charset="0"/>
+                <a:ea typeface="Courier New" pitchFamily="34" charset="-122"/>
+                <a:cs typeface="Courier New" pitchFamily="34" charset="-120"/>
+              </a:rPr>
+              <a:t>}</a:t>
+            </a:r>
+            <a:endParaRPr lang="en-US" sz="1100" dirty="0"/>
+          </a:p>
+        </p:txBody>
+      </p:sp>
+      <p:sp>
+        <p:nvSpPr>
+          <p:cNvPr id="5" name="superloop bullets"/>
+          <p:cNvSpPr txBox="1"/>
+          <p:nvPr/>
         </p:nvSpPr>
         <p:spPr>
           <a:xfrm>
-            <a:off x="548640" y="2743200"/>
-            <a:ext cx="8046720" cy="1737360"/>
+            <a:off x="5303520" y="1097280"/>
+            <a:ext cx="3383280" cy="3291840"/>
           </a:xfrm>
           <a:prstGeom prst="rect">
             <a:avLst/>
@@ -6636,18 +6668,76 @@
           <a:bodyPr wrap="square" rtlCol="0" anchor="t"/>
           <a:lstStyle/>
           <a:p>
-            <a:pPr algn="l" indent="0" marL="0">
-              <a:buNone/>
-            </a:pPr>
-            <a:r>
-              <a:rPr lang="en-US" sz="1600" dirty="0">
-                <a:solidFill>
-                  <a:schemeClr val="bg1"/>
-                </a:solidFill>
-              </a:rPr>
-              <a:t>I2C bus scan: detect the five IO-board chips; set_rgb rewritten on raw HAL_I2C_Mem_Write; servo sweep.</a:t>
-            </a:r>
-            <a:endParaRPr lang="en-US" sz="1600" dirty="0"/>
+            <a:pPr marL="342900" indent="-342900">
+              <a:spcAft>
+                <a:spcPts val="800"/>
+              </a:spcAft>
+              <a:buSzPct val="100000"/>
+              <a:buChar char="•"/>
+            </a:pPr>
+            <a:r>
+              <a:rPr lang="en-US" sz="1500" dirty="0">
+                <a:solidFill>
+                  <a:srgbClr val="000000"/>
+                </a:solidFill>
+              </a:rPr>
+              <a:t>Keep every pass short, so polled inputs stay responsive.</a:t>
+            </a:r>
+            <a:endParaRPr lang="en-US" sz="1500" dirty="0"/>
+          </a:p>
+          <a:p>
+            <a:pPr marL="342900" indent="-342900">
+              <a:spcAft>
+                <a:spcPts val="800"/>
+              </a:spcAft>
+              <a:buSzPct val="100000"/>
+              <a:buChar char="•"/>
+            </a:pPr>
+            <a:r>
+              <a:rPr lang="en-US" sz="1500" dirty="0">
+                <a:solidFill>
+                  <a:srgbClr val="000000"/>
+                </a:solidFill>
+              </a:rPr>
+              <a:t>runStateTick: what the current state wants.</a:t>
+            </a:r>
+            <a:endParaRPr lang="en-US" sz="1500" dirty="0"/>
+          </a:p>
+          <a:p>
+            <a:pPr marL="342900" indent="-342900">
+              <a:spcAft>
+                <a:spcPts val="800"/>
+              </a:spcAft>
+              <a:buSzPct val="100000"/>
+              <a:buChar char="•"/>
+            </a:pPr>
+            <a:r>
+              <a:rPr lang="en-US" sz="1500" dirty="0">
+                <a:solidFill>
+                  <a:srgbClr val="000000"/>
+                </a:solidFill>
+              </a:rPr>
+              <a:t>Services: make the hardware match, in every state.</a:t>
+            </a:r>
+            <a:endParaRPr lang="en-US" sz="1500" dirty="0"/>
+          </a:p>
+          <a:p>
+            <a:pPr marL="342900" indent="-342900">
+              <a:spcAft>
+                <a:spcPts val="800"/>
+              </a:spcAft>
+              <a:buSzPct val="100000"/>
+              <a:buChar char="•"/>
+            </a:pPr>
+            <a:r>
+              <a:rPr lang="en-US" sz="1500" dirty="0">
+                <a:solidFill>
+                  <a:srgbClr val="B23A48"/>
+                </a:solidFill>
+              </a:rPr>
+              <a:t>Calling a service from inside one state's case would freeze that output in all other states.</a:t>
+            </a:r>
+            <a:endParaRPr lang="en-US" sz="1500" dirty="0"/>
           </a:p>
         </p:txBody>
       </p:sp>
@@ -6681,7 +6771,7 @@
             <a:lvl1pPr>
               <a:defRPr sz="1000">
                 <a:solidFill>
-                  <a:schemeClr val="bg2"/>
+                  <a:schemeClr val="tx2"/>
                 </a:solidFill>
               </a:defRPr>
             </a:lvl1pPr>
@@ -6753,7 +6843,7 @@
                   <a:schemeClr val="bg2"/>
                 </a:solidFill>
               </a:rPr>
-              <a:t>TUTORIAL 6  ·  7.12.2026</a:t>
+              <a:t>TUTORIAL 5  ·  30.11.2026</a:t>
             </a:r>
             <a:endParaRPr lang="en-US" sz="1600" dirty="0"/>
           </a:p>
@@ -6791,7 +6881,7 @@
                   <a:schemeClr val="bg1"/>
                 </a:solidFill>
               </a:rPr>
-              <a:t>PWM, input capture and EXTI</a:t>
+              <a:t>Inside the I2C bus</a:t>
             </a:r>
             <a:endParaRPr lang="en-US" sz="3600" dirty="0"/>
           </a:p>
@@ -6829,7 +6919,7 @@
                   <a:schemeClr val="bg1"/>
                 </a:solidFill>
               </a:rPr>
-              <a:t>One ultrasonic distance measurement; an EXTI interrupt with a counter; PWM on one motor channel.</a:t>
+              <a:t>I2C bus scan: detect the five IO-board chips; set_rgb rewritten on raw HAL_I2C_Mem_Write; servo sweep.</a:t>
             </a:r>
             <a:endParaRPr lang="en-US" sz="1600" dirty="0"/>
           </a:p>
@@ -6937,7 +7027,7 @@
                   <a:schemeClr val="bg2"/>
                 </a:solidFill>
               </a:rPr>
-              <a:t>TUTORIAL 7  ·  14.12.2026</a:t>
+              <a:t>TUTORIAL 6  ·  7.12.2026</a:t>
             </a:r>
             <a:endParaRPr lang="en-US" sz="1600" dirty="0"/>
           </a:p>
@@ -6975,7 +7065,7 @@
                   <a:schemeClr val="bg1"/>
                 </a:solidFill>
               </a:rPr>
-              <a:t>One wheel in the air</a:t>
+              <a:t>PWM, input capture and EXTI</a:t>
             </a:r>
             <a:endParaRPr lang="en-US" sz="3600" dirty="0"/>
           </a:p>
@@ -7013,7 +7103,7 @@
                   <a:schemeClr val="bg1"/>
                 </a:solidFill>
               </a:rPr>
-              <a:t>Open-loop PWM; encoder counts to rad/s; record a run and export it to MATLAB.</a:t>
+              <a:t>One ultrasonic distance measurement; an EXTI interrupt with a counter; PWM on one motor channel.</a:t>
             </a:r>
             <a:endParaRPr lang="en-US" sz="1600" dirty="0"/>
           </a:p>
@@ -7305,7 +7395,7 @@
                   <a:schemeClr val="bg2"/>
                 </a:solidFill>
               </a:rPr>
-              <a:t>TUTORIAL 8  ·  21.12.2026</a:t>
+              <a:t>TUTORIAL 7  ·  14.12.2026</a:t>
             </a:r>
             <a:endParaRPr lang="en-US" sz="1600" dirty="0"/>
           </a:p>
@@ -7343,7 +7433,7 @@
                   <a:schemeClr val="bg1"/>
                 </a:solidFill>
               </a:rPr>
-              <a:t>From model to PI controller</a:t>
+              <a:t>One wheel in the air</a:t>
             </a:r>
             <a:endParaRPr lang="en-US" sz="3600" dirty="0"/>
           </a:p>
@@ -7381,7 +7471,7 @@
                   <a:schemeClr val="bg1"/>
                 </a:solidFill>
               </a:rPr>
-              <a:t>Model fit, sisotool, c2d; the difference equation in C; simulated vs. measured step response.</a:t>
+              <a:t>Open-loop PWM; encoder counts to rad/s; record a run and export it to MATLAB.</a:t>
             </a:r>
             <a:endParaRPr lang="en-US" sz="1600" dirty="0"/>
           </a:p>
@@ -7489,7 +7579,7 @@
                   <a:schemeClr val="bg2"/>
                 </a:solidFill>
               </a:rPr>
-              <a:t>TUTORIAL 9  ·  28.12.2026</a:t>
+              <a:t>TUTORIAL 8  ·  21.12.2026</a:t>
             </a:r>
             <a:endParaRPr lang="en-US" sz="1600" dirty="0"/>
           </a:p>
@@ -7527,7 +7617,7 @@
                   <a:schemeClr val="bg1"/>
                 </a:solidFill>
               </a:rPr>
-              <a:t>UART commands and a MATLAB GUI</a:t>
+              <a:t>From model to PI controller</a:t>
             </a:r>
             <a:endParaRPr lang="en-US" sz="3600" dirty="0"/>
           </a:p>
@@ -7565,7 +7655,7 @@
                   <a:schemeClr val="bg1"/>
                 </a:solidFill>
               </a:rPr>
-              <a:t>An interrupt-driven UART command parser; a minimal MATLAB GUI that sends commands and plots telemetry.</a:t>
+              <a:t>Model fit, sisotool, c2d; the difference equation in C; simulated vs. measured step response.</a:t>
             </a:r>
             <a:endParaRPr lang="en-US" sz="1600" dirty="0"/>
           </a:p>
@@ -7673,7 +7763,7 @@
                   <a:schemeClr val="bg2"/>
                 </a:solidFill>
               </a:rPr>
-              <a:t>TUTORIAL 10  ·  4.1.2027</a:t>
+              <a:t>TUTORIAL 9  ·  28.12.2026</a:t>
             </a:r>
             <a:endParaRPr lang="en-US" sz="1600" dirty="0"/>
           </a:p>
@@ -7711,7 +7801,7 @@
                   <a:schemeClr val="bg1"/>
                 </a:solidFill>
               </a:rPr>
-              <a:t>Driving the cart</a:t>
+              <a:t>UART commands and a MATLAB GUI</a:t>
             </a:r>
             <a:endParaRPr lang="en-US" sz="3600" dirty="0"/>
           </a:p>
@@ -7749,7 +7839,7 @@
                   <a:schemeClr val="bg1"/>
                 </a:solidFill>
               </a:rPr>
-              <a:t>Kinematics exercises; driving on the floor; a trajectory array generated in MATLAB and sent to the cart.</a:t>
+              <a:t>An interrupt-driven UART command parser; a minimal MATLAB GUI that sends commands and plots telemetry.</a:t>
             </a:r>
             <a:endParaRPr lang="en-US" sz="1600" dirty="0"/>
           </a:p>
@@ -7857,7 +7947,7 @@
                   <a:schemeClr val="bg2"/>
                 </a:solidFill>
               </a:rPr>
-              <a:t>TUTORIAL 11  ·  11.1.2027</a:t>
+              <a:t>TUTORIAL 10  ·  4.1.2027</a:t>
             </a:r>
             <a:endParaRPr lang="en-US" sz="1600" dirty="0"/>
           </a:p>
@@ -7895,7 +7985,7 @@
                   <a:schemeClr val="bg1"/>
                 </a:solidFill>
               </a:rPr>
-              <a:t>Simulink to C</a:t>
+              <a:t>Driving the cart</a:t>
             </a:r>
             <a:endParaRPr lang="en-US" sz="3600" dirty="0"/>
           </a:p>
@@ -7933,7 +8023,7 @@
                   <a:schemeClr val="bg1"/>
                 </a:solidFill>
               </a:rPr>
-              <a:t>Export a Simulink PI controller or filter to C and run it on the cart.</a:t>
+              <a:t>Kinematics exercises; driving on the floor; a trajectory array generated in MATLAB and sent to the cart.</a:t>
             </a:r>
             <a:endParaRPr lang="en-US" sz="1600" dirty="0"/>
           </a:p>
@@ -8041,7 +8131,7 @@
                   <a:schemeClr val="bg2"/>
                 </a:solidFill>
               </a:rPr>
-              <a:t>TUTORIAL 12  ·  18.1.2027</a:t>
+              <a:t>TUTORIAL 11  ·  11.1.2027</a:t>
             </a:r>
             <a:endParaRPr lang="en-US" sz="1600" dirty="0"/>
           </a:p>
@@ -8079,7 +8169,7 @@
                   <a:schemeClr val="bg1"/>
                 </a:solidFill>
               </a:rPr>
-              <a:t>Project clinic</a:t>
+              <a:t>Simulink to C</a:t>
             </a:r>
             <a:endParaRPr lang="en-US" sz="3600" dirty="0"/>
           </a:p>
@@ -8117,7 +8207,7 @@
                   <a:schemeClr val="bg1"/>
                 </a:solidFill>
               </a:rPr>
-              <a:t>Open session for Assignment 3 questions.</a:t>
+              <a:t>Export a Simulink PI controller or filter to C and run it on the cart.</a:t>
             </a:r>
             <a:endParaRPr lang="en-US" sz="1600" dirty="0"/>
           </a:p>
@@ -8225,7 +8315,7 @@
                   <a:schemeClr val="bg2"/>
                 </a:solidFill>
               </a:rPr>
-              <a:t>SESSION 13  ·  25.1.2027</a:t>
+              <a:t>TUTORIAL 12  ·  18.1.2027</a:t>
             </a:r>
             <a:endParaRPr lang="en-US" sz="1600" dirty="0"/>
           </a:p>
@@ -8263,7 +8353,7 @@
                   <a:schemeClr val="bg1"/>
                 </a:solidFill>
               </a:rPr>
-              <a:t>Lab meeting</a:t>
+              <a:t>Project clinic</a:t>
             </a:r>
             <a:endParaRPr lang="en-US" sz="3600" dirty="0"/>
           </a:p>
@@ -8301,7 +8391,7 @@
                   <a:schemeClr val="bg1"/>
                 </a:solidFill>
               </a:rPr>
-              <a:t>Open questions.</a:t>
+              <a:t>Open session for Assignment 3 questions.</a:t>
             </a:r>
             <a:endParaRPr lang="en-US" sz="1600" dirty="0"/>
           </a:p>
@@ -8347,6 +8437,190 @@
             <a:fld id="{F7021451-1387-4CA6-816F-3879F97B5CBC}" type="slidenum">
               <a:rPr b="0" lang="en-US"/>
               <a:t>25</a:t>
+            </a:fld>
+            <a:endParaRPr lang="en-US"/>
+          </a:p>
+        </p:txBody>
+      </p:sp>
+    </p:spTree>
+  </p:cSld>
+  <p:clrMapOvr>
+    <a:masterClrMapping/>
+  </p:clrMapOvr>
+</p:sld>
+</file>
+
+<file path=ppt/slides/slide26.xml><?xml version="1.0" encoding="utf-8"?>
+<p:sld xmlns:a="http://schemas.openxmlformats.org/drawingml/2006/main" xmlns:r="http://schemas.openxmlformats.org/officeDocument/2006/relationships" xmlns:p="http://schemas.openxmlformats.org/presentationml/2006/main">
+  <p:cSld name="Slide 26">
+    <p:spTree>
+      <p:nvGrpSpPr>
+        <p:cNvPr id="1" name=""/>
+        <p:cNvGrpSpPr/>
+        <p:nvPr/>
+      </p:nvGrpSpPr>
+      <p:grpSpPr>
+        <a:xfrm>
+          <a:off x="0" y="0"/>
+          <a:ext cx="0" cy="0"/>
+          <a:chOff x="0" y="0"/>
+          <a:chExt cx="0" cy="0"/>
+        </a:xfrm>
+      </p:grpSpPr>
+      <p:sp>
+        <p:nvSpPr>
+          <p:cNvPr id="2" name="Text 0"/>
+          <p:cNvSpPr/>
+          <p:nvPr>
+            <p:ph idx="100" type="body" hasCustomPrompt="1"/>
+          </p:nvPr>
+        </p:nvSpPr>
+        <p:spPr>
+          <a:xfrm>
+            <a:off x="548640" y="914400"/>
+            <a:ext cx="8046720" cy="457200"/>
+          </a:xfrm>
+          <a:prstGeom prst="rect">
+            <a:avLst/>
+          </a:prstGeom>
+          <a:noFill/>
+          <a:ln/>
+        </p:spPr>
+        <p:txBody>
+          <a:bodyPr wrap="square" rtlCol="0"/>
+          <a:lstStyle/>
+          <a:p>
+            <a:pPr algn="l" indent="0" marL="0">
+              <a:buNone/>
+            </a:pPr>
+            <a:r>
+              <a:rPr lang="en-US" sz="1600" b="1" dirty="0">
+                <a:solidFill>
+                  <a:schemeClr val="bg2"/>
+                </a:solidFill>
+              </a:rPr>
+              <a:t>SESSION 13  ·  25.1.2027</a:t>
+            </a:r>
+            <a:endParaRPr lang="en-US" sz="1600" dirty="0"/>
+          </a:p>
+        </p:txBody>
+      </p:sp>
+      <p:sp>
+        <p:nvSpPr>
+          <p:cNvPr id="3" name="Text 0"/>
+          <p:cNvSpPr/>
+          <p:nvPr>
+            <p:ph idx="101" type="title" hasCustomPrompt="1"/>
+          </p:nvPr>
+        </p:nvSpPr>
+        <p:spPr>
+          <a:xfrm>
+            <a:off x="548640" y="1371600"/>
+            <a:ext cx="8046720" cy="1097280"/>
+          </a:xfrm>
+          <a:prstGeom prst="rect">
+            <a:avLst/>
+          </a:prstGeom>
+          <a:noFill/>
+          <a:ln/>
+        </p:spPr>
+        <p:txBody>
+          <a:bodyPr wrap="square" rtlCol="0" anchor="t"/>
+          <a:lstStyle/>
+          <a:p>
+            <a:pPr algn="l" indent="0" marL="0">
+              <a:buNone/>
+            </a:pPr>
+            <a:r>
+              <a:rPr lang="en-US" sz="3600" b="1" dirty="0">
+                <a:solidFill>
+                  <a:schemeClr val="bg1"/>
+                </a:solidFill>
+              </a:rPr>
+              <a:t>Lab meeting</a:t>
+            </a:r>
+            <a:endParaRPr lang="en-US" sz="3600" dirty="0"/>
+          </a:p>
+        </p:txBody>
+      </p:sp>
+      <p:sp>
+        <p:nvSpPr>
+          <p:cNvPr id="4" name="Text 0"/>
+          <p:cNvSpPr/>
+          <p:nvPr>
+            <p:ph idx="102" type="body" hasCustomPrompt="1"/>
+          </p:nvPr>
+        </p:nvSpPr>
+        <p:spPr>
+          <a:xfrm>
+            <a:off x="548640" y="2743200"/>
+            <a:ext cx="8046720" cy="1737360"/>
+          </a:xfrm>
+          <a:prstGeom prst="rect">
+            <a:avLst/>
+          </a:prstGeom>
+          <a:noFill/>
+          <a:ln/>
+        </p:spPr>
+        <p:txBody>
+          <a:bodyPr wrap="square" rtlCol="0" anchor="t"/>
+          <a:lstStyle/>
+          <a:p>
+            <a:pPr algn="l" indent="0" marL="0">
+              <a:buNone/>
+            </a:pPr>
+            <a:r>
+              <a:rPr lang="en-US" sz="1600" dirty="0">
+                <a:solidFill>
+                  <a:schemeClr val="bg1"/>
+                </a:solidFill>
+              </a:rPr>
+              <a:t>Open questions.</a:t>
+            </a:r>
+            <a:endParaRPr lang="en-US" sz="1600" dirty="0"/>
+          </a:p>
+        </p:txBody>
+      </p:sp>
+      <p:sp>
+        <p:nvSpPr>
+          <p:cNvPr id="25" name="Slide Number Placeholder 0"/>
+          <p:cNvSpPr>
+            <a:spLocks noGrp="1"/>
+          </p:cNvSpPr>
+          <p:nvPr>
+            <p:ph type="sldNum" sz="quarter" idx="4294967295"/>
+          </p:nvPr>
+        </p:nvSpPr>
+        <p:spPr>
+          <a:xfrm>
+            <a:off x="8412480" y="4754880"/>
+            <a:ext cx="800000" cy="300000"/>
+          </a:xfrm>
+          <a:prstGeom prst="rect">
+            <a:avLst/>
+          </a:prstGeom>
+          <a:extLst>
+            <a:ext uri="{C572A759-6A51-4108-AA02-DFA0A04FC94B}">
+              <ma14:wrappingTextBoxFlag xmlns:ma14="http://schemas.microsoft.com/office/mac/drawingml/2011/main" val="0"/>
+            </a:ext>
+          </a:extLst>
+        </p:spPr>
+        <p:txBody>
+          <a:bodyPr/>
+          <a:lstStyle>
+            <a:lvl1pPr>
+              <a:defRPr sz="1000">
+                <a:solidFill>
+                  <a:schemeClr val="bg2"/>
+                </a:solidFill>
+              </a:defRPr>
+            </a:lvl1pPr>
+          </a:lstStyle>
+          <a:p>
+            <a:pPr algn="l"/>
+            <a:fld id="{F7021451-1387-4CA6-816F-3879F97B5CBC}" type="slidenum">
+              <a:rPr b="0" lang="en-US"/>
+              <a:t>26</a:t>
             </a:fld>
             <a:endParaRPr lang="en-US"/>
           </a:p>
@@ -13901,13 +14175,13 @@
           <p:cNvPr id="2" name="Text 0"/>
           <p:cNvSpPr/>
           <p:nvPr>
-            <p:ph idx="100" type="body" hasCustomPrompt="1"/>
+            <p:ph idx="100" type="title" hasCustomPrompt="1"/>
           </p:nvPr>
         </p:nvSpPr>
         <p:spPr>
           <a:xfrm>
-            <a:off x="548640" y="914400"/>
-            <a:ext cx="8046720" cy="457200"/>
+            <a:off x="457200" y="274320"/>
+            <a:ext cx="8229600" cy="640080"/>
           </a:xfrm>
           <a:prstGeom prst="rect">
             <a:avLst/>
@@ -13916,36 +14190,61 @@
           <a:ln/>
         </p:spPr>
         <p:txBody>
-          <a:bodyPr wrap="square" rtlCol="0"/>
+          <a:bodyPr wrap="square" rtlCol="0" anchor="ctr"/>
           <a:lstStyle/>
           <a:p>
             <a:pPr algn="l" indent="0" marL="0">
               <a:buNone/>
             </a:pPr>
             <a:r>
-              <a:rPr lang="en-US" sz="1600" b="1" dirty="0">
-                <a:solidFill>
-                  <a:schemeClr val="bg2"/>
-                </a:solidFill>
-              </a:rPr>
-              <a:t>TUTORIAL 2  ·  9.11.2026</a:t>
-            </a:r>
-            <a:endParaRPr lang="en-US" sz="1600" dirty="0"/>
-          </a:p>
-        </p:txBody>
-      </p:sp>
-      <p:sp>
-        <p:nvSpPr>
-          <p:cNvPr id="3" name="Text 0"/>
+              <a:rPr lang="en-US" sz="2600" b="1" dirty="0">
+                <a:solidFill>
+                  <a:schemeClr val="tx2"/>
+                </a:solidFill>
+              </a:rPr>
+              <a:t>Moving a project to another PC</a:t>
+            </a:r>
+            <a:endParaRPr lang="en-US" sz="2600" dirty="0"/>
+          </a:p>
+        </p:txBody>
+      </p:sp>
+      <p:sp>
+        <p:nvSpPr>
+          <p:cNvPr id="3" name="move card 1"/>
           <p:cNvSpPr/>
-          <p:nvPr>
-            <p:ph idx="101" type="title" hasCustomPrompt="1"/>
-          </p:nvPr>
+          <p:nvPr/>
         </p:nvSpPr>
         <p:spPr>
           <a:xfrm>
-            <a:off x="548640" y="1371600"/>
-            <a:ext cx="8046720" cy="1097280"/>
+            <a:off x="457200" y="1097280"/>
+            <a:ext cx="3977640" cy="2011680"/>
+          </a:xfrm>
+          <a:prstGeom prst="roundRect">
+            <a:avLst>
+              <a:gd name="adj" fmla="val 4545"/>
+            </a:avLst>
+          </a:prstGeom>
+          <a:solidFill>
+            <a:srgbClr val="EEF3EF"/>
+          </a:solidFill>
+          <a:ln w="12700">
+            <a:solidFill>
+              <a:srgbClr val="EEF3EF"/>
+            </a:solidFill>
+            <a:prstDash val="solid"/>
+          </a:ln>
+        </p:spPr>
+      </p:sp>
+      <p:sp>
+        <p:nvSpPr>
+          <p:cNvPr id="4" name="move card 1 title"/>
+          <p:cNvSpPr txBox="1"/>
+          <p:nvPr/>
+        </p:nvSpPr>
+        <p:spPr>
+          <a:xfrm>
+            <a:off x="640080" y="1188720"/>
+            <a:ext cx="3611880" cy="411480"/>
           </a:xfrm>
           <a:prstGeom prst="rect">
             <a:avLst/>
@@ -13954,36 +14253,34 @@
           <a:ln/>
         </p:spPr>
         <p:txBody>
-          <a:bodyPr wrap="square" rtlCol="0" anchor="t"/>
+          <a:bodyPr wrap="square" lIns="0" tIns="0" rIns="0" bIns="0" rtlCol="0" anchor="ctr"/>
           <a:lstStyle/>
           <a:p>
-            <a:pPr algn="l" indent="0" marL="0">
+            <a:pPr indent="0" marL="0">
               <a:buNone/>
             </a:pPr>
             <a:r>
-              <a:rPr lang="en-US" sz="3600" b="1" dirty="0">
-                <a:solidFill>
-                  <a:schemeClr val="bg1"/>
-                </a:solidFill>
-              </a:rPr>
-              <a:t>Numbers and bits on the board</a:t>
-            </a:r>
-            <a:endParaRPr lang="en-US" sz="3600" dirty="0"/>
-          </a:p>
-        </p:txBody>
-      </p:sp>
-      <p:sp>
-        <p:nvSpPr>
-          <p:cNvPr id="4" name="Text 0"/>
-          <p:cNvSpPr/>
-          <p:nvPr>
-            <p:ph idx="102" type="body" hasCustomPrompt="1"/>
-          </p:nvPr>
+              <a:rPr lang="en-US" sz="1800" b="1" dirty="0">
+                <a:solidFill>
+                  <a:srgbClr val="1F6E43"/>
+                </a:solidFill>
+              </a:rPr>
+              <a:t>Pack (your PC)</a:t>
+            </a:r>
+            <a:endParaRPr lang="en-US" sz="1800" dirty="0"/>
+          </a:p>
+        </p:txBody>
+      </p:sp>
+      <p:sp>
+        <p:nvSpPr>
+          <p:cNvPr id="5" name="move card 1 steps"/>
+          <p:cNvSpPr txBox="1"/>
+          <p:nvPr/>
         </p:nvSpPr>
         <p:spPr>
           <a:xfrm>
-            <a:off x="548640" y="2743200"/>
-            <a:ext cx="8046720" cy="1737360"/>
+            <a:off x="640080" y="1645920"/>
+            <a:ext cx="3611880" cy="1371600"/>
           </a:xfrm>
           <a:prstGeom prst="rect">
             <a:avLst/>
@@ -13992,21 +14289,280 @@
           <a:ln/>
         </p:spPr>
         <p:txBody>
-          <a:bodyPr wrap="square" rtlCol="0" anchor="t"/>
+          <a:bodyPr wrap="square" lIns="0" tIns="0" rIns="0" bIns="0" rtlCol="0" anchor="t"/>
           <a:lstStyle/>
           <a:p>
-            <a:pPr algn="l" indent="0" marL="0">
+            <a:pPr marL="342900" indent="-342900">
+              <a:spcAft>
+                <a:spcPts val="500"/>
+              </a:spcAft>
+              <a:buSzPct val="100000"/>
+              <a:buFont typeface="+mj-lt"/>
+              <a:buAutoNum type="arabicPeriod" startAt="1"/>
+            </a:pPr>
+            <a:r>
+              <a:rPr lang="en-US" sz="1300" dirty="0">
+                <a:solidFill>
+                  <a:srgbClr val="1C1C1C"/>
+                </a:solidFill>
+              </a:rPr>
+              <a:t>Right-click the project &gt; Refresh (F5)</a:t>
+            </a:r>
+            <a:endParaRPr lang="en-US" sz="1300" dirty="0"/>
+          </a:p>
+          <a:p>
+            <a:pPr marL="342900" indent="-342900">
+              <a:spcAft>
+                <a:spcPts val="500"/>
+              </a:spcAft>
+              <a:buSzPct val="100000"/>
+              <a:buFont typeface="+mj-lt"/>
+              <a:buAutoNum type="arabicPeriod" startAt="1"/>
+            </a:pPr>
+            <a:r>
+              <a:rPr lang="en-US" sz="1300" dirty="0">
+                <a:solidFill>
+                  <a:srgbClr val="1C1C1C"/>
+                </a:solidFill>
+              </a:rPr>
+              <a:t>Right-click &gt; Export &gt; General &gt; Archive File</a:t>
+            </a:r>
+            <a:endParaRPr lang="en-US" sz="1300" dirty="0"/>
+          </a:p>
+          <a:p>
+            <a:pPr marL="342900" indent="-342900">
+              <a:spcAft>
+                <a:spcPts val="500"/>
+              </a:spcAft>
+              <a:buSzPct val="100000"/>
+              <a:buFont typeface="+mj-lt"/>
+              <a:buAutoNum type="arabicPeriod" startAt="1"/>
+            </a:pPr>
+            <a:r>
+              <a:rPr lang="en-US" sz="1300" dirty="0">
+                <a:solidFill>
+                  <a:srgbClr val="1C1C1C"/>
+                </a:solidFill>
+              </a:rPr>
+              <a:t>Untick the Debug folder (build output)</a:t>
+            </a:r>
+            <a:endParaRPr lang="en-US" sz="1300" dirty="0"/>
+          </a:p>
+          <a:p>
+            <a:pPr marL="342900" indent="-342900">
+              <a:spcAft>
+                <a:spcPts val="500"/>
+              </a:spcAft>
+              <a:buSzPct val="100000"/>
+              <a:buFont typeface="+mj-lt"/>
+              <a:buAutoNum type="arabicPeriod" startAt="1"/>
+            </a:pPr>
+            <a:r>
+              <a:rPr lang="en-US" sz="1300" dirty="0">
+                <a:solidFill>
+                  <a:srgbClr val="1C1C1C"/>
+                </a:solidFill>
+              </a:rPr>
+              <a:t>Save as project.zip, Finish</a:t>
+            </a:r>
+            <a:endParaRPr lang="en-US" sz="1300" dirty="0"/>
+          </a:p>
+        </p:txBody>
+      </p:sp>
+      <p:sp>
+        <p:nvSpPr>
+          <p:cNvPr id="6" name="move card 2"/>
+          <p:cNvSpPr/>
+          <p:nvPr/>
+        </p:nvSpPr>
+        <p:spPr>
+          <a:xfrm>
+            <a:off x="4709160" y="1097280"/>
+            <a:ext cx="3977640" cy="2011680"/>
+          </a:xfrm>
+          <a:prstGeom prst="roundRect">
+            <a:avLst>
+              <a:gd name="adj" fmla="val 4545"/>
+            </a:avLst>
+          </a:prstGeom>
+          <a:solidFill>
+            <a:srgbClr val="EEF3EF"/>
+          </a:solidFill>
+          <a:ln w="12700">
+            <a:solidFill>
+              <a:srgbClr val="EEF3EF"/>
+            </a:solidFill>
+            <a:prstDash val="solid"/>
+          </a:ln>
+        </p:spPr>
+      </p:sp>
+      <p:sp>
+        <p:nvSpPr>
+          <p:cNvPr id="7" name="move card 2 title"/>
+          <p:cNvSpPr txBox="1"/>
+          <p:nvPr/>
+        </p:nvSpPr>
+        <p:spPr>
+          <a:xfrm>
+            <a:off x="4892040" y="1188720"/>
+            <a:ext cx="3611880" cy="411480"/>
+          </a:xfrm>
+          <a:prstGeom prst="rect">
+            <a:avLst/>
+          </a:prstGeom>
+          <a:noFill/>
+          <a:ln/>
+        </p:spPr>
+        <p:txBody>
+          <a:bodyPr wrap="square" lIns="0" tIns="0" rIns="0" bIns="0" rtlCol="0" anchor="ctr"/>
+          <a:lstStyle/>
+          <a:p>
+            <a:pPr indent="0" marL="0">
               <a:buNone/>
             </a:pPr>
             <a:r>
-              <a:rPr lang="en-US" sz="1600" dirty="0">
-                <a:solidFill>
-                  <a:schemeClr val="bg1"/>
-                </a:solidFill>
-              </a:rPr>
-              <a:t>Predict-then-run wrap-around; signed and unsigned in the debugger; a binary printer; the four bit idioms: set, clear, toggle, test.</a:t>
-            </a:r>
-            <a:endParaRPr lang="en-US" sz="1600" dirty="0"/>
+              <a:rPr lang="en-US" sz="1800" b="1" dirty="0">
+                <a:solidFill>
+                  <a:srgbClr val="1F6E43"/>
+                </a:solidFill>
+              </a:rPr>
+              <a:t>Open (other PC)</a:t>
+            </a:r>
+            <a:endParaRPr lang="en-US" sz="1800" dirty="0"/>
+          </a:p>
+        </p:txBody>
+      </p:sp>
+      <p:sp>
+        <p:nvSpPr>
+          <p:cNvPr id="8" name="move card 2 steps"/>
+          <p:cNvSpPr txBox="1"/>
+          <p:nvPr/>
+        </p:nvSpPr>
+        <p:spPr>
+          <a:xfrm>
+            <a:off x="4892040" y="1645920"/>
+            <a:ext cx="3611880" cy="1371600"/>
+          </a:xfrm>
+          <a:prstGeom prst="rect">
+            <a:avLst/>
+          </a:prstGeom>
+          <a:noFill/>
+          <a:ln/>
+        </p:spPr>
+        <p:txBody>
+          <a:bodyPr wrap="square" lIns="0" tIns="0" rIns="0" bIns="0" rtlCol="0" anchor="t"/>
+          <a:lstStyle/>
+          <a:p>
+            <a:pPr marL="342900" indent="-342900">
+              <a:spcAft>
+                <a:spcPts val="500"/>
+              </a:spcAft>
+              <a:buSzPct val="100000"/>
+              <a:buFont typeface="+mj-lt"/>
+              <a:buAutoNum type="arabicPeriod" startAt="1"/>
+            </a:pPr>
+            <a:r>
+              <a:rPr lang="en-US" sz="1300" dirty="0">
+                <a:solidFill>
+                  <a:srgbClr val="1C1C1C"/>
+                </a:solidFill>
+              </a:rPr>
+              <a:t>File &gt; Import &gt; General &gt; Existing Projects into Workspace</a:t>
+            </a:r>
+            <a:endParaRPr lang="en-US" sz="1300" dirty="0"/>
+          </a:p>
+          <a:p>
+            <a:pPr marL="342900" indent="-342900">
+              <a:spcAft>
+                <a:spcPts val="500"/>
+              </a:spcAft>
+              <a:buSzPct val="100000"/>
+              <a:buFont typeface="+mj-lt"/>
+              <a:buAutoNum type="arabicPeriod" startAt="1"/>
+            </a:pPr>
+            <a:r>
+              <a:rPr lang="en-US" sz="1300" dirty="0">
+                <a:solidFill>
+                  <a:srgbClr val="1C1C1C"/>
+                </a:solidFill>
+              </a:rPr>
+              <a:t>Select archive file &gt; the .zip (do not unzip it)</a:t>
+            </a:r>
+            <a:endParaRPr lang="en-US" sz="1300" dirty="0"/>
+          </a:p>
+          <a:p>
+            <a:pPr marL="342900" indent="-342900">
+              <a:spcAft>
+                <a:spcPts val="500"/>
+              </a:spcAft>
+              <a:buSzPct val="100000"/>
+              <a:buFont typeface="+mj-lt"/>
+              <a:buAutoNum type="arabicPeriod" startAt="1"/>
+            </a:pPr>
+            <a:r>
+              <a:rPr lang="en-US" sz="1300" dirty="0">
+                <a:solidFill>
+                  <a:srgbClr val="1C1C1C"/>
+                </a:solidFill>
+              </a:rPr>
+              <a:t>Tick the project &gt; Finish</a:t>
+            </a:r>
+            <a:endParaRPr lang="en-US" sz="1300" dirty="0"/>
+          </a:p>
+          <a:p>
+            <a:pPr marL="342900" indent="-342900">
+              <a:spcAft>
+                <a:spcPts val="500"/>
+              </a:spcAft>
+              <a:buSzPct val="100000"/>
+              <a:buFont typeface="+mj-lt"/>
+              <a:buAutoNum type="arabicPeriod" startAt="1"/>
+            </a:pPr>
+            <a:r>
+              <a:rPr lang="en-US" sz="1300" dirty="0">
+                <a:solidFill>
+                  <a:srgbClr val="1C1C1C"/>
+                </a:solidFill>
+              </a:rPr>
+              <a:t>Build, then Debug</a:t>
+            </a:r>
+            <a:endParaRPr lang="en-US" sz="1300" dirty="0"/>
+          </a:p>
+        </p:txBody>
+      </p:sp>
+      <p:sp>
+        <p:nvSpPr>
+          <p:cNvPr id="9" name="move note"/>
+          <p:cNvSpPr txBox="1"/>
+          <p:nvPr/>
+        </p:nvSpPr>
+        <p:spPr>
+          <a:xfrm>
+            <a:off x="457200" y="3291840"/>
+            <a:ext cx="8229600" cy="457200"/>
+          </a:xfrm>
+          <a:prstGeom prst="rect">
+            <a:avLst/>
+          </a:prstGeom>
+          <a:noFill/>
+          <a:ln/>
+        </p:spPr>
+        <p:txBody>
+          <a:bodyPr wrap="square" rtlCol="0" anchor="ctr"/>
+          <a:lstStyle/>
+          <a:p>
+            <a:pPr indent="0" marL="0">
+              <a:buNone/>
+            </a:pPr>
+            <a:r>
+              <a:rPr lang="en-US" sz="1300" i="1" dirty="0">
+                <a:solidFill>
+                  <a:srgbClr val="5C5C5C"/>
+                </a:solidFill>
+              </a:rPr>
+              <a:t>Project greyed out in the import list? A project with the same name is already in the workspace: delete it first.</a:t>
+            </a:r>
+            <a:endParaRPr lang="en-US" sz="1300" dirty="0"/>
           </a:p>
         </p:txBody>
       </p:sp>
@@ -14040,7 +14596,7 @@
             <a:lvl1pPr>
               <a:defRPr sz="1000">
                 <a:solidFill>
-                  <a:schemeClr val="bg2"/>
+                  <a:schemeClr val="tx2"/>
                 </a:solidFill>
               </a:defRPr>
             </a:lvl1pPr>

</xml_diff>

<commit_message>
A1: provide ass1.ioc; tutorial 5 slides on creating a .ioc; A2 starts from ass1.ioc
Plan: A1 provides ass1.ioc, tutorial 5 teaches .ioc creation, A2 duplicates
ass1.ioc; system clock corrected to PLL from HSI. MP.md updated.

Co-Authored-By: Claude Opus 5.5 <noreply@anthropic.com>
</commit_message>
<xml_diff>
--- a/tutorials/MP_tutorials_2026.pptx
+++ b/tutorials/MP_tutorials_2026.pptx
@@ -23,6 +23,10 @@
     <p:sldId id="271" r:id="rId17"/>
     <p:sldId id="272" r:id="rId18"/>
     <p:sldId id="273" r:id="rId19"/>
+    <p:sldId id="282" r:id="rId33"/>
+    <p:sldId id="283" r:id="rId34"/>
+    <p:sldId id="284" r:id="rId35"/>
+    <p:sldId id="285" r:id="rId36"/>
     <p:sldId id="274" r:id="rId20"/>
     <p:sldId id="275" r:id="rId21"/>
     <p:sldId id="276" r:id="rId22"/>
@@ -167,6 +171,10 @@
         <p14:section name="Tutorial 5: Inside the I2C bus" id="{cdafa046-4960-08d9-dade-13722ea2c76e}">
           <p14:sldIdLst>
             <p14:sldId id="273"/>
+            <p14:sldId id="282"/>
+            <p14:sldId id="283"/>
+            <p14:sldId id="284"/>
+            <p14:sldId id="285"/>
           </p14:sldIdLst>
         </p14:section>
         <p14:section name="Tutorial 6: PWM, input capture and EXTI" id="{22b1a7f2-0b5c-f1e2-f58f-3b4012e84f69}">
@@ -6919,7 +6927,7 @@
                   <a:schemeClr val="bg1"/>
                 </a:solidFill>
               </a:rPr>
-              <a:t>I2C bus scan: detect the five IO-board chips; set_rgb rewritten on raw HAL_I2C_Mem_Write; servo sweep.</a:t>
+              <a:t>I2C bus scan: detect the five IO-board chips; set_rgb rewritten on raw HAL_I2C_Mem_Write; servo sweep. Short part: creating a .ioc in STM32CubeMX, and starting Assignment 2 from it.</a:t>
             </a:r>
             <a:endParaRPr lang="en-US" sz="1600" dirty="0"/>
           </a:p>
@@ -8634,6 +8642,3031 @@
 </p:sld>
 </file>
 
+<file path=ppt/slides/slide27.xml><?xml version="1.0" encoding="utf-8"?>
+<p:sld xmlns:a="http://schemas.openxmlformats.org/drawingml/2006/main" xmlns:r="http://schemas.openxmlformats.org/officeDocument/2006/relationships" xmlns:p="http://schemas.openxmlformats.org/presentationml/2006/main">
+  <p:cSld name="Slide 19">
+    <p:spTree>
+      <p:nvGrpSpPr>
+        <p:cNvPr id="1" name=""/>
+        <p:cNvGrpSpPr/>
+        <p:nvPr/>
+      </p:nvGrpSpPr>
+      <p:grpSpPr>
+        <a:xfrm>
+          <a:off x="0" y="0"/>
+          <a:ext cx="0" cy="0"/>
+          <a:chOff x="0" y="0"/>
+          <a:chExt cx="0" cy="0"/>
+        </a:xfrm>
+      </p:grpSpPr>
+      <p:sp>
+        <p:nvSpPr>
+          <p:cNvPr id="2" name="Text 0"/>
+          <p:cNvSpPr/>
+          <p:nvPr>
+            <p:ph idx="100" type="title" hasCustomPrompt="1"/>
+          </p:nvPr>
+        </p:nvSpPr>
+        <p:spPr>
+          <a:xfrm>
+            <a:off x="457200" y="274320"/>
+            <a:ext cx="8229600" cy="640080"/>
+          </a:xfrm>
+          <a:prstGeom prst="rect">
+            <a:avLst/>
+          </a:prstGeom>
+          <a:noFill/>
+          <a:ln/>
+        </p:spPr>
+        <p:txBody>
+          <a:bodyPr wrap="square" rtlCol="0" anchor="ctr"/>
+          <a:lstStyle/>
+          <a:p>
+            <a:pPr algn="l" indent="0" marL="0">
+              <a:buNone/>
+            </a:pPr>
+            <a:r>
+              <a:rPr lang="en-US" sz="2600" b="1" dirty="0">
+                <a:solidFill>
+                  <a:schemeClr val="tx2"/>
+                </a:solidFill>
+              </a:rPr>
+              <a:t>From a .ioc to a running project</a:t>
+            </a:r>
+            <a:endParaRPr lang="en-US" sz="2600" dirty="0"/>
+          </a:p>
+        </p:txBody>
+      </p:sp>
+      <p:sp>
+        <p:nvSpPr>
+          <p:cNvPr id="3" name="ioc flow card 1"/>
+          <p:cNvSpPr/>
+          <p:nvPr/>
+        </p:nvSpPr>
+        <p:spPr>
+          <a:xfrm>
+            <a:off x="457200" y="1097280"/>
+            <a:ext cx="2560320" cy="2286000"/>
+          </a:xfrm>
+          <a:prstGeom prst="roundRect">
+            <a:avLst>
+              <a:gd name="adj" fmla="val 4545"/>
+            </a:avLst>
+          </a:prstGeom>
+          <a:solidFill>
+            <a:srgbClr val="EEF3EF"/>
+          </a:solidFill>
+          <a:ln w="12700">
+            <a:solidFill>
+              <a:srgbClr val="EEF3EF"/>
+            </a:solidFill>
+            <a:prstDash val="solid"/>
+          </a:ln>
+        </p:spPr>
+      </p:sp>
+      <p:sp>
+        <p:nvSpPr>
+          <p:cNvPr id="4" name="ioc flow card 1 title"/>
+          <p:cNvSpPr txBox="1"/>
+          <p:nvPr/>
+        </p:nvSpPr>
+        <p:spPr>
+          <a:xfrm>
+            <a:off x="640080" y="1188720"/>
+            <a:ext cx="2194560" cy="411480"/>
+          </a:xfrm>
+          <a:prstGeom prst="rect">
+            <a:avLst/>
+          </a:prstGeom>
+          <a:noFill/>
+          <a:ln/>
+        </p:spPr>
+        <p:txBody>
+          <a:bodyPr wrap="square" lIns="0" tIns="0" rIns="0" bIns="0" rtlCol="0" anchor="ctr"/>
+          <a:lstStyle/>
+          <a:p>
+            <a:pPr indent="0" marL="0">
+              <a:buNone/>
+            </a:pPr>
+            <a:r>
+              <a:rPr lang="en-US" sz="1800" b="1" dirty="0">
+                <a:solidFill>
+                  <a:srgbClr val="1F6E43"/>
+                </a:solidFill>
+              </a:rPr>
+              <a:t>1. Configure</a:t>
+            </a:r>
+            <a:endParaRPr lang="en-US" sz="1800" dirty="0"/>
+          </a:p>
+        </p:txBody>
+      </p:sp>
+      <p:sp>
+        <p:nvSpPr>
+          <p:cNvPr id="5" name="ioc flow card 1 steps"/>
+          <p:cNvSpPr txBox="1"/>
+          <p:nvPr/>
+        </p:nvSpPr>
+        <p:spPr>
+          <a:xfrm>
+            <a:off x="640080" y="1645920"/>
+            <a:ext cx="2194560" cy="1645920"/>
+          </a:xfrm>
+          <a:prstGeom prst="rect">
+            <a:avLst/>
+          </a:prstGeom>
+          <a:noFill/>
+          <a:ln/>
+        </p:spPr>
+        <p:txBody>
+          <a:bodyPr wrap="square" lIns="0" tIns="0" rIns="0" bIns="0" rtlCol="0" anchor="t"/>
+          <a:lstStyle/>
+          <a:p>
+            <a:pPr marL="228600" indent="-228600">
+              <a:spcAft>
+                <a:spcPts val="500"/>
+              </a:spcAft>
+              <a:buSzPct val="100000"/>
+              <a:buFont typeface="Arial"/>
+              <a:buChar char="•"/>
+            </a:pPr>
+            <a:r>
+              <a:rPr lang="en-US" sz="1300" dirty="0">
+                <a:solidFill>
+                  <a:srgbClr val="1C1C1C"/>
+                </a:solidFill>
+              </a:rPr>
+              <a:t>STM32CubeMX, file </a:t>
+            </a:r>
+            <a:r>
+              <a:rPr lang="en-US" sz="1300" dirty="0">
+                <a:solidFill>
+                  <a:srgbClr val="1C1C1C"/>
+                </a:solidFill>
+                <a:latin typeface="Courier New"/>
+                <a:cs typeface="Courier New"/>
+              </a:rPr>
+              <a:t>ass1.ioc</a:t>
+            </a:r>
+            <a:endParaRPr lang="en-US" sz="1300" dirty="0"/>
+          </a:p>
+          <a:p>
+            <a:pPr marL="228600" indent="-228600">
+              <a:spcAft>
+                <a:spcPts val="500"/>
+              </a:spcAft>
+              <a:buSzPct val="100000"/>
+              <a:buFont typeface="Arial"/>
+              <a:buChar char="•"/>
+            </a:pPr>
+            <a:r>
+              <a:rPr lang="en-US" sz="1300" dirty="0">
+                <a:solidFill>
+                  <a:srgbClr val="1C1C1C"/>
+                </a:solidFill>
+              </a:rPr>
+              <a:t>The whole hardware setup: pins, peripherals, clock, interrupts</a:t>
+            </a:r>
+            <a:endParaRPr lang="en-US" sz="1300" dirty="0"/>
+          </a:p>
+        </p:txBody>
+      </p:sp>
+      <p:sp>
+        <p:nvSpPr>
+          <p:cNvPr id="6" name="ioc flow card 2"/>
+          <p:cNvSpPr/>
+          <p:nvPr/>
+        </p:nvSpPr>
+        <p:spPr>
+          <a:xfrm>
+            <a:off x="3291840" y="1097280"/>
+            <a:ext cx="2560320" cy="2286000"/>
+          </a:xfrm>
+          <a:prstGeom prst="roundRect">
+            <a:avLst>
+              <a:gd name="adj" fmla="val 4545"/>
+            </a:avLst>
+          </a:prstGeom>
+          <a:solidFill>
+            <a:srgbClr val="EEF3EF"/>
+          </a:solidFill>
+          <a:ln w="12700">
+            <a:solidFill>
+              <a:srgbClr val="EEF3EF"/>
+            </a:solidFill>
+            <a:prstDash val="solid"/>
+          </a:ln>
+        </p:spPr>
+      </p:sp>
+      <p:sp>
+        <p:nvSpPr>
+          <p:cNvPr id="7" name="ioc flow card 2 title"/>
+          <p:cNvSpPr txBox="1"/>
+          <p:nvPr/>
+        </p:nvSpPr>
+        <p:spPr>
+          <a:xfrm>
+            <a:off x="3474720" y="1188720"/>
+            <a:ext cx="2194560" cy="411480"/>
+          </a:xfrm>
+          <a:prstGeom prst="rect">
+            <a:avLst/>
+          </a:prstGeom>
+          <a:noFill/>
+          <a:ln/>
+        </p:spPr>
+        <p:txBody>
+          <a:bodyPr wrap="square" lIns="0" tIns="0" rIns="0" bIns="0" rtlCol="0" anchor="ctr"/>
+          <a:lstStyle/>
+          <a:p>
+            <a:pPr indent="0" marL="0">
+              <a:buNone/>
+            </a:pPr>
+            <a:r>
+              <a:rPr lang="en-US" sz="1800" b="1" dirty="0">
+                <a:solidFill>
+                  <a:srgbClr val="1F6E43"/>
+                </a:solidFill>
+              </a:rPr>
+              <a:t>2. Generate</a:t>
+            </a:r>
+            <a:endParaRPr lang="en-US" sz="1800" dirty="0"/>
+          </a:p>
+        </p:txBody>
+      </p:sp>
+      <p:sp>
+        <p:nvSpPr>
+          <p:cNvPr id="8" name="ioc flow card 2 steps"/>
+          <p:cNvSpPr txBox="1"/>
+          <p:nvPr/>
+        </p:nvSpPr>
+        <p:spPr>
+          <a:xfrm>
+            <a:off x="3474720" y="1645920"/>
+            <a:ext cx="2194560" cy="1645920"/>
+          </a:xfrm>
+          <a:prstGeom prst="rect">
+            <a:avLst/>
+          </a:prstGeom>
+          <a:noFill/>
+          <a:ln/>
+        </p:spPr>
+        <p:txBody>
+          <a:bodyPr wrap="square" lIns="0" tIns="0" rIns="0" bIns="0" rtlCol="0" anchor="t"/>
+          <a:lstStyle/>
+          <a:p>
+            <a:pPr marL="228600" indent="-228600">
+              <a:spcAft>
+                <a:spcPts val="500"/>
+              </a:spcAft>
+              <a:buSzPct val="100000"/>
+              <a:buFont typeface="Arial"/>
+              <a:buChar char="•"/>
+            </a:pPr>
+            <a:r>
+              <a:rPr lang="en-US" sz="1300" dirty="0">
+                <a:solidFill>
+                  <a:srgbClr val="1C1C1C"/>
+                </a:solidFill>
+              </a:rPr>
+              <a:t>GENERATE CODE writes </a:t>
+            </a:r>
+            <a:r>
+              <a:rPr lang="en-US" sz="1300" dirty="0">
+                <a:solidFill>
+                  <a:srgbClr val="1C1C1C"/>
+                </a:solidFill>
+                <a:latin typeface="Courier New"/>
+                <a:cs typeface="Courier New"/>
+              </a:rPr>
+              <a:t>main.c</a:t>
+            </a:r>
+            <a:r>
+              <a:rPr lang="en-US" sz="1300" dirty="0">
+                <a:solidFill>
+                  <a:srgbClr val="1C1C1C"/>
+                </a:solidFill>
+              </a:rPr>
+              <a:t> with </a:t>
+            </a:r>
+            <a:r>
+              <a:rPr lang="en-US" sz="1300" dirty="0">
+                <a:solidFill>
+                  <a:srgbClr val="1C1C1C"/>
+                </a:solidFill>
+                <a:latin typeface="Courier New"/>
+                <a:cs typeface="Courier New"/>
+              </a:rPr>
+              <a:t>MX_GPIO_Init()</a:t>
+            </a:r>
+            <a:r>
+              <a:rPr lang="en-US" sz="1300" dirty="0">
+                <a:solidFill>
+                  <a:srgbClr val="1C1C1C"/>
+                </a:solidFill>
+              </a:rPr>
+              <a:t>, </a:t>
+            </a:r>
+            <a:r>
+              <a:rPr lang="en-US" sz="1300" dirty="0">
+                <a:solidFill>
+                  <a:srgbClr val="1C1C1C"/>
+                </a:solidFill>
+                <a:latin typeface="Courier New"/>
+                <a:cs typeface="Courier New"/>
+              </a:rPr>
+              <a:t>MX_I2C1_Init()</a:t>
+            </a:r>
+            <a:r>
+              <a:rPr lang="en-US" sz="1300" dirty="0">
+                <a:solidFill>
+                  <a:srgbClr val="1C1C1C"/>
+                </a:solidFill>
+              </a:rPr>
+              <a:t>, ...</a:t>
+            </a:r>
+            <a:endParaRPr lang="en-US" sz="1300" dirty="0"/>
+          </a:p>
+          <a:p>
+            <a:pPr marL="228600" indent="-228600">
+              <a:spcAft>
+                <a:spcPts val="500"/>
+              </a:spcAft>
+              <a:buSzPct val="100000"/>
+              <a:buFont typeface="Arial"/>
+              <a:buChar char="•"/>
+            </a:pPr>
+            <a:r>
+              <a:rPr lang="en-US" sz="1300" dirty="0">
+                <a:solidFill>
+                  <a:srgbClr val="1C1C1C"/>
+                </a:solidFill>
+              </a:rPr>
+              <a:t>and copies the HAL drivers</a:t>
+            </a:r>
+            <a:endParaRPr lang="en-US" sz="1300" dirty="0"/>
+          </a:p>
+        </p:txBody>
+      </p:sp>
+      <p:sp>
+        <p:nvSpPr>
+          <p:cNvPr id="9" name="ioc flow card 3"/>
+          <p:cNvSpPr/>
+          <p:nvPr/>
+        </p:nvSpPr>
+        <p:spPr>
+          <a:xfrm>
+            <a:off x="6126480" y="1097280"/>
+            <a:ext cx="2560320" cy="2286000"/>
+          </a:xfrm>
+          <a:prstGeom prst="roundRect">
+            <a:avLst>
+              <a:gd name="adj" fmla="val 4545"/>
+            </a:avLst>
+          </a:prstGeom>
+          <a:solidFill>
+            <a:srgbClr val="EEF3EF"/>
+          </a:solidFill>
+          <a:ln w="12700">
+            <a:solidFill>
+              <a:srgbClr val="EEF3EF"/>
+            </a:solidFill>
+            <a:prstDash val="solid"/>
+          </a:ln>
+        </p:spPr>
+      </p:sp>
+      <p:sp>
+        <p:nvSpPr>
+          <p:cNvPr id="10" name="ioc flow card 3 title"/>
+          <p:cNvSpPr txBox="1"/>
+          <p:nvPr/>
+        </p:nvSpPr>
+        <p:spPr>
+          <a:xfrm>
+            <a:off x="6309360" y="1188720"/>
+            <a:ext cx="2194560" cy="411480"/>
+          </a:xfrm>
+          <a:prstGeom prst="rect">
+            <a:avLst/>
+          </a:prstGeom>
+          <a:noFill/>
+          <a:ln/>
+        </p:spPr>
+        <p:txBody>
+          <a:bodyPr wrap="square" lIns="0" tIns="0" rIns="0" bIns="0" rtlCol="0" anchor="ctr"/>
+          <a:lstStyle/>
+          <a:p>
+            <a:pPr indent="0" marL="0">
+              <a:buNone/>
+            </a:pPr>
+            <a:r>
+              <a:rPr lang="en-US" sz="1800" b="1" dirty="0">
+                <a:solidFill>
+                  <a:srgbClr val="1F6E43"/>
+                </a:solidFill>
+              </a:rPr>
+              <a:t>3. Import and code</a:t>
+            </a:r>
+            <a:endParaRPr lang="en-US" sz="1800" dirty="0"/>
+          </a:p>
+        </p:txBody>
+      </p:sp>
+      <p:sp>
+        <p:nvSpPr>
+          <p:cNvPr id="11" name="ioc flow card 3 steps"/>
+          <p:cNvSpPr txBox="1"/>
+          <p:nvPr/>
+        </p:nvSpPr>
+        <p:spPr>
+          <a:xfrm>
+            <a:off x="6309360" y="1645920"/>
+            <a:ext cx="2194560" cy="1645920"/>
+          </a:xfrm>
+          <a:prstGeom prst="rect">
+            <a:avLst/>
+          </a:prstGeom>
+          <a:noFill/>
+          <a:ln/>
+        </p:spPr>
+        <p:txBody>
+          <a:bodyPr wrap="square" lIns="0" tIns="0" rIns="0" bIns="0" rtlCol="0" anchor="t"/>
+          <a:lstStyle/>
+          <a:p>
+            <a:pPr marL="228600" indent="-228600">
+              <a:spcAft>
+                <a:spcPts val="500"/>
+              </a:spcAft>
+              <a:buSzPct val="100000"/>
+              <a:buFont typeface="Arial"/>
+              <a:buChar char="•"/>
+            </a:pPr>
+            <a:r>
+              <a:rPr lang="en-US" sz="1300" dirty="0">
+                <a:solidFill>
+                  <a:srgbClr val="1C1C1C"/>
+                </a:solidFill>
+              </a:rPr>
+              <a:t>STM32CubeIDE: File &gt; Import, then the wizard STM32CubeMX/ STM32CubeIDE Project</a:t>
+            </a:r>
+            <a:endParaRPr lang="en-US" sz="1300" dirty="0"/>
+          </a:p>
+          <a:p>
+            <a:pPr marL="228600" indent="-228600">
+              <a:spcAft>
+                <a:spcPts val="500"/>
+              </a:spcAft>
+              <a:buSzPct val="100000"/>
+              <a:buFont typeface="Arial"/>
+              <a:buChar char="•"/>
+            </a:pPr>
+            <a:r>
+              <a:rPr lang="en-US" sz="1300" dirty="0">
+                <a:solidFill>
+                  <a:srgbClr val="1C1C1C"/>
+                </a:solidFill>
+              </a:rPr>
+              <a:t>Your code goes only between USER CODE BEGIN and END</a:t>
+            </a:r>
+            <a:endParaRPr lang="en-US" sz="1300" dirty="0"/>
+          </a:p>
+        </p:txBody>
+      </p:sp>
+      <p:sp>
+        <p:nvSpPr>
+          <p:cNvPr id="12" name="ioc flow note"/>
+          <p:cNvSpPr txBox="1"/>
+          <p:nvPr/>
+        </p:nvSpPr>
+        <p:spPr>
+          <a:xfrm>
+            <a:off x="457200" y="3566160"/>
+            <a:ext cx="8229600" cy="457200"/>
+          </a:xfrm>
+          <a:prstGeom prst="rect">
+            <a:avLst/>
+          </a:prstGeom>
+          <a:noFill/>
+          <a:ln/>
+        </p:spPr>
+        <p:txBody>
+          <a:bodyPr wrap="square" rtlCol="0" anchor="ctr"/>
+          <a:lstStyle/>
+          <a:p>
+            <a:pPr indent="0" marL="0">
+              <a:buNone/>
+            </a:pPr>
+            <a:r>
+              <a:rPr lang="en-US" sz="1300" i="1" dirty="0">
+                <a:solidFill>
+                  <a:srgbClr val="5C5C5C"/>
+                </a:solidFill>
+              </a:rPr>
+              <a:t>The .ioc is the source. Every GENERATE CODE rewrites the generated code and keeps only what is inside the USER CODE sections.</a:t>
+            </a:r>
+            <a:endParaRPr lang="en-US" sz="1300" dirty="0"/>
+          </a:p>
+        </p:txBody>
+      </p:sp>
+      <p:sp>
+        <p:nvSpPr>
+          <p:cNvPr id="13" name="Slide Number Placeholder 0"/>
+          <p:cNvSpPr>
+            <a:spLocks noGrp="1"/>
+          </p:cNvSpPr>
+          <p:nvPr>
+            <p:ph type="sldNum" sz="quarter" idx="4294967295"/>
+          </p:nvPr>
+        </p:nvSpPr>
+        <p:spPr>
+          <a:xfrm>
+            <a:off x="8412480" y="4754880"/>
+            <a:ext cx="800000" cy="300000"/>
+          </a:xfrm>
+          <a:prstGeom prst="rect">
+            <a:avLst/>
+          </a:prstGeom>
+        </p:spPr>
+        <p:txBody>
+          <a:bodyPr/>
+          <a:lstStyle>
+            <a:lvl1pPr>
+              <a:defRPr sz="1000">
+                <a:solidFill>
+                  <a:schemeClr val="tx2"/>
+                </a:solidFill>
+              </a:defRPr>
+            </a:lvl1pPr>
+          </a:lstStyle>
+          <a:p>
+            <a:pPr algn="l"/>
+            <a:fld id="{F7021451-1387-4CA6-816F-3879F97B5CBC}" type="slidenum">
+              <a:rPr b="0" lang="en-US"/>
+              <a:t>19</a:t>
+            </a:fld>
+            <a:endParaRPr lang="en-US"/>
+          </a:p>
+        </p:txBody>
+      </p:sp>
+    </p:spTree>
+  </p:cSld>
+  <p:clrMapOvr>
+    <a:masterClrMapping/>
+  </p:clrMapOvr>
+</p:sld>
+</file>
+
+<file path=ppt/slides/slide28.xml><?xml version="1.0" encoding="utf-8"?>
+<p:sld xmlns:a="http://schemas.openxmlformats.org/drawingml/2006/main" xmlns:r="http://schemas.openxmlformats.org/officeDocument/2006/relationships" xmlns:p="http://schemas.openxmlformats.org/presentationml/2006/main">
+  <p:cSld name="Slide 20">
+    <p:spTree>
+      <p:nvGrpSpPr>
+        <p:cNvPr id="1" name=""/>
+        <p:cNvGrpSpPr/>
+        <p:nvPr/>
+      </p:nvGrpSpPr>
+      <p:grpSpPr>
+        <a:xfrm>
+          <a:off x="0" y="0"/>
+          <a:ext cx="0" cy="0"/>
+          <a:chOff x="0" y="0"/>
+          <a:chExt cx="0" cy="0"/>
+        </a:xfrm>
+      </p:grpSpPr>
+      <p:sp>
+        <p:nvSpPr>
+          <p:cNvPr id="2" name="Text 0"/>
+          <p:cNvSpPr/>
+          <p:nvPr>
+            <p:ph idx="100" type="title" hasCustomPrompt="1"/>
+          </p:nvPr>
+        </p:nvSpPr>
+        <p:spPr>
+          <a:xfrm>
+            <a:off x="457200" y="274320"/>
+            <a:ext cx="8229600" cy="640080"/>
+          </a:xfrm>
+          <a:prstGeom prst="rect">
+            <a:avLst/>
+          </a:prstGeom>
+          <a:noFill/>
+          <a:ln/>
+        </p:spPr>
+        <p:txBody>
+          <a:bodyPr wrap="square" rtlCol="0" anchor="ctr"/>
+          <a:lstStyle/>
+          <a:p>
+            <a:pPr algn="l" indent="0" marL="0">
+              <a:buNone/>
+            </a:pPr>
+            <a:r>
+              <a:rPr lang="en-US" sz="2600" b="1" dirty="0">
+                <a:solidFill>
+                  <a:schemeClr val="tx2"/>
+                </a:solidFill>
+              </a:rPr>
+              <a:t>Rebuilding ass1.ioc: board and pins</a:t>
+            </a:r>
+            <a:endParaRPr lang="en-US" sz="2600" dirty="0"/>
+          </a:p>
+        </p:txBody>
+      </p:sp>
+      <p:graphicFrame>
+        <p:nvGraphicFramePr>
+          <p:cNvPr id="3" name="ioc pins table"/>
+          <p:cNvGraphicFramePr>
+            <a:graphicFrameLocks noGrp="1"/>
+          </p:cNvGraphicFramePr>
+          <p:nvPr/>
+        </p:nvGraphicFramePr>
+        <p:xfrm>
+          <a:off x="457200" y="1051560"/>
+          <a:ext cx="8229600" cy="2743200"/>
+        </p:xfrm>
+        <a:graphic>
+          <a:graphicData uri="http://schemas.openxmlformats.org/drawingml/2006/table">
+            <a:tbl>
+              <a:tblPr/>
+              <a:tblGrid>
+                <a:gridCol w="1463040"/>
+                <a:gridCol w="3017520"/>
+                <a:gridCol w="3749040"/>
+              </a:tblGrid>
+              <a:tr h="548640">
+                <a:tc>
+                  <a:txBody>
+                    <a:bodyPr/>
+                    <a:lstStyle/>
+                    <a:p>
+                      <a:pPr indent="0" marL="0">
+                        <a:buNone/>
+                      </a:pPr>
+                      <a:r>
+                        <a:rPr lang="en-US" sz="1200" b="1" dirty="0">
+                          <a:solidFill>
+                            <a:srgbClr val="EEF3EF"/>
+                          </a:solidFill>
+                        </a:rPr>
+                        <a:t>What</a:t>
+                      </a:r>
+                      <a:endParaRPr lang="en-US" sz="1200" dirty="0"/>
+                    </a:p>
+                  </a:txBody>
+                  <a:tcPr marL="91440" marR="91440" marT="45720" marB="45720" anchor="ctr">
+                    <a:lnL w="6350" cap="flat" cmpd="sng" algn="ctr">
+                      <a:solidFill>
+                        <a:srgbClr val="D5DDD6"/>
+                      </a:solidFill>
+                      <a:prstDash val="solid"/>
+                      <a:round/>
+                      <a:headEnd type="none" w="med" len="med"/>
+                      <a:tailEnd type="none" w="med" len="med"/>
+                    </a:lnL>
+                    <a:lnR w="6350" cap="flat" cmpd="sng" algn="ctr">
+                      <a:solidFill>
+                        <a:srgbClr val="D5DDD6"/>
+                      </a:solidFill>
+                      <a:prstDash val="solid"/>
+                      <a:round/>
+                      <a:headEnd type="none" w="med" len="med"/>
+                      <a:tailEnd type="none" w="med" len="med"/>
+                    </a:lnR>
+                    <a:lnT w="6350" cap="flat" cmpd="sng" algn="ctr">
+                      <a:solidFill>
+                        <a:srgbClr val="D5DDD6"/>
+                      </a:solidFill>
+                      <a:prstDash val="solid"/>
+                      <a:round/>
+                      <a:headEnd type="none" w="med" len="med"/>
+                      <a:tailEnd type="none" w="med" len="med"/>
+                    </a:lnT>
+                    <a:lnB w="6350" cap="flat" cmpd="sng" algn="ctr">
+                      <a:solidFill>
+                        <a:srgbClr val="D5DDD6"/>
+                      </a:solidFill>
+                      <a:prstDash val="solid"/>
+                      <a:round/>
+                      <a:headEnd type="none" w="med" len="med"/>
+                      <a:tailEnd type="none" w="med" len="med"/>
+                    </a:lnB>
+                    <a:solidFill>
+                      <a:srgbClr val="1F6E43"/>
+                    </a:solidFill>
+                  </a:tcPr>
+                </a:tc>
+                <a:tc>
+                  <a:txBody>
+                    <a:bodyPr/>
+                    <a:lstStyle/>
+                    <a:p>
+                      <a:pPr indent="0" marL="0">
+                        <a:buNone/>
+                      </a:pPr>
+                      <a:r>
+                        <a:rPr lang="en-US" sz="1200" b="1" dirty="0">
+                          <a:solidFill>
+                            <a:srgbClr val="EEF3EF"/>
+                          </a:solidFill>
+                        </a:rPr>
+                        <a:t>Where in CubeMX</a:t>
+                      </a:r>
+                      <a:endParaRPr lang="en-US" sz="1200" dirty="0"/>
+                    </a:p>
+                  </a:txBody>
+                  <a:tcPr marL="91440" marR="91440" marT="45720" marB="45720" anchor="ctr">
+                    <a:lnL w="6350" cap="flat" cmpd="sng" algn="ctr">
+                      <a:solidFill>
+                        <a:srgbClr val="D5DDD6"/>
+                      </a:solidFill>
+                      <a:prstDash val="solid"/>
+                      <a:round/>
+                      <a:headEnd type="none" w="med" len="med"/>
+                      <a:tailEnd type="none" w="med" len="med"/>
+                    </a:lnL>
+                    <a:lnR w="6350" cap="flat" cmpd="sng" algn="ctr">
+                      <a:solidFill>
+                        <a:srgbClr val="D5DDD6"/>
+                      </a:solidFill>
+                      <a:prstDash val="solid"/>
+                      <a:round/>
+                      <a:headEnd type="none" w="med" len="med"/>
+                      <a:tailEnd type="none" w="med" len="med"/>
+                    </a:lnR>
+                    <a:lnT w="6350" cap="flat" cmpd="sng" algn="ctr">
+                      <a:solidFill>
+                        <a:srgbClr val="D5DDD6"/>
+                      </a:solidFill>
+                      <a:prstDash val="solid"/>
+                      <a:round/>
+                      <a:headEnd type="none" w="med" len="med"/>
+                      <a:tailEnd type="none" w="med" len="med"/>
+                    </a:lnT>
+                    <a:lnB w="6350" cap="flat" cmpd="sng" algn="ctr">
+                      <a:solidFill>
+                        <a:srgbClr val="D5DDD6"/>
+                      </a:solidFill>
+                      <a:prstDash val="solid"/>
+                      <a:round/>
+                      <a:headEnd type="none" w="med" len="med"/>
+                      <a:tailEnd type="none" w="med" len="med"/>
+                    </a:lnB>
+                    <a:solidFill>
+                      <a:srgbClr val="1F6E43"/>
+                    </a:solidFill>
+                  </a:tcPr>
+                </a:tc>
+                <a:tc>
+                  <a:txBody>
+                    <a:bodyPr/>
+                    <a:lstStyle/>
+                    <a:p>
+                      <a:pPr indent="0" marL="0">
+                        <a:buNone/>
+                      </a:pPr>
+                      <a:r>
+                        <a:rPr lang="en-US" sz="1200" b="1" dirty="0">
+                          <a:solidFill>
+                            <a:srgbClr val="EEF3EF"/>
+                          </a:solidFill>
+                        </a:rPr>
+                        <a:t>Set</a:t>
+                      </a:r>
+                      <a:endParaRPr lang="en-US" sz="1200" dirty="0"/>
+                    </a:p>
+                  </a:txBody>
+                  <a:tcPr marL="91440" marR="91440" marT="45720" marB="45720" anchor="ctr">
+                    <a:lnL w="6350" cap="flat" cmpd="sng" algn="ctr">
+                      <a:solidFill>
+                        <a:srgbClr val="D5DDD6"/>
+                      </a:solidFill>
+                      <a:prstDash val="solid"/>
+                      <a:round/>
+                      <a:headEnd type="none" w="med" len="med"/>
+                      <a:tailEnd type="none" w="med" len="med"/>
+                    </a:lnL>
+                    <a:lnR w="6350" cap="flat" cmpd="sng" algn="ctr">
+                      <a:solidFill>
+                        <a:srgbClr val="D5DDD6"/>
+                      </a:solidFill>
+                      <a:prstDash val="solid"/>
+                      <a:round/>
+                      <a:headEnd type="none" w="med" len="med"/>
+                      <a:tailEnd type="none" w="med" len="med"/>
+                    </a:lnR>
+                    <a:lnT w="6350" cap="flat" cmpd="sng" algn="ctr">
+                      <a:solidFill>
+                        <a:srgbClr val="D5DDD6"/>
+                      </a:solidFill>
+                      <a:prstDash val="solid"/>
+                      <a:round/>
+                      <a:headEnd type="none" w="med" len="med"/>
+                      <a:tailEnd type="none" w="med" len="med"/>
+                    </a:lnT>
+                    <a:lnB w="6350" cap="flat" cmpd="sng" algn="ctr">
+                      <a:solidFill>
+                        <a:srgbClr val="D5DDD6"/>
+                      </a:solidFill>
+                      <a:prstDash val="solid"/>
+                      <a:round/>
+                      <a:headEnd type="none" w="med" len="med"/>
+                      <a:tailEnd type="none" w="med" len="med"/>
+                    </a:lnB>
+                    <a:solidFill>
+                      <a:srgbClr val="1F6E43"/>
+                    </a:solidFill>
+                  </a:tcPr>
+                </a:tc>
+              </a:tr>
+              <a:tr h="548640">
+                <a:tc>
+                  <a:txBody>
+                    <a:bodyPr/>
+                    <a:lstStyle/>
+                    <a:p>
+                      <a:pPr indent="0" marL="0">
+                        <a:buNone/>
+                      </a:pPr>
+                      <a:r>
+                        <a:rPr lang="en-US" sz="1200" b="1" dirty="0">
+                          <a:solidFill>
+                            <a:srgbClr val="123524"/>
+                          </a:solidFill>
+                        </a:rPr>
+                        <a:t>Board</a:t>
+                      </a:r>
+                      <a:endParaRPr lang="en-US" sz="1200" dirty="0"/>
+                    </a:p>
+                  </a:txBody>
+                  <a:tcPr marL="91440" marR="91440" marT="45720" marB="45720" anchor="ctr">
+                    <a:lnL w="6350" cap="flat" cmpd="sng" algn="ctr">
+                      <a:solidFill>
+                        <a:srgbClr val="D5DDD6"/>
+                      </a:solidFill>
+                      <a:prstDash val="solid"/>
+                      <a:round/>
+                      <a:headEnd type="none" w="med" len="med"/>
+                      <a:tailEnd type="none" w="med" len="med"/>
+                    </a:lnL>
+                    <a:lnR w="6350" cap="flat" cmpd="sng" algn="ctr">
+                      <a:solidFill>
+                        <a:srgbClr val="D5DDD6"/>
+                      </a:solidFill>
+                      <a:prstDash val="solid"/>
+                      <a:round/>
+                      <a:headEnd type="none" w="med" len="med"/>
+                      <a:tailEnd type="none" w="med" len="med"/>
+                    </a:lnR>
+                    <a:lnT w="6350" cap="flat" cmpd="sng" algn="ctr">
+                      <a:solidFill>
+                        <a:srgbClr val="D5DDD6"/>
+                      </a:solidFill>
+                      <a:prstDash val="solid"/>
+                      <a:round/>
+                      <a:headEnd type="none" w="med" len="med"/>
+                      <a:tailEnd type="none" w="med" len="med"/>
+                    </a:lnT>
+                    <a:lnB w="6350" cap="flat" cmpd="sng" algn="ctr">
+                      <a:solidFill>
+                        <a:srgbClr val="D5DDD6"/>
+                      </a:solidFill>
+                      <a:prstDash val="solid"/>
+                      <a:round/>
+                      <a:headEnd type="none" w="med" len="med"/>
+                      <a:tailEnd type="none" w="med" len="med"/>
+                    </a:lnB>
+                    <a:solidFill>
+                      <a:srgbClr val="FFFFFF"/>
+                    </a:solidFill>
+                  </a:tcPr>
+                </a:tc>
+                <a:tc>
+                  <a:txBody>
+                    <a:bodyPr/>
+                    <a:lstStyle/>
+                    <a:p>
+                      <a:pPr indent="0" marL="0">
+                        <a:buNone/>
+                      </a:pPr>
+                      <a:r>
+                        <a:rPr lang="en-US" sz="1200" dirty="0">
+                          <a:solidFill>
+                            <a:srgbClr val="1C1C1C"/>
+                          </a:solidFill>
+                        </a:rPr>
+                        <a:t>File &gt; New Project &gt; Board Selector</a:t>
+                      </a:r>
+                      <a:endParaRPr lang="en-US" sz="1200" dirty="0"/>
+                    </a:p>
+                  </a:txBody>
+                  <a:tcPr marL="91440" marR="91440" marT="45720" marB="45720" anchor="ctr">
+                    <a:lnL w="6350" cap="flat" cmpd="sng" algn="ctr">
+                      <a:solidFill>
+                        <a:srgbClr val="D5DDD6"/>
+                      </a:solidFill>
+                      <a:prstDash val="solid"/>
+                      <a:round/>
+                      <a:headEnd type="none" w="med" len="med"/>
+                      <a:tailEnd type="none" w="med" len="med"/>
+                    </a:lnL>
+                    <a:lnR w="6350" cap="flat" cmpd="sng" algn="ctr">
+                      <a:solidFill>
+                        <a:srgbClr val="D5DDD6"/>
+                      </a:solidFill>
+                      <a:prstDash val="solid"/>
+                      <a:round/>
+                      <a:headEnd type="none" w="med" len="med"/>
+                      <a:tailEnd type="none" w="med" len="med"/>
+                    </a:lnR>
+                    <a:lnT w="6350" cap="flat" cmpd="sng" algn="ctr">
+                      <a:solidFill>
+                        <a:srgbClr val="D5DDD6"/>
+                      </a:solidFill>
+                      <a:prstDash val="solid"/>
+                      <a:round/>
+                      <a:headEnd type="none" w="med" len="med"/>
+                      <a:tailEnd type="none" w="med" len="med"/>
+                    </a:lnT>
+                    <a:lnB w="6350" cap="flat" cmpd="sng" algn="ctr">
+                      <a:solidFill>
+                        <a:srgbClr val="D5DDD6"/>
+                      </a:solidFill>
+                      <a:prstDash val="solid"/>
+                      <a:round/>
+                      <a:headEnd type="none" w="med" len="med"/>
+                      <a:tailEnd type="none" w="med" len="med"/>
+                    </a:lnB>
+                    <a:solidFill>
+                      <a:srgbClr val="FFFFFF"/>
+                    </a:solidFill>
+                  </a:tcPr>
+                </a:tc>
+                <a:tc>
+                  <a:txBody>
+                    <a:bodyPr/>
+                    <a:lstStyle/>
+                    <a:p>
+                      <a:pPr indent="0" marL="0">
+                        <a:buNone/>
+                      </a:pPr>
+                      <a:r>
+                        <a:rPr lang="en-US" sz="1200" dirty="0">
+                          <a:solidFill>
+                            <a:srgbClr val="1C1C1C"/>
+                          </a:solidFill>
+                        </a:rPr>
+                        <a:t>NUCLEO-G474RE; answer Yes to initialise all peripherals with their default mode (gives LD2, B1, LPUART1 and the debug pins)</a:t>
+                      </a:r>
+                      <a:endParaRPr lang="en-US" sz="1200" dirty="0"/>
+                    </a:p>
+                  </a:txBody>
+                  <a:tcPr marL="91440" marR="91440" marT="45720" marB="45720" anchor="ctr">
+                    <a:lnL w="6350" cap="flat" cmpd="sng" algn="ctr">
+                      <a:solidFill>
+                        <a:srgbClr val="D5DDD6"/>
+                      </a:solidFill>
+                      <a:prstDash val="solid"/>
+                      <a:round/>
+                      <a:headEnd type="none" w="med" len="med"/>
+                      <a:tailEnd type="none" w="med" len="med"/>
+                    </a:lnL>
+                    <a:lnR w="6350" cap="flat" cmpd="sng" algn="ctr">
+                      <a:solidFill>
+                        <a:srgbClr val="D5DDD6"/>
+                      </a:solidFill>
+                      <a:prstDash val="solid"/>
+                      <a:round/>
+                      <a:headEnd type="none" w="med" len="med"/>
+                      <a:tailEnd type="none" w="med" len="med"/>
+                    </a:lnR>
+                    <a:lnT w="6350" cap="flat" cmpd="sng" algn="ctr">
+                      <a:solidFill>
+                        <a:srgbClr val="D5DDD6"/>
+                      </a:solidFill>
+                      <a:prstDash val="solid"/>
+                      <a:round/>
+                      <a:headEnd type="none" w="med" len="med"/>
+                      <a:tailEnd type="none" w="med" len="med"/>
+                    </a:lnT>
+                    <a:lnB w="6350" cap="flat" cmpd="sng" algn="ctr">
+                      <a:solidFill>
+                        <a:srgbClr val="D5DDD6"/>
+                      </a:solidFill>
+                      <a:prstDash val="solid"/>
+                      <a:round/>
+                      <a:headEnd type="none" w="med" len="med"/>
+                      <a:tailEnd type="none" w="med" len="med"/>
+                    </a:lnB>
+                    <a:solidFill>
+                      <a:srgbClr val="FFFFFF"/>
+                    </a:solidFill>
+                  </a:tcPr>
+                </a:tc>
+              </a:tr>
+              <a:tr h="548640">
+                <a:tc>
+                  <a:txBody>
+                    <a:bodyPr/>
+                    <a:lstStyle/>
+                    <a:p>
+                      <a:pPr indent="0" marL="0">
+                        <a:buNone/>
+                      </a:pPr>
+                      <a:r>
+                        <a:rPr lang="en-US" sz="1200" b="1" dirty="0">
+                          <a:solidFill>
+                            <a:srgbClr val="123524"/>
+                          </a:solidFill>
+                        </a:rPr>
+                        <a:t>IR sensor</a:t>
+                      </a:r>
+                      <a:endParaRPr lang="en-US" sz="1200" dirty="0"/>
+                    </a:p>
+                  </a:txBody>
+                  <a:tcPr marL="91440" marR="91440" marT="45720" marB="45720" anchor="ctr">
+                    <a:lnL w="6350" cap="flat" cmpd="sng" algn="ctr">
+                      <a:solidFill>
+                        <a:srgbClr val="D5DDD6"/>
+                      </a:solidFill>
+                      <a:prstDash val="solid"/>
+                      <a:round/>
+                      <a:headEnd type="none" w="med" len="med"/>
+                      <a:tailEnd type="none" w="med" len="med"/>
+                    </a:lnL>
+                    <a:lnR w="6350" cap="flat" cmpd="sng" algn="ctr">
+                      <a:solidFill>
+                        <a:srgbClr val="D5DDD6"/>
+                      </a:solidFill>
+                      <a:prstDash val="solid"/>
+                      <a:round/>
+                      <a:headEnd type="none" w="med" len="med"/>
+                      <a:tailEnd type="none" w="med" len="med"/>
+                    </a:lnR>
+                    <a:lnT w="6350" cap="flat" cmpd="sng" algn="ctr">
+                      <a:solidFill>
+                        <a:srgbClr val="D5DDD6"/>
+                      </a:solidFill>
+                      <a:prstDash val="solid"/>
+                      <a:round/>
+                      <a:headEnd type="none" w="med" len="med"/>
+                      <a:tailEnd type="none" w="med" len="med"/>
+                    </a:lnT>
+                    <a:lnB w="6350" cap="flat" cmpd="sng" algn="ctr">
+                      <a:solidFill>
+                        <a:srgbClr val="D5DDD6"/>
+                      </a:solidFill>
+                      <a:prstDash val="solid"/>
+                      <a:round/>
+                      <a:headEnd type="none" w="med" len="med"/>
+                      <a:tailEnd type="none" w="med" len="med"/>
+                    </a:lnB>
+                    <a:solidFill>
+                      <a:srgbClr val="FFFFFF"/>
+                    </a:solidFill>
+                  </a:tcPr>
+                </a:tc>
+                <a:tc>
+                  <a:txBody>
+                    <a:bodyPr/>
+                    <a:lstStyle/>
+                    <a:p>
+                      <a:pPr indent="0" marL="0">
+                        <a:buNone/>
+                      </a:pPr>
+                      <a:r>
+                        <a:rPr lang="en-US" sz="1200" dirty="0">
+                          <a:solidFill>
+                            <a:srgbClr val="1C1C1C"/>
+                          </a:solidFill>
+                        </a:rPr>
+                        <a:t>Pinout view: click PA7</a:t>
+                      </a:r>
+                      <a:endParaRPr lang="en-US" sz="1200" dirty="0"/>
+                    </a:p>
+                  </a:txBody>
+                  <a:tcPr marL="91440" marR="91440" marT="45720" marB="45720" anchor="ctr">
+                    <a:lnL w="6350" cap="flat" cmpd="sng" algn="ctr">
+                      <a:solidFill>
+                        <a:srgbClr val="D5DDD6"/>
+                      </a:solidFill>
+                      <a:prstDash val="solid"/>
+                      <a:round/>
+                      <a:headEnd type="none" w="med" len="med"/>
+                      <a:tailEnd type="none" w="med" len="med"/>
+                    </a:lnL>
+                    <a:lnR w="6350" cap="flat" cmpd="sng" algn="ctr">
+                      <a:solidFill>
+                        <a:srgbClr val="D5DDD6"/>
+                      </a:solidFill>
+                      <a:prstDash val="solid"/>
+                      <a:round/>
+                      <a:headEnd type="none" w="med" len="med"/>
+                      <a:tailEnd type="none" w="med" len="med"/>
+                    </a:lnR>
+                    <a:lnT w="6350" cap="flat" cmpd="sng" algn="ctr">
+                      <a:solidFill>
+                        <a:srgbClr val="D5DDD6"/>
+                      </a:solidFill>
+                      <a:prstDash val="solid"/>
+                      <a:round/>
+                      <a:headEnd type="none" w="med" len="med"/>
+                      <a:tailEnd type="none" w="med" len="med"/>
+                    </a:lnT>
+                    <a:lnB w="6350" cap="flat" cmpd="sng" algn="ctr">
+                      <a:solidFill>
+                        <a:srgbClr val="D5DDD6"/>
+                      </a:solidFill>
+                      <a:prstDash val="solid"/>
+                      <a:round/>
+                      <a:headEnd type="none" w="med" len="med"/>
+                      <a:tailEnd type="none" w="med" len="med"/>
+                    </a:lnB>
+                    <a:solidFill>
+                      <a:srgbClr val="FFFFFF"/>
+                    </a:solidFill>
+                  </a:tcPr>
+                </a:tc>
+                <a:tc>
+                  <a:txBody>
+                    <a:bodyPr/>
+                    <a:lstStyle/>
+                    <a:p>
+                      <a:pPr indent="0" marL="0">
+                        <a:buNone/>
+                      </a:pPr>
+                      <a:r>
+                        <a:rPr lang="en-US" sz="1200" dirty="0">
+                          <a:solidFill>
+                            <a:srgbClr val="1C1C1C"/>
+                          </a:solidFill>
+                        </a:rPr>
+                        <a:t>GPIO_Input; right-click &gt; Enter User Label: IR_SENSOR</a:t>
+                      </a:r>
+                      <a:endParaRPr lang="en-US" sz="1200" dirty="0"/>
+                    </a:p>
+                  </a:txBody>
+                  <a:tcPr marL="91440" marR="91440" marT="45720" marB="45720" anchor="ctr">
+                    <a:lnL w="6350" cap="flat" cmpd="sng" algn="ctr">
+                      <a:solidFill>
+                        <a:srgbClr val="D5DDD6"/>
+                      </a:solidFill>
+                      <a:prstDash val="solid"/>
+                      <a:round/>
+                      <a:headEnd type="none" w="med" len="med"/>
+                      <a:tailEnd type="none" w="med" len="med"/>
+                    </a:lnL>
+                    <a:lnR w="6350" cap="flat" cmpd="sng" algn="ctr">
+                      <a:solidFill>
+                        <a:srgbClr val="D5DDD6"/>
+                      </a:solidFill>
+                      <a:prstDash val="solid"/>
+                      <a:round/>
+                      <a:headEnd type="none" w="med" len="med"/>
+                      <a:tailEnd type="none" w="med" len="med"/>
+                    </a:lnR>
+                    <a:lnT w="6350" cap="flat" cmpd="sng" algn="ctr">
+                      <a:solidFill>
+                        <a:srgbClr val="D5DDD6"/>
+                      </a:solidFill>
+                      <a:prstDash val="solid"/>
+                      <a:round/>
+                      <a:headEnd type="none" w="med" len="med"/>
+                      <a:tailEnd type="none" w="med" len="med"/>
+                    </a:lnT>
+                    <a:lnB w="6350" cap="flat" cmpd="sng" algn="ctr">
+                      <a:solidFill>
+                        <a:srgbClr val="D5DDD6"/>
+                      </a:solidFill>
+                      <a:prstDash val="solid"/>
+                      <a:round/>
+                      <a:headEnd type="none" w="med" len="med"/>
+                      <a:tailEnd type="none" w="med" len="med"/>
+                    </a:lnB>
+                    <a:solidFill>
+                      <a:srgbClr val="FFFFFF"/>
+                    </a:solidFill>
+                  </a:tcPr>
+                </a:tc>
+              </a:tr>
+              <a:tr h="548640">
+                <a:tc>
+                  <a:txBody>
+                    <a:bodyPr/>
+                    <a:lstStyle/>
+                    <a:p>
+                      <a:pPr indent="0" marL="0">
+                        <a:buNone/>
+                      </a:pPr>
+                      <a:r>
+                        <a:rPr lang="en-US" sz="1200" b="1" dirty="0">
+                          <a:solidFill>
+                            <a:srgbClr val="123524"/>
+                          </a:solidFill>
+                        </a:rPr>
+                        <a:t>I2C1</a:t>
+                      </a:r>
+                      <a:endParaRPr lang="en-US" sz="1200" dirty="0"/>
+                    </a:p>
+                  </a:txBody>
+                  <a:tcPr marL="91440" marR="91440" marT="45720" marB="45720" anchor="ctr">
+                    <a:lnL w="6350" cap="flat" cmpd="sng" algn="ctr">
+                      <a:solidFill>
+                        <a:srgbClr val="D5DDD6"/>
+                      </a:solidFill>
+                      <a:prstDash val="solid"/>
+                      <a:round/>
+                      <a:headEnd type="none" w="med" len="med"/>
+                      <a:tailEnd type="none" w="med" len="med"/>
+                    </a:lnL>
+                    <a:lnR w="6350" cap="flat" cmpd="sng" algn="ctr">
+                      <a:solidFill>
+                        <a:srgbClr val="D5DDD6"/>
+                      </a:solidFill>
+                      <a:prstDash val="solid"/>
+                      <a:round/>
+                      <a:headEnd type="none" w="med" len="med"/>
+                      <a:tailEnd type="none" w="med" len="med"/>
+                    </a:lnR>
+                    <a:lnT w="6350" cap="flat" cmpd="sng" algn="ctr">
+                      <a:solidFill>
+                        <a:srgbClr val="D5DDD6"/>
+                      </a:solidFill>
+                      <a:prstDash val="solid"/>
+                      <a:round/>
+                      <a:headEnd type="none" w="med" len="med"/>
+                      <a:tailEnd type="none" w="med" len="med"/>
+                    </a:lnT>
+                    <a:lnB w="6350" cap="flat" cmpd="sng" algn="ctr">
+                      <a:solidFill>
+                        <a:srgbClr val="D5DDD6"/>
+                      </a:solidFill>
+                      <a:prstDash val="solid"/>
+                      <a:round/>
+                      <a:headEnd type="none" w="med" len="med"/>
+                      <a:tailEnd type="none" w="med" len="med"/>
+                    </a:lnB>
+                    <a:solidFill>
+                      <a:srgbClr val="FFFFFF"/>
+                    </a:solidFill>
+                  </a:tcPr>
+                </a:tc>
+                <a:tc>
+                  <a:txBody>
+                    <a:bodyPr/>
+                    <a:lstStyle/>
+                    <a:p>
+                      <a:pPr indent="0" marL="0">
+                        <a:buNone/>
+                      </a:pPr>
+                      <a:r>
+                        <a:rPr lang="en-US" sz="1200" dirty="0">
+                          <a:solidFill>
+                            <a:srgbClr val="1C1C1C"/>
+                          </a:solidFill>
+                        </a:rPr>
+                        <a:t>Connectivity &gt; I2C1 &gt; Mode: I2C</a:t>
+                      </a:r>
+                      <a:endParaRPr lang="en-US" sz="1200" dirty="0"/>
+                    </a:p>
+                  </a:txBody>
+                  <a:tcPr marL="91440" marR="91440" marT="45720" marB="45720" anchor="ctr">
+                    <a:lnL w="6350" cap="flat" cmpd="sng" algn="ctr">
+                      <a:solidFill>
+                        <a:srgbClr val="D5DDD6"/>
+                      </a:solidFill>
+                      <a:prstDash val="solid"/>
+                      <a:round/>
+                      <a:headEnd type="none" w="med" len="med"/>
+                      <a:tailEnd type="none" w="med" len="med"/>
+                    </a:lnL>
+                    <a:lnR w="6350" cap="flat" cmpd="sng" algn="ctr">
+                      <a:solidFill>
+                        <a:srgbClr val="D5DDD6"/>
+                      </a:solidFill>
+                      <a:prstDash val="solid"/>
+                      <a:round/>
+                      <a:headEnd type="none" w="med" len="med"/>
+                      <a:tailEnd type="none" w="med" len="med"/>
+                    </a:lnR>
+                    <a:lnT w="6350" cap="flat" cmpd="sng" algn="ctr">
+                      <a:solidFill>
+                        <a:srgbClr val="D5DDD6"/>
+                      </a:solidFill>
+                      <a:prstDash val="solid"/>
+                      <a:round/>
+                      <a:headEnd type="none" w="med" len="med"/>
+                      <a:tailEnd type="none" w="med" len="med"/>
+                    </a:lnT>
+                    <a:lnB w="6350" cap="flat" cmpd="sng" algn="ctr">
+                      <a:solidFill>
+                        <a:srgbClr val="D5DDD6"/>
+                      </a:solidFill>
+                      <a:prstDash val="solid"/>
+                      <a:round/>
+                      <a:headEnd type="none" w="med" len="med"/>
+                      <a:tailEnd type="none" w="med" len="med"/>
+                    </a:lnB>
+                    <a:solidFill>
+                      <a:srgbClr val="FFFFFF"/>
+                    </a:solidFill>
+                  </a:tcPr>
+                </a:tc>
+                <a:tc>
+                  <a:txBody>
+                    <a:bodyPr/>
+                    <a:lstStyle/>
+                    <a:p>
+                      <a:pPr indent="0" marL="0">
+                        <a:buNone/>
+                      </a:pPr>
+                      <a:r>
+                        <a:rPr lang="en-US" sz="1200" dirty="0">
+                          <a:solidFill>
+                            <a:srgbClr val="1C1C1C"/>
+                          </a:solidFill>
+                        </a:rPr>
+                        <a:t>Check the pins: PB8 = SCL, PB9 = SDA. Ctrl+click a pin to see where else it can go</a:t>
+                      </a:r>
+                      <a:endParaRPr lang="en-US" sz="1200" dirty="0"/>
+                    </a:p>
+                  </a:txBody>
+                  <a:tcPr marL="91440" marR="91440" marT="45720" marB="45720" anchor="ctr">
+                    <a:lnL w="6350" cap="flat" cmpd="sng" algn="ctr">
+                      <a:solidFill>
+                        <a:srgbClr val="D5DDD6"/>
+                      </a:solidFill>
+                      <a:prstDash val="solid"/>
+                      <a:round/>
+                      <a:headEnd type="none" w="med" len="med"/>
+                      <a:tailEnd type="none" w="med" len="med"/>
+                    </a:lnL>
+                    <a:lnR w="6350" cap="flat" cmpd="sng" algn="ctr">
+                      <a:solidFill>
+                        <a:srgbClr val="D5DDD6"/>
+                      </a:solidFill>
+                      <a:prstDash val="solid"/>
+                      <a:round/>
+                      <a:headEnd type="none" w="med" len="med"/>
+                      <a:tailEnd type="none" w="med" len="med"/>
+                    </a:lnR>
+                    <a:lnT w="6350" cap="flat" cmpd="sng" algn="ctr">
+                      <a:solidFill>
+                        <a:srgbClr val="D5DDD6"/>
+                      </a:solidFill>
+                      <a:prstDash val="solid"/>
+                      <a:round/>
+                      <a:headEnd type="none" w="med" len="med"/>
+                      <a:tailEnd type="none" w="med" len="med"/>
+                    </a:lnT>
+                    <a:lnB w="6350" cap="flat" cmpd="sng" algn="ctr">
+                      <a:solidFill>
+                        <a:srgbClr val="D5DDD6"/>
+                      </a:solidFill>
+                      <a:prstDash val="solid"/>
+                      <a:round/>
+                      <a:headEnd type="none" w="med" len="med"/>
+                      <a:tailEnd type="none" w="med" len="med"/>
+                    </a:lnB>
+                    <a:solidFill>
+                      <a:srgbClr val="FFFFFF"/>
+                    </a:solidFill>
+                  </a:tcPr>
+                </a:tc>
+              </a:tr>
+              <a:tr h="548640">
+                <a:tc>
+                  <a:txBody>
+                    <a:bodyPr/>
+                    <a:lstStyle/>
+                    <a:p>
+                      <a:pPr indent="0" marL="0">
+                        <a:buNone/>
+                      </a:pPr>
+                      <a:r>
+                        <a:rPr lang="en-US" sz="1200" b="1" dirty="0">
+                          <a:solidFill>
+                            <a:srgbClr val="123524"/>
+                          </a:solidFill>
+                        </a:rPr>
+                        <a:t>Debug pins</a:t>
+                      </a:r>
+                      <a:endParaRPr lang="en-US" sz="1200" dirty="0"/>
+                    </a:p>
+                  </a:txBody>
+                  <a:tcPr marL="91440" marR="91440" marT="45720" marB="45720" anchor="ctr">
+                    <a:lnL w="6350" cap="flat" cmpd="sng" algn="ctr">
+                      <a:solidFill>
+                        <a:srgbClr val="D5DDD6"/>
+                      </a:solidFill>
+                      <a:prstDash val="solid"/>
+                      <a:round/>
+                      <a:headEnd type="none" w="med" len="med"/>
+                      <a:tailEnd type="none" w="med" len="med"/>
+                    </a:lnL>
+                    <a:lnR w="6350" cap="flat" cmpd="sng" algn="ctr">
+                      <a:solidFill>
+                        <a:srgbClr val="D5DDD6"/>
+                      </a:solidFill>
+                      <a:prstDash val="solid"/>
+                      <a:round/>
+                      <a:headEnd type="none" w="med" len="med"/>
+                      <a:tailEnd type="none" w="med" len="med"/>
+                    </a:lnR>
+                    <a:lnT w="6350" cap="flat" cmpd="sng" algn="ctr">
+                      <a:solidFill>
+                        <a:srgbClr val="D5DDD6"/>
+                      </a:solidFill>
+                      <a:prstDash val="solid"/>
+                      <a:round/>
+                      <a:headEnd type="none" w="med" len="med"/>
+                      <a:tailEnd type="none" w="med" len="med"/>
+                    </a:lnT>
+                    <a:lnB w="6350" cap="flat" cmpd="sng" algn="ctr">
+                      <a:solidFill>
+                        <a:srgbClr val="D5DDD6"/>
+                      </a:solidFill>
+                      <a:prstDash val="solid"/>
+                      <a:round/>
+                      <a:headEnd type="none" w="med" len="med"/>
+                      <a:tailEnd type="none" w="med" len="med"/>
+                    </a:lnB>
+                    <a:solidFill>
+                      <a:srgbClr val="FFFFFF"/>
+                    </a:solidFill>
+                  </a:tcPr>
+                </a:tc>
+                <a:tc>
+                  <a:txBody>
+                    <a:bodyPr/>
+                    <a:lstStyle/>
+                    <a:p>
+                      <a:pPr indent="0" marL="0">
+                        <a:buNone/>
+                      </a:pPr>
+                      <a:r>
+                        <a:rPr lang="en-US" sz="1200" dirty="0">
+                          <a:solidFill>
+                            <a:srgbClr val="1C1C1C"/>
+                          </a:solidFill>
+                        </a:rPr>
+                        <a:t>PA13, PA14, PB3</a:t>
+                      </a:r>
+                      <a:endParaRPr lang="en-US" sz="1200" dirty="0"/>
+                    </a:p>
+                  </a:txBody>
+                  <a:tcPr marL="91440" marR="91440" marT="45720" marB="45720" anchor="ctr">
+                    <a:lnL w="6350" cap="flat" cmpd="sng" algn="ctr">
+                      <a:solidFill>
+                        <a:srgbClr val="D5DDD6"/>
+                      </a:solidFill>
+                      <a:prstDash val="solid"/>
+                      <a:round/>
+                      <a:headEnd type="none" w="med" len="med"/>
+                      <a:tailEnd type="none" w="med" len="med"/>
+                    </a:lnL>
+                    <a:lnR w="6350" cap="flat" cmpd="sng" algn="ctr">
+                      <a:solidFill>
+                        <a:srgbClr val="D5DDD6"/>
+                      </a:solidFill>
+                      <a:prstDash val="solid"/>
+                      <a:round/>
+                      <a:headEnd type="none" w="med" len="med"/>
+                      <a:tailEnd type="none" w="med" len="med"/>
+                    </a:lnR>
+                    <a:lnT w="6350" cap="flat" cmpd="sng" algn="ctr">
+                      <a:solidFill>
+                        <a:srgbClr val="D5DDD6"/>
+                      </a:solidFill>
+                      <a:prstDash val="solid"/>
+                      <a:round/>
+                      <a:headEnd type="none" w="med" len="med"/>
+                      <a:tailEnd type="none" w="med" len="med"/>
+                    </a:lnT>
+                    <a:lnB w="6350" cap="flat" cmpd="sng" algn="ctr">
+                      <a:solidFill>
+                        <a:srgbClr val="D5DDD6"/>
+                      </a:solidFill>
+                      <a:prstDash val="solid"/>
+                      <a:round/>
+                      <a:headEnd type="none" w="med" len="med"/>
+                      <a:tailEnd type="none" w="med" len="med"/>
+                    </a:lnB>
+                    <a:solidFill>
+                      <a:srgbClr val="FFFFFF"/>
+                    </a:solidFill>
+                  </a:tcPr>
+                </a:tc>
+                <a:tc>
+                  <a:txBody>
+                    <a:bodyPr/>
+                    <a:lstStyle/>
+                    <a:p>
+                      <a:pPr indent="0" marL="0">
+                        <a:buNone/>
+                      </a:pPr>
+                      <a:r>
+                        <a:rPr lang="en-US" sz="1200" dirty="0">
+                          <a:solidFill>
+                            <a:srgbClr val="1C1C1C"/>
+                          </a:solidFill>
+                        </a:rPr>
+                        <a:t>Never reassign them: they connect the ST-LINK debugger</a:t>
+                      </a:r>
+                      <a:endParaRPr lang="en-US" sz="1200" dirty="0"/>
+                    </a:p>
+                  </a:txBody>
+                  <a:tcPr marL="91440" marR="91440" marT="45720" marB="45720" anchor="ctr">
+                    <a:lnL w="6350" cap="flat" cmpd="sng" algn="ctr">
+                      <a:solidFill>
+                        <a:srgbClr val="D5DDD6"/>
+                      </a:solidFill>
+                      <a:prstDash val="solid"/>
+                      <a:round/>
+                      <a:headEnd type="none" w="med" len="med"/>
+                      <a:tailEnd type="none" w="med" len="med"/>
+                    </a:lnL>
+                    <a:lnR w="6350" cap="flat" cmpd="sng" algn="ctr">
+                      <a:solidFill>
+                        <a:srgbClr val="D5DDD6"/>
+                      </a:solidFill>
+                      <a:prstDash val="solid"/>
+                      <a:round/>
+                      <a:headEnd type="none" w="med" len="med"/>
+                      <a:tailEnd type="none" w="med" len="med"/>
+                    </a:lnR>
+                    <a:lnT w="6350" cap="flat" cmpd="sng" algn="ctr">
+                      <a:solidFill>
+                        <a:srgbClr val="D5DDD6"/>
+                      </a:solidFill>
+                      <a:prstDash val="solid"/>
+                      <a:round/>
+                      <a:headEnd type="none" w="med" len="med"/>
+                      <a:tailEnd type="none" w="med" len="med"/>
+                    </a:lnT>
+                    <a:lnB w="6350" cap="flat" cmpd="sng" algn="ctr">
+                      <a:solidFill>
+                        <a:srgbClr val="D5DDD6"/>
+                      </a:solidFill>
+                      <a:prstDash val="solid"/>
+                      <a:round/>
+                      <a:headEnd type="none" w="med" len="med"/>
+                      <a:tailEnd type="none" w="med" len="med"/>
+                    </a:lnB>
+                    <a:solidFill>
+                      <a:srgbClr val="FFFFFF"/>
+                    </a:solidFill>
+                  </a:tcPr>
+                </a:tc>
+              </a:tr>
+            </a:tbl>
+          </a:graphicData>
+        </a:graphic>
+      </p:graphicFrame>
+      <p:sp>
+        <p:nvSpPr>
+          <p:cNvPr id="4" name="ioc pins note"/>
+          <p:cNvSpPr txBox="1"/>
+          <p:nvPr/>
+        </p:nvSpPr>
+        <p:spPr>
+          <a:xfrm>
+            <a:off x="457200" y="3931920"/>
+            <a:ext cx="8229600" cy="457200"/>
+          </a:xfrm>
+          <a:prstGeom prst="rect">
+            <a:avLst/>
+          </a:prstGeom>
+          <a:noFill/>
+          <a:ln/>
+        </p:spPr>
+        <p:txBody>
+          <a:bodyPr wrap="square" rtlCol="0" anchor="ctr"/>
+          <a:lstStyle/>
+          <a:p>
+            <a:pPr indent="0" marL="0">
+              <a:buNone/>
+            </a:pPr>
+            <a:r>
+              <a:rPr lang="en-US" sz="1300" i="1" dirty="0">
+                <a:solidFill>
+                  <a:srgbClr val="5C5C5C"/>
+                </a:solidFill>
+              </a:rPr>
+              <a:t>A user label becomes a name in main.h: </a:t>
+            </a:r>
+            <a:r>
+              <a:rPr lang="en-US" sz="1300" i="1" dirty="0">
+                <a:solidFill>
+                  <a:srgbClr val="5C5C5C"/>
+                </a:solidFill>
+                <a:latin typeface="Courier New"/>
+                <a:cs typeface="Courier New"/>
+              </a:rPr>
+              <a:t>IR_SENSOR_Pin</a:t>
+            </a:r>
+            <a:r>
+              <a:rPr lang="en-US" sz="1300" i="1" dirty="0">
+                <a:solidFill>
+                  <a:srgbClr val="5C5C5C"/>
+                </a:solidFill>
+              </a:rPr>
+              <a:t>, </a:t>
+            </a:r>
+            <a:r>
+              <a:rPr lang="en-US" sz="1300" i="1" dirty="0">
+                <a:solidFill>
+                  <a:srgbClr val="5C5C5C"/>
+                </a:solidFill>
+                <a:latin typeface="Courier New"/>
+                <a:cs typeface="Courier New"/>
+              </a:rPr>
+              <a:t>IR_SENSOR_GPIO_Port</a:t>
+            </a:r>
+            <a:r>
+              <a:rPr lang="en-US" sz="1300" i="1" dirty="0">
+                <a:solidFill>
+                  <a:srgbClr val="5C5C5C"/>
+                </a:solidFill>
+              </a:rPr>
+              <a:t>.</a:t>
+            </a:r>
+            <a:endParaRPr lang="en-US" sz="1300" dirty="0"/>
+          </a:p>
+        </p:txBody>
+      </p:sp>
+      <p:sp>
+        <p:nvSpPr>
+          <p:cNvPr id="5" name="Slide Number Placeholder 0"/>
+          <p:cNvSpPr>
+            <a:spLocks noGrp="1"/>
+          </p:cNvSpPr>
+          <p:nvPr>
+            <p:ph type="sldNum" sz="quarter" idx="4294967295"/>
+          </p:nvPr>
+        </p:nvSpPr>
+        <p:spPr>
+          <a:xfrm>
+            <a:off x="8412480" y="4754880"/>
+            <a:ext cx="800000" cy="300000"/>
+          </a:xfrm>
+          <a:prstGeom prst="rect">
+            <a:avLst/>
+          </a:prstGeom>
+        </p:spPr>
+        <p:txBody>
+          <a:bodyPr/>
+          <a:lstStyle>
+            <a:lvl1pPr>
+              <a:defRPr sz="1000">
+                <a:solidFill>
+                  <a:schemeClr val="tx2"/>
+                </a:solidFill>
+              </a:defRPr>
+            </a:lvl1pPr>
+          </a:lstStyle>
+          <a:p>
+            <a:pPr algn="l"/>
+            <a:fld id="{F7021451-1387-4CA6-816F-3879F97B5CBC}" type="slidenum">
+              <a:rPr b="0" lang="en-US"/>
+              <a:t>20</a:t>
+            </a:fld>
+            <a:endParaRPr lang="en-US"/>
+          </a:p>
+        </p:txBody>
+      </p:sp>
+    </p:spTree>
+  </p:cSld>
+  <p:clrMapOvr>
+    <a:masterClrMapping/>
+  </p:clrMapOvr>
+</p:sld>
+</file>
+
+<file path=ppt/slides/slide29.xml><?xml version="1.0" encoding="utf-8"?>
+<p:sld xmlns:a="http://schemas.openxmlformats.org/drawingml/2006/main" xmlns:r="http://schemas.openxmlformats.org/officeDocument/2006/relationships" xmlns:p="http://schemas.openxmlformats.org/presentationml/2006/main">
+  <p:cSld name="Slide 21">
+    <p:spTree>
+      <p:nvGrpSpPr>
+        <p:cNvPr id="1" name=""/>
+        <p:cNvGrpSpPr/>
+        <p:nvPr/>
+      </p:nvGrpSpPr>
+      <p:grpSpPr>
+        <a:xfrm>
+          <a:off x="0" y="0"/>
+          <a:ext cx="0" cy="0"/>
+          <a:chOff x="0" y="0"/>
+          <a:chExt cx="0" cy="0"/>
+        </a:xfrm>
+      </p:grpSpPr>
+      <p:sp>
+        <p:nvSpPr>
+          <p:cNvPr id="2" name="Text 0"/>
+          <p:cNvSpPr/>
+          <p:nvPr>
+            <p:ph idx="100" type="title" hasCustomPrompt="1"/>
+          </p:nvPr>
+        </p:nvSpPr>
+        <p:spPr>
+          <a:xfrm>
+            <a:off x="457200" y="274320"/>
+            <a:ext cx="8229600" cy="640080"/>
+          </a:xfrm>
+          <a:prstGeom prst="rect">
+            <a:avLst/>
+          </a:prstGeom>
+          <a:noFill/>
+          <a:ln/>
+        </p:spPr>
+        <p:txBody>
+          <a:bodyPr wrap="square" rtlCol="0" anchor="ctr"/>
+          <a:lstStyle/>
+          <a:p>
+            <a:pPr algn="l" indent="0" marL="0">
+              <a:buNone/>
+            </a:pPr>
+            <a:r>
+              <a:rPr lang="en-US" sz="2600" b="1" dirty="0">
+                <a:solidFill>
+                  <a:schemeClr val="tx2"/>
+                </a:solidFill>
+              </a:rPr>
+              <a:t>Peripherals, clock and interrupts</a:t>
+            </a:r>
+            <a:endParaRPr lang="en-US" sz="2600" dirty="0"/>
+          </a:p>
+        </p:txBody>
+      </p:sp>
+      <p:graphicFrame>
+        <p:nvGraphicFramePr>
+          <p:cNvPr id="3" name="ioc periph table"/>
+          <p:cNvGraphicFramePr>
+            <a:graphicFrameLocks noGrp="1"/>
+          </p:cNvGraphicFramePr>
+          <p:nvPr/>
+        </p:nvGraphicFramePr>
+        <p:xfrm>
+          <a:off x="457200" y="1051560"/>
+          <a:ext cx="8229600" cy="2743200"/>
+        </p:xfrm>
+        <a:graphic>
+          <a:graphicData uri="http://schemas.openxmlformats.org/drawingml/2006/table">
+            <a:tbl>
+              <a:tblPr/>
+              <a:tblGrid>
+                <a:gridCol w="1463040"/>
+                <a:gridCol w="3017520"/>
+                <a:gridCol w="3749040"/>
+              </a:tblGrid>
+              <a:tr h="457200">
+                <a:tc>
+                  <a:txBody>
+                    <a:bodyPr/>
+                    <a:lstStyle/>
+                    <a:p>
+                      <a:pPr indent="0" marL="0">
+                        <a:buNone/>
+                      </a:pPr>
+                      <a:r>
+                        <a:rPr lang="en-US" sz="1200" b="1" dirty="0">
+                          <a:solidFill>
+                            <a:srgbClr val="EEF3EF"/>
+                          </a:solidFill>
+                        </a:rPr>
+                        <a:t>What</a:t>
+                      </a:r>
+                      <a:endParaRPr lang="en-US" sz="1200" dirty="0"/>
+                    </a:p>
+                  </a:txBody>
+                  <a:tcPr marL="91440" marR="91440" marT="45720" marB="45720" anchor="ctr">
+                    <a:lnL w="6350" cap="flat" cmpd="sng" algn="ctr">
+                      <a:solidFill>
+                        <a:srgbClr val="D5DDD6"/>
+                      </a:solidFill>
+                      <a:prstDash val="solid"/>
+                      <a:round/>
+                      <a:headEnd type="none" w="med" len="med"/>
+                      <a:tailEnd type="none" w="med" len="med"/>
+                    </a:lnL>
+                    <a:lnR w="6350" cap="flat" cmpd="sng" algn="ctr">
+                      <a:solidFill>
+                        <a:srgbClr val="D5DDD6"/>
+                      </a:solidFill>
+                      <a:prstDash val="solid"/>
+                      <a:round/>
+                      <a:headEnd type="none" w="med" len="med"/>
+                      <a:tailEnd type="none" w="med" len="med"/>
+                    </a:lnR>
+                    <a:lnT w="6350" cap="flat" cmpd="sng" algn="ctr">
+                      <a:solidFill>
+                        <a:srgbClr val="D5DDD6"/>
+                      </a:solidFill>
+                      <a:prstDash val="solid"/>
+                      <a:round/>
+                      <a:headEnd type="none" w="med" len="med"/>
+                      <a:tailEnd type="none" w="med" len="med"/>
+                    </a:lnT>
+                    <a:lnB w="6350" cap="flat" cmpd="sng" algn="ctr">
+                      <a:solidFill>
+                        <a:srgbClr val="D5DDD6"/>
+                      </a:solidFill>
+                      <a:prstDash val="solid"/>
+                      <a:round/>
+                      <a:headEnd type="none" w="med" len="med"/>
+                      <a:tailEnd type="none" w="med" len="med"/>
+                    </a:lnB>
+                    <a:solidFill>
+                      <a:srgbClr val="1F6E43"/>
+                    </a:solidFill>
+                  </a:tcPr>
+                </a:tc>
+                <a:tc>
+                  <a:txBody>
+                    <a:bodyPr/>
+                    <a:lstStyle/>
+                    <a:p>
+                      <a:pPr indent="0" marL="0">
+                        <a:buNone/>
+                      </a:pPr>
+                      <a:r>
+                        <a:rPr lang="en-US" sz="1200" b="1" dirty="0">
+                          <a:solidFill>
+                            <a:srgbClr val="EEF3EF"/>
+                          </a:solidFill>
+                        </a:rPr>
+                        <a:t>Where in CubeMX</a:t>
+                      </a:r>
+                      <a:endParaRPr lang="en-US" sz="1200" dirty="0"/>
+                    </a:p>
+                  </a:txBody>
+                  <a:tcPr marL="91440" marR="91440" marT="45720" marB="45720" anchor="ctr">
+                    <a:lnL w="6350" cap="flat" cmpd="sng" algn="ctr">
+                      <a:solidFill>
+                        <a:srgbClr val="D5DDD6"/>
+                      </a:solidFill>
+                      <a:prstDash val="solid"/>
+                      <a:round/>
+                      <a:headEnd type="none" w="med" len="med"/>
+                      <a:tailEnd type="none" w="med" len="med"/>
+                    </a:lnL>
+                    <a:lnR w="6350" cap="flat" cmpd="sng" algn="ctr">
+                      <a:solidFill>
+                        <a:srgbClr val="D5DDD6"/>
+                      </a:solidFill>
+                      <a:prstDash val="solid"/>
+                      <a:round/>
+                      <a:headEnd type="none" w="med" len="med"/>
+                      <a:tailEnd type="none" w="med" len="med"/>
+                    </a:lnR>
+                    <a:lnT w="6350" cap="flat" cmpd="sng" algn="ctr">
+                      <a:solidFill>
+                        <a:srgbClr val="D5DDD6"/>
+                      </a:solidFill>
+                      <a:prstDash val="solid"/>
+                      <a:round/>
+                      <a:headEnd type="none" w="med" len="med"/>
+                      <a:tailEnd type="none" w="med" len="med"/>
+                    </a:lnT>
+                    <a:lnB w="6350" cap="flat" cmpd="sng" algn="ctr">
+                      <a:solidFill>
+                        <a:srgbClr val="D5DDD6"/>
+                      </a:solidFill>
+                      <a:prstDash val="solid"/>
+                      <a:round/>
+                      <a:headEnd type="none" w="med" len="med"/>
+                      <a:tailEnd type="none" w="med" len="med"/>
+                    </a:lnB>
+                    <a:solidFill>
+                      <a:srgbClr val="1F6E43"/>
+                    </a:solidFill>
+                  </a:tcPr>
+                </a:tc>
+                <a:tc>
+                  <a:txBody>
+                    <a:bodyPr/>
+                    <a:lstStyle/>
+                    <a:p>
+                      <a:pPr indent="0" marL="0">
+                        <a:buNone/>
+                      </a:pPr>
+                      <a:r>
+                        <a:rPr lang="en-US" sz="1200" b="1" dirty="0">
+                          <a:solidFill>
+                            <a:srgbClr val="EEF3EF"/>
+                          </a:solidFill>
+                        </a:rPr>
+                        <a:t>Set</a:t>
+                      </a:r>
+                      <a:endParaRPr lang="en-US" sz="1200" dirty="0"/>
+                    </a:p>
+                  </a:txBody>
+                  <a:tcPr marL="91440" marR="91440" marT="45720" marB="45720" anchor="ctr">
+                    <a:lnL w="6350" cap="flat" cmpd="sng" algn="ctr">
+                      <a:solidFill>
+                        <a:srgbClr val="D5DDD6"/>
+                      </a:solidFill>
+                      <a:prstDash val="solid"/>
+                      <a:round/>
+                      <a:headEnd type="none" w="med" len="med"/>
+                      <a:tailEnd type="none" w="med" len="med"/>
+                    </a:lnL>
+                    <a:lnR w="6350" cap="flat" cmpd="sng" algn="ctr">
+                      <a:solidFill>
+                        <a:srgbClr val="D5DDD6"/>
+                      </a:solidFill>
+                      <a:prstDash val="solid"/>
+                      <a:round/>
+                      <a:headEnd type="none" w="med" len="med"/>
+                      <a:tailEnd type="none" w="med" len="med"/>
+                    </a:lnR>
+                    <a:lnT w="6350" cap="flat" cmpd="sng" algn="ctr">
+                      <a:solidFill>
+                        <a:srgbClr val="D5DDD6"/>
+                      </a:solidFill>
+                      <a:prstDash val="solid"/>
+                      <a:round/>
+                      <a:headEnd type="none" w="med" len="med"/>
+                      <a:tailEnd type="none" w="med" len="med"/>
+                    </a:lnT>
+                    <a:lnB w="6350" cap="flat" cmpd="sng" algn="ctr">
+                      <a:solidFill>
+                        <a:srgbClr val="D5DDD6"/>
+                      </a:solidFill>
+                      <a:prstDash val="solid"/>
+                      <a:round/>
+                      <a:headEnd type="none" w="med" len="med"/>
+                      <a:tailEnd type="none" w="med" len="med"/>
+                    </a:lnB>
+                    <a:solidFill>
+                      <a:srgbClr val="1F6E43"/>
+                    </a:solidFill>
+                  </a:tcPr>
+                </a:tc>
+              </a:tr>
+              <a:tr h="457200">
+                <a:tc>
+                  <a:txBody>
+                    <a:bodyPr/>
+                    <a:lstStyle/>
+                    <a:p>
+                      <a:pPr indent="0" marL="0">
+                        <a:buNone/>
+                      </a:pPr>
+                      <a:r>
+                        <a:rPr lang="en-US" sz="1200" b="1" dirty="0">
+                          <a:solidFill>
+                            <a:srgbClr val="123524"/>
+                          </a:solidFill>
+                        </a:rPr>
+                        <a:t>I2C1</a:t>
+                      </a:r>
+                      <a:endParaRPr lang="en-US" sz="1200" dirty="0"/>
+                    </a:p>
+                  </a:txBody>
+                  <a:tcPr marL="91440" marR="91440" marT="45720" marB="45720" anchor="ctr">
+                    <a:lnL w="6350" cap="flat" cmpd="sng" algn="ctr">
+                      <a:solidFill>
+                        <a:srgbClr val="D5DDD6"/>
+                      </a:solidFill>
+                      <a:prstDash val="solid"/>
+                      <a:round/>
+                      <a:headEnd type="none" w="med" len="med"/>
+                      <a:tailEnd type="none" w="med" len="med"/>
+                    </a:lnL>
+                    <a:lnR w="6350" cap="flat" cmpd="sng" algn="ctr">
+                      <a:solidFill>
+                        <a:srgbClr val="D5DDD6"/>
+                      </a:solidFill>
+                      <a:prstDash val="solid"/>
+                      <a:round/>
+                      <a:headEnd type="none" w="med" len="med"/>
+                      <a:tailEnd type="none" w="med" len="med"/>
+                    </a:lnR>
+                    <a:lnT w="6350" cap="flat" cmpd="sng" algn="ctr">
+                      <a:solidFill>
+                        <a:srgbClr val="D5DDD6"/>
+                      </a:solidFill>
+                      <a:prstDash val="solid"/>
+                      <a:round/>
+                      <a:headEnd type="none" w="med" len="med"/>
+                      <a:tailEnd type="none" w="med" len="med"/>
+                    </a:lnT>
+                    <a:lnB w="6350" cap="flat" cmpd="sng" algn="ctr">
+                      <a:solidFill>
+                        <a:srgbClr val="D5DDD6"/>
+                      </a:solidFill>
+                      <a:prstDash val="solid"/>
+                      <a:round/>
+                      <a:headEnd type="none" w="med" len="med"/>
+                      <a:tailEnd type="none" w="med" len="med"/>
+                    </a:lnB>
+                    <a:solidFill>
+                      <a:srgbClr val="FFFFFF"/>
+                    </a:solidFill>
+                  </a:tcPr>
+                </a:tc>
+                <a:tc>
+                  <a:txBody>
+                    <a:bodyPr/>
+                    <a:lstStyle/>
+                    <a:p>
+                      <a:pPr indent="0" marL="0">
+                        <a:buNone/>
+                      </a:pPr>
+                      <a:r>
+                        <a:rPr lang="en-US" sz="1200" dirty="0">
+                          <a:solidFill>
+                            <a:srgbClr val="1C1C1C"/>
+                          </a:solidFill>
+                        </a:rPr>
+                        <a:t>Connectivity &gt; I2C1 &gt; Parameter Settings</a:t>
+                      </a:r>
+                      <a:endParaRPr lang="en-US" sz="1200" dirty="0"/>
+                    </a:p>
+                  </a:txBody>
+                  <a:tcPr marL="91440" marR="91440" marT="45720" marB="45720" anchor="ctr">
+                    <a:lnL w="6350" cap="flat" cmpd="sng" algn="ctr">
+                      <a:solidFill>
+                        <a:srgbClr val="D5DDD6"/>
+                      </a:solidFill>
+                      <a:prstDash val="solid"/>
+                      <a:round/>
+                      <a:headEnd type="none" w="med" len="med"/>
+                      <a:tailEnd type="none" w="med" len="med"/>
+                    </a:lnL>
+                    <a:lnR w="6350" cap="flat" cmpd="sng" algn="ctr">
+                      <a:solidFill>
+                        <a:srgbClr val="D5DDD6"/>
+                      </a:solidFill>
+                      <a:prstDash val="solid"/>
+                      <a:round/>
+                      <a:headEnd type="none" w="med" len="med"/>
+                      <a:tailEnd type="none" w="med" len="med"/>
+                    </a:lnR>
+                    <a:lnT w="6350" cap="flat" cmpd="sng" algn="ctr">
+                      <a:solidFill>
+                        <a:srgbClr val="D5DDD6"/>
+                      </a:solidFill>
+                      <a:prstDash val="solid"/>
+                      <a:round/>
+                      <a:headEnd type="none" w="med" len="med"/>
+                      <a:tailEnd type="none" w="med" len="med"/>
+                    </a:lnT>
+                    <a:lnB w="6350" cap="flat" cmpd="sng" algn="ctr">
+                      <a:solidFill>
+                        <a:srgbClr val="D5DDD6"/>
+                      </a:solidFill>
+                      <a:prstDash val="solid"/>
+                      <a:round/>
+                      <a:headEnd type="none" w="med" len="med"/>
+                      <a:tailEnd type="none" w="med" len="med"/>
+                    </a:lnB>
+                    <a:solidFill>
+                      <a:srgbClr val="FFFFFF"/>
+                    </a:solidFill>
+                  </a:tcPr>
+                </a:tc>
+                <a:tc>
+                  <a:txBody>
+                    <a:bodyPr/>
+                    <a:lstStyle/>
+                    <a:p>
+                      <a:pPr indent="0" marL="0">
+                        <a:buNone/>
+                      </a:pPr>
+                      <a:r>
+                        <a:rPr lang="en-US" sz="1200" dirty="0">
+                          <a:solidFill>
+                            <a:srgbClr val="1C1C1C"/>
+                          </a:solidFill>
+                        </a:rPr>
+                        <a:t>Standard mode, 100 kHz</a:t>
+                      </a:r>
+                      <a:endParaRPr lang="en-US" sz="1200" dirty="0"/>
+                    </a:p>
+                  </a:txBody>
+                  <a:tcPr marL="91440" marR="91440" marT="45720" marB="45720" anchor="ctr">
+                    <a:lnL w="6350" cap="flat" cmpd="sng" algn="ctr">
+                      <a:solidFill>
+                        <a:srgbClr val="D5DDD6"/>
+                      </a:solidFill>
+                      <a:prstDash val="solid"/>
+                      <a:round/>
+                      <a:headEnd type="none" w="med" len="med"/>
+                      <a:tailEnd type="none" w="med" len="med"/>
+                    </a:lnL>
+                    <a:lnR w="6350" cap="flat" cmpd="sng" algn="ctr">
+                      <a:solidFill>
+                        <a:srgbClr val="D5DDD6"/>
+                      </a:solidFill>
+                      <a:prstDash val="solid"/>
+                      <a:round/>
+                      <a:headEnd type="none" w="med" len="med"/>
+                      <a:tailEnd type="none" w="med" len="med"/>
+                    </a:lnR>
+                    <a:lnT w="6350" cap="flat" cmpd="sng" algn="ctr">
+                      <a:solidFill>
+                        <a:srgbClr val="D5DDD6"/>
+                      </a:solidFill>
+                      <a:prstDash val="solid"/>
+                      <a:round/>
+                      <a:headEnd type="none" w="med" len="med"/>
+                      <a:tailEnd type="none" w="med" len="med"/>
+                    </a:lnT>
+                    <a:lnB w="6350" cap="flat" cmpd="sng" algn="ctr">
+                      <a:solidFill>
+                        <a:srgbClr val="D5DDD6"/>
+                      </a:solidFill>
+                      <a:prstDash val="solid"/>
+                      <a:round/>
+                      <a:headEnd type="none" w="med" len="med"/>
+                      <a:tailEnd type="none" w="med" len="med"/>
+                    </a:lnB>
+                    <a:solidFill>
+                      <a:srgbClr val="FFFFFF"/>
+                    </a:solidFill>
+                  </a:tcPr>
+                </a:tc>
+              </a:tr>
+              <a:tr h="457200">
+                <a:tc>
+                  <a:txBody>
+                    <a:bodyPr/>
+                    <a:lstStyle/>
+                    <a:p>
+                      <a:pPr indent="0" marL="0">
+                        <a:buNone/>
+                      </a:pPr>
+                      <a:r>
+                        <a:rPr lang="en-US" sz="1200" b="1" dirty="0">
+                          <a:solidFill>
+                            <a:srgbClr val="123524"/>
+                          </a:solidFill>
+                        </a:rPr>
+                        <a:t>LPUART1</a:t>
+                      </a:r>
+                      <a:endParaRPr lang="en-US" sz="1200" dirty="0"/>
+                    </a:p>
+                  </a:txBody>
+                  <a:tcPr marL="91440" marR="91440" marT="45720" marB="45720" anchor="ctr">
+                    <a:lnL w="6350" cap="flat" cmpd="sng" algn="ctr">
+                      <a:solidFill>
+                        <a:srgbClr val="D5DDD6"/>
+                      </a:solidFill>
+                      <a:prstDash val="solid"/>
+                      <a:round/>
+                      <a:headEnd type="none" w="med" len="med"/>
+                      <a:tailEnd type="none" w="med" len="med"/>
+                    </a:lnL>
+                    <a:lnR w="6350" cap="flat" cmpd="sng" algn="ctr">
+                      <a:solidFill>
+                        <a:srgbClr val="D5DDD6"/>
+                      </a:solidFill>
+                      <a:prstDash val="solid"/>
+                      <a:round/>
+                      <a:headEnd type="none" w="med" len="med"/>
+                      <a:tailEnd type="none" w="med" len="med"/>
+                    </a:lnR>
+                    <a:lnT w="6350" cap="flat" cmpd="sng" algn="ctr">
+                      <a:solidFill>
+                        <a:srgbClr val="D5DDD6"/>
+                      </a:solidFill>
+                      <a:prstDash val="solid"/>
+                      <a:round/>
+                      <a:headEnd type="none" w="med" len="med"/>
+                      <a:tailEnd type="none" w="med" len="med"/>
+                    </a:lnT>
+                    <a:lnB w="6350" cap="flat" cmpd="sng" algn="ctr">
+                      <a:solidFill>
+                        <a:srgbClr val="D5DDD6"/>
+                      </a:solidFill>
+                      <a:prstDash val="solid"/>
+                      <a:round/>
+                      <a:headEnd type="none" w="med" len="med"/>
+                      <a:tailEnd type="none" w="med" len="med"/>
+                    </a:lnB>
+                    <a:solidFill>
+                      <a:srgbClr val="FFFFFF"/>
+                    </a:solidFill>
+                  </a:tcPr>
+                </a:tc>
+                <a:tc>
+                  <a:txBody>
+                    <a:bodyPr/>
+                    <a:lstStyle/>
+                    <a:p>
+                      <a:pPr indent="0" marL="0">
+                        <a:buNone/>
+                      </a:pPr>
+                      <a:r>
+                        <a:rPr lang="en-US" sz="1200" dirty="0">
+                          <a:solidFill>
+                            <a:srgbClr val="1C1C1C"/>
+                          </a:solidFill>
+                        </a:rPr>
+                        <a:t>Connectivity &gt; LPUART1</a:t>
+                      </a:r>
+                      <a:endParaRPr lang="en-US" sz="1200" dirty="0"/>
+                    </a:p>
+                  </a:txBody>
+                  <a:tcPr marL="91440" marR="91440" marT="45720" marB="45720" anchor="ctr">
+                    <a:lnL w="6350" cap="flat" cmpd="sng" algn="ctr">
+                      <a:solidFill>
+                        <a:srgbClr val="D5DDD6"/>
+                      </a:solidFill>
+                      <a:prstDash val="solid"/>
+                      <a:round/>
+                      <a:headEnd type="none" w="med" len="med"/>
+                      <a:tailEnd type="none" w="med" len="med"/>
+                    </a:lnL>
+                    <a:lnR w="6350" cap="flat" cmpd="sng" algn="ctr">
+                      <a:solidFill>
+                        <a:srgbClr val="D5DDD6"/>
+                      </a:solidFill>
+                      <a:prstDash val="solid"/>
+                      <a:round/>
+                      <a:headEnd type="none" w="med" len="med"/>
+                      <a:tailEnd type="none" w="med" len="med"/>
+                    </a:lnR>
+                    <a:lnT w="6350" cap="flat" cmpd="sng" algn="ctr">
+                      <a:solidFill>
+                        <a:srgbClr val="D5DDD6"/>
+                      </a:solidFill>
+                      <a:prstDash val="solid"/>
+                      <a:round/>
+                      <a:headEnd type="none" w="med" len="med"/>
+                      <a:tailEnd type="none" w="med" len="med"/>
+                    </a:lnT>
+                    <a:lnB w="6350" cap="flat" cmpd="sng" algn="ctr">
+                      <a:solidFill>
+                        <a:srgbClr val="D5DDD6"/>
+                      </a:solidFill>
+                      <a:prstDash val="solid"/>
+                      <a:round/>
+                      <a:headEnd type="none" w="med" len="med"/>
+                      <a:tailEnd type="none" w="med" len="med"/>
+                    </a:lnB>
+                    <a:solidFill>
+                      <a:srgbClr val="FFFFFF"/>
+                    </a:solidFill>
+                  </a:tcPr>
+                </a:tc>
+                <a:tc>
+                  <a:txBody>
+                    <a:bodyPr/>
+                    <a:lstStyle/>
+                    <a:p>
+                      <a:pPr indent="0" marL="0">
+                        <a:buNone/>
+                      </a:pPr>
+                      <a:r>
+                        <a:rPr lang="en-US" sz="1200" dirty="0">
+                          <a:solidFill>
+                            <a:srgbClr val="1C1C1C"/>
+                          </a:solidFill>
+                        </a:rPr>
+                        <a:t>Asynchronous, 115200 baud, 8 bits, no parity, 1 stop bit</a:t>
+                      </a:r>
+                      <a:endParaRPr lang="en-US" sz="1200" dirty="0"/>
+                    </a:p>
+                  </a:txBody>
+                  <a:tcPr marL="91440" marR="91440" marT="45720" marB="45720" anchor="ctr">
+                    <a:lnL w="6350" cap="flat" cmpd="sng" algn="ctr">
+                      <a:solidFill>
+                        <a:srgbClr val="D5DDD6"/>
+                      </a:solidFill>
+                      <a:prstDash val="solid"/>
+                      <a:round/>
+                      <a:headEnd type="none" w="med" len="med"/>
+                      <a:tailEnd type="none" w="med" len="med"/>
+                    </a:lnL>
+                    <a:lnR w="6350" cap="flat" cmpd="sng" algn="ctr">
+                      <a:solidFill>
+                        <a:srgbClr val="D5DDD6"/>
+                      </a:solidFill>
+                      <a:prstDash val="solid"/>
+                      <a:round/>
+                      <a:headEnd type="none" w="med" len="med"/>
+                      <a:tailEnd type="none" w="med" len="med"/>
+                    </a:lnR>
+                    <a:lnT w="6350" cap="flat" cmpd="sng" algn="ctr">
+                      <a:solidFill>
+                        <a:srgbClr val="D5DDD6"/>
+                      </a:solidFill>
+                      <a:prstDash val="solid"/>
+                      <a:round/>
+                      <a:headEnd type="none" w="med" len="med"/>
+                      <a:tailEnd type="none" w="med" len="med"/>
+                    </a:lnT>
+                    <a:lnB w="6350" cap="flat" cmpd="sng" algn="ctr">
+                      <a:solidFill>
+                        <a:srgbClr val="D5DDD6"/>
+                      </a:solidFill>
+                      <a:prstDash val="solid"/>
+                      <a:round/>
+                      <a:headEnd type="none" w="med" len="med"/>
+                      <a:tailEnd type="none" w="med" len="med"/>
+                    </a:lnB>
+                    <a:solidFill>
+                      <a:srgbClr val="FFFFFF"/>
+                    </a:solidFill>
+                  </a:tcPr>
+                </a:tc>
+              </a:tr>
+              <a:tr h="457200">
+                <a:tc>
+                  <a:txBody>
+                    <a:bodyPr/>
+                    <a:lstStyle/>
+                    <a:p>
+                      <a:pPr indent="0" marL="0">
+                        <a:buNone/>
+                      </a:pPr>
+                      <a:r>
+                        <a:rPr lang="en-US" sz="1200" b="1" dirty="0">
+                          <a:solidFill>
+                            <a:srgbClr val="123524"/>
+                          </a:solidFill>
+                        </a:rPr>
+                        <a:t>Clock</a:t>
+                      </a:r>
+                      <a:endParaRPr lang="en-US" sz="1200" dirty="0"/>
+                    </a:p>
+                  </a:txBody>
+                  <a:tcPr marL="91440" marR="91440" marT="45720" marB="45720" anchor="ctr">
+                    <a:lnL w="6350" cap="flat" cmpd="sng" algn="ctr">
+                      <a:solidFill>
+                        <a:srgbClr val="D5DDD6"/>
+                      </a:solidFill>
+                      <a:prstDash val="solid"/>
+                      <a:round/>
+                      <a:headEnd type="none" w="med" len="med"/>
+                      <a:tailEnd type="none" w="med" len="med"/>
+                    </a:lnL>
+                    <a:lnR w="6350" cap="flat" cmpd="sng" algn="ctr">
+                      <a:solidFill>
+                        <a:srgbClr val="D5DDD6"/>
+                      </a:solidFill>
+                      <a:prstDash val="solid"/>
+                      <a:round/>
+                      <a:headEnd type="none" w="med" len="med"/>
+                      <a:tailEnd type="none" w="med" len="med"/>
+                    </a:lnR>
+                    <a:lnT w="6350" cap="flat" cmpd="sng" algn="ctr">
+                      <a:solidFill>
+                        <a:srgbClr val="D5DDD6"/>
+                      </a:solidFill>
+                      <a:prstDash val="solid"/>
+                      <a:round/>
+                      <a:headEnd type="none" w="med" len="med"/>
+                      <a:tailEnd type="none" w="med" len="med"/>
+                    </a:lnT>
+                    <a:lnB w="6350" cap="flat" cmpd="sng" algn="ctr">
+                      <a:solidFill>
+                        <a:srgbClr val="D5DDD6"/>
+                      </a:solidFill>
+                      <a:prstDash val="solid"/>
+                      <a:round/>
+                      <a:headEnd type="none" w="med" len="med"/>
+                      <a:tailEnd type="none" w="med" len="med"/>
+                    </a:lnB>
+                    <a:solidFill>
+                      <a:srgbClr val="FFFFFF"/>
+                    </a:solidFill>
+                  </a:tcPr>
+                </a:tc>
+                <a:tc>
+                  <a:txBody>
+                    <a:bodyPr/>
+                    <a:lstStyle/>
+                    <a:p>
+                      <a:pPr indent="0" marL="0">
+                        <a:buNone/>
+                      </a:pPr>
+                      <a:r>
+                        <a:rPr lang="en-US" sz="1200" dirty="0">
+                          <a:solidFill>
+                            <a:srgbClr val="1C1C1C"/>
+                          </a:solidFill>
+                        </a:rPr>
+                        <a:t>Clock Configuration tab</a:t>
+                      </a:r>
+                      <a:endParaRPr lang="en-US" sz="1200" dirty="0"/>
+                    </a:p>
+                  </a:txBody>
+                  <a:tcPr marL="91440" marR="91440" marT="45720" marB="45720" anchor="ctr">
+                    <a:lnL w="6350" cap="flat" cmpd="sng" algn="ctr">
+                      <a:solidFill>
+                        <a:srgbClr val="D5DDD6"/>
+                      </a:solidFill>
+                      <a:prstDash val="solid"/>
+                      <a:round/>
+                      <a:headEnd type="none" w="med" len="med"/>
+                      <a:tailEnd type="none" w="med" len="med"/>
+                    </a:lnL>
+                    <a:lnR w="6350" cap="flat" cmpd="sng" algn="ctr">
+                      <a:solidFill>
+                        <a:srgbClr val="D5DDD6"/>
+                      </a:solidFill>
+                      <a:prstDash val="solid"/>
+                      <a:round/>
+                      <a:headEnd type="none" w="med" len="med"/>
+                      <a:tailEnd type="none" w="med" len="med"/>
+                    </a:lnR>
+                    <a:lnT w="6350" cap="flat" cmpd="sng" algn="ctr">
+                      <a:solidFill>
+                        <a:srgbClr val="D5DDD6"/>
+                      </a:solidFill>
+                      <a:prstDash val="solid"/>
+                      <a:round/>
+                      <a:headEnd type="none" w="med" len="med"/>
+                      <a:tailEnd type="none" w="med" len="med"/>
+                    </a:lnT>
+                    <a:lnB w="6350" cap="flat" cmpd="sng" algn="ctr">
+                      <a:solidFill>
+                        <a:srgbClr val="D5DDD6"/>
+                      </a:solidFill>
+                      <a:prstDash val="solid"/>
+                      <a:round/>
+                      <a:headEnd type="none" w="med" len="med"/>
+                      <a:tailEnd type="none" w="med" len="med"/>
+                    </a:lnB>
+                    <a:solidFill>
+                      <a:srgbClr val="FFFFFF"/>
+                    </a:solidFill>
+                  </a:tcPr>
+                </a:tc>
+                <a:tc>
+                  <a:txBody>
+                    <a:bodyPr/>
+                    <a:lstStyle/>
+                    <a:p>
+                      <a:pPr indent="0" marL="0">
+                        <a:buNone/>
+                      </a:pPr>
+                      <a:r>
+                        <a:rPr lang="en-US" sz="1200" dirty="0">
+                          <a:solidFill>
+                            <a:srgbClr val="1C1C1C"/>
+                          </a:solidFill>
+                        </a:rPr>
+                        <a:t>HCLK = 170 MHz (PLL from HSI)</a:t>
+                      </a:r>
+                      <a:endParaRPr lang="en-US" sz="1200" dirty="0"/>
+                    </a:p>
+                  </a:txBody>
+                  <a:tcPr marL="91440" marR="91440" marT="45720" marB="45720" anchor="ctr">
+                    <a:lnL w="6350" cap="flat" cmpd="sng" algn="ctr">
+                      <a:solidFill>
+                        <a:srgbClr val="D5DDD6"/>
+                      </a:solidFill>
+                      <a:prstDash val="solid"/>
+                      <a:round/>
+                      <a:headEnd type="none" w="med" len="med"/>
+                      <a:tailEnd type="none" w="med" len="med"/>
+                    </a:lnL>
+                    <a:lnR w="6350" cap="flat" cmpd="sng" algn="ctr">
+                      <a:solidFill>
+                        <a:srgbClr val="D5DDD6"/>
+                      </a:solidFill>
+                      <a:prstDash val="solid"/>
+                      <a:round/>
+                      <a:headEnd type="none" w="med" len="med"/>
+                      <a:tailEnd type="none" w="med" len="med"/>
+                    </a:lnR>
+                    <a:lnT w="6350" cap="flat" cmpd="sng" algn="ctr">
+                      <a:solidFill>
+                        <a:srgbClr val="D5DDD6"/>
+                      </a:solidFill>
+                      <a:prstDash val="solid"/>
+                      <a:round/>
+                      <a:headEnd type="none" w="med" len="med"/>
+                      <a:tailEnd type="none" w="med" len="med"/>
+                    </a:lnT>
+                    <a:lnB w="6350" cap="flat" cmpd="sng" algn="ctr">
+                      <a:solidFill>
+                        <a:srgbClr val="D5DDD6"/>
+                      </a:solidFill>
+                      <a:prstDash val="solid"/>
+                      <a:round/>
+                      <a:headEnd type="none" w="med" len="med"/>
+                      <a:tailEnd type="none" w="med" len="med"/>
+                    </a:lnB>
+                    <a:solidFill>
+                      <a:srgbClr val="FFFFFF"/>
+                    </a:solidFill>
+                  </a:tcPr>
+                </a:tc>
+              </a:tr>
+              <a:tr h="457200">
+                <a:tc>
+                  <a:txBody>
+                    <a:bodyPr/>
+                    <a:lstStyle/>
+                    <a:p>
+                      <a:pPr indent="0" marL="0">
+                        <a:buNone/>
+                      </a:pPr>
+                      <a:r>
+                        <a:rPr lang="en-US" sz="1200" b="1" dirty="0">
+                          <a:solidFill>
+                            <a:srgbClr val="123524"/>
+                          </a:solidFill>
+                        </a:rPr>
+                        <a:t>B1 interrupt</a:t>
+                      </a:r>
+                      <a:endParaRPr lang="en-US" sz="1200" dirty="0"/>
+                    </a:p>
+                  </a:txBody>
+                  <a:tcPr marL="91440" marR="91440" marT="45720" marB="45720" anchor="ctr">
+                    <a:lnL w="6350" cap="flat" cmpd="sng" algn="ctr">
+                      <a:solidFill>
+                        <a:srgbClr val="D5DDD6"/>
+                      </a:solidFill>
+                      <a:prstDash val="solid"/>
+                      <a:round/>
+                      <a:headEnd type="none" w="med" len="med"/>
+                      <a:tailEnd type="none" w="med" len="med"/>
+                    </a:lnL>
+                    <a:lnR w="6350" cap="flat" cmpd="sng" algn="ctr">
+                      <a:solidFill>
+                        <a:srgbClr val="D5DDD6"/>
+                      </a:solidFill>
+                      <a:prstDash val="solid"/>
+                      <a:round/>
+                      <a:headEnd type="none" w="med" len="med"/>
+                      <a:tailEnd type="none" w="med" len="med"/>
+                    </a:lnR>
+                    <a:lnT w="6350" cap="flat" cmpd="sng" algn="ctr">
+                      <a:solidFill>
+                        <a:srgbClr val="D5DDD6"/>
+                      </a:solidFill>
+                      <a:prstDash val="solid"/>
+                      <a:round/>
+                      <a:headEnd type="none" w="med" len="med"/>
+                      <a:tailEnd type="none" w="med" len="med"/>
+                    </a:lnT>
+                    <a:lnB w="6350" cap="flat" cmpd="sng" algn="ctr">
+                      <a:solidFill>
+                        <a:srgbClr val="D5DDD6"/>
+                      </a:solidFill>
+                      <a:prstDash val="solid"/>
+                      <a:round/>
+                      <a:headEnd type="none" w="med" len="med"/>
+                      <a:tailEnd type="none" w="med" len="med"/>
+                    </a:lnB>
+                    <a:solidFill>
+                      <a:srgbClr val="FFFFFF"/>
+                    </a:solidFill>
+                  </a:tcPr>
+                </a:tc>
+                <a:tc>
+                  <a:txBody>
+                    <a:bodyPr/>
+                    <a:lstStyle/>
+                    <a:p>
+                      <a:pPr indent="0" marL="0">
+                        <a:buNone/>
+                      </a:pPr>
+                      <a:r>
+                        <a:rPr lang="en-US" sz="1200" dirty="0">
+                          <a:solidFill>
+                            <a:srgbClr val="1C1C1C"/>
+                          </a:solidFill>
+                        </a:rPr>
+                        <a:t>System Core &gt; NVIC</a:t>
+                      </a:r>
+                      <a:endParaRPr lang="en-US" sz="1200" dirty="0"/>
+                    </a:p>
+                  </a:txBody>
+                  <a:tcPr marL="91440" marR="91440" marT="45720" marB="45720" anchor="ctr">
+                    <a:lnL w="6350" cap="flat" cmpd="sng" algn="ctr">
+                      <a:solidFill>
+                        <a:srgbClr val="D5DDD6"/>
+                      </a:solidFill>
+                      <a:prstDash val="solid"/>
+                      <a:round/>
+                      <a:headEnd type="none" w="med" len="med"/>
+                      <a:tailEnd type="none" w="med" len="med"/>
+                    </a:lnL>
+                    <a:lnR w="6350" cap="flat" cmpd="sng" algn="ctr">
+                      <a:solidFill>
+                        <a:srgbClr val="D5DDD6"/>
+                      </a:solidFill>
+                      <a:prstDash val="solid"/>
+                      <a:round/>
+                      <a:headEnd type="none" w="med" len="med"/>
+                      <a:tailEnd type="none" w="med" len="med"/>
+                    </a:lnR>
+                    <a:lnT w="6350" cap="flat" cmpd="sng" algn="ctr">
+                      <a:solidFill>
+                        <a:srgbClr val="D5DDD6"/>
+                      </a:solidFill>
+                      <a:prstDash val="solid"/>
+                      <a:round/>
+                      <a:headEnd type="none" w="med" len="med"/>
+                      <a:tailEnd type="none" w="med" len="med"/>
+                    </a:lnT>
+                    <a:lnB w="6350" cap="flat" cmpd="sng" algn="ctr">
+                      <a:solidFill>
+                        <a:srgbClr val="D5DDD6"/>
+                      </a:solidFill>
+                      <a:prstDash val="solid"/>
+                      <a:round/>
+                      <a:headEnd type="none" w="med" len="med"/>
+                      <a:tailEnd type="none" w="med" len="med"/>
+                    </a:lnB>
+                    <a:solidFill>
+                      <a:srgbClr val="FFFFFF"/>
+                    </a:solidFill>
+                  </a:tcPr>
+                </a:tc>
+                <a:tc>
+                  <a:txBody>
+                    <a:bodyPr/>
+                    <a:lstStyle/>
+                    <a:p>
+                      <a:pPr indent="0" marL="0">
+                        <a:buNone/>
+                      </a:pPr>
+                      <a:r>
+                        <a:rPr lang="en-US" sz="1200" dirty="0">
+                          <a:solidFill>
+                            <a:srgbClr val="1C1C1C"/>
+                          </a:solidFill>
+                        </a:rPr>
+                        <a:t>EXTI line[15:10] interrupts: Enabled</a:t>
+                      </a:r>
+                      <a:endParaRPr lang="en-US" sz="1200" dirty="0"/>
+                    </a:p>
+                  </a:txBody>
+                  <a:tcPr marL="91440" marR="91440" marT="45720" marB="45720" anchor="ctr">
+                    <a:lnL w="6350" cap="flat" cmpd="sng" algn="ctr">
+                      <a:solidFill>
+                        <a:srgbClr val="D5DDD6"/>
+                      </a:solidFill>
+                      <a:prstDash val="solid"/>
+                      <a:round/>
+                      <a:headEnd type="none" w="med" len="med"/>
+                      <a:tailEnd type="none" w="med" len="med"/>
+                    </a:lnL>
+                    <a:lnR w="6350" cap="flat" cmpd="sng" algn="ctr">
+                      <a:solidFill>
+                        <a:srgbClr val="D5DDD6"/>
+                      </a:solidFill>
+                      <a:prstDash val="solid"/>
+                      <a:round/>
+                      <a:headEnd type="none" w="med" len="med"/>
+                      <a:tailEnd type="none" w="med" len="med"/>
+                    </a:lnR>
+                    <a:lnT w="6350" cap="flat" cmpd="sng" algn="ctr">
+                      <a:solidFill>
+                        <a:srgbClr val="D5DDD6"/>
+                      </a:solidFill>
+                      <a:prstDash val="solid"/>
+                      <a:round/>
+                      <a:headEnd type="none" w="med" len="med"/>
+                      <a:tailEnd type="none" w="med" len="med"/>
+                    </a:lnT>
+                    <a:lnB w="6350" cap="flat" cmpd="sng" algn="ctr">
+                      <a:solidFill>
+                        <a:srgbClr val="D5DDD6"/>
+                      </a:solidFill>
+                      <a:prstDash val="solid"/>
+                      <a:round/>
+                      <a:headEnd type="none" w="med" len="med"/>
+                      <a:tailEnd type="none" w="med" len="med"/>
+                    </a:lnB>
+                    <a:solidFill>
+                      <a:srgbClr val="FFFFFF"/>
+                    </a:solidFill>
+                  </a:tcPr>
+                </a:tc>
+              </a:tr>
+              <a:tr h="457200">
+                <a:tc>
+                  <a:txBody>
+                    <a:bodyPr/>
+                    <a:lstStyle/>
+                    <a:p>
+                      <a:pPr indent="0" marL="0">
+                        <a:buNone/>
+                      </a:pPr>
+                      <a:r>
+                        <a:rPr lang="en-US" sz="1200" b="1" dirty="0">
+                          <a:solidFill>
+                            <a:srgbClr val="123524"/>
+                          </a:solidFill>
+                        </a:rPr>
+                        <a:t>Project</a:t>
+                      </a:r>
+                      <a:endParaRPr lang="en-US" sz="1200" dirty="0"/>
+                    </a:p>
+                  </a:txBody>
+                  <a:tcPr marL="91440" marR="91440" marT="45720" marB="45720" anchor="ctr">
+                    <a:lnL w="6350" cap="flat" cmpd="sng" algn="ctr">
+                      <a:solidFill>
+                        <a:srgbClr val="D5DDD6"/>
+                      </a:solidFill>
+                      <a:prstDash val="solid"/>
+                      <a:round/>
+                      <a:headEnd type="none" w="med" len="med"/>
+                      <a:tailEnd type="none" w="med" len="med"/>
+                    </a:lnL>
+                    <a:lnR w="6350" cap="flat" cmpd="sng" algn="ctr">
+                      <a:solidFill>
+                        <a:srgbClr val="D5DDD6"/>
+                      </a:solidFill>
+                      <a:prstDash val="solid"/>
+                      <a:round/>
+                      <a:headEnd type="none" w="med" len="med"/>
+                      <a:tailEnd type="none" w="med" len="med"/>
+                    </a:lnR>
+                    <a:lnT w="6350" cap="flat" cmpd="sng" algn="ctr">
+                      <a:solidFill>
+                        <a:srgbClr val="D5DDD6"/>
+                      </a:solidFill>
+                      <a:prstDash val="solid"/>
+                      <a:round/>
+                      <a:headEnd type="none" w="med" len="med"/>
+                      <a:tailEnd type="none" w="med" len="med"/>
+                    </a:lnT>
+                    <a:lnB w="6350" cap="flat" cmpd="sng" algn="ctr">
+                      <a:solidFill>
+                        <a:srgbClr val="D5DDD6"/>
+                      </a:solidFill>
+                      <a:prstDash val="solid"/>
+                      <a:round/>
+                      <a:headEnd type="none" w="med" len="med"/>
+                      <a:tailEnd type="none" w="med" len="med"/>
+                    </a:lnB>
+                    <a:solidFill>
+                      <a:srgbClr val="FFFFFF"/>
+                    </a:solidFill>
+                  </a:tcPr>
+                </a:tc>
+                <a:tc>
+                  <a:txBody>
+                    <a:bodyPr/>
+                    <a:lstStyle/>
+                    <a:p>
+                      <a:pPr indent="0" marL="0">
+                        <a:buNone/>
+                      </a:pPr>
+                      <a:r>
+                        <a:rPr lang="en-US" sz="1200" dirty="0">
+                          <a:solidFill>
+                            <a:srgbClr val="1C1C1C"/>
+                          </a:solidFill>
+                        </a:rPr>
+                        <a:t>Project Manager tab</a:t>
+                      </a:r>
+                      <a:endParaRPr lang="en-US" sz="1200" dirty="0"/>
+                    </a:p>
+                  </a:txBody>
+                  <a:tcPr marL="91440" marR="91440" marT="45720" marB="45720" anchor="ctr">
+                    <a:lnL w="6350" cap="flat" cmpd="sng" algn="ctr">
+                      <a:solidFill>
+                        <a:srgbClr val="D5DDD6"/>
+                      </a:solidFill>
+                      <a:prstDash val="solid"/>
+                      <a:round/>
+                      <a:headEnd type="none" w="med" len="med"/>
+                      <a:tailEnd type="none" w="med" len="med"/>
+                    </a:lnL>
+                    <a:lnR w="6350" cap="flat" cmpd="sng" algn="ctr">
+                      <a:solidFill>
+                        <a:srgbClr val="D5DDD6"/>
+                      </a:solidFill>
+                      <a:prstDash val="solid"/>
+                      <a:round/>
+                      <a:headEnd type="none" w="med" len="med"/>
+                      <a:tailEnd type="none" w="med" len="med"/>
+                    </a:lnR>
+                    <a:lnT w="6350" cap="flat" cmpd="sng" algn="ctr">
+                      <a:solidFill>
+                        <a:srgbClr val="D5DDD6"/>
+                      </a:solidFill>
+                      <a:prstDash val="solid"/>
+                      <a:round/>
+                      <a:headEnd type="none" w="med" len="med"/>
+                      <a:tailEnd type="none" w="med" len="med"/>
+                    </a:lnT>
+                    <a:lnB w="6350" cap="flat" cmpd="sng" algn="ctr">
+                      <a:solidFill>
+                        <a:srgbClr val="D5DDD6"/>
+                      </a:solidFill>
+                      <a:prstDash val="solid"/>
+                      <a:round/>
+                      <a:headEnd type="none" w="med" len="med"/>
+                      <a:tailEnd type="none" w="med" len="med"/>
+                    </a:lnB>
+                    <a:solidFill>
+                      <a:srgbClr val="FFFFFF"/>
+                    </a:solidFill>
+                  </a:tcPr>
+                </a:tc>
+                <a:tc>
+                  <a:txBody>
+                    <a:bodyPr/>
+                    <a:lstStyle/>
+                    <a:p>
+                      <a:pPr indent="0" marL="0">
+                        <a:buNone/>
+                      </a:pPr>
+                      <a:r>
+                        <a:rPr lang="en-US" sz="1200" dirty="0">
+                          <a:solidFill>
+                            <a:srgbClr val="1C1C1C"/>
+                          </a:solidFill>
+                        </a:rPr>
+                        <a:t>Name ass1, Toolchain / IDE: STM32CubeIDE. Then GENERATE CODE</a:t>
+                      </a:r>
+                      <a:endParaRPr lang="en-US" sz="1200" dirty="0"/>
+                    </a:p>
+                  </a:txBody>
+                  <a:tcPr marL="91440" marR="91440" marT="45720" marB="45720" anchor="ctr">
+                    <a:lnL w="6350" cap="flat" cmpd="sng" algn="ctr">
+                      <a:solidFill>
+                        <a:srgbClr val="D5DDD6"/>
+                      </a:solidFill>
+                      <a:prstDash val="solid"/>
+                      <a:round/>
+                      <a:headEnd type="none" w="med" len="med"/>
+                      <a:tailEnd type="none" w="med" len="med"/>
+                    </a:lnL>
+                    <a:lnR w="6350" cap="flat" cmpd="sng" algn="ctr">
+                      <a:solidFill>
+                        <a:srgbClr val="D5DDD6"/>
+                      </a:solidFill>
+                      <a:prstDash val="solid"/>
+                      <a:round/>
+                      <a:headEnd type="none" w="med" len="med"/>
+                      <a:tailEnd type="none" w="med" len="med"/>
+                    </a:lnR>
+                    <a:lnT w="6350" cap="flat" cmpd="sng" algn="ctr">
+                      <a:solidFill>
+                        <a:srgbClr val="D5DDD6"/>
+                      </a:solidFill>
+                      <a:prstDash val="solid"/>
+                      <a:round/>
+                      <a:headEnd type="none" w="med" len="med"/>
+                      <a:tailEnd type="none" w="med" len="med"/>
+                    </a:lnT>
+                    <a:lnB w="6350" cap="flat" cmpd="sng" algn="ctr">
+                      <a:solidFill>
+                        <a:srgbClr val="D5DDD6"/>
+                      </a:solidFill>
+                      <a:prstDash val="solid"/>
+                      <a:round/>
+                      <a:headEnd type="none" w="med" len="med"/>
+                      <a:tailEnd type="none" w="med" len="med"/>
+                    </a:lnB>
+                    <a:solidFill>
+                      <a:srgbClr val="FFFFFF"/>
+                    </a:solidFill>
+                  </a:tcPr>
+                </a:tc>
+              </a:tr>
+            </a:tbl>
+          </a:graphicData>
+        </a:graphic>
+      </p:graphicFrame>
+      <p:sp>
+        <p:nvSpPr>
+          <p:cNvPr id="4" name="ioc periph note"/>
+          <p:cNvSpPr txBox="1"/>
+          <p:nvPr/>
+        </p:nvSpPr>
+        <p:spPr>
+          <a:xfrm>
+            <a:off x="457200" y="3931920"/>
+            <a:ext cx="8229600" cy="457200"/>
+          </a:xfrm>
+          <a:prstGeom prst="rect">
+            <a:avLst/>
+          </a:prstGeom>
+          <a:noFill/>
+          <a:ln/>
+        </p:spPr>
+        <p:txBody>
+          <a:bodyPr wrap="square" rtlCol="0" anchor="ctr"/>
+          <a:lstStyle/>
+          <a:p>
+            <a:pPr indent="0" marL="0">
+              <a:buNone/>
+            </a:pPr>
+            <a:r>
+              <a:rPr lang="en-US" sz="1300" i="1" dirty="0">
+                <a:solidFill>
+                  <a:srgbClr val="5C5C5C"/>
+                </a:solidFill>
+              </a:rPr>
+              <a:t>Check: main.c calls </a:t>
+            </a:r>
+            <a:r>
+              <a:rPr lang="en-US" sz="1300" i="1" dirty="0">
+                <a:solidFill>
+                  <a:srgbClr val="5C5C5C"/>
+                </a:solidFill>
+                <a:latin typeface="Courier New"/>
+                <a:cs typeface="Courier New"/>
+              </a:rPr>
+              <a:t>MX_GPIO_Init()</a:t>
+            </a:r>
+            <a:r>
+              <a:rPr lang="en-US" sz="1300" i="1" dirty="0">
+                <a:solidFill>
+                  <a:srgbClr val="5C5C5C"/>
+                </a:solidFill>
+              </a:rPr>
+              <a:t>, </a:t>
+            </a:r>
+            <a:r>
+              <a:rPr lang="en-US" sz="1300" i="1" dirty="0">
+                <a:solidFill>
+                  <a:srgbClr val="5C5C5C"/>
+                </a:solidFill>
+                <a:latin typeface="Courier New"/>
+                <a:cs typeface="Courier New"/>
+              </a:rPr>
+              <a:t>MX_LPUART1_UART_Init()</a:t>
+            </a:r>
+            <a:r>
+              <a:rPr lang="en-US" sz="1300" i="1" dirty="0">
+                <a:solidFill>
+                  <a:srgbClr val="5C5C5C"/>
+                </a:solidFill>
+              </a:rPr>
+              <a:t> and </a:t>
+            </a:r>
+            <a:r>
+              <a:rPr lang="en-US" sz="1300" i="1" dirty="0">
+                <a:solidFill>
+                  <a:srgbClr val="5C5C5C"/>
+                </a:solidFill>
+                <a:latin typeface="Courier New"/>
+                <a:cs typeface="Courier New"/>
+              </a:rPr>
+              <a:t>MX_I2C1_Init()</a:t>
+            </a:r>
+            <a:r>
+              <a:rPr lang="en-US" sz="1300" i="1" dirty="0">
+                <a:solidFill>
+                  <a:srgbClr val="5C5C5C"/>
+                </a:solidFill>
+              </a:rPr>
+              <a:t>, the same as the provided ass1.ioc.</a:t>
+            </a:r>
+            <a:endParaRPr lang="en-US" sz="1300" dirty="0"/>
+          </a:p>
+        </p:txBody>
+      </p:sp>
+      <p:sp>
+        <p:nvSpPr>
+          <p:cNvPr id="5" name="Slide Number Placeholder 0"/>
+          <p:cNvSpPr>
+            <a:spLocks noGrp="1"/>
+          </p:cNvSpPr>
+          <p:nvPr>
+            <p:ph type="sldNum" sz="quarter" idx="4294967295"/>
+          </p:nvPr>
+        </p:nvSpPr>
+        <p:spPr>
+          <a:xfrm>
+            <a:off x="8412480" y="4754880"/>
+            <a:ext cx="800000" cy="300000"/>
+          </a:xfrm>
+          <a:prstGeom prst="rect">
+            <a:avLst/>
+          </a:prstGeom>
+        </p:spPr>
+        <p:txBody>
+          <a:bodyPr/>
+          <a:lstStyle>
+            <a:lvl1pPr>
+              <a:defRPr sz="1000">
+                <a:solidFill>
+                  <a:schemeClr val="tx2"/>
+                </a:solidFill>
+              </a:defRPr>
+            </a:lvl1pPr>
+          </a:lstStyle>
+          <a:p>
+            <a:pPr algn="l"/>
+            <a:fld id="{F7021451-1387-4CA6-816F-3879F97B5CBC}" type="slidenum">
+              <a:rPr b="0" lang="en-US"/>
+              <a:t>21</a:t>
+            </a:fld>
+            <a:endParaRPr lang="en-US"/>
+          </a:p>
+        </p:txBody>
+      </p:sp>
+    </p:spTree>
+  </p:cSld>
+  <p:clrMapOvr>
+    <a:masterClrMapping/>
+  </p:clrMapOvr>
+</p:sld>
+</file>
+
 <file path=ppt/slides/slide3.xml><?xml version="1.0" encoding="utf-8"?>
 <p:sld xmlns:a="http://schemas.openxmlformats.org/drawingml/2006/main" xmlns:r="http://schemas.openxmlformats.org/officeDocument/2006/relationships" xmlns:p="http://schemas.openxmlformats.org/presentationml/2006/main">
   <p:cSld name="Slide 3">
@@ -9054,6 +12087,467 @@
             <a:fld id="{F7021451-1387-4CA6-816F-3879F97B5CBC}" type="slidenum">
               <a:rPr b="0" lang="en-US"/>
               <a:t>3</a:t>
+            </a:fld>
+            <a:endParaRPr lang="en-US"/>
+          </a:p>
+        </p:txBody>
+      </p:sp>
+    </p:spTree>
+  </p:cSld>
+  <p:clrMapOvr>
+    <a:masterClrMapping/>
+  </p:clrMapOvr>
+</p:sld>
+</file>
+
+<file path=ppt/slides/slide30.xml><?xml version="1.0" encoding="utf-8"?>
+<p:sld xmlns:a="http://schemas.openxmlformats.org/drawingml/2006/main" xmlns:r="http://schemas.openxmlformats.org/officeDocument/2006/relationships" xmlns:p="http://schemas.openxmlformats.org/presentationml/2006/main">
+  <p:cSld name="Slide 22">
+    <p:spTree>
+      <p:nvGrpSpPr>
+        <p:cNvPr id="1" name=""/>
+        <p:cNvGrpSpPr/>
+        <p:nvPr/>
+      </p:nvGrpSpPr>
+      <p:grpSpPr>
+        <a:xfrm>
+          <a:off x="0" y="0"/>
+          <a:ext cx="0" cy="0"/>
+          <a:chOff x="0" y="0"/>
+          <a:chExt cx="0" cy="0"/>
+        </a:xfrm>
+      </p:grpSpPr>
+      <p:sp>
+        <p:nvSpPr>
+          <p:cNvPr id="2" name="Text 0"/>
+          <p:cNvSpPr/>
+          <p:nvPr>
+            <p:ph idx="100" type="title" hasCustomPrompt="1"/>
+          </p:nvPr>
+        </p:nvSpPr>
+        <p:spPr>
+          <a:xfrm>
+            <a:off x="457200" y="274320"/>
+            <a:ext cx="8229600" cy="640080"/>
+          </a:xfrm>
+          <a:prstGeom prst="rect">
+            <a:avLst/>
+          </a:prstGeom>
+          <a:noFill/>
+          <a:ln/>
+        </p:spPr>
+        <p:txBody>
+          <a:bodyPr wrap="square" rtlCol="0" anchor="ctr"/>
+          <a:lstStyle/>
+          <a:p>
+            <a:pPr algn="l" indent="0" marL="0">
+              <a:buNone/>
+            </a:pPr>
+            <a:r>
+              <a:rPr lang="en-US" sz="2600" b="1" dirty="0">
+                <a:solidFill>
+                  <a:schemeClr val="tx2"/>
+                </a:solidFill>
+              </a:rPr>
+              <a:t>Assignment 2: start from ass1.ioc</a:t>
+            </a:r>
+            <a:endParaRPr lang="en-US" sz="2600" dirty="0"/>
+          </a:p>
+        </p:txBody>
+      </p:sp>
+      <p:sp>
+        <p:nvSpPr>
+          <p:cNvPr id="3" name="ass2 card 1"/>
+          <p:cNvSpPr/>
+          <p:nvPr/>
+        </p:nvSpPr>
+        <p:spPr>
+          <a:xfrm>
+            <a:off x="457200" y="1097280"/>
+            <a:ext cx="3977640" cy="2103120"/>
+          </a:xfrm>
+          <a:prstGeom prst="roundRect">
+            <a:avLst>
+              <a:gd name="adj" fmla="val 4545"/>
+            </a:avLst>
+          </a:prstGeom>
+          <a:solidFill>
+            <a:srgbClr val="EEF3EF"/>
+          </a:solidFill>
+          <a:ln w="12700">
+            <a:solidFill>
+              <a:srgbClr val="EEF3EF"/>
+            </a:solidFill>
+            <a:prstDash val="solid"/>
+          </a:ln>
+        </p:spPr>
+      </p:sp>
+      <p:sp>
+        <p:nvSpPr>
+          <p:cNvPr id="4" name="ass2 card 1 title"/>
+          <p:cNvSpPr txBox="1"/>
+          <p:nvPr/>
+        </p:nvSpPr>
+        <p:spPr>
+          <a:xfrm>
+            <a:off x="640080" y="1188720"/>
+            <a:ext cx="3611880" cy="411480"/>
+          </a:xfrm>
+          <a:prstGeom prst="rect">
+            <a:avLst/>
+          </a:prstGeom>
+          <a:noFill/>
+          <a:ln/>
+        </p:spPr>
+        <p:txBody>
+          <a:bodyPr wrap="square" lIns="0" tIns="0" rIns="0" bIns="0" rtlCol="0" anchor="ctr"/>
+          <a:lstStyle/>
+          <a:p>
+            <a:pPr indent="0" marL="0">
+              <a:buNone/>
+            </a:pPr>
+            <a:r>
+              <a:rPr lang="en-US" sz="1800" b="1" dirty="0">
+                <a:solidFill>
+                  <a:srgbClr val="1F6E43"/>
+                </a:solidFill>
+              </a:rPr>
+              <a:t>Duplicate</a:t>
+            </a:r>
+            <a:endParaRPr lang="en-US" sz="1800" dirty="0"/>
+          </a:p>
+        </p:txBody>
+      </p:sp>
+      <p:sp>
+        <p:nvSpPr>
+          <p:cNvPr id="5" name="ass2 card 1 steps"/>
+          <p:cNvSpPr txBox="1"/>
+          <p:nvPr/>
+        </p:nvSpPr>
+        <p:spPr>
+          <a:xfrm>
+            <a:off x="640080" y="1645920"/>
+            <a:ext cx="3611880" cy="1463040"/>
+          </a:xfrm>
+          <a:prstGeom prst="rect">
+            <a:avLst/>
+          </a:prstGeom>
+          <a:noFill/>
+          <a:ln/>
+        </p:spPr>
+        <p:txBody>
+          <a:bodyPr wrap="square" lIns="0" tIns="0" rIns="0" bIns="0" rtlCol="0" anchor="t"/>
+          <a:lstStyle/>
+          <a:p>
+            <a:pPr marL="342900" indent="-342900">
+              <a:spcAft>
+                <a:spcPts val="500"/>
+              </a:spcAft>
+              <a:buSzPct val="100000"/>
+              <a:buFont typeface="+mj-lt"/>
+              <a:buAutoNum type="arabicPeriod" startAt="1"/>
+            </a:pPr>
+            <a:r>
+              <a:rPr lang="en-US" sz="1300" dirty="0">
+                <a:solidFill>
+                  <a:srgbClr val="1C1C1C"/>
+                </a:solidFill>
+              </a:rPr>
+              <a:t>Open ass1.ioc in STM32CubeMX</a:t>
+            </a:r>
+            <a:endParaRPr lang="en-US" sz="1300" dirty="0"/>
+          </a:p>
+          <a:p>
+            <a:pPr marL="342900" indent="-342900">
+              <a:spcAft>
+                <a:spcPts val="500"/>
+              </a:spcAft>
+              <a:buSzPct val="100000"/>
+              <a:buFont typeface="+mj-lt"/>
+              <a:buAutoNum type="arabicPeriod" startAt="1"/>
+            </a:pPr>
+            <a:r>
+              <a:rPr lang="en-US" sz="1300" dirty="0">
+                <a:solidFill>
+                  <a:srgbClr val="1C1C1C"/>
+                </a:solidFill>
+              </a:rPr>
+              <a:t>File &gt; Save Project As</a:t>
+            </a:r>
+            <a:endParaRPr lang="en-US" sz="1300" dirty="0"/>
+          </a:p>
+          <a:p>
+            <a:pPr marL="342900" indent="-342900">
+              <a:spcAft>
+                <a:spcPts val="500"/>
+              </a:spcAft>
+              <a:buSzPct val="100000"/>
+              <a:buFont typeface="+mj-lt"/>
+              <a:buAutoNum type="arabicPeriod" startAt="1"/>
+            </a:pPr>
+            <a:r>
+              <a:rPr lang="en-US" sz="1300" dirty="0">
+                <a:solidFill>
+                  <a:srgbClr val="1C1C1C"/>
+                </a:solidFill>
+              </a:rPr>
+              <a:t>Choose a new folder named ass2: you get ass2.ioc</a:t>
+            </a:r>
+            <a:endParaRPr lang="en-US" sz="1300" dirty="0"/>
+          </a:p>
+          <a:p>
+            <a:pPr marL="342900" indent="-342900">
+              <a:spcAft>
+                <a:spcPts val="500"/>
+              </a:spcAft>
+              <a:buSzPct val="100000"/>
+              <a:buFont typeface="+mj-lt"/>
+              <a:buAutoNum type="arabicPeriod" startAt="1"/>
+            </a:pPr>
+            <a:r>
+              <a:rPr lang="en-US" sz="1300" dirty="0">
+                <a:solidFill>
+                  <a:srgbClr val="1C1C1C"/>
+                </a:solidFill>
+              </a:rPr>
+              <a:t>ass1.ioc stays unchanged</a:t>
+            </a:r>
+            <a:endParaRPr lang="en-US" sz="1300" dirty="0"/>
+          </a:p>
+        </p:txBody>
+      </p:sp>
+      <p:sp>
+        <p:nvSpPr>
+          <p:cNvPr id="6" name="ass2 card 2"/>
+          <p:cNvSpPr/>
+          <p:nvPr/>
+        </p:nvSpPr>
+        <p:spPr>
+          <a:xfrm>
+            <a:off x="4709160" y="1097280"/>
+            <a:ext cx="3977640" cy="2103120"/>
+          </a:xfrm>
+          <a:prstGeom prst="roundRect">
+            <a:avLst>
+              <a:gd name="adj" fmla="val 4545"/>
+            </a:avLst>
+          </a:prstGeom>
+          <a:solidFill>
+            <a:srgbClr val="EEF3EF"/>
+          </a:solidFill>
+          <a:ln w="12700">
+            <a:solidFill>
+              <a:srgbClr val="EEF3EF"/>
+            </a:solidFill>
+            <a:prstDash val="solid"/>
+          </a:ln>
+        </p:spPr>
+      </p:sp>
+      <p:sp>
+        <p:nvSpPr>
+          <p:cNvPr id="7" name="ass2 card 2 title"/>
+          <p:cNvSpPr txBox="1"/>
+          <p:nvPr/>
+        </p:nvSpPr>
+        <p:spPr>
+          <a:xfrm>
+            <a:off x="4892040" y="1188720"/>
+            <a:ext cx="3611880" cy="411480"/>
+          </a:xfrm>
+          <a:prstGeom prst="rect">
+            <a:avLst/>
+          </a:prstGeom>
+          <a:noFill/>
+          <a:ln/>
+        </p:spPr>
+        <p:txBody>
+          <a:bodyPr wrap="square" lIns="0" tIns="0" rIns="0" bIns="0" rtlCol="0" anchor="ctr"/>
+          <a:lstStyle/>
+          <a:p>
+            <a:pPr indent="0" marL="0">
+              <a:buNone/>
+            </a:pPr>
+            <a:r>
+              <a:rPr lang="en-US" sz="1800" b="1" dirty="0">
+                <a:solidFill>
+                  <a:srgbClr val="1F6E43"/>
+                </a:solidFill>
+              </a:rPr>
+              <a:t>Add only what is new</a:t>
+            </a:r>
+            <a:endParaRPr lang="en-US" sz="1800" dirty="0"/>
+          </a:p>
+        </p:txBody>
+      </p:sp>
+      <p:sp>
+        <p:nvSpPr>
+          <p:cNvPr id="8" name="ass2 card 2 steps"/>
+          <p:cNvSpPr txBox="1"/>
+          <p:nvPr/>
+        </p:nvSpPr>
+        <p:spPr>
+          <a:xfrm>
+            <a:off x="4892040" y="1645920"/>
+            <a:ext cx="3611880" cy="1463040"/>
+          </a:xfrm>
+          <a:prstGeom prst="rect">
+            <a:avLst/>
+          </a:prstGeom>
+          <a:noFill/>
+          <a:ln/>
+        </p:spPr>
+        <p:txBody>
+          <a:bodyPr wrap="square" lIns="0" tIns="0" rIns="0" bIns="0" rtlCol="0" anchor="t"/>
+          <a:lstStyle/>
+          <a:p>
+            <a:pPr marL="342900" indent="-342900">
+              <a:spcAft>
+                <a:spcPts val="500"/>
+              </a:spcAft>
+              <a:buSzPct val="100000"/>
+              <a:buFont typeface="+mj-lt"/>
+              <a:buAutoNum type="arabicPeriod" startAt="1"/>
+            </a:pPr>
+            <a:r>
+              <a:rPr lang="en-US" sz="1300" dirty="0">
+                <a:solidFill>
+                  <a:srgbClr val="1C1C1C"/>
+                </a:solidFill>
+              </a:rPr>
+              <a:t>Motors: TIM2 PWM CH1 to CH4, four DIR pins</a:t>
+            </a:r>
+            <a:endParaRPr lang="en-US" sz="1300" dirty="0"/>
+          </a:p>
+          <a:p>
+            <a:pPr marL="342900" indent="-342900">
+              <a:spcAft>
+                <a:spcPts val="500"/>
+              </a:spcAft>
+              <a:buSzPct val="100000"/>
+              <a:buFont typeface="+mj-lt"/>
+              <a:buAutoNum type="arabicPeriod" startAt="1"/>
+            </a:pPr>
+            <a:r>
+              <a:rPr lang="en-US" sz="1300" dirty="0">
+                <a:solidFill>
+                  <a:srgbClr val="1C1C1C"/>
+                </a:solidFill>
+              </a:rPr>
+              <a:t>Encoders: TIM1, TIM8, TIM3, TIM4 in encoder mode</a:t>
+            </a:r>
+            <a:endParaRPr lang="en-US" sz="1300" dirty="0"/>
+          </a:p>
+          <a:p>
+            <a:pPr marL="342900" indent="-342900">
+              <a:spcAft>
+                <a:spcPts val="500"/>
+              </a:spcAft>
+              <a:buSzPct val="100000"/>
+              <a:buFont typeface="+mj-lt"/>
+              <a:buAutoNum type="arabicPeriod" startAt="1"/>
+            </a:pPr>
+            <a:r>
+              <a:rPr lang="en-US" sz="1300" dirty="0">
+                <a:solidFill>
+                  <a:srgbClr val="1C1C1C"/>
+                </a:solidFill>
+              </a:rPr>
+              <a:t>Ultrasonic: TIM5 (TRIG by PWM, ECHO by input capture)</a:t>
+            </a:r>
+            <a:endParaRPr lang="en-US" sz="1300" dirty="0"/>
+          </a:p>
+          <a:p>
+            <a:pPr marL="342900" indent="-342900">
+              <a:spcAft>
+                <a:spcPts val="500"/>
+              </a:spcAft>
+              <a:buSzPct val="100000"/>
+              <a:buFont typeface="+mj-lt"/>
+              <a:buAutoNum type="arabicPeriod" startAt="1"/>
+            </a:pPr>
+            <a:r>
+              <a:rPr lang="en-US" sz="1300" dirty="0">
+                <a:solidFill>
+                  <a:srgbClr val="1C1C1C"/>
+                </a:solidFill>
+              </a:rPr>
+              <a:t>GENERATE CODE, then import the ass2 folder</a:t>
+            </a:r>
+            <a:endParaRPr lang="en-US" sz="1300" dirty="0"/>
+          </a:p>
+        </p:txBody>
+      </p:sp>
+      <p:sp>
+        <p:nvSpPr>
+          <p:cNvPr id="9" name="ass2 note"/>
+          <p:cNvSpPr txBox="1"/>
+          <p:nvPr/>
+        </p:nvSpPr>
+        <p:spPr>
+          <a:xfrm>
+            <a:off x="457200" y="3383280"/>
+            <a:ext cx="8229600" cy="457200"/>
+          </a:xfrm>
+          <a:prstGeom prst="rect">
+            <a:avLst/>
+          </a:prstGeom>
+          <a:noFill/>
+          <a:ln/>
+        </p:spPr>
+        <p:txBody>
+          <a:bodyPr wrap="square" rtlCol="0" anchor="ctr"/>
+          <a:lstStyle/>
+          <a:p>
+            <a:pPr indent="0" marL="0">
+              <a:buNone/>
+            </a:pPr>
+            <a:r>
+              <a:rPr lang="en-US" sz="1300" i="1" dirty="0">
+                <a:solidFill>
+                  <a:srgbClr val="5C5C5C"/>
+                </a:solidFill>
+              </a:rPr>
+              <a:t>Leave the Assignment 1 settings as they are. The full list is in the Assignment 2 configuration section of the assignment sheet.</a:t>
+            </a:r>
+            <a:endParaRPr lang="en-US" sz="1300" dirty="0"/>
+          </a:p>
+        </p:txBody>
+      </p:sp>
+      <p:sp>
+        <p:nvSpPr>
+          <p:cNvPr id="10" name="Slide Number Placeholder 0"/>
+          <p:cNvSpPr>
+            <a:spLocks noGrp="1"/>
+          </p:cNvSpPr>
+          <p:nvPr>
+            <p:ph type="sldNum" sz="quarter" idx="4294967295"/>
+          </p:nvPr>
+        </p:nvSpPr>
+        <p:spPr>
+          <a:xfrm>
+            <a:off x="8412480" y="4754880"/>
+            <a:ext cx="800000" cy="300000"/>
+          </a:xfrm>
+          <a:prstGeom prst="rect">
+            <a:avLst/>
+          </a:prstGeom>
+        </p:spPr>
+        <p:txBody>
+          <a:bodyPr/>
+          <a:lstStyle>
+            <a:lvl1pPr>
+              <a:defRPr sz="1000">
+                <a:solidFill>
+                  <a:schemeClr val="tx2"/>
+                </a:solidFill>
+              </a:defRPr>
+            </a:lvl1pPr>
+          </a:lstStyle>
+          <a:p>
+            <a:pPr algn="l"/>
+            <a:fld id="{F7021451-1387-4CA6-816F-3879F97B5CBC}" type="slidenum">
+              <a:rPr b="0" lang="en-US"/>
+              <a:t>22</a:t>
             </a:fld>
             <a:endParaRPr lang="en-US"/>
           </a:p>

</xml_diff>

<commit_message>
A2/A3 weights 30/30; tutorial 5 = I2C, .ioc slides moved to tutorial 6 (.ioc, SR04, self-learning last); session-table typo fixes; Word copy regenerated; CLAUDE.md rule on the Word copy; MP.md updates
Co-Authored-By: Claude Opus 5.5 <noreply@anthropic.com>
</commit_message>
<xml_diff>
--- a/tutorials/MP_tutorials_2026.pptx
+++ b/tutorials/MP_tutorials_2026.pptx
@@ -27,11 +27,11 @@
     <p:sldId id="289" r:id="rId18"/>
     <p:sldId id="292" r:id="rId19"/>
     <p:sldId id="273" r:id="rId20"/>
+    <p:sldId id="274" r:id="rId25"/>
     <p:sldId id="282" r:id="rId21"/>
     <p:sldId id="283" r:id="rId22"/>
     <p:sldId id="284" r:id="rId23"/>
     <p:sldId id="285" r:id="rId24"/>
-    <p:sldId id="274" r:id="rId25"/>
     <p:sldId id="268" r:id="rId26"/>
     <p:sldId id="269" r:id="rId27"/>
     <p:sldId id="270" r:id="rId28"/>
@@ -176,18 +176,18 @@
             <p14:sldId id="292"/>
           </p14:sldIdLst>
         </p14:section>
-        <p14:section name="Tutorial 5: Inside the I2C bus" id="{CDAFA046-4960-08D9-DADE-13722EA2C76E}">
+        <p14:section name="Tutorial 5: I2C" id="{CDAFA046-4960-08D9-DADE-13722EA2C76E}">
           <p14:sldIdLst>
             <p14:sldId id="273"/>
+          </p14:sldIdLst>
+        </p14:section>
+        <p14:section name="Tutorial 6: .ioc file and SR04 reading" id="{22B1A7F2-0B5C-F1E2-F58F-3B4012E84F69}">
+          <p14:sldIdLst>
+            <p14:sldId id="274"/>
             <p14:sldId id="282"/>
             <p14:sldId id="283"/>
             <p14:sldId id="284"/>
             <p14:sldId id="285"/>
-          </p14:sldIdLst>
-        </p14:section>
-        <p14:section name="Tutorial 6: Blocking vs. non-blocking" id="{22B1A7F2-0B5C-F1E2-F58F-3B4012E84F69}">
-          <p14:sldIdLst>
-            <p14:sldId id="274"/>
             <p14:sldId id="268"/>
             <p14:sldId id="269"/>
             <p14:sldId id="270"/>
@@ -2861,7 +2861,7 @@
           </a:prstGeom>
           <a:extLst>
             <a:ext uri="{C572A759-6A51-4108-AA02-DFA0A04FC94B}">
-              <ma14:wrappingTextBoxFlag xmlns="" xmlns:ma14="http://schemas.microsoft.com/office/mac/drawingml/2011/main" val="0"/>
+              <ma14:wrappingTextBoxFlag xmlns:ma14="http://schemas.microsoft.com/office/mac/drawingml/2011/main" xmlns="" val="0"/>
             </a:ext>
           </a:extLst>
         </p:spPr>
@@ -2980,7 +2980,7 @@
           </a:prstGeom>
           <a:extLst>
             <a:ext uri="{C572A759-6A51-4108-AA02-DFA0A04FC94B}">
-              <ma14:wrappingTextBoxFlag xmlns="" xmlns:ma14="http://schemas.microsoft.com/office/mac/drawingml/2011/main" val="0"/>
+              <ma14:wrappingTextBoxFlag xmlns:ma14="http://schemas.microsoft.com/office/mac/drawingml/2011/main" xmlns="" val="0"/>
             </a:ext>
           </a:extLst>
         </p:spPr>
@@ -3055,7 +3055,7 @@
           </a:prstGeom>
           <a:extLst>
             <a:ext uri="{C572A759-6A51-4108-AA02-DFA0A04FC94B}">
-              <ma14:wrappingTextBoxFlag xmlns="" xmlns:ma14="http://schemas.microsoft.com/office/mac/drawingml/2011/main" val="0"/>
+              <ma14:wrappingTextBoxFlag xmlns:ma14="http://schemas.microsoft.com/office/mac/drawingml/2011/main" xmlns="" val="0"/>
             </a:ext>
           </a:extLst>
         </p:spPr>
@@ -3605,7 +3605,7 @@
           </a:prstGeom>
           <a:extLst>
             <a:ext uri="{C572A759-6A51-4108-AA02-DFA0A04FC94B}">
-              <ma14:wrappingTextBoxFlag xmlns="" xmlns:ma14="http://schemas.microsoft.com/office/mac/drawingml/2011/main" val="0"/>
+              <ma14:wrappingTextBoxFlag xmlns:ma14="http://schemas.microsoft.com/office/mac/drawingml/2011/main" xmlns="" val="0"/>
             </a:ext>
           </a:extLst>
         </p:spPr>
@@ -3724,12 +3724,20 @@
               <a:buNone/>
             </a:pPr>
             <a:r>
+              <a:rPr lang="en-US" sz="3600" b="1" dirty="0" err="1">
+                <a:solidFill>
+                  <a:schemeClr val="bg1"/>
+                </a:solidFill>
+              </a:rPr>
+              <a:t>Trigerring</a:t>
+            </a:r>
+            <a:r>
               <a:rPr lang="en-US" sz="3600" b="1" dirty="0">
                 <a:solidFill>
                   <a:schemeClr val="bg1"/>
                 </a:solidFill>
               </a:rPr>
-              <a:t>RGB LEDs and buttons</a:t>
+              <a:t> and Timing</a:t>
             </a:r>
             <a:endParaRPr lang="en-US" sz="3600" dirty="0"/>
           </a:p>
@@ -3769,7 +3777,31 @@
                   <a:schemeClr val="bg1"/>
                 </a:solidFill>
               </a:rPr>
-              <a:t>A set_rgb helper; a walking dot with masks; saturating brightness up and down; one press = one action.</a:t>
+              <a:t>Edge Vs level triggering; blinking with </a:t>
+            </a:r>
+            <a:r>
+              <a:rPr lang="en-US" sz="1600" dirty="0" err="1">
+                <a:solidFill>
+                  <a:schemeClr val="bg1"/>
+                </a:solidFill>
+              </a:rPr>
+              <a:t>HAL_GetTick</a:t>
+            </a:r>
+            <a:r>
+              <a:rPr lang="en-US" sz="1600" dirty="0">
+                <a:solidFill>
+                  <a:schemeClr val="bg1"/>
+                </a:solidFill>
+              </a:rPr>
+              <a:t> and </a:t>
+            </a:r>
+            <a:r>
+              <a:rPr lang="en-US" sz="1600" dirty="0" err="1">
+                <a:solidFill>
+                  <a:schemeClr val="bg1"/>
+                </a:solidFill>
+              </a:rPr>
+              <a:t>HEL_Delay</a:t>
             </a:r>
             <a:endParaRPr lang="en-US" sz="1600" dirty="0"/>
           </a:p>
@@ -3795,7 +3827,7 @@
           </a:prstGeom>
           <a:extLst>
             <a:ext uri="{C572A759-6A51-4108-AA02-DFA0A04FC94B}">
-              <ma14:wrappingTextBoxFlag xmlns="" xmlns:ma14="http://schemas.microsoft.com/office/mac/drawingml/2011/main" val="0"/>
+              <ma14:wrappingTextBoxFlag xmlns:ma14="http://schemas.microsoft.com/office/mac/drawingml/2011/main" xmlns="" val="0"/>
             </a:ext>
           </a:extLst>
         </p:spPr>
@@ -3980,7 +4012,7 @@
           </a:prstGeom>
           <a:extLst>
             <a:ext uri="{C572A759-6A51-4108-AA02-DFA0A04FC94B}">
-              <ma14:wrappingTextBoxFlag xmlns="" xmlns:ma14="http://schemas.microsoft.com/office/mac/drawingml/2011/main" val="0"/>
+              <ma14:wrappingTextBoxFlag xmlns:ma14="http://schemas.microsoft.com/office/mac/drawingml/2011/main" xmlns="" val="0"/>
             </a:ext>
           </a:extLst>
         </p:spPr>
@@ -4090,7 +4122,7 @@
           </a:prstGeom>
           <a:extLst>
             <a:ext uri="{C572A759-6A51-4108-AA02-DFA0A04FC94B}">
-              <ma14:wrappingTextBoxFlag xmlns="" xmlns:ma14="http://schemas.microsoft.com/office/mac/drawingml/2011/main" val="0"/>
+              <ma14:wrappingTextBoxFlag xmlns:ma14="http://schemas.microsoft.com/office/mac/drawingml/2011/main" xmlns="" val="0"/>
             </a:ext>
           </a:extLst>
         </p:spPr>
@@ -5769,7 +5801,7 @@
           </a:prstGeom>
           <a:extLst>
             <a:ext uri="{C572A759-6A51-4108-AA02-DFA0A04FC94B}">
-              <ma14:wrappingTextBoxFlag xmlns="" xmlns:ma14="http://schemas.microsoft.com/office/mac/drawingml/2011/main" val="0"/>
+              <ma14:wrappingTextBoxFlag xmlns:ma14="http://schemas.microsoft.com/office/mac/drawingml/2011/main" xmlns="" val="0"/>
             </a:ext>
           </a:extLst>
         </p:spPr>
@@ -5879,7 +5911,7 @@
           </a:prstGeom>
           <a:extLst>
             <a:ext uri="{C572A759-6A51-4108-AA02-DFA0A04FC94B}">
-              <ma14:wrappingTextBoxFlag xmlns="" xmlns:ma14="http://schemas.microsoft.com/office/mac/drawingml/2011/main" val="0"/>
+              <ma14:wrappingTextBoxFlag xmlns:ma14="http://schemas.microsoft.com/office/mac/drawingml/2011/main" xmlns="" val="0"/>
             </a:ext>
           </a:extLst>
         </p:spPr>
@@ -7110,7 +7142,7 @@
           </a:prstGeom>
           <a:extLst>
             <a:ext uri="{C572A759-6A51-4108-AA02-DFA0A04FC94B}">
-              <ma14:wrappingTextBoxFlag xmlns="" xmlns:ma14="http://schemas.microsoft.com/office/mac/drawingml/2011/main" val="0"/>
+              <ma14:wrappingTextBoxFlag xmlns:ma14="http://schemas.microsoft.com/office/mac/drawingml/2011/main" xmlns="" val="0"/>
             </a:ext>
           </a:extLst>
         </p:spPr>
@@ -8606,7 +8638,7 @@
           </a:prstGeom>
           <a:extLst>
             <a:ext uri="{C572A759-6A51-4108-AA02-DFA0A04FC94B}">
-              <ma14:wrappingTextBoxFlag xmlns="" xmlns:ma14="http://schemas.microsoft.com/office/mac/drawingml/2011/main" val="0"/>
+              <ma14:wrappingTextBoxFlag xmlns:ma14="http://schemas.microsoft.com/office/mac/drawingml/2011/main" xmlns="" val="0"/>
             </a:ext>
           </a:extLst>
         </p:spPr>
@@ -10256,7 +10288,7 @@
           </a:prstGeom>
           <a:extLst>
             <a:ext uri="{C572A759-6A51-4108-AA02-DFA0A04FC94B}">
-              <ma14:wrappingTextBoxFlag xmlns="" xmlns:ma14="http://schemas.microsoft.com/office/mac/drawingml/2011/main" val="0"/>
+              <ma14:wrappingTextBoxFlag xmlns:ma14="http://schemas.microsoft.com/office/mac/drawingml/2011/main" xmlns="" val="0"/>
             </a:ext>
           </a:extLst>
         </p:spPr>
@@ -11769,49 +11801,9 @@
                   <a:schemeClr val="bg1"/>
                 </a:solidFill>
               </a:rPr>
-              <a:t>Inside the I2C bus</a:t>
+              <a:t>I2C</a:t>
             </a:r>
             <a:endParaRPr lang="en-US" sz="3600" dirty="0"/>
-          </a:p>
-        </p:txBody>
-      </p:sp>
-      <p:sp>
-        <p:nvSpPr>
-          <p:cNvPr id="4" name="Text 0"/>
-          <p:cNvSpPr>
-            <a:spLocks noGrp="1"/>
-          </p:cNvSpPr>
-          <p:nvPr>
-            <p:ph type="body" idx="102" hasCustomPrompt="1"/>
-          </p:nvPr>
-        </p:nvSpPr>
-        <p:spPr>
-          <a:xfrm>
-            <a:off x="548640" y="2743200"/>
-            <a:ext cx="8046720" cy="1737360"/>
-          </a:xfrm>
-          <a:prstGeom prst="rect">
-            <a:avLst/>
-          </a:prstGeom>
-          <a:noFill/>
-          <a:ln/>
-        </p:spPr>
-        <p:txBody>
-          <a:bodyPr wrap="square" rtlCol="0" anchor="t"/>
-          <a:lstStyle/>
-          <a:p>
-            <a:pPr marL="0" indent="0" algn="l">
-              <a:buNone/>
-            </a:pPr>
-            <a:r>
-              <a:rPr lang="en-US" sz="1600" dirty="0">
-                <a:solidFill>
-                  <a:schemeClr val="bg1"/>
-                </a:solidFill>
-              </a:rPr>
-              <a:t>I2C bus scan: detect the five IO-board chips; set_rgb rewritten on raw HAL_I2C_Mem_Write; servo sweep. Short part: creating a .ioc in STM32CubeMX, and starting Assignment 2 from it.</a:t>
-            </a:r>
-            <a:endParaRPr lang="en-US" sz="1600" dirty="0"/>
           </a:p>
         </p:txBody>
       </p:sp>
@@ -11835,7 +11827,7 @@
           </a:prstGeom>
           <a:extLst>
             <a:ext uri="{C572A759-6A51-4108-AA02-DFA0A04FC94B}">
-              <ma14:wrappingTextBoxFlag xmlns="" xmlns:ma14="http://schemas.microsoft.com/office/mac/drawingml/2011/main" val="0"/>
+              <ma14:wrappingTextBoxFlag xmlns:ma14="http://schemas.microsoft.com/office/mac/drawingml/2011/main" xmlns="" val="0"/>
             </a:ext>
           </a:extLst>
         </p:spPr>
@@ -11990,16 +11982,49 @@
           <a:bodyPr wrap="square" rtlCol="0" anchor="t"/>
           <a:lstStyle/>
           <a:p>
-            <a:pPr marL="0" indent="0" algn="l">
-              <a:buNone/>
-            </a:pPr>
             <a:r>
               <a:rPr lang="en-US" sz="1600" dirty="0">
                 <a:solidFill>
                   <a:schemeClr val="bg1"/>
                 </a:solidFill>
               </a:rPr>
-              <a:t>CubeMX configuration, build, flash and run; blink LD2; printf to PuTTY; the debugger: breakpoints, stepping, live expressions; where your code goes (USER CODE sections).</a:t>
+              <a:t>Load *.</a:t>
+            </a:r>
+            <a:r>
+              <a:rPr lang="en-US" sz="1600" dirty="0" err="1">
+                <a:solidFill>
+                  <a:schemeClr val="bg1"/>
+                </a:solidFill>
+              </a:rPr>
+              <a:t>ioc</a:t>
+            </a:r>
+            <a:r>
+              <a:rPr lang="en-US" sz="1600" dirty="0">
+                <a:solidFill>
+                  <a:schemeClr val="bg1"/>
+                </a:solidFill>
+              </a:rPr>
+              <a:t>, build, flash and run; </a:t>
+            </a:r>
+            <a:r>
+              <a:rPr lang="en-US" dirty="0"/>
+              <a:t>the debugger: breakpoints, stepping, live expressions; where your code goes (USER CODE sections); blink LD2; </a:t>
+            </a:r>
+            <a:r>
+              <a:rPr lang="en-US" sz="1600" dirty="0" err="1">
+                <a:solidFill>
+                  <a:schemeClr val="bg1"/>
+                </a:solidFill>
+              </a:rPr>
+              <a:t>printf</a:t>
+            </a:r>
+            <a:r>
+              <a:rPr lang="en-US" sz="1600" dirty="0">
+                <a:solidFill>
+                  <a:schemeClr val="bg1"/>
+                </a:solidFill>
+              </a:rPr>
+              <a:t> to PuTTY; </a:t>
             </a:r>
             <a:endParaRPr lang="en-US" sz="1600" dirty="0"/>
           </a:p>
@@ -12025,7 +12050,7 @@
           </a:prstGeom>
           <a:extLst>
             <a:ext uri="{C572A759-6A51-4108-AA02-DFA0A04FC94B}">
-              <ma14:wrappingTextBoxFlag xmlns="" xmlns:ma14="http://schemas.microsoft.com/office/mac/drawingml/2011/main" val="0"/>
+              <ma14:wrappingTextBoxFlag xmlns:ma14="http://schemas.microsoft.com/office/mac/drawingml/2011/main" xmlns="" val="0"/>
             </a:ext>
           </a:extLst>
         </p:spPr>
@@ -12720,7 +12745,7 @@
         </p:nvGraphicFramePr>
         <p:xfrm>
           <a:off x="457200" y="1051560"/>
-          <a:ext cx="8229600" cy="2743200"/>
+          <a:ext cx="8229600" cy="2834640"/>
         </p:xfrm>
         <a:graphic>
           <a:graphicData uri="http://schemas.openxmlformats.org/drawingml/2006/table">
@@ -15769,7 +15794,7 @@
                   <a:schemeClr val="bg1"/>
                 </a:solidFill>
               </a:rPr>
-              <a:t>Blocking vs. non-blocking</a:t>
+              <a:t>.ioc file and SR04 reading</a:t>
             </a:r>
             <a:endParaRPr lang="en-US" sz="3600" dirty="0"/>
           </a:p>
@@ -15809,7 +15834,7 @@
                   <a:schemeClr val="bg1"/>
                 </a:solidFill>
               </a:rPr>
-              <a:t>Registers on another chip vs. in RAM; one ultrasonic distance measurement; an EXTI interrupt with a counter.</a:t>
+              <a:t>Creating a .ioc in STM32CubeMX, and starting Assignment 2 from ass1.ioc; reading the SR04 ultrasonic sensor; self-learning: blocking vs. non-blocking.</a:t>
             </a:r>
             <a:endParaRPr lang="en-US" sz="1600" dirty="0"/>
           </a:p>
@@ -15835,7 +15860,7 @@
           </a:prstGeom>
           <a:extLst>
             <a:ext uri="{C572A759-6A51-4108-AA02-DFA0A04FC94B}">
-              <ma14:wrappingTextBoxFlag xmlns="" xmlns:ma14="http://schemas.microsoft.com/office/mac/drawingml/2011/main" val="0"/>
+              <ma14:wrappingTextBoxFlag xmlns:ma14="http://schemas.microsoft.com/office/mac/drawingml/2011/main" xmlns="" val="0"/>
             </a:ext>
           </a:extLst>
         </p:spPr>
@@ -16245,7 +16270,7 @@
           </a:prstGeom>
           <a:extLst>
             <a:ext uri="{C572A759-6A51-4108-AA02-DFA0A04FC94B}">
-              <ma14:wrappingTextBoxFlag xmlns="" xmlns:ma14="http://schemas.microsoft.com/office/mac/drawingml/2011/main" val="0"/>
+              <ma14:wrappingTextBoxFlag xmlns:ma14="http://schemas.microsoft.com/office/mac/drawingml/2011/main" xmlns="" val="0"/>
             </a:ext>
           </a:extLst>
         </p:spPr>
@@ -16629,7 +16654,7 @@
           </a:prstGeom>
           <a:extLst>
             <a:ext uri="{C572A759-6A51-4108-AA02-DFA0A04FC94B}">
-              <ma14:wrappingTextBoxFlag xmlns="" xmlns:ma14="http://schemas.microsoft.com/office/mac/drawingml/2011/main" val="0"/>
+              <ma14:wrappingTextBoxFlag xmlns:ma14="http://schemas.microsoft.com/office/mac/drawingml/2011/main" xmlns="" val="0"/>
             </a:ext>
           </a:extLst>
         </p:spPr>
@@ -17036,7 +17061,7 @@
           </a:prstGeom>
           <a:extLst>
             <a:ext uri="{C572A759-6A51-4108-AA02-DFA0A04FC94B}">
-              <ma14:wrappingTextBoxFlag xmlns="" xmlns:ma14="http://schemas.microsoft.com/office/mac/drawingml/2011/main" val="0"/>
+              <ma14:wrappingTextBoxFlag xmlns:ma14="http://schemas.microsoft.com/office/mac/drawingml/2011/main" xmlns="" val="0"/>
             </a:ext>
           </a:extLst>
         </p:spPr>
@@ -17990,7 +18015,7 @@
           </a:prstGeom>
           <a:extLst>
             <a:ext uri="{C572A759-6A51-4108-AA02-DFA0A04FC94B}">
-              <ma14:wrappingTextBoxFlag xmlns="" xmlns:ma14="http://schemas.microsoft.com/office/mac/drawingml/2011/main" val="0"/>
+              <ma14:wrappingTextBoxFlag xmlns:ma14="http://schemas.microsoft.com/office/mac/drawingml/2011/main" xmlns="" val="0"/>
             </a:ext>
           </a:extLst>
         </p:spPr>
@@ -18437,7 +18462,7 @@
           </a:prstGeom>
           <a:extLst>
             <a:ext uri="{C572A759-6A51-4108-AA02-DFA0A04FC94B}">
-              <ma14:wrappingTextBoxFlag xmlns="" xmlns:ma14="http://schemas.microsoft.com/office/mac/drawingml/2011/main" val="0"/>
+              <ma14:wrappingTextBoxFlag xmlns:ma14="http://schemas.microsoft.com/office/mac/drawingml/2011/main" xmlns="" val="0"/>
             </a:ext>
           </a:extLst>
         </p:spPr>
@@ -18884,7 +18909,7 @@
           </a:prstGeom>
           <a:extLst>
             <a:ext uri="{C572A759-6A51-4108-AA02-DFA0A04FC94B}">
-              <ma14:wrappingTextBoxFlag xmlns="" xmlns:ma14="http://schemas.microsoft.com/office/mac/drawingml/2011/main" val="0"/>
+              <ma14:wrappingTextBoxFlag xmlns:ma14="http://schemas.microsoft.com/office/mac/drawingml/2011/main" xmlns="" val="0"/>
             </a:ext>
           </a:extLst>
         </p:spPr>
@@ -19074,7 +19099,7 @@
           </a:prstGeom>
           <a:extLst>
             <a:ext uri="{C572A759-6A51-4108-AA02-DFA0A04FC94B}">
-              <ma14:wrappingTextBoxFlag xmlns="" xmlns:ma14="http://schemas.microsoft.com/office/mac/drawingml/2011/main" val="0"/>
+              <ma14:wrappingTextBoxFlag xmlns:ma14="http://schemas.microsoft.com/office/mac/drawingml/2011/main" xmlns="" val="0"/>
             </a:ext>
           </a:extLst>
         </p:spPr>
@@ -19264,7 +19289,7 @@
           </a:prstGeom>
           <a:extLst>
             <a:ext uri="{C572A759-6A51-4108-AA02-DFA0A04FC94B}">
-              <ma14:wrappingTextBoxFlag xmlns="" xmlns:ma14="http://schemas.microsoft.com/office/mac/drawingml/2011/main" val="0"/>
+              <ma14:wrappingTextBoxFlag xmlns:ma14="http://schemas.microsoft.com/office/mac/drawingml/2011/main" xmlns="" val="0"/>
             </a:ext>
           </a:extLst>
         </p:spPr>
@@ -19454,7 +19479,7 @@
           </a:prstGeom>
           <a:extLst>
             <a:ext uri="{C572A759-6A51-4108-AA02-DFA0A04FC94B}">
-              <ma14:wrappingTextBoxFlag xmlns="" xmlns:ma14="http://schemas.microsoft.com/office/mac/drawingml/2011/main" val="0"/>
+              <ma14:wrappingTextBoxFlag xmlns:ma14="http://schemas.microsoft.com/office/mac/drawingml/2011/main" xmlns="" val="0"/>
             </a:ext>
           </a:extLst>
         </p:spPr>
@@ -19644,7 +19669,7 @@
           </a:prstGeom>
           <a:extLst>
             <a:ext uri="{C572A759-6A51-4108-AA02-DFA0A04FC94B}">
-              <ma14:wrappingTextBoxFlag xmlns="" xmlns:ma14="http://schemas.microsoft.com/office/mac/drawingml/2011/main" val="0"/>
+              <ma14:wrappingTextBoxFlag xmlns:ma14="http://schemas.microsoft.com/office/mac/drawingml/2011/main" xmlns="" val="0"/>
             </a:ext>
           </a:extLst>
         </p:spPr>
@@ -19834,7 +19859,7 @@
           </a:prstGeom>
           <a:extLst>
             <a:ext uri="{C572A759-6A51-4108-AA02-DFA0A04FC94B}">
-              <ma14:wrappingTextBoxFlag xmlns="" xmlns:ma14="http://schemas.microsoft.com/office/mac/drawingml/2011/main" val="0"/>
+              <ma14:wrappingTextBoxFlag xmlns:ma14="http://schemas.microsoft.com/office/mac/drawingml/2011/main" xmlns="" val="0"/>
             </a:ext>
           </a:extLst>
         </p:spPr>
@@ -20024,7 +20049,7 @@
           </a:prstGeom>
           <a:extLst>
             <a:ext uri="{C572A759-6A51-4108-AA02-DFA0A04FC94B}">
-              <ma14:wrappingTextBoxFlag xmlns="" xmlns:ma14="http://schemas.microsoft.com/office/mac/drawingml/2011/main" val="0"/>
+              <ma14:wrappingTextBoxFlag xmlns:ma14="http://schemas.microsoft.com/office/mac/drawingml/2011/main" xmlns="" val="0"/>
             </a:ext>
           </a:extLst>
         </p:spPr>
@@ -20214,7 +20239,7 @@
           </a:prstGeom>
           <a:extLst>
             <a:ext uri="{C572A759-6A51-4108-AA02-DFA0A04FC94B}">
-              <ma14:wrappingTextBoxFlag xmlns="" xmlns:ma14="http://schemas.microsoft.com/office/mac/drawingml/2011/main" val="0"/>
+              <ma14:wrappingTextBoxFlag xmlns:ma14="http://schemas.microsoft.com/office/mac/drawingml/2011/main" xmlns="" val="0"/>
             </a:ext>
           </a:extLst>
         </p:spPr>
@@ -20320,7 +20345,7 @@
         </p:nvGraphicFramePr>
         <p:xfrm>
           <a:off x="457200" y="1051560"/>
-          <a:ext cx="8229600" cy="914400"/>
+          <a:ext cx="8229600" cy="2962656"/>
         </p:xfrm>
         <a:graphic>
           <a:graphicData uri="http://schemas.openxmlformats.org/drawingml/2006/table">
@@ -22231,7 +22256,7 @@
           </a:prstGeom>
           <a:extLst>
             <a:ext uri="{C572A759-6A51-4108-AA02-DFA0A04FC94B}">
-              <ma14:wrappingTextBoxFlag xmlns="" xmlns:ma14="http://schemas.microsoft.com/office/mac/drawingml/2011/main" val="0"/>
+              <ma14:wrappingTextBoxFlag xmlns:ma14="http://schemas.microsoft.com/office/mac/drawingml/2011/main" xmlns="" val="0"/>
             </a:ext>
           </a:extLst>
         </p:spPr>
@@ -22337,7 +22362,7 @@
         </p:nvGraphicFramePr>
         <p:xfrm>
           <a:off x="457200" y="1051560"/>
-          <a:ext cx="8229600" cy="914400"/>
+          <a:ext cx="8229600" cy="2798064"/>
         </p:xfrm>
         <a:graphic>
           <a:graphicData uri="http://schemas.openxmlformats.org/drawingml/2006/table">
@@ -24044,7 +24069,7 @@
           </a:prstGeom>
           <a:extLst>
             <a:ext uri="{C572A759-6A51-4108-AA02-DFA0A04FC94B}">
-              <ma14:wrappingTextBoxFlag xmlns="" xmlns:ma14="http://schemas.microsoft.com/office/mac/drawingml/2011/main" val="0"/>
+              <ma14:wrappingTextBoxFlag xmlns:ma14="http://schemas.microsoft.com/office/mac/drawingml/2011/main" xmlns="" val="0"/>
             </a:ext>
           </a:extLst>
         </p:spPr>
@@ -24486,7 +24511,7 @@
           </a:prstGeom>
           <a:extLst>
             <a:ext uri="{C572A759-6A51-4108-AA02-DFA0A04FC94B}">
-              <ma14:wrappingTextBoxFlag xmlns="" xmlns:ma14="http://schemas.microsoft.com/office/mac/drawingml/2011/main" val="0"/>
+              <ma14:wrappingTextBoxFlag xmlns:ma14="http://schemas.microsoft.com/office/mac/drawingml/2011/main" xmlns="" val="0"/>
             </a:ext>
           </a:extLst>
         </p:spPr>
@@ -25036,7 +25061,7 @@
           </a:prstGeom>
           <a:extLst>
             <a:ext uri="{C572A759-6A51-4108-AA02-DFA0A04FC94B}">
-              <ma14:wrappingTextBoxFlag xmlns="" xmlns:ma14="http://schemas.microsoft.com/office/mac/drawingml/2011/main" val="0"/>
+              <ma14:wrappingTextBoxFlag xmlns:ma14="http://schemas.microsoft.com/office/mac/drawingml/2011/main" xmlns="" val="0"/>
             </a:ext>
           </a:extLst>
         </p:spPr>
@@ -25473,7 +25498,7 @@
           </a:prstGeom>
           <a:extLst>
             <a:ext uri="{C572A759-6A51-4108-AA02-DFA0A04FC94B}">
-              <ma14:wrappingTextBoxFlag xmlns="" xmlns:ma14="http://schemas.microsoft.com/office/mac/drawingml/2011/main" val="0"/>
+              <ma14:wrappingTextBoxFlag xmlns:ma14="http://schemas.microsoft.com/office/mac/drawingml/2011/main" xmlns="" val="0"/>
             </a:ext>
           </a:extLst>
         </p:spPr>
@@ -25955,7 +25980,7 @@
           </a:prstGeom>
           <a:extLst>
             <a:ext uri="{C572A759-6A51-4108-AA02-DFA0A04FC94B}">
-              <ma14:wrappingTextBoxFlag xmlns="" xmlns:ma14="http://schemas.microsoft.com/office/mac/drawingml/2011/main" val="0"/>
+              <ma14:wrappingTextBoxFlag xmlns:ma14="http://schemas.microsoft.com/office/mac/drawingml/2011/main" xmlns="" val="0"/>
             </a:ext>
           </a:extLst>
         </p:spPr>

</xml_diff>